<commit_message>
snolab: presentation — slide 3 shows fan plots (no-cut vs NRMSE-cut) as the fit-step output; slide 11 keeps the after-cuts fan only
Co-Authored-By: Claude Opus 4.8 <noreply@anthropic.com>
</commit_message>
<xml_diff>
--- a/snolab/presentation/SNOLAB_R4_pulse_templates_20260715.pptx
+++ b/snolab/presentation/SNOLAB_R4_pulse_templates_20260715.pptx
@@ -670,7 +670,7 @@
           <a:lstStyle/>
           <a:p>
             <a:r>
-              <a:t>First template family: the analytic one. For each channel we take every physical fitted curve, put them at the common onset, and average them with a weight of one over NRMSE squared - so badly fit events count less but nothing is excluded by hand. The fan plots show the shape distribution before and after the cuts: after the cuts a single tight shape family remains, and its weighted mean is the 1x1 template - smooth and noise-free by construction because it is built from analytic curves.</a:t>
+              <a:t>First template family: the analytic one. For each channel we take every physical fitted curve at the common onset and average them with a weight of one over NRMSE squared - badly fit events count less but nothing is excluded by hand. After the cuts, shown here, a single tight shape family remains, and its weighted mean is the 1x1 template - smooth and noise-free by construction because it is built from analytic curves, delivered as peak-normalized ROOT histograms.</a:t>
             </a:r>
           </a:p>
         </p:txBody>
@@ -950,7 +950,7 @@
           <a:lstStyle/>
           <a:p>
             <a:r>
-              <a:t>The per-trace algorithm. Low-pass at 100 kHz, baseline subtraction, peak normalization, then a two-exponential fit where all five parameters are free, including the pulse onset. The onset is never pinned: real trigger times vary, and the fitted onsets cluster about 230 samples after the nominal pretrigger - pinning it would bias the time constants. Each fit gives two quality numbers, a physicality flag and an NRMSE, which we only record at this stage. Finally the measured trace is aligned by shifting it by the fitted onset - a pure translation, no analytic re-generation.</a:t>
+              <a:t>The per-trace algorithm, five steps. Low-pass at 100 kilohertz, baseline subtraction, peak normalization, then a two-exponential fit where all five parameters are free, including the pulse onset. The onset is never pinned: real trigger times vary, and the fitted onsets cluster about 230 samples after the nominal pretrigger - pinning it would bias the time constants. Each fit records a physicality flag and an NRMSE; no cut yet. Finally the measured trace is aligned by shifting it by the fitted onset - a pure translation. The two fan plots show the output of the fit step: every fitted curve drawn at the common onset, peak-normalized. On the left, all physical fits - you can see slow components spreading off the main bundle. On the right, after the NRMSE cut, a single tight shape family remains. Where that cut comes from is the next part of the talk.</a:t>
             </a:r>
           </a:p>
         </p:txBody>
@@ -4943,72 +4943,7 @@
       </p:sp>
       <p:pic>
         <p:nvPicPr>
-          <p:cNvPr id="5" name="Picture 4" descr="fan_zip7_PBS1_before.png"/>
-          <p:cNvPicPr>
-            <a:picLocks noChangeAspect="1"/>
-          </p:cNvPicPr>
-          <p:nvPr/>
-        </p:nvPicPr>
-        <p:blipFill>
-          <a:blip r:embed="rId1"/>
-          <a:stretch>
-            <a:fillRect/>
-          </a:stretch>
-        </p:blipFill>
-        <p:spPr>
-          <a:xfrm>
-            <a:off x="2974786" y="2606040"/>
-            <a:ext cx="6211947" cy="1874519"/>
-          </a:xfrm>
-          <a:prstGeom prst="rect">
-            <a:avLst/>
-          </a:prstGeom>
-        </p:spPr>
-      </p:pic>
-      <p:sp>
-        <p:nvSpPr>
-          <p:cNvPr id="6" name="TextBox 5"/>
-          <p:cNvSpPr txBox="1"/>
-          <p:nvPr/>
-        </p:nvSpPr>
-        <p:spPr>
-          <a:xfrm>
-            <a:off x="1554480" y="4510559"/>
-            <a:ext cx="9052560" cy="274320"/>
-          </a:xfrm>
-          <a:prstGeom prst="rect">
-            <a:avLst/>
-          </a:prstGeom>
-          <a:noFill/>
-        </p:spPr>
-        <p:txBody>
-          <a:bodyPr wrap="square">
-            <a:spAutoFit/>
-          </a:bodyPr>
-          <a:lstStyle/>
-          <a:p>
-            <a:pPr algn="ctr"/>
-            <a:r>
-              <a:rPr sz="1100" i="1">
-                <a:solidFill>
-                  <a:srgbClr val="666666"/>
-                </a:solidFill>
-                <a:latin typeface="Arial" panose="020B0604020202090204"/>
-              </a:rPr>
-              <a:t>Z7 PBS1, fitted curves at common onset — before cuts</a:t>
-            </a:r>
-            <a:endParaRPr sz="1100" i="1">
-              <a:solidFill>
-                <a:srgbClr val="666666"/>
-              </a:solidFill>
-              <a:latin typeface="Arial" panose="020B0604020202090204"/>
-            </a:endParaRPr>
-          </a:p>
-        </p:txBody>
-      </p:sp>
-      <p:pic>
-        <p:nvPicPr>
-          <p:cNvPr id="7" name="Picture 6" descr="fan_zip7_PBS1_after.png"/>
+          <p:cNvPr id="5" name="Picture 4" descr="image.png"/>
           <p:cNvPicPr>
             <a:picLocks noChangeAspect="1"/>
           </p:cNvPicPr>
@@ -5022,8 +4957,8 @@
         </p:blipFill>
         <p:spPr>
           <a:xfrm>
-            <a:off x="2974786" y="4617720"/>
-            <a:ext cx="6211947" cy="1874519"/>
+            <a:off x="1383919" y="3063240"/>
+            <a:ext cx="9393682" cy="2834640"/>
           </a:xfrm>
           <a:prstGeom prst="rect">
             <a:avLst/>
@@ -5032,14 +4967,14 @@
       </p:pic>
       <p:sp>
         <p:nvSpPr>
-          <p:cNvPr id="8" name="TextBox 7"/>
+          <p:cNvPr id="6" name="TextBox 5"/>
           <p:cNvSpPr txBox="1"/>
           <p:nvPr/>
         </p:nvSpPr>
         <p:spPr>
           <a:xfrm>
-            <a:off x="1554480" y="6522239"/>
-            <a:ext cx="9052560" cy="274320"/>
+            <a:off x="1280160" y="5927880"/>
+            <a:ext cx="9601200" cy="292608"/>
           </a:xfrm>
           <a:prstGeom prst="rect">
             <a:avLst/>
@@ -5058,16 +4993,10 @@
                 <a:solidFill>
                   <a:srgbClr val="666666"/>
                 </a:solidFill>
-                <a:latin typeface="Arial" panose="020B0604020202090204"/>
+                <a:latin typeface="Arial"/>
               </a:rPr>
-              <a:t>…after NRMSE ≤ 0.4 and τ_rise ≤ 0.3 ms — a single tight shape family; the weighted mean of these is the 1x1 template</a:t>
-            </a:r>
-            <a:endParaRPr sz="1100" i="1">
-              <a:solidFill>
-                <a:srgbClr val="666666"/>
-              </a:solidFill>
-              <a:latin typeface="Arial" panose="020B0604020202090204"/>
-            </a:endParaRPr>
+              <a:t>Z7 PBS1, fitted curves after NRMSE ≤ 0.4 and τ_rise ≤ 0.3 ms — the NRMSE-weighted mean of this family is the 1x1 template</a:t>
+            </a:r>
           </a:p>
         </p:txBody>
       </p:sp>
@@ -6206,8 +6135,8 @@
         </p:nvSpPr>
         <p:spPr>
           <a:xfrm>
-            <a:off x="502920" y="4114800"/>
-            <a:ext cx="5120640" cy="1737360"/>
+            <a:off x="502920" y="4005072"/>
+            <a:ext cx="11247120" cy="685800"/>
           </a:xfrm>
           <a:prstGeom prst="rect">
             <a:avLst/>
@@ -6243,24 +6172,65 @@
           </a:p>
         </p:txBody>
       </p:sp>
+      <p:sp>
+        <p:nvSpPr>
+          <p:cNvPr id="7" name="TextBox 6"/>
+          <p:cNvSpPr txBox="1"/>
+          <p:nvPr/>
+        </p:nvSpPr>
+        <p:spPr>
+          <a:xfrm>
+            <a:off x="5852160" y="5665803"/>
+            <a:ext cx="5852160" cy="274320"/>
+          </a:xfrm>
+          <a:prstGeom prst="rect">
+            <a:avLst/>
+          </a:prstGeom>
+          <a:noFill/>
+        </p:spPr>
+        <p:txBody>
+          <a:bodyPr wrap="square">
+            <a:spAutoFit/>
+          </a:bodyPr>
+          <a:lstStyle/>
+          <a:p>
+            <a:pPr algn="ctr"/>
+            <a:r>
+              <a:rPr sz="1100" i="1">
+                <a:solidFill>
+                  <a:srgbClr val="666666"/>
+                </a:solidFill>
+                <a:latin typeface="Arial" panose="020B0604020202090204"/>
+              </a:rPr>
+              <a:t>Z7 PAS1: fitted onset distribution — offset from nominal, narrow core</a:t>
+            </a:r>
+            <a:endParaRPr sz="1100" i="1">
+              <a:solidFill>
+                <a:srgbClr val="666666"/>
+              </a:solidFill>
+              <a:latin typeface="Arial" panose="020B0604020202090204"/>
+            </a:endParaRPr>
+          </a:p>
+        </p:txBody>
+      </p:sp>
       <p:pic>
         <p:nvPicPr>
-          <p:cNvPr id="6" name="Picture 5" descr="pretrigger_zip7_crop.png"/>
+          <p:cNvPr id="8" name="Picture 7" descr="image.png"/>
           <p:cNvPicPr>
             <a:picLocks noChangeAspect="1"/>
           </p:cNvPicPr>
           <p:nvPr/>
         </p:nvPicPr>
         <p:blipFill>
-          <a:blip r:embed="rId1"/>
+          <a:blip r:embed="rId4"/>
           <a:stretch>
             <a:fillRect/>
           </a:stretch>
         </p:blipFill>
         <p:spPr>
           <a:xfrm>
-            <a:off x="5852160" y="4037965"/>
-            <a:ext cx="5852160" cy="1475283"/>
+            <a:off x="594677" y="4800600"/>
+            <a:ext cx="5302885" cy="1600200"/>
           </a:xfrm>
           <a:prstGeom prst="rect">
             <a:avLst/>
@@ -6269,14 +6239,14 @@
       </p:pic>
       <p:sp>
         <p:nvSpPr>
-          <p:cNvPr id="7" name="TextBox 6"/>
+          <p:cNvPr id="9" name="TextBox 8"/>
           <p:cNvSpPr txBox="1"/>
           <p:nvPr/>
         </p:nvSpPr>
         <p:spPr>
           <a:xfrm>
-            <a:off x="5852160" y="5665803"/>
-            <a:ext cx="5852160" cy="274320"/>
+            <a:off x="502920" y="6430800"/>
+            <a:ext cx="5486400" cy="292608"/>
           </a:xfrm>
           <a:prstGeom prst="rect">
             <a:avLst/>
@@ -6295,16 +6265,69 @@
                 <a:solidFill>
                   <a:srgbClr val="666666"/>
                 </a:solidFill>
-                <a:latin typeface="Arial" panose="020B0604020202090204"/>
+                <a:latin typeface="Arial"/>
               </a:rPr>
-              <a:t>Z7 PAS1: fitted onset distribution — offset from nominal, narrow core</a:t>
-            </a:r>
-            <a:endParaRPr sz="1100" i="1">
-              <a:solidFill>
-                <a:srgbClr val="666666"/>
-              </a:solidFill>
-              <a:latin typeface="Arial" panose="020B0604020202090204"/>
-            </a:endParaRPr>
+              <a:t>Fitted curves at common onset, peak-normalized — ALL fit_ok events (no cut)</a:t>
+            </a:r>
+          </a:p>
+        </p:txBody>
+      </p:sp>
+      <p:pic>
+        <p:nvPicPr>
+          <p:cNvPr id="10" name="Picture 9" descr="image.png"/>
+          <p:cNvPicPr>
+            <a:picLocks noChangeAspect="1"/>
+          </p:cNvPicPr>
+          <p:nvPr/>
+        </p:nvPicPr>
+        <p:blipFill>
+          <a:blip r:embed="rId5"/>
+          <a:stretch>
+            <a:fillRect/>
+          </a:stretch>
+        </p:blipFill>
+        <p:spPr>
+          <a:xfrm>
+            <a:off x="6355397" y="4800600"/>
+            <a:ext cx="5302885" cy="1600200"/>
+          </a:xfrm>
+          <a:prstGeom prst="rect">
+            <a:avLst/>
+          </a:prstGeom>
+        </p:spPr>
+      </p:pic>
+      <p:sp>
+        <p:nvSpPr>
+          <p:cNvPr id="11" name="TextBox 10"/>
+          <p:cNvSpPr txBox="1"/>
+          <p:nvPr/>
+        </p:nvSpPr>
+        <p:spPr>
+          <a:xfrm>
+            <a:off x="6263640" y="6430800"/>
+            <a:ext cx="5486400" cy="292608"/>
+          </a:xfrm>
+          <a:prstGeom prst="rect">
+            <a:avLst/>
+          </a:prstGeom>
+          <a:noFill/>
+        </p:spPr>
+        <p:txBody>
+          <a:bodyPr wrap="square">
+            <a:spAutoFit/>
+          </a:bodyPr>
+          <a:lstStyle/>
+          <a:p>
+            <a:pPr algn="ctr"/>
+            <a:r>
+              <a:rPr sz="1100" i="1">
+                <a:solidFill>
+                  <a:srgbClr val="666666"/>
+                </a:solidFill>
+                <a:latin typeface="Arial"/>
+              </a:rPr>
+              <a:t>Same, after NRMSE ≤ 0.4 — a single tight shape family remains (Z7 PBS1)</a:t>
+            </a:r>
           </a:p>
         </p:txBody>
       </p:sp>

</xml_diff>

<commit_message>
snolab: presentation — slide 5 shows two large peak zooms (PCS1 + PBS2) with the shadow bundle visible on both faces; fix aligned_overlay panel indexing (tall header block shifted channel indices by one)
Co-Authored-By: Claude Opus 4.8 <noreply@anthropic.com>
</commit_message>
<xml_diff>
--- a/snolab/presentation/SNOLAB_R4_pulse_templates_20260715.pptx
+++ b/snolab/presentation/SNOLAB_R4_pulse_templates_20260715.pptx
@@ -1090,7 +1090,7 @@
           <a:lstStyle/>
           <a:p>
             <a:r>
-              <a:t>After alignment the measured traces stack into a tight bundle - here channel PBS1 and PCS1 of Z7, with the full window on the left and the peak zoom on the right. Red is the plain mean of the measured traces, orange the NRMSE-weighted mean of the fitted curves - already almost a template. In the PCS1 zoom you can see a faint displaced bundle next to the main one; keep it in mind, it comes back in a few slides.</a:t>
+              <a:t>Here's what things look like after alignment - zoomed right on the peak. The blue band is thousands of measured traces stacked on top of each other; red is their average; orange is the weighted average of the fitted curves. On a quiet detector the bundle is very tight - the pulse shape really is highly consistent, so the raw material for a template is good. Now please notice one detail: in both channels there is a faint, displaced little bundle next to the main one - very clear in the left panel. And these two channels sit on opposite faces of the crystal, so this is not a quirk of one channel. Keep it in mind - we'll come back to what it is.</a:t>
             </a:r>
           </a:p>
         </p:txBody>
@@ -6776,7 +6776,7 @@
           <a:p>
             <a:pPr>
               <a:spcAft>
-                <a:spcPts val="500"/>
+                <a:spcPts val="400"/>
               </a:spcAft>
             </a:pPr>
             <a:r>
@@ -6784,7 +6784,7 @@
                 <a:solidFill>
                   <a:srgbClr val="333333"/>
                 </a:solidFill>
-                <a:latin typeface="Arial" panose="020B0604020202090204"/>
+                <a:latin typeface="Arial"/>
               </a:rPr>
               <a:t>• All fit_ok traces shifted to the common onset (blue) + point-by-point mean (red) + NRMSE-weighted mean of the fitted curves (orange, w = 1/max(NRMSE, 0.01)²)</a:t>
             </a:r>
@@ -6798,7 +6798,7 @@
           <a:p>
             <a:pPr>
               <a:spcAft>
-                <a:spcPts val="500"/>
+                <a:spcPts val="400"/>
               </a:spcAft>
             </a:pPr>
             <a:r>
@@ -6806,61 +6806,90 @@
                 <a:solidFill>
                   <a:srgbClr val="333333"/>
                 </a:solidFill>
-                <a:latin typeface="Arial" panose="020B0604020202090204"/>
+                <a:latin typeface="Arial"/>
               </a:rPr>
-              <a:t>• Quiet detectors give a tight bundle — the template input is well defined; right panels zoom on the peak</a:t>
-            </a:r>
-            <a:endParaRPr sz="1400">
-              <a:solidFill>
-                <a:srgbClr val="333333"/>
-              </a:solidFill>
-              <a:latin typeface="Arial" panose="020B0604020202090204"/>
-            </a:endParaRPr>
+              <a:t>• Peak zoom on a quiet detector: a tight bundle — the template input is well defined. Note the faint displaced bundle beside the main one, visible on both crystal faces (S1 and S2) — more on it later</a:t>
+            </a:r>
           </a:p>
         </p:txBody>
       </p:sp>
       <p:pic>
         <p:nvPicPr>
-          <p:cNvPr id="5" name="Picture 4" descr="aligned_overlay_zip7_PBS1.png"/>
+          <p:cNvPr id="5" name="Picture 4" descr="aligned_zoom_zip7_PCS1.png"/>
           <p:cNvPicPr>
             <a:picLocks noChangeAspect="1"/>
           </p:cNvPicPr>
           <p:nvPr/>
         </p:nvPicPr>
         <p:blipFill>
-          <a:blip r:embed="rId1"/>
+          <a:blip r:embed="rId5"/>
           <a:stretch>
             <a:fillRect/>
           </a:stretch>
         </p:blipFill>
         <p:spPr>
           <a:xfrm>
-            <a:off x="1540995" y="2286000"/>
-            <a:ext cx="9079529" cy="2148840"/>
+            <a:off x="320040" y="2834640"/>
+            <a:ext cx="5623560" cy="2705090"/>
           </a:xfrm>
           <a:prstGeom prst="rect">
             <a:avLst/>
           </a:prstGeom>
         </p:spPr>
       </p:pic>
+      <p:sp>
+        <p:nvSpPr>
+          <p:cNvPr id="6" name="TextBox 5"/>
+          <p:cNvSpPr txBox="1"/>
+          <p:nvPr/>
+        </p:nvSpPr>
+        <p:spPr>
+          <a:xfrm>
+            <a:off x="320040" y="5569730"/>
+            <a:ext cx="5623560" cy="274320"/>
+          </a:xfrm>
+          <a:prstGeom prst="rect">
+            <a:avLst/>
+          </a:prstGeom>
+          <a:noFill/>
+        </p:spPr>
+        <p:txBody>
+          <a:bodyPr wrap="square">
+            <a:spAutoFit/>
+          </a:bodyPr>
+          <a:lstStyle/>
+          <a:p>
+            <a:pPr algn="ctr"/>
+            <a:r>
+              <a:rPr sz="1200" i="1">
+                <a:solidFill>
+                  <a:srgbClr val="666666"/>
+                </a:solidFill>
+                <a:latin typeface="Arial"/>
+              </a:rPr>
+              <a:t>Z7 PCS1 (S1 face) — peak zoom; the faint displaced bundle is clearly visible</a:t>
+            </a:r>
+          </a:p>
+        </p:txBody>
+      </p:sp>
       <p:pic>
         <p:nvPicPr>
-          <p:cNvPr id="6" name="Picture 5" descr="aligned_overlay_zip7_PCS1.png"/>
+          <p:cNvPr id="7" name="Picture 6" descr="aligned_zoom_zip7_PBS2.png"/>
           <p:cNvPicPr>
             <a:picLocks noChangeAspect="1"/>
           </p:cNvPicPr>
           <p:nvPr/>
         </p:nvPicPr>
         <p:blipFill>
-          <a:blip r:embed="rId2"/>
+          <a:blip r:embed="rId6"/>
           <a:stretch>
             <a:fillRect/>
           </a:stretch>
         </p:blipFill>
         <p:spPr>
           <a:xfrm>
-            <a:off x="1637586" y="4526280"/>
-            <a:ext cx="8886347" cy="2103120"/>
+            <a:off x="6263640" y="2834640"/>
+            <a:ext cx="5623560" cy="2705090"/>
           </a:xfrm>
           <a:prstGeom prst="rect">
             <a:avLst/>
@@ -6869,14 +6898,14 @@
       </p:pic>
       <p:sp>
         <p:nvSpPr>
-          <p:cNvPr id="7" name="TextBox 6"/>
+          <p:cNvPr id="8" name="TextBox 7"/>
           <p:cNvSpPr txBox="1"/>
           <p:nvPr/>
         </p:nvSpPr>
         <p:spPr>
           <a:xfrm>
-            <a:off x="822960" y="6659400"/>
-            <a:ext cx="10515600" cy="274320"/>
+            <a:off x="6263640" y="5569730"/>
+            <a:ext cx="5623560" cy="274320"/>
           </a:xfrm>
           <a:prstGeom prst="rect">
             <a:avLst/>
@@ -6891,20 +6920,14 @@
           <a:p>
             <a:pPr algn="ctr"/>
             <a:r>
-              <a:rPr sz="1100" i="1">
+              <a:rPr sz="1200" i="1">
                 <a:solidFill>
                   <a:srgbClr val="666666"/>
                 </a:solidFill>
-                <a:latin typeface="Arial" panose="020B0604020202090204"/>
+                <a:latin typeface="Arial"/>
               </a:rPr>
-              <a:t>Z7 PBS1 (top) and PCS1 (bottom). Note the faint displaced bundle in the PCS1 zoom — more on it later</a:t>
-            </a:r>
-            <a:endParaRPr sz="1100" i="1">
-              <a:solidFill>
-                <a:srgbClr val="666666"/>
-              </a:solidFill>
-              <a:latin typeface="Arial" panose="020B0604020202090204"/>
-            </a:endParaRPr>
+              <a:t>Z7 PBS2 (S2 face) — same faint displaced bundle</a:t>
+            </a:r>
           </a:p>
         </p:txBody>
       </p:sp>

</xml_diff>

<commit_message>
snolab: presentation — restructure slides 8-10 in investigation order (post-cut fan tails -> slow-fall sampling = PDS2 artifact, no fall cut -> shadow slow-rise = real pulses -> t_rise ceiling vs drift); new labeled slow_fall crop; script rewritten to match
Co-Authored-By: Claude Opus 4.8 <noreply@anthropic.com>
</commit_message>
<xml_diff>
--- a/snolab/presentation/SNOLAB_R4_pulse_templates_20260715.pptx
+++ b/snolab/presentation/SNOLAB_R4_pulse_templates_20260715.pptx
@@ -1,28 +1,25 @@
 
 <file path=ppt/presentation.xml><?xml version="1.0" encoding="utf-8"?>
-<p:presentation xmlns:a="http://schemas.openxmlformats.org/drawingml/2006/main" xmlns:r="http://schemas.openxmlformats.org/officeDocument/2006/relationships" xmlns:p="http://schemas.openxmlformats.org/presentationml/2006/main" autoCompressPictures="0">
+<p:presentation xmlns:a="http://schemas.openxmlformats.org/drawingml/2006/main" xmlns:r="http://schemas.openxmlformats.org/officeDocument/2006/relationships" xmlns:p="http://schemas.openxmlformats.org/presentationml/2006/main" saveSubsetFonts="1" autoCompressPictures="0">
   <p:sldMasterIdLst>
     <p:sldMasterId id="2147483648" r:id="rId1"/>
   </p:sldMasterIdLst>
-  <p:notesMasterIdLst>
-    <p:notesMasterId r:id="rId4"/>
-  </p:notesMasterIdLst>
   <p:sldIdLst>
-    <p:sldId id="256" r:id="rId3"/>
-    <p:sldId id="257" r:id="rId5"/>
-    <p:sldId id="258" r:id="rId6"/>
-    <p:sldId id="259" r:id="rId7"/>
-    <p:sldId id="260" r:id="rId8"/>
-    <p:sldId id="261" r:id="rId9"/>
-    <p:sldId id="262" r:id="rId10"/>
-    <p:sldId id="263" r:id="rId11"/>
-    <p:sldId id="264" r:id="rId12"/>
-    <p:sldId id="265" r:id="rId13"/>
-    <p:sldId id="266" r:id="rId14"/>
-    <p:sldId id="267" r:id="rId15"/>
-    <p:sldId id="268" r:id="rId16"/>
+    <p:sldId id="256" r:id="rId7"/>
+    <p:sldId id="257" r:id="rId9"/>
+    <p:sldId id="258" r:id="rId10"/>
+    <p:sldId id="259" r:id="rId11"/>
+    <p:sldId id="260" r:id="rId12"/>
+    <p:sldId id="261" r:id="rId13"/>
+    <p:sldId id="262" r:id="rId14"/>
+    <p:sldId id="263" r:id="rId15"/>
+    <p:sldId id="264" r:id="rId16"/>
+    <p:sldId id="265" r:id="rId17"/>
+    <p:sldId id="266" r:id="rId18"/>
+    <p:sldId id="267" r:id="rId19"/>
+    <p:sldId id="268" r:id="rId20"/>
   </p:sldIdLst>
-  <p:sldSz cx="12191365" cy="6858000" type="screen4x3"/>
+  <p:sldSz cx="12191695" cy="6858000" type="screen4x3"/>
   <p:notesSz cx="6858000" cy="9144000"/>
   <p:defaultTextStyle>
     <a:defPPr>
@@ -119,27 +116,11 @@
       </a:defRPr>
     </a:lvl9pPr>
   </p:defaultTextStyle>
-  <p:extLst>
-    <p:ext uri="{EFAFB233-063F-42B5-8137-9DF3F51BA10A}">
-      <p15:sldGuideLst xmlns:p15="http://schemas.microsoft.com/office/powerpoint/2012/main">
-        <p15:guide id="1" orient="horz" pos="2160" userDrawn="1">
-          <p15:clr>
-            <a:srgbClr val="A4A3A4"/>
-          </p15:clr>
-        </p15:guide>
-        <p15:guide id="2" pos="2880" userDrawn="1">
-          <p15:clr>
-            <a:srgbClr val="A4A3A4"/>
-          </p15:clr>
-        </p15:guide>
-      </p15:sldGuideLst>
-    </p:ext>
-  </p:extLst>
 </p:presentation>
 </file>
 
 <file path=ppt/notesMasters/notesMaster1.xml><?xml version="1.0" encoding="utf-8"?>
-<p:notesMaster xmlns:a="http://schemas.openxmlformats.org/drawingml/2006/main" xmlns:r="http://schemas.openxmlformats.org/officeDocument/2006/relationships" xmlns:p="http://schemas.openxmlformats.org/presentationml/2006/main">
+<p:notesMaster xmlns:a="http://schemas.openxmlformats.org/drawingml/2006/main" xmlns:p="http://schemas.openxmlformats.org/presentationml/2006/main" xmlns:r="http://schemas.openxmlformats.org/officeDocument/2006/relationships">
   <p:cSld>
     <p:bg>
       <p:bgRef idx="1001">
@@ -220,6 +201,7 @@
           <a:p>
             <a:fld id="{0F89C1C7-3DCD-1040-A9CF-14679D8B5DDD}" type="datetimeFigureOut">
               <a:rPr lang="en-US" smtClean="0"/>
+              <a:t>10/17/16</a:t>
             </a:fld>
             <a:endParaRPr lang="en-US"/>
           </a:p>
@@ -286,7 +268,6 @@
               <a:rPr lang="en-US" smtClean="0"/>
               <a:t>Click to edit Master text styles</a:t>
             </a:r>
-            <a:endParaRPr lang="en-US" smtClean="0"/>
           </a:p>
           <a:p>
             <a:pPr lvl="1"/>
@@ -294,7 +275,6 @@
               <a:rPr lang="en-US" smtClean="0"/>
               <a:t>Second level</a:t>
             </a:r>
-            <a:endParaRPr lang="en-US" smtClean="0"/>
           </a:p>
           <a:p>
             <a:pPr lvl="2"/>
@@ -302,7 +282,6 @@
               <a:rPr lang="en-US" smtClean="0"/>
               <a:t>Third level</a:t>
             </a:r>
-            <a:endParaRPr lang="en-US" smtClean="0"/>
           </a:p>
           <a:p>
             <a:pPr lvl="3"/>
@@ -310,7 +289,6 @@
               <a:rPr lang="en-US" smtClean="0"/>
               <a:t>Fourth level</a:t>
             </a:r>
-            <a:endParaRPr lang="en-US" smtClean="0"/>
           </a:p>
           <a:p>
             <a:pPr lvl="4"/>
@@ -382,12 +360,18 @@
           <a:p>
             <a:fld id="{BB5E49A5-4136-284D-997B-48E1D791AD67}" type="slidenum">
               <a:rPr lang="en-US" smtClean="0"/>
+              <a:t>‹#›</a:t>
             </a:fld>
             <a:endParaRPr lang="en-US"/>
           </a:p>
         </p:txBody>
       </p:sp>
     </p:spTree>
+    <p:extLst>
+      <p:ext uri="{BB962C8B-B14F-4D97-AF65-F5344CB8AC3E}">
+        <p14:creationId xmlns:p14="http://schemas.microsoft.com/office/powerpoint/2010/main" val="2623252185"/>
+      </p:ext>
+    </p:extLst>
   </p:cSld>
   <p:clrMap bg1="lt1" tx1="dk1" bg2="lt2" tx2="dk2" accent1="accent1" accent2="accent2" accent3="accent3" accent4="accent4" accent5="accent5" accent6="accent6" hlink="hlink" folHlink="folHlink"/>
   <p:notesStyle>
@@ -486,7 +470,7 @@
 </file>
 
 <file path=ppt/notesSlides/notesSlide1.xml><?xml version="1.0" encoding="utf-8"?>
-<p:notes xmlns:a="http://schemas.openxmlformats.org/drawingml/2006/main" xmlns:r="http://schemas.openxmlformats.org/officeDocument/2006/relationships" xmlns:p="http://schemas.openxmlformats.org/presentationml/2006/main">
+<p:notes xmlns:a="http://schemas.openxmlformats.org/drawingml/2006/main" xmlns:p="http://schemas.openxmlformats.org/presentationml/2006/main" xmlns:r="http://schemas.openxmlformats.org/officeDocument/2006/relationships">
   <p:cSld>
     <p:spTree>
       <p:nvGrpSpPr>
@@ -521,7 +505,7 @@
             <a:spLocks noGrp="1"/>
           </p:cNvSpPr>
           <p:nvPr>
-            <p:ph type="body" sz="quarter" idx="3"/>
+            <p:ph type="body" idx="3" sz="quarter"/>
           </p:nvPr>
         </p:nvSpPr>
         <p:spPr/>
@@ -542,7 +526,7 @@
             <a:spLocks noGrp="1"/>
           </p:cNvSpPr>
           <p:nvPr>
-            <p:ph type="sldNum" sz="quarter" idx="5"/>
+            <p:ph type="sldNum" idx="5" sz="quarter"/>
           </p:nvPr>
         </p:nvSpPr>
         <p:spPr/>
@@ -556,7 +540,7 @@
 </file>
 
 <file path=ppt/notesSlides/notesSlide10.xml><?xml version="1.0" encoding="utf-8"?>
-<p:notes xmlns:a="http://schemas.openxmlformats.org/drawingml/2006/main" xmlns:r="http://schemas.openxmlformats.org/officeDocument/2006/relationships" xmlns:p="http://schemas.openxmlformats.org/presentationml/2006/main">
+<p:notes xmlns:a="http://schemas.openxmlformats.org/drawingml/2006/main" xmlns:p="http://schemas.openxmlformats.org/presentationml/2006/main" xmlns:r="http://schemas.openxmlformats.org/officeDocument/2006/relationships">
   <p:cSld>
     <p:spTree>
       <p:nvGrpSpPr>
@@ -591,7 +575,7 @@
             <a:spLocks noGrp="1"/>
           </p:cNvSpPr>
           <p:nvPr>
-            <p:ph type="body" sz="quarter" idx="3"/>
+            <p:ph type="body" idx="3" sz="quarter"/>
           </p:nvPr>
         </p:nvSpPr>
         <p:spPr/>
@@ -600,7 +584,7 @@
           <a:lstStyle/>
           <a:p>
             <a:r>
-              <a:t>One more diagnostic worth showing. On Z7, channel PDS2 has a much broader fall-time distribution than every other channel. Drawing the same events across all channels shows they are perfectly normal fast pulses in the other eleven - so the long fall is a PDS2-only low-frequency disturbance, not slow physics, and it does not contaminate the shape conclusions.</a:t>
+              <a:t>But on the slow-rise side there is also a troublemaker: on detectors with a noisy window, a slow baseline drift also fits as a slow rise, with a tiny residual - NRMSE cannot catch it. The real pulses cluster near zero point one milliseconds while the drift tail stretches much further, so for the template input we set a ceiling at zero point three milliseconds. That blocks the drift and keeps the vast majority of real pulses - including part of the shadow population; the price is that the very slowest genuine pulses get trimmed too. That trade-off is documented and not final - I would like your input on it later.</a:t>
             </a:r>
           </a:p>
         </p:txBody>
@@ -612,7 +596,7 @@
             <a:spLocks noGrp="1"/>
           </p:cNvSpPr>
           <p:nvPr>
-            <p:ph type="sldNum" sz="quarter" idx="5"/>
+            <p:ph type="sldNum" idx="5" sz="quarter"/>
           </p:nvPr>
         </p:nvSpPr>
         <p:spPr/>
@@ -626,7 +610,7 @@
 </file>
 
 <file path=ppt/notesSlides/notesSlide11.xml><?xml version="1.0" encoding="utf-8"?>
-<p:notes xmlns:a="http://schemas.openxmlformats.org/drawingml/2006/main" xmlns:r="http://schemas.openxmlformats.org/officeDocument/2006/relationships" xmlns:p="http://schemas.openxmlformats.org/presentationml/2006/main">
+<p:notes xmlns:a="http://schemas.openxmlformats.org/drawingml/2006/main" xmlns:p="http://schemas.openxmlformats.org/presentationml/2006/main" xmlns:r="http://schemas.openxmlformats.org/officeDocument/2006/relationships">
   <p:cSld>
     <p:spTree>
       <p:nvGrpSpPr>
@@ -661,7 +645,7 @@
             <a:spLocks noGrp="1"/>
           </p:cNvSpPr>
           <p:nvPr>
-            <p:ph type="body" sz="quarter" idx="3"/>
+            <p:ph type="body" idx="3" sz="quarter"/>
           </p:nvPr>
         </p:nvSpPr>
         <p:spPr/>
@@ -682,7 +666,7 @@
             <a:spLocks noGrp="1"/>
           </p:cNvSpPr>
           <p:nvPr>
-            <p:ph type="sldNum" sz="quarter" idx="5"/>
+            <p:ph type="sldNum" idx="5" sz="quarter"/>
           </p:nvPr>
         </p:nvSpPr>
         <p:spPr/>
@@ -696,7 +680,7 @@
 </file>
 
 <file path=ppt/notesSlides/notesSlide12.xml><?xml version="1.0" encoding="utf-8"?>
-<p:notes xmlns:a="http://schemas.openxmlformats.org/drawingml/2006/main" xmlns:r="http://schemas.openxmlformats.org/officeDocument/2006/relationships" xmlns:p="http://schemas.openxmlformats.org/presentationml/2006/main">
+<p:notes xmlns:a="http://schemas.openxmlformats.org/drawingml/2006/main" xmlns:p="http://schemas.openxmlformats.org/presentationml/2006/main" xmlns:r="http://schemas.openxmlformats.org/officeDocument/2006/relationships">
   <p:cSld>
     <p:spTree>
       <p:nvGrpSpPr>
@@ -731,7 +715,7 @@
             <a:spLocks noGrp="1"/>
           </p:cNvSpPr>
           <p:nvPr>
-            <p:ph type="body" sz="quarter" idx="3"/>
+            <p:ph type="body" idx="3" sz="quarter"/>
           </p:nvPr>
         </p:nvSpPr>
         <p:spPr/>
@@ -752,7 +736,7 @@
             <a:spLocks noGrp="1"/>
           </p:cNvSpPr>
           <p:nvPr>
-            <p:ph type="sldNum" sz="quarter" idx="5"/>
+            <p:ph type="sldNum" idx="5" sz="quarter"/>
           </p:nvPr>
         </p:nvSpPr>
         <p:spPr/>
@@ -766,7 +750,7 @@
 </file>
 
 <file path=ppt/notesSlides/notesSlide13.xml><?xml version="1.0" encoding="utf-8"?>
-<p:notes xmlns:a="http://schemas.openxmlformats.org/drawingml/2006/main" xmlns:r="http://schemas.openxmlformats.org/officeDocument/2006/relationships" xmlns:p="http://schemas.openxmlformats.org/presentationml/2006/main">
+<p:notes xmlns:a="http://schemas.openxmlformats.org/drawingml/2006/main" xmlns:p="http://schemas.openxmlformats.org/presentationml/2006/main" xmlns:r="http://schemas.openxmlformats.org/officeDocument/2006/relationships">
   <p:cSld>
     <p:spTree>
       <p:nvGrpSpPr>
@@ -801,7 +785,7 @@
             <a:spLocks noGrp="1"/>
           </p:cNvSpPr>
           <p:nvPr>
-            <p:ph type="body" sz="quarter" idx="3"/>
+            <p:ph type="body" idx="3" sz="quarter"/>
           </p:nvPr>
         </p:nvSpPr>
         <p:spPr/>
@@ -822,7 +806,7 @@
             <a:spLocks noGrp="1"/>
           </p:cNvSpPr>
           <p:nvPr>
-            <p:ph type="sldNum" sz="quarter" idx="5"/>
+            <p:ph type="sldNum" idx="5" sz="quarter"/>
           </p:nvPr>
         </p:nvSpPr>
         <p:spPr/>
@@ -836,7 +820,7 @@
 </file>
 
 <file path=ppt/notesSlides/notesSlide2.xml><?xml version="1.0" encoding="utf-8"?>
-<p:notes xmlns:a="http://schemas.openxmlformats.org/drawingml/2006/main" xmlns:r="http://schemas.openxmlformats.org/officeDocument/2006/relationships" xmlns:p="http://schemas.openxmlformats.org/presentationml/2006/main">
+<p:notes xmlns:a="http://schemas.openxmlformats.org/drawingml/2006/main" xmlns:p="http://schemas.openxmlformats.org/presentationml/2006/main" xmlns:r="http://schemas.openxmlformats.org/officeDocument/2006/relationships">
   <p:cSld>
     <p:spTree>
       <p:nvGrpSpPr>
@@ -871,7 +855,7 @@
             <a:spLocks noGrp="1"/>
           </p:cNvSpPr>
           <p:nvPr>
-            <p:ph type="body" sz="quarter" idx="3"/>
+            <p:ph type="body" idx="3" sz="quarter"/>
           </p:nvPr>
         </p:nvSpPr>
         <p:spPr/>
@@ -892,7 +876,7 @@
             <a:spLocks noGrp="1"/>
           </p:cNvSpPr>
           <p:nvPr>
-            <p:ph type="sldNum" sz="quarter" idx="5"/>
+            <p:ph type="sldNum" idx="5" sz="quarter"/>
           </p:nvPr>
         </p:nvSpPr>
         <p:spPr/>
@@ -906,7 +890,7 @@
 </file>
 
 <file path=ppt/notesSlides/notesSlide3.xml><?xml version="1.0" encoding="utf-8"?>
-<p:notes xmlns:a="http://schemas.openxmlformats.org/drawingml/2006/main" xmlns:r="http://schemas.openxmlformats.org/officeDocument/2006/relationships" xmlns:p="http://schemas.openxmlformats.org/presentationml/2006/main">
+<p:notes xmlns:a="http://schemas.openxmlformats.org/drawingml/2006/main" xmlns:p="http://schemas.openxmlformats.org/presentationml/2006/main" xmlns:r="http://schemas.openxmlformats.org/officeDocument/2006/relationships">
   <p:cSld>
     <p:spTree>
       <p:nvGrpSpPr>
@@ -941,7 +925,7 @@
             <a:spLocks noGrp="1"/>
           </p:cNvSpPr>
           <p:nvPr>
-            <p:ph type="body" sz="quarter" idx="3"/>
+            <p:ph type="body" idx="3" sz="quarter"/>
           </p:nvPr>
         </p:nvSpPr>
         <p:spPr/>
@@ -962,7 +946,7 @@
             <a:spLocks noGrp="1"/>
           </p:cNvSpPr>
           <p:nvPr>
-            <p:ph type="sldNum" sz="quarter" idx="5"/>
+            <p:ph type="sldNum" idx="5" sz="quarter"/>
           </p:nvPr>
         </p:nvSpPr>
         <p:spPr/>
@@ -976,7 +960,7 @@
 </file>
 
 <file path=ppt/notesSlides/notesSlide4.xml><?xml version="1.0" encoding="utf-8"?>
-<p:notes xmlns:a="http://schemas.openxmlformats.org/drawingml/2006/main" xmlns:r="http://schemas.openxmlformats.org/officeDocument/2006/relationships" xmlns:p="http://schemas.openxmlformats.org/presentationml/2006/main">
+<p:notes xmlns:a="http://schemas.openxmlformats.org/drawingml/2006/main" xmlns:p="http://schemas.openxmlformats.org/presentationml/2006/main" xmlns:r="http://schemas.openxmlformats.org/officeDocument/2006/relationships">
   <p:cSld>
     <p:spTree>
       <p:nvGrpSpPr>
@@ -1011,7 +995,7 @@
             <a:spLocks noGrp="1"/>
           </p:cNvSpPr>
           <p:nvPr>
-            <p:ph type="body" sz="quarter" idx="3"/>
+            <p:ph type="body" idx="3" sz="quarter"/>
           </p:nvPr>
         </p:nvSpPr>
         <p:spPr/>
@@ -1032,7 +1016,7 @@
             <a:spLocks noGrp="1"/>
           </p:cNvSpPr>
           <p:nvPr>
-            <p:ph type="sldNum" sz="quarter" idx="5"/>
+            <p:ph type="sldNum" idx="5" sz="quarter"/>
           </p:nvPr>
         </p:nvSpPr>
         <p:spPr/>
@@ -1046,7 +1030,7 @@
 </file>
 
 <file path=ppt/notesSlides/notesSlide5.xml><?xml version="1.0" encoding="utf-8"?>
-<p:notes xmlns:a="http://schemas.openxmlformats.org/drawingml/2006/main" xmlns:r="http://schemas.openxmlformats.org/officeDocument/2006/relationships" xmlns:p="http://schemas.openxmlformats.org/presentationml/2006/main">
+<p:notes xmlns:a="http://schemas.openxmlformats.org/drawingml/2006/main" xmlns:p="http://schemas.openxmlformats.org/presentationml/2006/main" xmlns:r="http://schemas.openxmlformats.org/officeDocument/2006/relationships">
   <p:cSld>
     <p:spTree>
       <p:nvGrpSpPr>
@@ -1081,7 +1065,7 @@
             <a:spLocks noGrp="1"/>
           </p:cNvSpPr>
           <p:nvPr>
-            <p:ph type="body" sz="quarter" idx="3"/>
+            <p:ph type="body" idx="3" sz="quarter"/>
           </p:nvPr>
         </p:nvSpPr>
         <p:spPr/>
@@ -1102,7 +1086,7 @@
             <a:spLocks noGrp="1"/>
           </p:cNvSpPr>
           <p:nvPr>
-            <p:ph type="sldNum" sz="quarter" idx="5"/>
+            <p:ph type="sldNum" idx="5" sz="quarter"/>
           </p:nvPr>
         </p:nvSpPr>
         <p:spPr/>
@@ -1116,7 +1100,7 @@
 </file>
 
 <file path=ppt/notesSlides/notesSlide6.xml><?xml version="1.0" encoding="utf-8"?>
-<p:notes xmlns:a="http://schemas.openxmlformats.org/drawingml/2006/main" xmlns:r="http://schemas.openxmlformats.org/officeDocument/2006/relationships" xmlns:p="http://schemas.openxmlformats.org/presentationml/2006/main">
+<p:notes xmlns:a="http://schemas.openxmlformats.org/drawingml/2006/main" xmlns:p="http://schemas.openxmlformats.org/presentationml/2006/main" xmlns:r="http://schemas.openxmlformats.org/officeDocument/2006/relationships">
   <p:cSld>
     <p:spTree>
       <p:nvGrpSpPr>
@@ -1151,7 +1135,7 @@
             <a:spLocks noGrp="1"/>
           </p:cNvSpPr>
           <p:nvPr>
-            <p:ph type="body" sz="quarter" idx="3"/>
+            <p:ph type="body" idx="3" sz="quarter"/>
           </p:nvPr>
         </p:nvSpPr>
         <p:spPr/>
@@ -1172,7 +1156,7 @@
             <a:spLocks noGrp="1"/>
           </p:cNvSpPr>
           <p:nvPr>
-            <p:ph type="sldNum" sz="quarter" idx="5"/>
+            <p:ph type="sldNum" idx="5" sz="quarter"/>
           </p:nvPr>
         </p:nvSpPr>
         <p:spPr/>
@@ -1186,7 +1170,7 @@
 </file>
 
 <file path=ppt/notesSlides/notesSlide7.xml><?xml version="1.0" encoding="utf-8"?>
-<p:notes xmlns:a="http://schemas.openxmlformats.org/drawingml/2006/main" xmlns:r="http://schemas.openxmlformats.org/officeDocument/2006/relationships" xmlns:p="http://schemas.openxmlformats.org/presentationml/2006/main">
+<p:notes xmlns:a="http://schemas.openxmlformats.org/drawingml/2006/main" xmlns:p="http://schemas.openxmlformats.org/presentationml/2006/main" xmlns:r="http://schemas.openxmlformats.org/officeDocument/2006/relationships">
   <p:cSld>
     <p:spTree>
       <p:nvGrpSpPr>
@@ -1221,7 +1205,7 @@
             <a:spLocks noGrp="1"/>
           </p:cNvSpPr>
           <p:nvPr>
-            <p:ph type="body" sz="quarter" idx="3"/>
+            <p:ph type="body" idx="3" sz="quarter"/>
           </p:nvPr>
         </p:nvSpPr>
         <p:spPr/>
@@ -1242,7 +1226,7 @@
             <a:spLocks noGrp="1"/>
           </p:cNvSpPr>
           <p:nvPr>
-            <p:ph type="sldNum" sz="quarter" idx="5"/>
+            <p:ph type="sldNum" idx="5" sz="quarter"/>
           </p:nvPr>
         </p:nvSpPr>
         <p:spPr/>
@@ -1256,7 +1240,7 @@
 </file>
 
 <file path=ppt/notesSlides/notesSlide8.xml><?xml version="1.0" encoding="utf-8"?>
-<p:notes xmlns:a="http://schemas.openxmlformats.org/drawingml/2006/main" xmlns:r="http://schemas.openxmlformats.org/officeDocument/2006/relationships" xmlns:p="http://schemas.openxmlformats.org/presentationml/2006/main">
+<p:notes xmlns:a="http://schemas.openxmlformats.org/drawingml/2006/main" xmlns:p="http://schemas.openxmlformats.org/presentationml/2006/main" xmlns:r="http://schemas.openxmlformats.org/officeDocument/2006/relationships">
   <p:cSld>
     <p:spTree>
       <p:nvGrpSpPr>
@@ -1291,7 +1275,7 @@
             <a:spLocks noGrp="1"/>
           </p:cNvSpPr>
           <p:nvPr>
-            <p:ph type="body" sz="quarter" idx="3"/>
+            <p:ph type="body" idx="3" sz="quarter"/>
           </p:nvPr>
         </p:nvSpPr>
         <p:spPr/>
@@ -1300,7 +1284,7 @@
           <a:lstStyle/>
           <a:p>
             <a:r>
-              <a:t>Second cut. On detectors with a noisy window, a smooth slow baseline drift can sneak past the NRMSE cut, because a slow two-exponential can hug it with a tiny residual. But the real pulses have a rise time around 0.1 milliseconds with the 90th percentile at 0.15, far from the drift tail, so a ceiling at 0.3 milliseconds removes the leakage at a signal cost of a few percent. One documented trade-off: the same ceiling also trims a small population of genuine slow pulses - that decision is still open, and here is that population.</a:t>
+              <a:t>The first lead comes from the fan plot after the cut: some curves still fall very slowly. We chased it with the same recipe: among events passing the cut, take fall times above one point five milliseconds, randomly sample ten, and draw raw versus fit in every channel. The result is clean: in the other eleven channels these events are perfectly normal fast pulses - only PDS2, one single channel, is swinging wildly. So it's not the event that's slow, it's that one channel's low-frequency disturbance. Conclusion: no fall cut is needed - artifact, not physics.</a:t>
             </a:r>
           </a:p>
         </p:txBody>
@@ -1312,7 +1296,7 @@
             <a:spLocks noGrp="1"/>
           </p:cNvSpPr>
           <p:nvPr>
-            <p:ph type="sldNum" sz="quarter" idx="5"/>
+            <p:ph type="sldNum" idx="5" sz="quarter"/>
           </p:nvPr>
         </p:nvSpPr>
         <p:spPr/>
@@ -1326,7 +1310,7 @@
 </file>
 
 <file path=ppt/notesSlides/notesSlide9.xml><?xml version="1.0" encoding="utf-8"?>
-<p:notes xmlns:a="http://schemas.openxmlformats.org/drawingml/2006/main" xmlns:r="http://schemas.openxmlformats.org/officeDocument/2006/relationships" xmlns:p="http://schemas.openxmlformats.org/presentationml/2006/main">
+<p:notes xmlns:a="http://schemas.openxmlformats.org/drawingml/2006/main" xmlns:p="http://schemas.openxmlformats.org/presentationml/2006/main" xmlns:r="http://schemas.openxmlformats.org/officeDocument/2006/relationships">
   <p:cSld>
     <p:spTree>
       <p:nvGrpSpPr>
@@ -1361,7 +1345,7 @@
             <a:spLocks noGrp="1"/>
           </p:cNvSpPr>
           <p:nvPr>
-            <p:ph type="body" sz="quarter" idx="3"/>
+            <p:ph type="body" idx="3" sz="quarter"/>
           </p:nvPr>
         </p:nvSpPr>
         <p:spPr/>
@@ -1370,7 +1354,7 @@
           <a:lstStyle/>
           <a:p>
             <a:r>
-              <a:t>Here is that slow population on Z7. These events pass the NRMSE cut - they are well fit - but their rise time is above 0.2 milliseconds. In the raw traces they are clearly real pulses, not noise. They are exactly the faint displaced bundle we saw in the aligned overlay earlier. This is genuine pulse-shape variation, possibly a surface or bulk effect - and it is precisely what a multi-template NxM optimal filter is meant to capture, which motivates the second template family.</a:t>
+              <a:t>The second lead is the slow rise. Same recipe: take events that fit well - NRMSE fine - but whose median rise time is above zero point two milliseconds, sample them, look at the raw traces. This time the conclusion is the opposite: these are real pulses. Onset aligned, peak arriving late, consistent across all channels - they are exactly the shadow from the alignment plot. So the slow rise cannot simply be cut away: there is real physics in it, possibly related to where in the crystal the event happens; that is not settled yet.</a:t>
             </a:r>
           </a:p>
         </p:txBody>
@@ -1382,7 +1366,7 @@
             <a:spLocks noGrp="1"/>
           </p:cNvSpPr>
           <p:nvPr>
-            <p:ph type="sldNum" sz="quarter" idx="5"/>
+            <p:ph type="sldNum" idx="5" sz="quarter"/>
           </p:nvPr>
         </p:nvSpPr>
         <p:spPr/>
@@ -1576,6 +1560,7 @@
           <a:p>
             <a:fld id="{5BCAD085-E8A6-8845-BD4E-CB4CCA059FC4}" type="datetimeFigureOut">
               <a:rPr lang="en-US" smtClean="0"/>
+              <a:t>1/27/13</a:t>
             </a:fld>
             <a:endParaRPr lang="en-US"/>
           </a:p>
@@ -1617,12 +1602,18 @@
           <a:p>
             <a:fld id="{C1FF6DA9-008F-8B48-92A6-B652298478BF}" type="slidenum">
               <a:rPr lang="en-US" smtClean="0"/>
+              <a:t>‹#›</a:t>
             </a:fld>
             <a:endParaRPr lang="en-US"/>
           </a:p>
         </p:txBody>
       </p:sp>
     </p:spTree>
+    <p:extLst>
+      <p:ext uri="{BB962C8B-B14F-4D97-AF65-F5344CB8AC3E}">
+        <p14:creationId xmlns:p14="http://schemas.microsoft.com/office/powerpoint/2010/main" val="3168075583"/>
+      </p:ext>
+    </p:extLst>
   </p:cSld>
   <p:clrMapOvr>
     <a:masterClrMapping/>
@@ -1690,7 +1681,6 @@
               <a:rPr lang="en-US" smtClean="0"/>
               <a:t>Click to edit Master text styles</a:t>
             </a:r>
-            <a:endParaRPr lang="en-US" smtClean="0"/>
           </a:p>
           <a:p>
             <a:pPr lvl="1"/>
@@ -1698,7 +1688,6 @@
               <a:rPr lang="en-US" smtClean="0"/>
               <a:t>Second level</a:t>
             </a:r>
-            <a:endParaRPr lang="en-US" smtClean="0"/>
           </a:p>
           <a:p>
             <a:pPr lvl="2"/>
@@ -1706,7 +1695,6 @@
               <a:rPr lang="en-US" smtClean="0"/>
               <a:t>Third level</a:t>
             </a:r>
-            <a:endParaRPr lang="en-US" smtClean="0"/>
           </a:p>
           <a:p>
             <a:pPr lvl="3"/>
@@ -1714,7 +1702,6 @@
               <a:rPr lang="en-US" smtClean="0"/>
               <a:t>Fourth level</a:t>
             </a:r>
-            <a:endParaRPr lang="en-US" smtClean="0"/>
           </a:p>
           <a:p>
             <a:pPr lvl="4"/>
@@ -1743,6 +1730,7 @@
           <a:p>
             <a:fld id="{5BCAD085-E8A6-8845-BD4E-CB4CCA059FC4}" type="datetimeFigureOut">
               <a:rPr lang="en-US" smtClean="0"/>
+              <a:t>1/27/13</a:t>
             </a:fld>
             <a:endParaRPr lang="en-US"/>
           </a:p>
@@ -1784,12 +1772,18 @@
           <a:p>
             <a:fld id="{C1FF6DA9-008F-8B48-92A6-B652298478BF}" type="slidenum">
               <a:rPr lang="en-US" smtClean="0"/>
+              <a:t>‹#›</a:t>
             </a:fld>
             <a:endParaRPr lang="en-US"/>
           </a:p>
         </p:txBody>
       </p:sp>
     </p:spTree>
+    <p:extLst>
+      <p:ext uri="{BB962C8B-B14F-4D97-AF65-F5344CB8AC3E}">
+        <p14:creationId xmlns:p14="http://schemas.microsoft.com/office/powerpoint/2010/main" val="2910927964"/>
+      </p:ext>
+    </p:extLst>
   </p:cSld>
   <p:clrMapOvr>
     <a:masterClrMapping/>
@@ -1867,7 +1861,6 @@
               <a:rPr lang="en-US" smtClean="0"/>
               <a:t>Click to edit Master text styles</a:t>
             </a:r>
-            <a:endParaRPr lang="en-US" smtClean="0"/>
           </a:p>
           <a:p>
             <a:pPr lvl="1"/>
@@ -1875,7 +1868,6 @@
               <a:rPr lang="en-US" smtClean="0"/>
               <a:t>Second level</a:t>
             </a:r>
-            <a:endParaRPr lang="en-US" smtClean="0"/>
           </a:p>
           <a:p>
             <a:pPr lvl="2"/>
@@ -1883,7 +1875,6 @@
               <a:rPr lang="en-US" smtClean="0"/>
               <a:t>Third level</a:t>
             </a:r>
-            <a:endParaRPr lang="en-US" smtClean="0"/>
           </a:p>
           <a:p>
             <a:pPr lvl="3"/>
@@ -1891,7 +1882,6 @@
               <a:rPr lang="en-US" smtClean="0"/>
               <a:t>Fourth level</a:t>
             </a:r>
-            <a:endParaRPr lang="en-US" smtClean="0"/>
           </a:p>
           <a:p>
             <a:pPr lvl="4"/>
@@ -1920,6 +1910,7 @@
           <a:p>
             <a:fld id="{5BCAD085-E8A6-8845-BD4E-CB4CCA059FC4}" type="datetimeFigureOut">
               <a:rPr lang="en-US" smtClean="0"/>
+              <a:t>1/27/13</a:t>
             </a:fld>
             <a:endParaRPr lang="en-US"/>
           </a:p>
@@ -1961,12 +1952,18 @@
           <a:p>
             <a:fld id="{C1FF6DA9-008F-8B48-92A6-B652298478BF}" type="slidenum">
               <a:rPr lang="en-US" smtClean="0"/>
+              <a:t>‹#›</a:t>
             </a:fld>
             <a:endParaRPr lang="en-US"/>
           </a:p>
         </p:txBody>
       </p:sp>
     </p:spTree>
+    <p:extLst>
+      <p:ext uri="{BB962C8B-B14F-4D97-AF65-F5344CB8AC3E}">
+        <p14:creationId xmlns:p14="http://schemas.microsoft.com/office/powerpoint/2010/main" val="3612223792"/>
+      </p:ext>
+    </p:extLst>
   </p:cSld>
   <p:clrMapOvr>
     <a:masterClrMapping/>
@@ -2034,7 +2031,6 @@
               <a:rPr lang="en-US" smtClean="0"/>
               <a:t>Click to edit Master text styles</a:t>
             </a:r>
-            <a:endParaRPr lang="en-US" smtClean="0"/>
           </a:p>
           <a:p>
             <a:pPr lvl="1"/>
@@ -2042,7 +2038,6 @@
               <a:rPr lang="en-US" smtClean="0"/>
               <a:t>Second level</a:t>
             </a:r>
-            <a:endParaRPr lang="en-US" smtClean="0"/>
           </a:p>
           <a:p>
             <a:pPr lvl="2"/>
@@ -2050,7 +2045,6 @@
               <a:rPr lang="en-US" smtClean="0"/>
               <a:t>Third level</a:t>
             </a:r>
-            <a:endParaRPr lang="en-US" smtClean="0"/>
           </a:p>
           <a:p>
             <a:pPr lvl="3"/>
@@ -2058,7 +2052,6 @@
               <a:rPr lang="en-US" smtClean="0"/>
               <a:t>Fourth level</a:t>
             </a:r>
-            <a:endParaRPr lang="en-US" smtClean="0"/>
           </a:p>
           <a:p>
             <a:pPr lvl="4"/>
@@ -2087,6 +2080,7 @@
           <a:p>
             <a:fld id="{5BCAD085-E8A6-8845-BD4E-CB4CCA059FC4}" type="datetimeFigureOut">
               <a:rPr lang="en-US" smtClean="0"/>
+              <a:t>1/27/13</a:t>
             </a:fld>
             <a:endParaRPr lang="en-US"/>
           </a:p>
@@ -2128,12 +2122,18 @@
           <a:p>
             <a:fld id="{C1FF6DA9-008F-8B48-92A6-B652298478BF}" type="slidenum">
               <a:rPr lang="en-US" smtClean="0"/>
+              <a:t>‹#›</a:t>
             </a:fld>
             <a:endParaRPr lang="en-US"/>
           </a:p>
         </p:txBody>
       </p:sp>
     </p:spTree>
+    <p:extLst>
+      <p:ext uri="{BB962C8B-B14F-4D97-AF65-F5344CB8AC3E}">
+        <p14:creationId xmlns:p14="http://schemas.microsoft.com/office/powerpoint/2010/main" val="2614314258"/>
+      </p:ext>
+    </p:extLst>
   </p:cSld>
   <p:clrMapOvr>
     <a:masterClrMapping/>
@@ -2306,7 +2306,6 @@
               <a:rPr lang="en-US" smtClean="0"/>
               <a:t>Click to edit Master text styles</a:t>
             </a:r>
-            <a:endParaRPr lang="en-US" smtClean="0"/>
           </a:p>
         </p:txBody>
       </p:sp>
@@ -2327,6 +2326,7 @@
           <a:p>
             <a:fld id="{5BCAD085-E8A6-8845-BD4E-CB4CCA059FC4}" type="datetimeFigureOut">
               <a:rPr lang="en-US" smtClean="0"/>
+              <a:t>1/27/13</a:t>
             </a:fld>
             <a:endParaRPr lang="en-US"/>
           </a:p>
@@ -2368,12 +2368,18 @@
           <a:p>
             <a:fld id="{C1FF6DA9-008F-8B48-92A6-B652298478BF}" type="slidenum">
               <a:rPr lang="en-US" smtClean="0"/>
+              <a:t>‹#›</a:t>
             </a:fld>
             <a:endParaRPr lang="en-US"/>
           </a:p>
         </p:txBody>
       </p:sp>
     </p:spTree>
+    <p:extLst>
+      <p:ext uri="{BB962C8B-B14F-4D97-AF65-F5344CB8AC3E}">
+        <p14:creationId xmlns:p14="http://schemas.microsoft.com/office/powerpoint/2010/main" val="960648375"/>
+      </p:ext>
+    </p:extLst>
   </p:cSld>
   <p:clrMapOvr>
     <a:masterClrMapping/>
@@ -2474,7 +2480,6 @@
               <a:rPr lang="en-US" smtClean="0"/>
               <a:t>Click to edit Master text styles</a:t>
             </a:r>
-            <a:endParaRPr lang="en-US" smtClean="0"/>
           </a:p>
           <a:p>
             <a:pPr lvl="1"/>
@@ -2482,7 +2487,6 @@
               <a:rPr lang="en-US" smtClean="0"/>
               <a:t>Second level</a:t>
             </a:r>
-            <a:endParaRPr lang="en-US" smtClean="0"/>
           </a:p>
           <a:p>
             <a:pPr lvl="2"/>
@@ -2490,7 +2494,6 @@
               <a:rPr lang="en-US" smtClean="0"/>
               <a:t>Third level</a:t>
             </a:r>
-            <a:endParaRPr lang="en-US" smtClean="0"/>
           </a:p>
           <a:p>
             <a:pPr lvl="3"/>
@@ -2498,7 +2501,6 @@
               <a:rPr lang="en-US" smtClean="0"/>
               <a:t>Fourth level</a:t>
             </a:r>
-            <a:endParaRPr lang="en-US" smtClean="0"/>
           </a:p>
           <a:p>
             <a:pPr lvl="4"/>
@@ -2563,7 +2565,6 @@
               <a:rPr lang="en-US" smtClean="0"/>
               <a:t>Click to edit Master text styles</a:t>
             </a:r>
-            <a:endParaRPr lang="en-US" smtClean="0"/>
           </a:p>
           <a:p>
             <a:pPr lvl="1"/>
@@ -2571,7 +2572,6 @@
               <a:rPr lang="en-US" smtClean="0"/>
               <a:t>Second level</a:t>
             </a:r>
-            <a:endParaRPr lang="en-US" smtClean="0"/>
           </a:p>
           <a:p>
             <a:pPr lvl="2"/>
@@ -2579,7 +2579,6 @@
               <a:rPr lang="en-US" smtClean="0"/>
               <a:t>Third level</a:t>
             </a:r>
-            <a:endParaRPr lang="en-US" smtClean="0"/>
           </a:p>
           <a:p>
             <a:pPr lvl="3"/>
@@ -2587,7 +2586,6 @@
               <a:rPr lang="en-US" smtClean="0"/>
               <a:t>Fourth level</a:t>
             </a:r>
-            <a:endParaRPr lang="en-US" smtClean="0"/>
           </a:p>
           <a:p>
             <a:pPr lvl="4"/>
@@ -2616,6 +2614,7 @@
           <a:p>
             <a:fld id="{5BCAD085-E8A6-8845-BD4E-CB4CCA059FC4}" type="datetimeFigureOut">
               <a:rPr lang="en-US" smtClean="0"/>
+              <a:t>1/27/13</a:t>
             </a:fld>
             <a:endParaRPr lang="en-US"/>
           </a:p>
@@ -2657,12 +2656,18 @@
           <a:p>
             <a:fld id="{C1FF6DA9-008F-8B48-92A6-B652298478BF}" type="slidenum">
               <a:rPr lang="en-US" smtClean="0"/>
+              <a:t>‹#›</a:t>
             </a:fld>
             <a:endParaRPr lang="en-US"/>
           </a:p>
         </p:txBody>
       </p:sp>
     </p:spTree>
+    <p:extLst>
+      <p:ext uri="{BB962C8B-B14F-4D97-AF65-F5344CB8AC3E}">
+        <p14:creationId xmlns:p14="http://schemas.microsoft.com/office/powerpoint/2010/main" val="2782244947"/>
+      </p:ext>
+    </p:extLst>
   </p:cSld>
   <p:clrMapOvr>
     <a:masterClrMapping/>
@@ -2776,7 +2781,6 @@
               <a:rPr lang="en-US" smtClean="0"/>
               <a:t>Click to edit Master text styles</a:t>
             </a:r>
-            <a:endParaRPr lang="en-US" smtClean="0"/>
           </a:p>
         </p:txBody>
       </p:sp>
@@ -2833,7 +2837,6 @@
               <a:rPr lang="en-US" smtClean="0"/>
               <a:t>Click to edit Master text styles</a:t>
             </a:r>
-            <a:endParaRPr lang="en-US" smtClean="0"/>
           </a:p>
           <a:p>
             <a:pPr lvl="1"/>
@@ -2841,7 +2844,6 @@
               <a:rPr lang="en-US" smtClean="0"/>
               <a:t>Second level</a:t>
             </a:r>
-            <a:endParaRPr lang="en-US" smtClean="0"/>
           </a:p>
           <a:p>
             <a:pPr lvl="2"/>
@@ -2849,7 +2851,6 @@
               <a:rPr lang="en-US" smtClean="0"/>
               <a:t>Third level</a:t>
             </a:r>
-            <a:endParaRPr lang="en-US" smtClean="0"/>
           </a:p>
           <a:p>
             <a:pPr lvl="3"/>
@@ -2857,7 +2858,6 @@
               <a:rPr lang="en-US" smtClean="0"/>
               <a:t>Fourth level</a:t>
             </a:r>
-            <a:endParaRPr lang="en-US" smtClean="0"/>
           </a:p>
           <a:p>
             <a:pPr lvl="4"/>
@@ -2931,7 +2931,6 @@
               <a:rPr lang="en-US" smtClean="0"/>
               <a:t>Click to edit Master text styles</a:t>
             </a:r>
-            <a:endParaRPr lang="en-US" smtClean="0"/>
           </a:p>
         </p:txBody>
       </p:sp>
@@ -2988,7 +2987,6 @@
               <a:rPr lang="en-US" smtClean="0"/>
               <a:t>Click to edit Master text styles</a:t>
             </a:r>
-            <a:endParaRPr lang="en-US" smtClean="0"/>
           </a:p>
           <a:p>
             <a:pPr lvl="1"/>
@@ -2996,7 +2994,6 @@
               <a:rPr lang="en-US" smtClean="0"/>
               <a:t>Second level</a:t>
             </a:r>
-            <a:endParaRPr lang="en-US" smtClean="0"/>
           </a:p>
           <a:p>
             <a:pPr lvl="2"/>
@@ -3004,7 +3001,6 @@
               <a:rPr lang="en-US" smtClean="0"/>
               <a:t>Third level</a:t>
             </a:r>
-            <a:endParaRPr lang="en-US" smtClean="0"/>
           </a:p>
           <a:p>
             <a:pPr lvl="3"/>
@@ -3012,7 +3008,6 @@
               <a:rPr lang="en-US" smtClean="0"/>
               <a:t>Fourth level</a:t>
             </a:r>
-            <a:endParaRPr lang="en-US" smtClean="0"/>
           </a:p>
           <a:p>
             <a:pPr lvl="4"/>
@@ -3041,6 +3036,7 @@
           <a:p>
             <a:fld id="{5BCAD085-E8A6-8845-BD4E-CB4CCA059FC4}" type="datetimeFigureOut">
               <a:rPr lang="en-US" smtClean="0"/>
+              <a:t>1/27/13</a:t>
             </a:fld>
             <a:endParaRPr lang="en-US"/>
           </a:p>
@@ -3082,12 +3078,18 @@
           <a:p>
             <a:fld id="{C1FF6DA9-008F-8B48-92A6-B652298478BF}" type="slidenum">
               <a:rPr lang="en-US" smtClean="0"/>
+              <a:t>‹#›</a:t>
             </a:fld>
             <a:endParaRPr lang="en-US"/>
           </a:p>
         </p:txBody>
       </p:sp>
     </p:spTree>
+    <p:extLst>
+      <p:ext uri="{BB962C8B-B14F-4D97-AF65-F5344CB8AC3E}">
+        <p14:creationId xmlns:p14="http://schemas.microsoft.com/office/powerpoint/2010/main" val="990158736"/>
+      </p:ext>
+    </p:extLst>
   </p:cSld>
   <p:clrMapOvr>
     <a:masterClrMapping/>
@@ -3152,6 +3154,7 @@
           <a:p>
             <a:fld id="{5BCAD085-E8A6-8845-BD4E-CB4CCA059FC4}" type="datetimeFigureOut">
               <a:rPr lang="en-US" smtClean="0"/>
+              <a:t>1/27/13</a:t>
             </a:fld>
             <a:endParaRPr lang="en-US"/>
           </a:p>
@@ -3193,12 +3196,18 @@
           <a:p>
             <a:fld id="{C1FF6DA9-008F-8B48-92A6-B652298478BF}" type="slidenum">
               <a:rPr lang="en-US" smtClean="0"/>
+              <a:t>‹#›</a:t>
             </a:fld>
             <a:endParaRPr lang="en-US"/>
           </a:p>
         </p:txBody>
       </p:sp>
     </p:spTree>
+    <p:extLst>
+      <p:ext uri="{BB962C8B-B14F-4D97-AF65-F5344CB8AC3E}">
+        <p14:creationId xmlns:p14="http://schemas.microsoft.com/office/powerpoint/2010/main" val="727027711"/>
+      </p:ext>
+    </p:extLst>
   </p:cSld>
   <p:clrMapOvr>
     <a:masterClrMapping/>
@@ -3240,6 +3249,7 @@
           <a:p>
             <a:fld id="{5BCAD085-E8A6-8845-BD4E-CB4CCA059FC4}" type="datetimeFigureOut">
               <a:rPr lang="en-US" smtClean="0"/>
+              <a:t>1/27/13</a:t>
             </a:fld>
             <a:endParaRPr lang="en-US"/>
           </a:p>
@@ -3281,12 +3291,18 @@
           <a:p>
             <a:fld id="{C1FF6DA9-008F-8B48-92A6-B652298478BF}" type="slidenum">
               <a:rPr lang="en-US" smtClean="0"/>
+              <a:t>‹#›</a:t>
             </a:fld>
             <a:endParaRPr lang="en-US"/>
           </a:p>
         </p:txBody>
       </p:sp>
     </p:spTree>
+    <p:extLst>
+      <p:ext uri="{BB962C8B-B14F-4D97-AF65-F5344CB8AC3E}">
+        <p14:creationId xmlns:p14="http://schemas.microsoft.com/office/powerpoint/2010/main" val="1212999818"/>
+      </p:ext>
+    </p:extLst>
   </p:cSld>
   <p:clrMapOvr>
     <a:masterClrMapping/>
@@ -3396,7 +3412,6 @@
               <a:rPr lang="en-US" smtClean="0"/>
               <a:t>Click to edit Master text styles</a:t>
             </a:r>
-            <a:endParaRPr lang="en-US" smtClean="0"/>
           </a:p>
           <a:p>
             <a:pPr lvl="1"/>
@@ -3404,7 +3419,6 @@
               <a:rPr lang="en-US" smtClean="0"/>
               <a:t>Second level</a:t>
             </a:r>
-            <a:endParaRPr lang="en-US" smtClean="0"/>
           </a:p>
           <a:p>
             <a:pPr lvl="2"/>
@@ -3412,7 +3426,6 @@
               <a:rPr lang="en-US" smtClean="0"/>
               <a:t>Third level</a:t>
             </a:r>
-            <a:endParaRPr lang="en-US" smtClean="0"/>
           </a:p>
           <a:p>
             <a:pPr lvl="3"/>
@@ -3420,7 +3433,6 @@
               <a:rPr lang="en-US" smtClean="0"/>
               <a:t>Fourth level</a:t>
             </a:r>
-            <a:endParaRPr lang="en-US" smtClean="0"/>
           </a:p>
           <a:p>
             <a:pPr lvl="4"/>
@@ -3494,7 +3506,6 @@
               <a:rPr lang="en-US" smtClean="0"/>
               <a:t>Click to edit Master text styles</a:t>
             </a:r>
-            <a:endParaRPr lang="en-US" smtClean="0"/>
           </a:p>
         </p:txBody>
       </p:sp>
@@ -3515,6 +3526,7 @@
           <a:p>
             <a:fld id="{5BCAD085-E8A6-8845-BD4E-CB4CCA059FC4}" type="datetimeFigureOut">
               <a:rPr lang="en-US" smtClean="0"/>
+              <a:t>1/27/13</a:t>
             </a:fld>
             <a:endParaRPr lang="en-US"/>
           </a:p>
@@ -3556,12 +3568,18 @@
           <a:p>
             <a:fld id="{C1FF6DA9-008F-8B48-92A6-B652298478BF}" type="slidenum">
               <a:rPr lang="en-US" smtClean="0"/>
+              <a:t>‹#›</a:t>
             </a:fld>
             <a:endParaRPr lang="en-US"/>
           </a:p>
         </p:txBody>
       </p:sp>
     </p:spTree>
+    <p:extLst>
+      <p:ext uri="{BB962C8B-B14F-4D97-AF65-F5344CB8AC3E}">
+        <p14:creationId xmlns:p14="http://schemas.microsoft.com/office/powerpoint/2010/main" val="1840726560"/>
+      </p:ext>
+    </p:extLst>
   </p:cSld>
   <p:clrMapOvr>
     <a:masterClrMapping/>
@@ -3741,7 +3759,6 @@
               <a:rPr lang="en-US" smtClean="0"/>
               <a:t>Click to edit Master text styles</a:t>
             </a:r>
-            <a:endParaRPr lang="en-US" smtClean="0"/>
           </a:p>
         </p:txBody>
       </p:sp>
@@ -3762,6 +3779,7 @@
           <a:p>
             <a:fld id="{5BCAD085-E8A6-8845-BD4E-CB4CCA059FC4}" type="datetimeFigureOut">
               <a:rPr lang="en-US" smtClean="0"/>
+              <a:t>1/27/13</a:t>
             </a:fld>
             <a:endParaRPr lang="en-US"/>
           </a:p>
@@ -3803,12 +3821,18 @@
           <a:p>
             <a:fld id="{C1FF6DA9-008F-8B48-92A6-B652298478BF}" type="slidenum">
               <a:rPr lang="en-US" smtClean="0"/>
+              <a:t>‹#›</a:t>
             </a:fld>
             <a:endParaRPr lang="en-US"/>
           </a:p>
         </p:txBody>
       </p:sp>
     </p:spTree>
+    <p:extLst>
+      <p:ext uri="{BB962C8B-B14F-4D97-AF65-F5344CB8AC3E}">
+        <p14:creationId xmlns:p14="http://schemas.microsoft.com/office/powerpoint/2010/main" val="3889236939"/>
+      </p:ext>
+    </p:extLst>
   </p:cSld>
   <p:clrMapOvr>
     <a:masterClrMapping/>
@@ -3901,7 +3925,6 @@
               <a:rPr lang="en-US" smtClean="0"/>
               <a:t>Click to edit Master text styles</a:t>
             </a:r>
-            <a:endParaRPr lang="en-US" smtClean="0"/>
           </a:p>
           <a:p>
             <a:pPr lvl="1"/>
@@ -3909,7 +3932,6 @@
               <a:rPr lang="en-US" smtClean="0"/>
               <a:t>Second level</a:t>
             </a:r>
-            <a:endParaRPr lang="en-US" smtClean="0"/>
           </a:p>
           <a:p>
             <a:pPr lvl="2"/>
@@ -3917,7 +3939,6 @@
               <a:rPr lang="en-US" smtClean="0"/>
               <a:t>Third level</a:t>
             </a:r>
-            <a:endParaRPr lang="en-US" smtClean="0"/>
           </a:p>
           <a:p>
             <a:pPr lvl="3"/>
@@ -3925,7 +3946,6 @@
               <a:rPr lang="en-US" smtClean="0"/>
               <a:t>Fourth level</a:t>
             </a:r>
-            <a:endParaRPr lang="en-US" smtClean="0"/>
           </a:p>
           <a:p>
             <a:pPr lvl="4"/>
@@ -3972,6 +3992,7 @@
           <a:p>
             <a:fld id="{5BCAD085-E8A6-8845-BD4E-CB4CCA059FC4}" type="datetimeFigureOut">
               <a:rPr lang="en-US" smtClean="0"/>
+              <a:t>1/27/13</a:t>
             </a:fld>
             <a:endParaRPr lang="en-US"/>
           </a:p>
@@ -4049,12 +4070,18 @@
           <a:p>
             <a:fld id="{C1FF6DA9-008F-8B48-92A6-B652298478BF}" type="slidenum">
               <a:rPr lang="en-US" smtClean="0"/>
+              <a:t>‹#›</a:t>
             </a:fld>
             <a:endParaRPr lang="en-US"/>
           </a:p>
         </p:txBody>
       </p:sp>
     </p:spTree>
+    <p:extLst>
+      <p:ext uri="{BB962C8B-B14F-4D97-AF65-F5344CB8AC3E}">
+        <p14:creationId xmlns:p14="http://schemas.microsoft.com/office/powerpoint/2010/main" val="2209977519"/>
+      </p:ext>
+    </p:extLst>
   </p:cSld>
   <p:clrMap bg1="lt1" tx1="dk1" bg2="lt2" tx2="dk2" accent1="accent1" accent2="accent2" accent3="accent3" accent4="accent4" accent5="accent5" accent6="accent6" hlink="hlink" folHlink="folHlink"/>
   <p:sldLayoutIdLst>
@@ -4092,7 +4119,7 @@
         <a:spcBef>
           <a:spcPct val="20000"/>
         </a:spcBef>
-        <a:buFont typeface="Arial" panose="020B0604020202090204"/>
+        <a:buFont typeface="Arial"/>
         <a:buChar char="•"/>
         <a:defRPr sz="3200" kern="1200">
           <a:solidFill>
@@ -4107,7 +4134,7 @@
         <a:spcBef>
           <a:spcPct val="20000"/>
         </a:spcBef>
-        <a:buFont typeface="Arial" panose="020B0604020202090204"/>
+        <a:buFont typeface="Arial"/>
         <a:buChar char="–"/>
         <a:defRPr sz="2800" kern="1200">
           <a:solidFill>
@@ -4122,7 +4149,7 @@
         <a:spcBef>
           <a:spcPct val="20000"/>
         </a:spcBef>
-        <a:buFont typeface="Arial" panose="020B0604020202090204"/>
+        <a:buFont typeface="Arial"/>
         <a:buChar char="•"/>
         <a:defRPr sz="2400" kern="1200">
           <a:solidFill>
@@ -4137,7 +4164,7 @@
         <a:spcBef>
           <a:spcPct val="20000"/>
         </a:spcBef>
-        <a:buFont typeface="Arial" panose="020B0604020202090204"/>
+        <a:buFont typeface="Arial"/>
         <a:buChar char="–"/>
         <a:defRPr sz="2000" kern="1200">
           <a:solidFill>
@@ -4152,7 +4179,7 @@
         <a:spcBef>
           <a:spcPct val="20000"/>
         </a:spcBef>
-        <a:buFont typeface="Arial" panose="020B0604020202090204"/>
+        <a:buFont typeface="Arial"/>
         <a:buChar char="»"/>
         <a:defRPr sz="2000" kern="1200">
           <a:solidFill>
@@ -4167,7 +4194,7 @@
         <a:spcBef>
           <a:spcPct val="20000"/>
         </a:spcBef>
-        <a:buFont typeface="Arial" panose="020B0604020202090204"/>
+        <a:buFont typeface="Arial"/>
         <a:buChar char="•"/>
         <a:defRPr sz="2000" kern="1200">
           <a:solidFill>
@@ -4182,7 +4209,7 @@
         <a:spcBef>
           <a:spcPct val="20000"/>
         </a:spcBef>
-        <a:buFont typeface="Arial" panose="020B0604020202090204"/>
+        <a:buFont typeface="Arial"/>
         <a:buChar char="•"/>
         <a:defRPr sz="2000" kern="1200">
           <a:solidFill>
@@ -4197,7 +4224,7 @@
         <a:spcBef>
           <a:spcPct val="20000"/>
         </a:spcBef>
-        <a:buFont typeface="Arial" panose="020B0604020202090204"/>
+        <a:buFont typeface="Arial"/>
         <a:buChar char="•"/>
         <a:defRPr sz="2000" kern="1200">
           <a:solidFill>
@@ -4212,7 +4239,7 @@
         <a:spcBef>
           <a:spcPct val="20000"/>
         </a:spcBef>
-        <a:buFont typeface="Arial" panose="020B0604020202090204"/>
+        <a:buFont typeface="Arial"/>
         <a:buChar char="•"/>
         <a:defRPr sz="2000" kern="1200">
           <a:solidFill>
@@ -4324,7 +4351,7 @@
 </file>
 
 <file path=ppt/slides/slide1.xml><?xml version="1.0" encoding="utf-8"?>
-<p:sld xmlns:a="http://schemas.openxmlformats.org/drawingml/2006/main" xmlns:r="http://schemas.openxmlformats.org/officeDocument/2006/relationships" xmlns:p="http://schemas.openxmlformats.org/presentationml/2006/main">
+<p:sld xmlns:a="http://schemas.openxmlformats.org/drawingml/2006/main" xmlns:p="http://schemas.openxmlformats.org/presentationml/2006/main" xmlns:r="http://schemas.openxmlformats.org/officeDocument/2006/relationships">
   <p:cSld>
     <p:spTree>
       <p:nvGrpSpPr>
@@ -4360,16 +4387,10 @@
                 <a:solidFill>
                   <a:srgbClr val="1F3864"/>
                 </a:solidFill>
-                <a:latin typeface="Arial" panose="020B0604020202090204"/>
+                <a:latin typeface="Arial"/>
               </a:rPr>
               <a:t>Phonon Pulse Templates for SuperCDMS SNOLAB Run 4</a:t>
             </a:r>
-            <a:endParaRPr sz="3600" b="1">
-              <a:solidFill>
-                <a:srgbClr val="1F3864"/>
-              </a:solidFill>
-              <a:latin typeface="Arial" panose="020B0604020202090204"/>
-            </a:endParaRPr>
           </a:p>
         </p:txBody>
       </p:sp>
@@ -4400,16 +4421,10 @@
                 <a:solidFill>
                   <a:srgbClr val="666666"/>
                 </a:solidFill>
-                <a:latin typeface="Arial" panose="020B0604020202090204"/>
+                <a:latin typeface="Arial"/>
               </a:rPr>
               <a:t>K-line event selection  ·  free-pretrigger two-exponential fits  ·  1x1 and NxM (PCA) templates</a:t>
             </a:r>
-            <a:endParaRPr sz="1800">
-              <a:solidFill>
-                <a:srgbClr val="666666"/>
-              </a:solidFill>
-              <a:latin typeface="Arial" panose="020B0604020202090204"/>
-            </a:endParaRPr>
           </a:p>
         </p:txBody>
       </p:sp>
@@ -4440,16 +4455,10 @@
                 <a:solidFill>
                   <a:srgbClr val="333333"/>
                 </a:solidFill>
-                <a:latin typeface="Arial" panose="020B0604020202090204"/>
+                <a:latin typeface="Arial"/>
               </a:rPr>
               <a:t>Zhiheng Li  —  July 15, 2026</a:t>
             </a:r>
-            <a:endParaRPr sz="1600">
-              <a:solidFill>
-                <a:srgbClr val="333333"/>
-              </a:solidFill>
-              <a:latin typeface="Arial" panose="020B0604020202090204"/>
-            </a:endParaRPr>
           </a:p>
         </p:txBody>
       </p:sp>
@@ -4462,7 +4471,7 @@
 </file>
 
 <file path=ppt/slides/slide10.xml><?xml version="1.0" encoding="utf-8"?>
-<p:sld xmlns:a="http://schemas.openxmlformats.org/drawingml/2006/main" xmlns:r="http://schemas.openxmlformats.org/officeDocument/2006/relationships" xmlns:p="http://schemas.openxmlformats.org/presentationml/2006/main">
+<p:sld xmlns:a="http://schemas.openxmlformats.org/drawingml/2006/main" xmlns:p="http://schemas.openxmlformats.org/presentationml/2006/main" xmlns:r="http://schemas.openxmlformats.org/officeDocument/2006/relationships">
   <p:cSld>
     <p:spTree>
       <p:nvGrpSpPr>
@@ -4498,16 +4507,10 @@
                 <a:solidFill>
                   <a:srgbClr val="1F3864"/>
                 </a:solidFill>
-                <a:latin typeface="Arial" panose="020B0604020202090204"/>
+                <a:latin typeface="Arial"/>
               </a:rPr>
-              <a:t>Side finding: long-τ_fall events on Z7 are a one-channel artifact</a:t>
-            </a:r>
-            <a:endParaRPr sz="2700" b="1">
-              <a:solidFill>
-                <a:srgbClr val="1F3864"/>
-              </a:solidFill>
-              <a:latin typeface="Arial" panose="020B0604020202090204"/>
-            </a:endParaRPr>
+              <a:t>Slow drift also fits “slow”: a τ_rise ≤ 0.3 ms ceiling</a:t>
+            </a:r>
           </a:p>
         </p:txBody>
       </p:sp>
@@ -4563,7 +4566,7 @@
         <p:spPr>
           <a:xfrm>
             <a:off x="502920" y="1097280"/>
-            <a:ext cx="11247120" cy="1188720"/>
+            <a:ext cx="11247120" cy="1600200"/>
           </a:xfrm>
           <a:prstGeom prst="rect">
             <a:avLst/>
@@ -4586,16 +4589,10 @@
                 <a:solidFill>
                   <a:srgbClr val="333333"/>
                 </a:solidFill>
-                <a:latin typeface="Arial" panose="020B0604020202090204"/>
+                <a:latin typeface="Arial"/>
               </a:rPr>
-              <a:t>• PDS2 shows a broad τ_fall tail (median 0.51 ms vs ≈ 0.25 ms elsewhere) and a smeared τ_rise distribution</a:t>
-            </a:r>
-            <a:endParaRPr sz="1400">
-              <a:solidFill>
-                <a:srgbClr val="333333"/>
-              </a:solidFill>
-              <a:latin typeface="Arial" panose="020B0604020202090204"/>
-            </a:endParaRPr>
+              <a:t>• On noisy-window detectors a smooth baseline drift survives the NRMSE cut — a slow 2-exp hugs it with a tiny residual — and mimics a slow rise</a:t>
+            </a:r>
           </a:p>
           <a:p>
             <a:pPr>
@@ -4608,87 +4605,32 @@
                 <a:solidFill>
                   <a:srgbClr val="333333"/>
                 </a:solidFill>
-                <a:latin typeface="Arial" panose="020B0604020202090204"/>
+                <a:latin typeface="Arial"/>
               </a:rPr>
-              <a:t>• Cross-channel check: the same events are normal fast pulses in the other 11 channels → a PDS2-only low-frequency disturbance, not slow physics</a:t>
-            </a:r>
-            <a:endParaRPr sz="1400">
-              <a:solidFill>
-                <a:srgbClr val="333333"/>
-              </a:solidFill>
-              <a:latin typeface="Arial" panose="020B0604020202090204"/>
-            </a:endParaRPr>
+              <a:t>• Fast pulses sit at τ_rise ≈ 0.1 ms (p90 ≈ 0.15 ms), far below the drift tail → a ceiling at 0.3 ms blocks the drift at ≈ 2–5% signal cost</a:t>
+            </a:r>
+          </a:p>
+          <a:p>
+            <a:pPr>
+              <a:spcAft>
+                <a:spcPts val="500"/>
+              </a:spcAft>
+            </a:pPr>
+            <a:r>
+              <a:rPr sz="1400">
+                <a:solidFill>
+                  <a:srgbClr val="333333"/>
+                </a:solidFill>
+                <a:latin typeface="Arial"/>
+              </a:rPr>
+              <a:t>• Keeps most genuine slow pulses, trims the very slowest — documented trade-off, final decision pending</a:t>
+            </a:r>
           </a:p>
         </p:txBody>
       </p:sp>
       <p:pic>
         <p:nvPicPr>
           <p:cNvPr id="5" name="Picture 4" descr="time_constants_zip7_PAS1.png"/>
-          <p:cNvPicPr>
-            <a:picLocks noChangeAspect="1"/>
-          </p:cNvPicPr>
-          <p:nvPr/>
-        </p:nvPicPr>
-        <p:blipFill>
-          <a:blip r:embed="rId1"/>
-          <a:stretch>
-            <a:fillRect/>
-          </a:stretch>
-        </p:blipFill>
-        <p:spPr>
-          <a:xfrm>
-            <a:off x="1280160" y="2377440"/>
-            <a:ext cx="9601200" cy="1851803"/>
-          </a:xfrm>
-          <a:prstGeom prst="rect">
-            <a:avLst/>
-          </a:prstGeom>
-        </p:spPr>
-      </p:pic>
-      <p:sp>
-        <p:nvSpPr>
-          <p:cNvPr id="6" name="TextBox 5"/>
-          <p:cNvSpPr txBox="1"/>
-          <p:nvPr/>
-        </p:nvSpPr>
-        <p:spPr>
-          <a:xfrm>
-            <a:off x="1280160" y="4259243"/>
-            <a:ext cx="9601200" cy="274320"/>
-          </a:xfrm>
-          <a:prstGeom prst="rect">
-            <a:avLst/>
-          </a:prstGeom>
-          <a:noFill/>
-        </p:spPr>
-        <p:txBody>
-          <a:bodyPr wrap="square">
-            <a:spAutoFit/>
-          </a:bodyPr>
-          <a:lstStyle/>
-          <a:p>
-            <a:pPr algn="ctr"/>
-            <a:r>
-              <a:rPr sz="1100" i="1">
-                <a:solidFill>
-                  <a:srgbClr val="666666"/>
-                </a:solidFill>
-                <a:latin typeface="Arial" panose="020B0604020202090204"/>
-              </a:rPr>
-              <a:t>Z7 PAS1 — reference channel: narrow τ_rise / τ_fall</a:t>
-            </a:r>
-            <a:endParaRPr sz="1100" i="1">
-              <a:solidFill>
-                <a:srgbClr val="666666"/>
-              </a:solidFill>
-              <a:latin typeface="Arial" panose="020B0604020202090204"/>
-            </a:endParaRPr>
-          </a:p>
-        </p:txBody>
-      </p:sp>
-      <p:pic>
-        <p:nvPicPr>
-          <p:cNvPr id="7" name="Picture 6" descr="time_constants_zip7_PDS2.png"/>
           <p:cNvPicPr>
             <a:picLocks noChangeAspect="1"/>
           </p:cNvPicPr>
@@ -4702,8 +4644,8 @@
         </p:blipFill>
         <p:spPr>
           <a:xfrm>
-            <a:off x="1280160" y="4480560"/>
-            <a:ext cx="9601200" cy="1845094"/>
+            <a:off x="1280160" y="2880360"/>
+            <a:ext cx="9601200" cy="1851803"/>
           </a:xfrm>
           <a:prstGeom prst="rect">
             <a:avLst/>
@@ -4712,13 +4654,13 @@
       </p:pic>
       <p:sp>
         <p:nvSpPr>
-          <p:cNvPr id="8" name="TextBox 7"/>
+          <p:cNvPr id="6" name="TextBox 5"/>
           <p:cNvSpPr txBox="1"/>
           <p:nvPr/>
         </p:nvSpPr>
         <p:spPr>
           <a:xfrm>
-            <a:off x="1280160" y="6355654"/>
+            <a:off x="1280160" y="4762163"/>
             <a:ext cx="9601200" cy="274320"/>
           </a:xfrm>
           <a:prstGeom prst="rect">
@@ -4738,16 +4680,49 @@
                 <a:solidFill>
                   <a:srgbClr val="666666"/>
                 </a:solidFill>
-                <a:latin typeface="Arial" panose="020B0604020202090204"/>
+                <a:latin typeface="Arial"/>
               </a:rPr>
-              <a:t>Z7 PDS2 — broad tails from a channel-specific low-frequency artifact</a:t>
-            </a:r>
-            <a:endParaRPr sz="1100" i="1">
-              <a:solidFill>
-                <a:srgbClr val="666666"/>
-              </a:solidFill>
-              <a:latin typeface="Arial" panose="020B0604020202090204"/>
-            </a:endParaRPr>
+              <a:t>Z7 PAS1: fitted τ_rise (median 0.105 ms) and τ_fall distributions</a:t>
+            </a:r>
+          </a:p>
+        </p:txBody>
+      </p:sp>
+      <p:sp>
+        <p:nvSpPr>
+          <p:cNvPr id="7" name="TextBox 6"/>
+          <p:cNvSpPr txBox="1"/>
+          <p:nvPr/>
+        </p:nvSpPr>
+        <p:spPr>
+          <a:xfrm>
+            <a:off x="1280160" y="5257800"/>
+            <a:ext cx="9601200" cy="914400"/>
+          </a:xfrm>
+          <a:prstGeom prst="rect">
+            <a:avLst/>
+          </a:prstGeom>
+          <a:noFill/>
+        </p:spPr>
+        <p:txBody>
+          <a:bodyPr wrap="square">
+            <a:spAutoFit/>
+          </a:bodyPr>
+          <a:lstStyle/>
+          <a:p>
+            <a:pPr>
+              <a:spcAft>
+                <a:spcPts val="500"/>
+              </a:spcAft>
+            </a:pPr>
+            <a:r>
+              <a:rPr sz="1300">
+                <a:solidFill>
+                  <a:srgbClr val="333333"/>
+                </a:solidFill>
+                <a:latin typeface="Arial"/>
+              </a:rPr>
+              <a:t>• On quiet detectors both τ_rise and τ_fall distributions are narrow — the pulse shape is stable across events</a:t>
+            </a:r>
           </a:p>
         </p:txBody>
       </p:sp>
@@ -4760,7 +4735,7 @@
 </file>
 
 <file path=ppt/slides/slide11.xml><?xml version="1.0" encoding="utf-8"?>
-<p:sld xmlns:a="http://schemas.openxmlformats.org/drawingml/2006/main" xmlns:r="http://schemas.openxmlformats.org/officeDocument/2006/relationships" xmlns:p="http://schemas.openxmlformats.org/presentationml/2006/main">
+<p:sld xmlns:a="http://schemas.openxmlformats.org/drawingml/2006/main" xmlns:p="http://schemas.openxmlformats.org/presentationml/2006/main" xmlns:r="http://schemas.openxmlformats.org/officeDocument/2006/relationships">
   <p:cSld>
     <p:spTree>
       <p:nvGrpSpPr>
@@ -4796,16 +4771,10 @@
                 <a:solidFill>
                   <a:srgbClr val="1F3864"/>
                 </a:solidFill>
-                <a:latin typeface="Arial" panose="020B0604020202090204"/>
+                <a:latin typeface="Arial"/>
               </a:rPr>
               <a:t>Template family 1 — analytic 2-exp, NRMSE-weighted (1x1)</a:t>
             </a:r>
-            <a:endParaRPr sz="2700" b="1">
-              <a:solidFill>
-                <a:srgbClr val="1F3864"/>
-              </a:solidFill>
-              <a:latin typeface="Arial" panose="020B0604020202090204"/>
-            </a:endParaRPr>
           </a:p>
         </p:txBody>
       </p:sp>
@@ -4884,16 +4853,10 @@
                 <a:solidFill>
                   <a:srgbClr val="333333"/>
                 </a:solidFill>
-                <a:latin typeface="Arial" panose="020B0604020202090204"/>
+                <a:latin typeface="Arial"/>
               </a:rPr>
               <a:t>• Per channel: weighted mean of ALL fit_ok fitted curves at the common onset, weight w = 1/max(NRMSE, 0.01)²</a:t>
             </a:r>
-            <a:endParaRPr sz="1400">
-              <a:solidFill>
-                <a:srgbClr val="333333"/>
-              </a:solidFill>
-              <a:latin typeface="Arial" panose="020B0604020202090204"/>
-            </a:endParaRPr>
           </a:p>
           <a:p>
             <a:pPr>
@@ -4906,16 +4869,10 @@
                 <a:solidFill>
                   <a:srgbClr val="333333"/>
                 </a:solidFill>
-                <a:latin typeface="Arial" panose="020B0604020202090204"/>
+                <a:latin typeface="Arial"/>
               </a:rPr>
               <a:t>• Badly-fit events count less but are never excluded — robust and smooth (noise-free by construction)</a:t>
             </a:r>
-            <a:endParaRPr sz="1400">
-              <a:solidFill>
-                <a:srgbClr val="333333"/>
-              </a:solidFill>
-              <a:latin typeface="Arial" panose="020B0604020202090204"/>
-            </a:endParaRPr>
           </a:p>
           <a:p>
             <a:pPr>
@@ -4928,22 +4885,16 @@
                 <a:solidFill>
                   <a:srgbClr val="333333"/>
                 </a:solidFill>
-                <a:latin typeface="Arial" panose="020B0604020202090204"/>
+                <a:latin typeface="Arial"/>
               </a:rPr>
               <a:t>• Delivered as peak-normalized 32768-bin ROOT TH1D per channel + summed PT/PS1/PS2 templates</a:t>
             </a:r>
-            <a:endParaRPr sz="1400">
-              <a:solidFill>
-                <a:srgbClr val="333333"/>
-              </a:solidFill>
-              <a:latin typeface="Arial" panose="020B0604020202090204"/>
-            </a:endParaRPr>
           </a:p>
         </p:txBody>
       </p:sp>
       <p:pic>
         <p:nvPicPr>
-          <p:cNvPr id="5" name="Picture 4" descr="image.png"/>
+          <p:cNvPr id="5" name="Picture 4" descr="fan_zip7_PBS1_nrmse.png"/>
           <p:cNvPicPr>
             <a:picLocks noChangeAspect="1"/>
           </p:cNvPicPr>
@@ -4974,7 +4925,7 @@
         <p:spPr>
           <a:xfrm>
             <a:off x="1280160" y="5927880"/>
-            <a:ext cx="9601200" cy="292608"/>
+            <a:ext cx="9601200" cy="274320"/>
           </a:xfrm>
           <a:prstGeom prst="rect">
             <a:avLst/>
@@ -5009,7 +4960,7 @@
 </file>
 
 <file path=ppt/slides/slide12.xml><?xml version="1.0" encoding="utf-8"?>
-<p:sld xmlns:a="http://schemas.openxmlformats.org/drawingml/2006/main" xmlns:r="http://schemas.openxmlformats.org/officeDocument/2006/relationships" xmlns:p="http://schemas.openxmlformats.org/presentationml/2006/main">
+<p:sld xmlns:a="http://schemas.openxmlformats.org/drawingml/2006/main" xmlns:p="http://schemas.openxmlformats.org/presentationml/2006/main" xmlns:r="http://schemas.openxmlformats.org/officeDocument/2006/relationships">
   <p:cSld>
     <p:spTree>
       <p:nvGrpSpPr>
@@ -5045,16 +4996,10 @@
                 <a:solidFill>
                   <a:srgbClr val="1F3864"/>
                 </a:solidFill>
-                <a:latin typeface="Arial" panose="020B0604020202090204"/>
+                <a:latin typeface="Arial"/>
               </a:rPr>
               <a:t>Template family 2 — NxM PCA templates</a:t>
             </a:r>
-            <a:endParaRPr sz="2700" b="1">
-              <a:solidFill>
-                <a:srgbClr val="1F3864"/>
-              </a:solidFill>
-              <a:latin typeface="Arial" panose="020B0604020202090204"/>
-            </a:endParaRPr>
           </a:p>
         </p:txBody>
       </p:sp>
@@ -5133,16 +5078,10 @@
                 <a:solidFill>
                   <a:srgbClr val="333333"/>
                 </a:solidFill>
-                <a:latin typeface="Arial" panose="020B0604020202090204"/>
+                <a:latin typeface="Arial"/>
               </a:rPr>
               <a:t>• Input: fitted curves passing fit_ok + NRMSE ≤ 0.4 + τ_rise ≤ 0.3 ms, at common onset, peak-normalized (PCA window 15550–24050, ≤ 3000 curves/channel)</a:t>
             </a:r>
-            <a:endParaRPr sz="1400">
-              <a:solidFill>
-                <a:srgbClr val="333333"/>
-              </a:solidFill>
-              <a:latin typeface="Arial" panose="020B0604020202090204"/>
-            </a:endParaRPr>
           </a:p>
           <a:p>
             <a:pPr>
@@ -5155,16 +5094,10 @@
                 <a:solidFill>
                   <a:srgbClr val="333333"/>
                 </a:solidFill>
-                <a:latin typeface="Arial" panose="020B0604020202090204"/>
+                <a:latin typeface="Arial"/>
               </a:rPr>
               <a:t>• nxm0 = mean shape;  nxm1…nxm4 = first four principal components — a real pulse is fit as Σᵢ ampᵢ · nxmᵢ</a:t>
             </a:r>
-            <a:endParaRPr sz="1400">
-              <a:solidFill>
-                <a:srgbClr val="333333"/>
-              </a:solidFill>
-              <a:latin typeface="Arial" panose="020B0604020202090204"/>
-            </a:endParaRPr>
           </a:p>
           <a:p>
             <a:pPr>
@@ -5177,46 +5110,16 @@
                 <a:solidFill>
                   <a:srgbClr val="333333"/>
                 </a:solidFill>
-                <a:latin typeface="Arial" panose="020B0604020202090204"/>
+                <a:latin typeface="Arial"/>
               </a:rPr>
-              <a:t>• PC1 + PC2 already capture 96–98% of the shape variance; all five delivered peak-normalized</a:t>
-            </a:r>
-            <a:endParaRPr sz="1400">
-              <a:solidFill>
-                <a:srgbClr val="333333"/>
-              </a:solidFill>
-              <a:latin typeface="Arial" panose="020B0604020202090204"/>
-            </a:endParaRPr>
+              <a:t>• PC1 + PC2 already capture 96–98% of the shape variance; final step before delivery: normalize all five to unit peak — the delivered product</a:t>
+            </a:r>
           </a:p>
         </p:txBody>
       </p:sp>
       <p:pic>
         <p:nvPicPr>
           <p:cNvPr id="5" name="Picture 4" descr="pca_zip7_PAS1.png"/>
-          <p:cNvPicPr>
-            <a:picLocks noChangeAspect="1"/>
-          </p:cNvPicPr>
-          <p:nvPr/>
-        </p:nvPicPr>
-        <p:blipFill>
-          <a:blip r:embed="rId1"/>
-          <a:stretch>
-            <a:fillRect/>
-          </a:stretch>
-        </p:blipFill>
-        <p:spPr>
-          <a:xfrm>
-            <a:off x="2831374" y="2697480"/>
-            <a:ext cx="6498771" cy="1828800"/>
-          </a:xfrm>
-          <a:prstGeom prst="rect">
-            <a:avLst/>
-          </a:prstGeom>
-        </p:spPr>
-      </p:pic>
-      <p:pic>
-        <p:nvPicPr>
-          <p:cNvPr id="6" name="Picture 5" descr="pca_zip7_PBS1.png"/>
           <p:cNvPicPr>
             <a:picLocks noChangeAspect="1"/>
           </p:cNvPicPr>
@@ -5230,6 +5133,30 @@
         </p:blipFill>
         <p:spPr>
           <a:xfrm>
+            <a:off x="2831374" y="2697480"/>
+            <a:ext cx="6498771" cy="1828800"/>
+          </a:xfrm>
+          <a:prstGeom prst="rect">
+            <a:avLst/>
+          </a:prstGeom>
+        </p:spPr>
+      </p:pic>
+      <p:pic>
+        <p:nvPicPr>
+          <p:cNvPr id="6" name="Picture 5" descr="pca_zip7_PBS1.png"/>
+          <p:cNvPicPr>
+            <a:picLocks noChangeAspect="1"/>
+          </p:cNvPicPr>
+          <p:nvPr/>
+        </p:nvPicPr>
+        <p:blipFill>
+          <a:blip r:embed="rId3"/>
+          <a:stretch>
+            <a:fillRect/>
+          </a:stretch>
+        </p:blipFill>
+        <p:spPr>
+          <a:xfrm>
             <a:off x="2831374" y="4572000"/>
             <a:ext cx="6498771" cy="1828800"/>
           </a:xfrm>
@@ -5266,16 +5193,10 @@
                 <a:solidFill>
                   <a:srgbClr val="666666"/>
                 </a:solidFill>
-                <a:latin typeface="Arial" panose="020B0604020202090204"/>
+                <a:latin typeface="Arial"/>
               </a:rPr>
               <a:t>Z7 PAS1 / PBS1: nxm0 (mean) + nxm1–4 (PCs) — the oscillating components encode rise/fall-time variation</a:t>
             </a:r>
-            <a:endParaRPr sz="1100" i="1">
-              <a:solidFill>
-                <a:srgbClr val="666666"/>
-              </a:solidFill>
-              <a:latin typeface="Arial" panose="020B0604020202090204"/>
-            </a:endParaRPr>
           </a:p>
         </p:txBody>
       </p:sp>
@@ -5288,7 +5209,7 @@
 </file>
 
 <file path=ppt/slides/slide13.xml><?xml version="1.0" encoding="utf-8"?>
-<p:sld xmlns:a="http://schemas.openxmlformats.org/drawingml/2006/main" xmlns:r="http://schemas.openxmlformats.org/officeDocument/2006/relationships" xmlns:p="http://schemas.openxmlformats.org/presentationml/2006/main">
+<p:sld xmlns:a="http://schemas.openxmlformats.org/drawingml/2006/main" xmlns:p="http://schemas.openxmlformats.org/presentationml/2006/main" xmlns:r="http://schemas.openxmlformats.org/officeDocument/2006/relationships">
   <p:cSld>
     <p:spTree>
       <p:nvGrpSpPr>
@@ -5324,16 +5245,10 @@
                 <a:solidFill>
                   <a:srgbClr val="1F3864"/>
                 </a:solidFill>
-                <a:latin typeface="Arial" panose="020B0604020202090204"/>
+                <a:latin typeface="Arial"/>
               </a:rPr>
               <a:t>Delivered — and what remains</a:t>
             </a:r>
-            <a:endParaRPr sz="2700" b="1">
-              <a:solidFill>
-                <a:srgbClr val="1F3864"/>
-              </a:solidFill>
-              <a:latin typeface="Arial" panose="020B0604020202090204"/>
-            </a:endParaRPr>
           </a:p>
         </p:txBody>
       </p:sp>
@@ -5412,16 +5327,10 @@
                 <a:solidFill>
                   <a:srgbClr val="333333"/>
                 </a:solidFill>
-                <a:latin typeface="Arial" panose="020B0604020202090204"/>
+                <a:latin typeface="Arial"/>
               </a:rPr>
               <a:t>• Delivered for all 13 zips, official cdmsbats PulseTemplates layout (zip{N}/{chan}, {chan}nxm0–4, summed PT/PS1/PS2):</a:t>
             </a:r>
-            <a:endParaRPr sz="1600">
-              <a:solidFill>
-                <a:srgbClr val="333333"/>
-              </a:solidFill>
-              <a:latin typeface="Arial" panose="020B0604020202090204"/>
-            </a:endParaRPr>
           </a:p>
           <a:p>
             <a:pPr lvl="1">
@@ -5434,16 +5343,10 @@
                 <a:solidFill>
                   <a:srgbClr val="666666"/>
                 </a:solidFill>
-                <a:latin typeface="Arial" panose="020B0604020202090204"/>
+                <a:latin typeface="Arial"/>
               </a:rPr>
               <a:t>– SNOLAB_R4_20260706_ZhihengLi_zip{N}.root — 2-exp NRMSE-weighted (1x1)</a:t>
             </a:r>
-            <a:endParaRPr sz="1400">
-              <a:solidFill>
-                <a:srgbClr val="666666"/>
-              </a:solidFill>
-              <a:latin typeface="Arial" panose="020B0604020202090204"/>
-            </a:endParaRPr>
           </a:p>
           <a:p>
             <a:pPr lvl="1">
@@ -5456,16 +5359,10 @@
                 <a:solidFill>
                   <a:srgbClr val="666666"/>
                 </a:solidFill>
-                <a:latin typeface="Arial" panose="020B0604020202090204"/>
+                <a:latin typeface="Arial"/>
               </a:rPr>
               <a:t>– SNOLAB_R4_20260707_ZhihengLi_pca_zip{N}.root — NxM PCA (normalized)</a:t>
             </a:r>
-            <a:endParaRPr sz="1400">
-              <a:solidFill>
-                <a:srgbClr val="666666"/>
-              </a:solidFill>
-              <a:latin typeface="Arial" panose="020B0604020202090204"/>
-            </a:endParaRPr>
           </a:p>
           <a:p>
             <a:pPr>
@@ -5478,16 +5375,10 @@
                 <a:solidFill>
                   <a:srgbClr val="333333"/>
                 </a:solidFill>
-                <a:latin typeface="Arial" panose="020B0604020202090204"/>
+                <a:latin typeface="Arial"/>
               </a:rPr>
               <a:t>• Every step is traceable: raw cache → per-series fit checkpoints indexed by EventNumber → self-documenting figures (11 types × 13 zips, all versioned)</a:t>
             </a:r>
-            <a:endParaRPr sz="1600">
-              <a:solidFill>
-                <a:srgbClr val="333333"/>
-              </a:solidFill>
-              <a:latin typeface="Arial" panose="020B0604020202090204"/>
-            </a:endParaRPr>
           </a:p>
           <a:p>
             <a:pPr>
@@ -5500,16 +5391,10 @@
                 <a:solidFill>
                   <a:srgbClr val="333333"/>
                 </a:solidFill>
-                <a:latin typeface="Arial" panose="020B0604020202090204"/>
+                <a:latin typeface="Arial"/>
               </a:rPr>
               <a:t>• Cuts derived from the data, validated in raw traces: NRMSE ≤ 0.4 (bimodal valley), τ_rise ≤ 0.3 ms (drift leakage)</a:t>
             </a:r>
-            <a:endParaRPr sz="1600">
-              <a:solidFill>
-                <a:srgbClr val="333333"/>
-              </a:solidFill>
-              <a:latin typeface="Arial" panose="020B0604020202090204"/>
-            </a:endParaRPr>
           </a:p>
           <a:p>
             <a:pPr>
@@ -5522,16 +5407,10 @@
                 <a:solidFill>
                   <a:srgbClr val="333333"/>
                 </a:solidFill>
-                <a:latin typeface="Arial" panose="020B0604020202090204"/>
+                <a:latin typeface="Arial"/>
               </a:rPr>
               <a:t>• Open items:</a:t>
             </a:r>
-            <a:endParaRPr sz="1600">
-              <a:solidFill>
-                <a:srgbClr val="333333"/>
-              </a:solidFill>
-              <a:latin typeface="Arial" panose="020B0604020202090204"/>
-            </a:endParaRPr>
           </a:p>
           <a:p>
             <a:pPr lvl="1">
@@ -5544,16 +5423,10 @@
                 <a:solidFill>
                   <a:srgbClr val="666666"/>
                 </a:solidFill>
-                <a:latin typeface="Arial" panose="020B0604020202090204"/>
+                <a:latin typeface="Arial"/>
               </a:rPr>
               <a:t>– final decision on the τ_rise ceiling vs the genuine slow-pulse population</a:t>
             </a:r>
-            <a:endParaRPr sz="1400">
-              <a:solidFill>
-                <a:srgbClr val="666666"/>
-              </a:solidFill>
-              <a:latin typeface="Arial" panose="020B0604020202090204"/>
-            </a:endParaRPr>
           </a:p>
           <a:p>
             <a:pPr lvl="1">
@@ -5566,16 +5439,10 @@
                 <a:solidFill>
                   <a:srgbClr val="666666"/>
                 </a:solidFill>
-                <a:latin typeface="Arial" panose="020B0604020202090204"/>
+                <a:latin typeface="Arial"/>
               </a:rPr>
               <a:t>– run the group's template-validation method on the new templates</a:t>
             </a:r>
-            <a:endParaRPr sz="1400">
-              <a:solidFill>
-                <a:srgbClr val="666666"/>
-              </a:solidFill>
-              <a:latin typeface="Arial" panose="020B0604020202090204"/>
-            </a:endParaRPr>
           </a:p>
         </p:txBody>
       </p:sp>
@@ -5588,7 +5455,7 @@
 </file>
 
 <file path=ppt/slides/slide2.xml><?xml version="1.0" encoding="utf-8"?>
-<p:sld xmlns:a="http://schemas.openxmlformats.org/drawingml/2006/main" xmlns:r="http://schemas.openxmlformats.org/officeDocument/2006/relationships" xmlns:p="http://schemas.openxmlformats.org/presentationml/2006/main">
+<p:sld xmlns:a="http://schemas.openxmlformats.org/drawingml/2006/main" xmlns:p="http://schemas.openxmlformats.org/presentationml/2006/main" xmlns:r="http://schemas.openxmlformats.org/officeDocument/2006/relationships">
   <p:cSld>
     <p:spTree>
       <p:nvGrpSpPr>
@@ -5624,16 +5491,10 @@
                 <a:solidFill>
                   <a:srgbClr val="1F3864"/>
                 </a:solidFill>
-                <a:latin typeface="Arial" panose="020B0604020202090204"/>
+                <a:latin typeface="Arial"/>
               </a:rPr>
               <a:t>From the Ge-activation K-line to an event sample</a:t>
             </a:r>
-            <a:endParaRPr sz="2700" b="1">
-              <a:solidFill>
-                <a:srgbClr val="1F3864"/>
-              </a:solidFill>
-              <a:latin typeface="Arial" panose="020B0604020202090204"/>
-            </a:endParaRPr>
           </a:p>
           <a:p>
             <a:r>
@@ -5641,16 +5502,10 @@
                 <a:solidFill>
                   <a:srgbClr val="666666"/>
                 </a:solidFill>
-                <a:latin typeface="Arial" panose="020B0604020202090204"/>
+                <a:latin typeface="Arial"/>
               </a:rPr>
               <a:t>Goal: one clean, minimally-biased pulse population per detector × channel</a:t>
             </a:r>
-            <a:endParaRPr sz="1400">
-              <a:solidFill>
-                <a:srgbClr val="666666"/>
-              </a:solidFill>
-              <a:latin typeface="Arial" panose="020B0604020202090204"/>
-            </a:endParaRPr>
           </a:p>
         </p:txBody>
       </p:sp>
@@ -5705,7 +5560,7 @@
         </p:nvSpPr>
         <p:spPr>
           <a:xfrm>
-            <a:off x="230505" y="1078992"/>
+            <a:off x="228600" y="1078992"/>
             <a:ext cx="11247120" cy="1325880"/>
           </a:xfrm>
           <a:prstGeom prst="rect">
@@ -5721,7 +5576,7 @@
           <a:p>
             <a:pPr>
               <a:spcAft>
-                <a:spcPts val="400"/>
+                <a:spcPts val="500"/>
               </a:spcAft>
             </a:pPr>
             <a:r>
@@ -5733,17 +5588,11 @@
               </a:rPr>
               <a:t>• Per detector, the ops-shift study marked the 10.37 keV K-line position in PTOFamps — the red line in each panel below</a:t>
             </a:r>
-            <a:endParaRPr sz="1400">
-              <a:solidFill>
-                <a:srgbClr val="333333"/>
-              </a:solidFill>
-              <a:latin typeface="Arial" panose="020B0604020202090204"/>
-            </a:endParaRPr>
           </a:p>
           <a:p>
             <a:pPr>
               <a:spcAft>
-                <a:spcPts val="400"/>
+                <a:spcPts val="500"/>
               </a:spcAft>
             </a:pPr>
             <a:r>
@@ -5759,7 +5608,7 @@
           <a:p>
             <a:pPr>
               <a:spcAft>
-                <a:spcPts val="400"/>
+                <a:spcPts val="500"/>
               </a:spcAft>
             </a:pPr>
             <a:r>
@@ -5775,7 +5624,7 @@
           <a:p>
             <a:pPr>
               <a:spcAft>
-                <a:spcPts val="400"/>
+                <a:spcPts val="500"/>
               </a:spcAft>
             </a:pPr>
             <a:r>
@@ -5790,51 +5639,16 @@
           </a:p>
         </p:txBody>
       </p:sp>
-      <p:sp>
-        <p:nvSpPr>
-          <p:cNvPr id="6" name="TextBox 5"/>
-          <p:cNvSpPr txBox="1"/>
-          <p:nvPr/>
-        </p:nvSpPr>
-        <p:spPr>
-          <a:xfrm>
-            <a:off x="384048" y="6504807"/>
-            <a:ext cx="11430000" cy="320040"/>
-          </a:xfrm>
-          <a:prstGeom prst="rect">
-            <a:avLst/>
-          </a:prstGeom>
-          <a:noFill/>
-        </p:spPr>
-        <p:txBody>
-          <a:bodyPr wrap="square">
-            <a:spAutoFit/>
-          </a:bodyPr>
-          <a:lstStyle/>
-          <a:p>
-            <a:pPr algn="ctr"/>
-            <a:r>
-              <a:rPr sz="1200" i="1">
-                <a:solidFill>
-                  <a:srgbClr val="666666"/>
-                </a:solidFill>
-                <a:latin typeface="Arial"/>
-              </a:rPr>
-              <a:t>All 13 detectors, PTOFamps spectra (ops-shift study): red line = fitted mean of the 10.37 keV K-line. Selection window per detector = red-line position ×/÷ 1.35.</a:t>
-            </a:r>
-          </a:p>
-        </p:txBody>
-      </p:sp>
       <p:pic>
         <p:nvPicPr>
-          <p:cNvPr id="7" name="Picture 6" descr="kline_all_zips.png"/>
+          <p:cNvPr id="5" name="Picture 4" descr="kline_all_zips.png"/>
           <p:cNvPicPr>
             <a:picLocks noChangeAspect="1"/>
           </p:cNvPicPr>
           <p:nvPr/>
         </p:nvPicPr>
         <p:blipFill>
-          <a:blip r:embed="rId5"/>
+          <a:blip r:embed="rId2"/>
           <a:stretch>
             <a:fillRect/>
           </a:stretch>
@@ -5849,6 +5663,41 @@
           </a:prstGeom>
         </p:spPr>
       </p:pic>
+      <p:sp>
+        <p:nvSpPr>
+          <p:cNvPr id="6" name="TextBox 5"/>
+          <p:cNvSpPr txBox="1"/>
+          <p:nvPr/>
+        </p:nvSpPr>
+        <p:spPr>
+          <a:xfrm>
+            <a:off x="384048" y="6494807"/>
+            <a:ext cx="11430000" cy="274320"/>
+          </a:xfrm>
+          <a:prstGeom prst="rect">
+            <a:avLst/>
+          </a:prstGeom>
+          <a:noFill/>
+        </p:spPr>
+        <p:txBody>
+          <a:bodyPr wrap="square">
+            <a:spAutoFit/>
+          </a:bodyPr>
+          <a:lstStyle/>
+          <a:p>
+            <a:pPr algn="ctr"/>
+            <a:r>
+              <a:rPr sz="1100" i="1">
+                <a:solidFill>
+                  <a:srgbClr val="666666"/>
+                </a:solidFill>
+                <a:latin typeface="Arial"/>
+              </a:rPr>
+              <a:t>All 13 detectors, PTOFamps spectra (ops-shift study): red line = fitted mean of the 10.37 keV K-line. Selection window per detector = red-line position ×/÷ 1.35.</a:t>
+            </a:r>
+          </a:p>
+        </p:txBody>
+      </p:sp>
     </p:spTree>
   </p:cSld>
   <p:clrMapOvr>
@@ -5858,7 +5707,7 @@
 </file>
 
 <file path=ppt/slides/slide3.xml><?xml version="1.0" encoding="utf-8"?>
-<p:sld xmlns:a="http://schemas.openxmlformats.org/drawingml/2006/main" xmlns:r="http://schemas.openxmlformats.org/officeDocument/2006/relationships" xmlns:p="http://schemas.openxmlformats.org/presentationml/2006/main">
+<p:sld xmlns:a="http://schemas.openxmlformats.org/drawingml/2006/main" xmlns:p="http://schemas.openxmlformats.org/presentationml/2006/main" xmlns:r="http://schemas.openxmlformats.org/officeDocument/2006/relationships">
   <p:cSld>
     <p:spTree>
       <p:nvGrpSpPr>
@@ -5894,16 +5743,10 @@
                 <a:solidFill>
                   <a:srgbClr val="1F3864"/>
                 </a:solidFill>
-                <a:latin typeface="Arial" panose="020B0604020202090204"/>
+                <a:latin typeface="Arial"/>
               </a:rPr>
               <a:t>Per-trace algorithm: low-pass → free-pretrigger fit → align</a:t>
             </a:r>
-            <a:endParaRPr sz="2700" b="1">
-              <a:solidFill>
-                <a:srgbClr val="1F3864"/>
-              </a:solidFill>
-              <a:latin typeface="Arial" panose="020B0604020202090204"/>
-            </a:endParaRPr>
           </a:p>
         </p:txBody>
       </p:sp>
@@ -5982,16 +5825,10 @@
                 <a:solidFill>
                   <a:srgbClr val="333333"/>
                 </a:solidFill>
-                <a:latin typeface="Arial" panose="020B0604020202090204"/>
+                <a:latin typeface="Arial"/>
               </a:rPr>
               <a:t>• 1.  100 kHz 4th-order Butterworth low-pass (steady-state init — no filter start-up transient)</a:t>
             </a:r>
-            <a:endParaRPr sz="1500">
-              <a:solidFill>
-                <a:srgbClr val="333333"/>
-              </a:solidFill>
-              <a:latin typeface="Arial" panose="020B0604020202090204"/>
-            </a:endParaRPr>
           </a:p>
           <a:p>
             <a:pPr>
@@ -6004,16 +5841,10 @@
                 <a:solidFill>
                   <a:srgbClr val="333333"/>
                 </a:solidFill>
-                <a:latin typeface="Arial" panose="020B0604020202090204"/>
+                <a:latin typeface="Arial"/>
               </a:rPr>
               <a:t>• 2.  Baseline = median of samples 2000–12000, subtracted; normalize by the global trace peak</a:t>
             </a:r>
-            <a:endParaRPr sz="1500">
-              <a:solidFill>
-                <a:srgbClr val="333333"/>
-              </a:solidFill>
-              <a:latin typeface="Arial" panose="020B0604020202090204"/>
-            </a:endParaRPr>
           </a:p>
           <a:p>
             <a:pPr>
@@ -6026,16 +5857,10 @@
                 <a:solidFill>
                   <a:srgbClr val="333333"/>
                 </a:solidFill>
-                <a:latin typeface="Arial" panose="020B0604020202090204"/>
+                <a:latin typeface="Arial"/>
               </a:rPr>
               <a:t>• 3.  Two-exponential fit — all 5 parameters free, including the onset:</a:t>
             </a:r>
-            <a:endParaRPr sz="1500">
-              <a:solidFill>
-                <a:srgbClr val="333333"/>
-              </a:solidFill>
-              <a:latin typeface="Arial" panose="020B0604020202090204"/>
-            </a:endParaRPr>
           </a:p>
           <a:p>
             <a:pPr lvl="1">
@@ -6048,16 +5873,10 @@
                 <a:solidFill>
                   <a:srgbClr val="666666"/>
                 </a:solidFill>
-                <a:latin typeface="Arial" panose="020B0604020202090204"/>
+                <a:latin typeface="Arial"/>
               </a:rPr>
               <a:t>– y(t) = A·[exp(−(t−t₀)/τ_fall) − exp(−(t−t₀)/τ_rise)] + b,   t₀ ∈ 16050 ± 3000 samples</a:t>
             </a:r>
-            <a:endParaRPr sz="1300">
-              <a:solidFill>
-                <a:srgbClr val="666666"/>
-              </a:solidFill>
-              <a:latin typeface="Arial" panose="020B0604020202090204"/>
-            </a:endParaRPr>
           </a:p>
           <a:p>
             <a:pPr lvl="1">
@@ -6070,16 +5889,10 @@
                 <a:solidFill>
                   <a:srgbClr val="666666"/>
                 </a:solidFill>
-                <a:latin typeface="Arial" panose="020B0604020202090204"/>
+                <a:latin typeface="Arial"/>
               </a:rPr>
               <a:t>– fit window 12550–24050 (stride 4);  τ_rise ∈ [1 µs, 5 ms],  τ_fall ∈ [10 µs, 20 ms]</a:t>
             </a:r>
-            <a:endParaRPr sz="1300">
-              <a:solidFill>
-                <a:srgbClr val="666666"/>
-              </a:solidFill>
-              <a:latin typeface="Arial" panose="020B0604020202090204"/>
-            </a:endParaRPr>
           </a:p>
           <a:p>
             <a:pPr>
@@ -6092,16 +5905,10 @@
                 <a:solidFill>
                   <a:srgbClr val="333333"/>
                 </a:solidFill>
-                <a:latin typeface="Arial" panose="020B0604020202090204"/>
+                <a:latin typeface="Arial"/>
               </a:rPr>
               <a:t>• 4.  Quality numbers — fit_ok := A&gt;0 and 0&lt;τ_rise&lt;τ_fall;  NRMSE := RMS(residual)/fit peak (recorded, no cut yet)</a:t>
             </a:r>
-            <a:endParaRPr sz="1500">
-              <a:solidFill>
-                <a:srgbClr val="333333"/>
-              </a:solidFill>
-              <a:latin typeface="Arial" panose="020B0604020202090204"/>
-            </a:endParaRPr>
           </a:p>
           <a:p>
             <a:pPr>
@@ -6114,16 +5921,10 @@
                 <a:solidFill>
                   <a:srgbClr val="333333"/>
                 </a:solidFill>
-                <a:latin typeface="Arial" panose="020B0604020202090204"/>
+                <a:latin typeface="Arial"/>
               </a:rPr>
               <a:t>• 5.  Align — shift the measured trace by (fitted onset − 16050), sub-sample interpolation: a pure translation</a:t>
             </a:r>
-            <a:endParaRPr sz="1500">
-              <a:solidFill>
-                <a:srgbClr val="333333"/>
-              </a:solidFill>
-              <a:latin typeface="Arial" panose="020B0604020202090204"/>
-            </a:endParaRPr>
           </a:p>
         </p:txBody>
       </p:sp>
@@ -6159,70 +5960,23 @@
                 <a:solidFill>
                   <a:srgbClr val="C0504D"/>
                 </a:solidFill>
-                <a:latin typeface="Arial" panose="020B0604020202090204"/>
+                <a:latin typeface="Arial"/>
               </a:rPr>
               <a:t>• Why a free onset?  Real trigger times vary event-by-event — fitted onsets cluster ≈230 samples after the nominal 16050. Pinning the onset distorts every other parameter.</a:t>
             </a:r>
-            <a:endParaRPr sz="1400">
-              <a:solidFill>
-                <a:srgbClr val="C0504D"/>
-              </a:solidFill>
-              <a:latin typeface="Arial" panose="020B0604020202090204"/>
-            </a:endParaRPr>
-          </a:p>
-        </p:txBody>
-      </p:sp>
-      <p:sp>
-        <p:nvSpPr>
-          <p:cNvPr id="7" name="TextBox 6"/>
-          <p:cNvSpPr txBox="1"/>
-          <p:nvPr/>
-        </p:nvSpPr>
-        <p:spPr>
-          <a:xfrm>
-            <a:off x="5852160" y="5665803"/>
-            <a:ext cx="5852160" cy="274320"/>
-          </a:xfrm>
-          <a:prstGeom prst="rect">
-            <a:avLst/>
-          </a:prstGeom>
-          <a:noFill/>
-        </p:spPr>
-        <p:txBody>
-          <a:bodyPr wrap="square">
-            <a:spAutoFit/>
-          </a:bodyPr>
-          <a:lstStyle/>
-          <a:p>
-            <a:pPr algn="ctr"/>
-            <a:r>
-              <a:rPr sz="1100" i="1">
-                <a:solidFill>
-                  <a:srgbClr val="666666"/>
-                </a:solidFill>
-                <a:latin typeface="Arial" panose="020B0604020202090204"/>
-              </a:rPr>
-              <a:t>Z7 PAS1: fitted onset distribution — offset from nominal, narrow core</a:t>
-            </a:r>
-            <a:endParaRPr sz="1100" i="1">
-              <a:solidFill>
-                <a:srgbClr val="666666"/>
-              </a:solidFill>
-              <a:latin typeface="Arial" panose="020B0604020202090204"/>
-            </a:endParaRPr>
           </a:p>
         </p:txBody>
       </p:sp>
       <p:pic>
         <p:nvPicPr>
-          <p:cNvPr id="8" name="Picture 7" descr="image.png"/>
+          <p:cNvPr id="6" name="Picture 5" descr="fan_zip7_PBS1_before.png"/>
           <p:cNvPicPr>
             <a:picLocks noChangeAspect="1"/>
           </p:cNvPicPr>
           <p:nvPr/>
         </p:nvPicPr>
         <p:blipFill>
-          <a:blip r:embed="rId4"/>
+          <a:blip r:embed="rId2"/>
           <a:stretch>
             <a:fillRect/>
           </a:stretch>
@@ -6239,14 +5993,14 @@
       </p:pic>
       <p:sp>
         <p:nvSpPr>
-          <p:cNvPr id="9" name="TextBox 8"/>
+          <p:cNvPr id="7" name="TextBox 6"/>
           <p:cNvSpPr txBox="1"/>
           <p:nvPr/>
         </p:nvSpPr>
         <p:spPr>
           <a:xfrm>
             <a:off x="502920" y="6430800"/>
-            <a:ext cx="5486400" cy="292608"/>
+            <a:ext cx="5486400" cy="274320"/>
           </a:xfrm>
           <a:prstGeom prst="rect">
             <a:avLst/>
@@ -6274,14 +6028,14 @@
       </p:sp>
       <p:pic>
         <p:nvPicPr>
-          <p:cNvPr id="10" name="Picture 9" descr="image.png"/>
+          <p:cNvPr id="8" name="Picture 7" descr="fan_zip7_PBS1_nrmse.png"/>
           <p:cNvPicPr>
             <a:picLocks noChangeAspect="1"/>
           </p:cNvPicPr>
           <p:nvPr/>
         </p:nvPicPr>
         <p:blipFill>
-          <a:blip r:embed="rId5"/>
+          <a:blip r:embed="rId3"/>
           <a:stretch>
             <a:fillRect/>
           </a:stretch>
@@ -6298,14 +6052,14 @@
       </p:pic>
       <p:sp>
         <p:nvSpPr>
-          <p:cNvPr id="11" name="TextBox 10"/>
+          <p:cNvPr id="9" name="TextBox 8"/>
           <p:cNvSpPr txBox="1"/>
           <p:nvPr/>
         </p:nvSpPr>
         <p:spPr>
           <a:xfrm>
             <a:off x="6263640" y="6430800"/>
-            <a:ext cx="5486400" cy="292608"/>
+            <a:ext cx="5486400" cy="274320"/>
           </a:xfrm>
           <a:prstGeom prst="rect">
             <a:avLst/>
@@ -6340,7 +6094,7 @@
 </file>
 
 <file path=ppt/slides/slide4.xml><?xml version="1.0" encoding="utf-8"?>
-<p:sld xmlns:a="http://schemas.openxmlformats.org/drawingml/2006/main" xmlns:r="http://schemas.openxmlformats.org/officeDocument/2006/relationships" xmlns:p="http://schemas.openxmlformats.org/presentationml/2006/main">
+<p:sld xmlns:a="http://schemas.openxmlformats.org/drawingml/2006/main" xmlns:p="http://schemas.openxmlformats.org/presentationml/2006/main" xmlns:r="http://schemas.openxmlformats.org/officeDocument/2006/relationships">
   <p:cSld>
     <p:spTree>
       <p:nvGrpSpPr>
@@ -6376,16 +6130,10 @@
                 <a:solidFill>
                   <a:srgbClr val="1F3864"/>
                 </a:solidFill>
-                <a:latin typeface="Arial" panose="020B0604020202090204"/>
+                <a:latin typeface="Arial"/>
               </a:rPr>
               <a:t>Fit quality at a glance — event × channel grids</a:t>
             </a:r>
-            <a:endParaRPr sz="2700" b="1">
-              <a:solidFill>
-                <a:srgbClr val="1F3864"/>
-              </a:solidFill>
-              <a:latin typeface="Arial" panose="020B0604020202090204"/>
-            </a:endParaRPr>
           </a:p>
         </p:txBody>
       </p:sp>
@@ -6464,16 +6212,10 @@
                 <a:solidFill>
                   <a:srgbClr val="333333"/>
                 </a:solidFill>
-                <a:latin typeface="Arial" panose="020B0604020202090204"/>
+                <a:latin typeface="Arial"/>
               </a:rPr>
               <a:t>• One row per event, one column per channel: low-passed trace (blue) vs 2-exp fit (red), NRMSE stamped per panel</a:t>
             </a:r>
-            <a:endParaRPr sz="1400">
-              <a:solidFill>
-                <a:srgbClr val="333333"/>
-              </a:solidFill>
-              <a:latin typeface="Arial" panose="020B0604020202090204"/>
-            </a:endParaRPr>
           </a:p>
           <a:p>
             <a:pPr>
@@ -6486,16 +6228,10 @@
                 <a:solidFill>
                   <a:srgbClr val="333333"/>
                 </a:solidFill>
-                <a:latin typeface="Arial" panose="020B0604020202090204"/>
+                <a:latin typeface="Arial"/>
               </a:rPr>
               <a:t>• The same event fits consistently across channels; a noise trigger fails in all channels at once</a:t>
             </a:r>
-            <a:endParaRPr sz="1400">
-              <a:solidFill>
-                <a:srgbClr val="333333"/>
-              </a:solidFill>
-              <a:latin typeface="Arial" panose="020B0604020202090204"/>
-            </a:endParaRPr>
           </a:p>
           <a:p>
             <a:pPr>
@@ -6508,87 +6244,16 @@
                 <a:solidFill>
                   <a:srgbClr val="333333"/>
                 </a:solidFill>
-                <a:latin typeface="Arial" panose="020B0604020202090204"/>
+                <a:latin typeface="Arial"/>
               </a:rPr>
               <a:t>• Every figure carries its full processing chain in the header → self-documenting</a:t>
             </a:r>
-            <a:endParaRPr sz="1400">
-              <a:solidFill>
-                <a:srgbClr val="333333"/>
-              </a:solidFill>
-              <a:latin typeface="Arial" panose="020B0604020202090204"/>
-            </a:endParaRPr>
           </a:p>
         </p:txBody>
       </p:sp>
       <p:pic>
         <p:nvPicPr>
           <p:cNvPr id="5" name="Picture 4" descr="fit_examples_zip7_noise.png"/>
-          <p:cNvPicPr>
-            <a:picLocks noChangeAspect="1"/>
-          </p:cNvPicPr>
-          <p:nvPr/>
-        </p:nvPicPr>
-        <p:blipFill>
-          <a:blip r:embed="rId1"/>
-          <a:stretch>
-            <a:fillRect/>
-          </a:stretch>
-        </p:blipFill>
-        <p:spPr>
-          <a:xfrm>
-            <a:off x="502920" y="2377440"/>
-            <a:ext cx="5486400" cy="2547707"/>
-          </a:xfrm>
-          <a:prstGeom prst="rect">
-            <a:avLst/>
-          </a:prstGeom>
-        </p:spPr>
-      </p:pic>
-      <p:sp>
-        <p:nvSpPr>
-          <p:cNvPr id="6" name="TextBox 5"/>
-          <p:cNvSpPr txBox="1"/>
-          <p:nvPr/>
-        </p:nvSpPr>
-        <p:spPr>
-          <a:xfrm>
-            <a:off x="502920" y="4955147"/>
-            <a:ext cx="5486400" cy="274320"/>
-          </a:xfrm>
-          <a:prstGeom prst="rect">
-            <a:avLst/>
-          </a:prstGeom>
-          <a:noFill/>
-        </p:spPr>
-        <p:txBody>
-          <a:bodyPr wrap="square">
-            <a:spAutoFit/>
-          </a:bodyPr>
-          <a:lstStyle/>
-          <a:p>
-            <a:pPr algn="ctr"/>
-            <a:r>
-              <a:rPr sz="1100" i="1">
-                <a:solidFill>
-                  <a:srgbClr val="666666"/>
-                </a:solidFill>
-                <a:latin typeface="Arial" panose="020B0604020202090204"/>
-              </a:rPr>
-              <a:t>Noise triggers: the fit fails in every channel at once</a:t>
-            </a:r>
-            <a:endParaRPr sz="1100" i="1">
-              <a:solidFill>
-                <a:srgbClr val="666666"/>
-              </a:solidFill>
-              <a:latin typeface="Arial" panose="020B0604020202090204"/>
-            </a:endParaRPr>
-          </a:p>
-        </p:txBody>
-      </p:sp>
-      <p:pic>
-        <p:nvPicPr>
-          <p:cNvPr id="7" name="Picture 6" descr="fit_examples_zip7_good.png"/>
           <p:cNvPicPr>
             <a:picLocks noChangeAspect="1"/>
           </p:cNvPicPr>
@@ -6602,6 +6267,65 @@
         </p:blipFill>
         <p:spPr>
           <a:xfrm>
+            <a:off x="502920" y="2377440"/>
+            <a:ext cx="5486400" cy="2547707"/>
+          </a:xfrm>
+          <a:prstGeom prst="rect">
+            <a:avLst/>
+          </a:prstGeom>
+        </p:spPr>
+      </p:pic>
+      <p:sp>
+        <p:nvSpPr>
+          <p:cNvPr id="6" name="TextBox 5"/>
+          <p:cNvSpPr txBox="1"/>
+          <p:nvPr/>
+        </p:nvSpPr>
+        <p:spPr>
+          <a:xfrm>
+            <a:off x="502920" y="4955147"/>
+            <a:ext cx="5486400" cy="274320"/>
+          </a:xfrm>
+          <a:prstGeom prst="rect">
+            <a:avLst/>
+          </a:prstGeom>
+          <a:noFill/>
+        </p:spPr>
+        <p:txBody>
+          <a:bodyPr wrap="square">
+            <a:spAutoFit/>
+          </a:bodyPr>
+          <a:lstStyle/>
+          <a:p>
+            <a:pPr algn="ctr"/>
+            <a:r>
+              <a:rPr sz="1100" i="1">
+                <a:solidFill>
+                  <a:srgbClr val="666666"/>
+                </a:solidFill>
+                <a:latin typeface="Arial"/>
+              </a:rPr>
+              <a:t>Noise triggers: the fit fails in every channel at once</a:t>
+            </a:r>
+          </a:p>
+        </p:txBody>
+      </p:sp>
+      <p:pic>
+        <p:nvPicPr>
+          <p:cNvPr id="7" name="Picture 6" descr="fit_examples_zip7_good.png"/>
+          <p:cNvPicPr>
+            <a:picLocks noChangeAspect="1"/>
+          </p:cNvPicPr>
+          <p:nvPr/>
+        </p:nvPicPr>
+        <p:blipFill>
+          <a:blip r:embed="rId3"/>
+          <a:stretch>
+            <a:fillRect/>
+          </a:stretch>
+        </p:blipFill>
+        <p:spPr>
+          <a:xfrm>
             <a:off x="6263640" y="2377440"/>
             <a:ext cx="5486400" cy="2453114"/>
           </a:xfrm>
@@ -6638,16 +6362,10 @@
                 <a:solidFill>
                   <a:srgbClr val="666666"/>
                 </a:solidFill>
-                <a:latin typeface="Arial" panose="020B0604020202090204"/>
+                <a:latin typeface="Arial"/>
               </a:rPr>
               <a:t>K-line events: consistent good fits across channels</a:t>
             </a:r>
-            <a:endParaRPr sz="1100" i="1">
-              <a:solidFill>
-                <a:srgbClr val="666666"/>
-              </a:solidFill>
-              <a:latin typeface="Arial" panose="020B0604020202090204"/>
-            </a:endParaRPr>
           </a:p>
         </p:txBody>
       </p:sp>
@@ -6660,7 +6378,7 @@
 </file>
 
 <file path=ppt/slides/slide5.xml><?xml version="1.0" encoding="utf-8"?>
-<p:sld xmlns:a="http://schemas.openxmlformats.org/drawingml/2006/main" xmlns:r="http://schemas.openxmlformats.org/officeDocument/2006/relationships" xmlns:p="http://schemas.openxmlformats.org/presentationml/2006/main">
+<p:sld xmlns:a="http://schemas.openxmlformats.org/drawingml/2006/main" xmlns:p="http://schemas.openxmlformats.org/presentationml/2006/main" xmlns:r="http://schemas.openxmlformats.org/officeDocument/2006/relationships">
   <p:cSld>
     <p:spTree>
       <p:nvGrpSpPr>
@@ -6696,16 +6414,10 @@
                 <a:solidFill>
                   <a:srgbClr val="1F3864"/>
                 </a:solidFill>
-                <a:latin typeface="Arial" panose="020B0604020202090204"/>
+                <a:latin typeface="Arial"/>
               </a:rPr>
               <a:t>Alignment result — overlaid measured traces</a:t>
             </a:r>
-            <a:endParaRPr sz="2700" b="1">
-              <a:solidFill>
-                <a:srgbClr val="1F3864"/>
-              </a:solidFill>
-              <a:latin typeface="Arial" panose="020B0604020202090204"/>
-            </a:endParaRPr>
           </a:p>
         </p:txBody>
       </p:sp>
@@ -6761,7 +6473,7 @@
         <p:spPr>
           <a:xfrm>
             <a:off x="502920" y="1097280"/>
-            <a:ext cx="11247120" cy="1051560"/>
+            <a:ext cx="11247120" cy="1371600"/>
           </a:xfrm>
           <a:prstGeom prst="rect">
             <a:avLst/>
@@ -6776,7 +6488,7 @@
           <a:p>
             <a:pPr>
               <a:spcAft>
-                <a:spcPts val="400"/>
+                <a:spcPts val="500"/>
               </a:spcAft>
             </a:pPr>
             <a:r>
@@ -6788,17 +6500,11 @@
               </a:rPr>
               <a:t>• All fit_ok traces shifted to the common onset (blue) + point-by-point mean (red) + NRMSE-weighted mean of the fitted curves (orange, w = 1/max(NRMSE, 0.01)²)</a:t>
             </a:r>
-            <a:endParaRPr sz="1400">
-              <a:solidFill>
-                <a:srgbClr val="333333"/>
-              </a:solidFill>
-              <a:latin typeface="Arial" panose="020B0604020202090204"/>
-            </a:endParaRPr>
           </a:p>
           <a:p>
             <a:pPr>
               <a:spcAft>
-                <a:spcPts val="400"/>
+                <a:spcPts val="500"/>
               </a:spcAft>
             </a:pPr>
             <a:r>
@@ -6822,7 +6528,7 @@
           <p:nvPr/>
         </p:nvPicPr>
         <p:blipFill>
-          <a:blip r:embed="rId5"/>
+          <a:blip r:embed="rId2"/>
           <a:stretch>
             <a:fillRect/>
           </a:stretch>
@@ -6861,7 +6567,7 @@
           <a:p>
             <a:pPr algn="ctr"/>
             <a:r>
-              <a:rPr sz="1200" i="1">
+              <a:rPr sz="1100" i="1">
                 <a:solidFill>
                   <a:srgbClr val="666666"/>
                 </a:solidFill>
@@ -6881,7 +6587,7 @@
           <p:nvPr/>
         </p:nvPicPr>
         <p:blipFill>
-          <a:blip r:embed="rId6"/>
+          <a:blip r:embed="rId3"/>
           <a:stretch>
             <a:fillRect/>
           </a:stretch>
@@ -6920,7 +6626,7 @@
           <a:p>
             <a:pPr algn="ctr"/>
             <a:r>
-              <a:rPr sz="1200" i="1">
+              <a:rPr sz="1100" i="1">
                 <a:solidFill>
                   <a:srgbClr val="666666"/>
                 </a:solidFill>
@@ -6940,7 +6646,7 @@
 </file>
 
 <file path=ppt/slides/slide6.xml><?xml version="1.0" encoding="utf-8"?>
-<p:sld xmlns:a="http://schemas.openxmlformats.org/drawingml/2006/main" xmlns:r="http://schemas.openxmlformats.org/officeDocument/2006/relationships" xmlns:p="http://schemas.openxmlformats.org/presentationml/2006/main">
+<p:sld xmlns:a="http://schemas.openxmlformats.org/drawingml/2006/main" xmlns:p="http://schemas.openxmlformats.org/presentationml/2006/main" xmlns:r="http://schemas.openxmlformats.org/officeDocument/2006/relationships">
   <p:cSld>
     <p:spTree>
       <p:nvGrpSpPr>
@@ -6976,16 +6682,10 @@
                 <a:solidFill>
                   <a:srgbClr val="1F3864"/>
                 </a:solidFill>
-                <a:latin typeface="Arial" panose="020B0604020202090204"/>
+                <a:latin typeface="Arial"/>
               </a:rPr>
               <a:t>Quality cut 1: NRMSE ≤ 0.4 — where the number comes from</a:t>
             </a:r>
-            <a:endParaRPr sz="2700" b="1">
-              <a:solidFill>
-                <a:srgbClr val="1F3864"/>
-              </a:solidFill>
-              <a:latin typeface="Arial" panose="020B0604020202090204"/>
-            </a:endParaRPr>
           </a:p>
         </p:txBody>
       </p:sp>
@@ -7064,16 +6764,10 @@
                 <a:solidFill>
                   <a:srgbClr val="333333"/>
                 </a:solidFill>
-                <a:latin typeface="Arial" panose="020B0604020202090204"/>
+                <a:latin typeface="Arial"/>
               </a:rPr>
               <a:t>• NRMSE of fit_ok events is bimodal: good fits (median ≈ 0.05–0.1) vs noise triggers (≈ 1–2), valley at ≈ 0.4–0.5</a:t>
             </a:r>
-            <a:endParaRPr sz="1400">
-              <a:solidFill>
-                <a:srgbClr val="333333"/>
-              </a:solidFill>
-              <a:latin typeface="Arial" panose="020B0604020202090204"/>
-            </a:endParaRPr>
           </a:p>
           <a:p>
             <a:pPr>
@@ -7086,16 +6780,10 @@
                 <a:solidFill>
                   <a:srgbClr val="333333"/>
                 </a:solidFill>
-                <a:latin typeface="Arial" panose="020B0604020202090204"/>
+                <a:latin typeface="Arial"/>
               </a:rPr>
               <a:t>• The cut sits in the valley — it is read off the distribution, not tuned on the templates</a:t>
             </a:r>
-            <a:endParaRPr sz="1400">
-              <a:solidFill>
-                <a:srgbClr val="333333"/>
-              </a:solidFill>
-              <a:latin typeface="Arial" panose="020B0604020202090204"/>
-            </a:endParaRPr>
           </a:p>
           <a:p>
             <a:pPr>
@@ -7108,87 +6796,16 @@
                 <a:solidFill>
                   <a:srgbClr val="333333"/>
                 </a:solidFill>
-                <a:latin typeface="Arial" panose="020B0604020202090204"/>
+                <a:latin typeface="Arial"/>
               </a:rPr>
               <a:t>• Weak detectors (Z1, Z4, Z6, Z18, Z19, Z22, Z24): the PTOF window admits a noise-dominated mixture — this cut is what extracts the real-pulse population</a:t>
             </a:r>
-            <a:endParaRPr sz="1400">
-              <a:solidFill>
-                <a:srgbClr val="333333"/>
-              </a:solidFill>
-              <a:latin typeface="Arial" panose="020B0604020202090204"/>
-            </a:endParaRPr>
           </a:p>
         </p:txBody>
       </p:sp>
       <p:pic>
         <p:nvPicPr>
           <p:cNvPr id="5" name="Picture 4" descr="nrmse_zip7_PBS1.png"/>
-          <p:cNvPicPr>
-            <a:picLocks noChangeAspect="1"/>
-          </p:cNvPicPr>
-          <p:nvPr/>
-        </p:nvPicPr>
-        <p:blipFill>
-          <a:blip r:embed="rId1"/>
-          <a:stretch>
-            <a:fillRect/>
-          </a:stretch>
-        </p:blipFill>
-        <p:spPr>
-          <a:xfrm>
-            <a:off x="1970576" y="2651760"/>
-            <a:ext cx="8220367" cy="1874519"/>
-          </a:xfrm>
-          <a:prstGeom prst="rect">
-            <a:avLst/>
-          </a:prstGeom>
-        </p:spPr>
-      </p:pic>
-      <p:sp>
-        <p:nvSpPr>
-          <p:cNvPr id="6" name="TextBox 5"/>
-          <p:cNvSpPr txBox="1"/>
-          <p:nvPr/>
-        </p:nvSpPr>
-        <p:spPr>
-          <a:xfrm>
-            <a:off x="1737360" y="4556279"/>
-            <a:ext cx="8686800" cy="274320"/>
-          </a:xfrm>
-          <a:prstGeom prst="rect">
-            <a:avLst/>
-          </a:prstGeom>
-          <a:noFill/>
-        </p:spPr>
-        <p:txBody>
-          <a:bodyPr wrap="square">
-            <a:spAutoFit/>
-          </a:bodyPr>
-          <a:lstStyle/>
-          <a:p>
-            <a:pPr algn="ctr"/>
-            <a:r>
-              <a:rPr sz="1100" i="1">
-                <a:solidFill>
-                  <a:srgbClr val="666666"/>
-                </a:solidFill>
-                <a:latin typeface="Arial" panose="020B0604020202090204"/>
-              </a:rPr>
-              <a:t>Z7 PBS1 (quiet): two clean populations, log-log axes</a:t>
-            </a:r>
-            <a:endParaRPr sz="1100" i="1">
-              <a:solidFill>
-                <a:srgbClr val="666666"/>
-              </a:solidFill>
-              <a:latin typeface="Arial" panose="020B0604020202090204"/>
-            </a:endParaRPr>
-          </a:p>
-        </p:txBody>
-      </p:sp>
-      <p:pic>
-        <p:nvPicPr>
-          <p:cNvPr id="7" name="Picture 6" descr="nrmse_zip22_PAS1.png"/>
           <p:cNvPicPr>
             <a:picLocks noChangeAspect="1"/>
           </p:cNvPicPr>
@@ -7202,6 +6819,65 @@
         </p:blipFill>
         <p:spPr>
           <a:xfrm>
+            <a:off x="1970576" y="2651760"/>
+            <a:ext cx="8220367" cy="1874519"/>
+          </a:xfrm>
+          <a:prstGeom prst="rect">
+            <a:avLst/>
+          </a:prstGeom>
+        </p:spPr>
+      </p:pic>
+      <p:sp>
+        <p:nvSpPr>
+          <p:cNvPr id="6" name="TextBox 5"/>
+          <p:cNvSpPr txBox="1"/>
+          <p:nvPr/>
+        </p:nvSpPr>
+        <p:spPr>
+          <a:xfrm>
+            <a:off x="1737360" y="4556279"/>
+            <a:ext cx="8686800" cy="274320"/>
+          </a:xfrm>
+          <a:prstGeom prst="rect">
+            <a:avLst/>
+          </a:prstGeom>
+          <a:noFill/>
+        </p:spPr>
+        <p:txBody>
+          <a:bodyPr wrap="square">
+            <a:spAutoFit/>
+          </a:bodyPr>
+          <a:lstStyle/>
+          <a:p>
+            <a:pPr algn="ctr"/>
+            <a:r>
+              <a:rPr sz="1100" i="1">
+                <a:solidFill>
+                  <a:srgbClr val="666666"/>
+                </a:solidFill>
+                <a:latin typeface="Arial"/>
+              </a:rPr>
+              <a:t>Z7 PBS1 (quiet): two clean populations, log-log axes</a:t>
+            </a:r>
+          </a:p>
+        </p:txBody>
+      </p:sp>
+      <p:pic>
+        <p:nvPicPr>
+          <p:cNvPr id="7" name="Picture 6" descr="nrmse_zip22_PAS1.png"/>
+          <p:cNvPicPr>
+            <a:picLocks noChangeAspect="1"/>
+          </p:cNvPicPr>
+          <p:nvPr/>
+        </p:nvPicPr>
+        <p:blipFill>
+          <a:blip r:embed="rId3"/>
+          <a:stretch>
+            <a:fillRect/>
+          </a:stretch>
+        </p:blipFill>
+        <p:spPr>
+          <a:xfrm>
             <a:off x="1989344" y="4754880"/>
             <a:ext cx="8182831" cy="1874519"/>
           </a:xfrm>
@@ -7238,16 +6914,10 @@
                 <a:solidFill>
                   <a:srgbClr val="666666"/>
                 </a:solidFill>
-                <a:latin typeface="Arial" panose="020B0604020202090204"/>
+                <a:latin typeface="Arial"/>
               </a:rPr>
               <a:t>Z22 PAS1 (weak): noise population dominates — the window alone is not enough</a:t>
             </a:r>
-            <a:endParaRPr sz="1100" i="1">
-              <a:solidFill>
-                <a:srgbClr val="666666"/>
-              </a:solidFill>
-              <a:latin typeface="Arial" panose="020B0604020202090204"/>
-            </a:endParaRPr>
           </a:p>
         </p:txBody>
       </p:sp>
@@ -7260,7 +6930,7 @@
 </file>
 
 <file path=ppt/slides/slide7.xml><?xml version="1.0" encoding="utf-8"?>
-<p:sld xmlns:a="http://schemas.openxmlformats.org/drawingml/2006/main" xmlns:r="http://schemas.openxmlformats.org/officeDocument/2006/relationships" xmlns:p="http://schemas.openxmlformats.org/presentationml/2006/main">
+<p:sld xmlns:a="http://schemas.openxmlformats.org/drawingml/2006/main" xmlns:p="http://schemas.openxmlformats.org/presentationml/2006/main" xmlns:r="http://schemas.openxmlformats.org/officeDocument/2006/relationships">
   <p:cSld>
     <p:spTree>
       <p:nvGrpSpPr>
@@ -7296,16 +6966,10 @@
                 <a:solidFill>
                   <a:srgbClr val="1F3864"/>
                 </a:solidFill>
-                <a:latin typeface="Arial" panose="020B0604020202090204"/>
+                <a:latin typeface="Arial"/>
               </a:rPr>
               <a:t>The rejected population is noise — verified in the raw traces</a:t>
             </a:r>
-            <a:endParaRPr sz="2700" b="1">
-              <a:solidFill>
-                <a:srgbClr val="1F3864"/>
-              </a:solidFill>
-              <a:latin typeface="Arial" panose="020B0604020202090204"/>
-            </a:endParaRPr>
           </a:p>
         </p:txBody>
       </p:sp>
@@ -7384,16 +7048,10 @@
                 <a:solidFill>
                   <a:srgbClr val="333333"/>
                 </a:solidFill>
-                <a:latin typeface="Arial" panose="020B0604020202090204"/>
+                <a:latin typeface="Arial"/>
               </a:rPr>
               <a:t>• Event grids of NRMSE-rejected events (median NRMSE &gt; 0.4 across channels): the raw traces show no pulse — the cut removes noise triggers, not physics</a:t>
             </a:r>
-            <a:endParaRPr sz="1400">
-              <a:solidFill>
-                <a:srgbClr val="333333"/>
-              </a:solidFill>
-              <a:latin typeface="Arial" panose="020B0604020202090204"/>
-            </a:endParaRPr>
           </a:p>
           <a:p>
             <a:pPr>
@@ -7406,87 +7064,16 @@
                 <a:solidFill>
                   <a:srgbClr val="333333"/>
                 </a:solidFill>
-                <a:latin typeface="Arial" panose="020B0604020202090204"/>
+                <a:latin typeface="Arial"/>
               </a:rPr>
               <a:t>• Fan-cut view: fitted curves that pass (green) vs cut away (red) on top of the aligned data, median NRMSE of each population stamped per channel</a:t>
             </a:r>
-            <a:endParaRPr sz="1400">
-              <a:solidFill>
-                <a:srgbClr val="333333"/>
-              </a:solidFill>
-              <a:latin typeface="Arial" panose="020B0604020202090204"/>
-            </a:endParaRPr>
           </a:p>
         </p:txBody>
       </p:sp>
       <p:pic>
         <p:nvPicPr>
           <p:cNvPr id="5" name="Picture 4" descr="slow_rise_zip22_crop.png"/>
-          <p:cNvPicPr>
-            <a:picLocks noChangeAspect="1"/>
-          </p:cNvPicPr>
-          <p:nvPr/>
-        </p:nvPicPr>
-        <p:blipFill>
-          <a:blip r:embed="rId1"/>
-          <a:stretch>
-            <a:fillRect/>
-          </a:stretch>
-        </p:blipFill>
-        <p:spPr>
-          <a:xfrm>
-            <a:off x="502920" y="2468880"/>
-            <a:ext cx="5394960" cy="3699401"/>
-          </a:xfrm>
-          <a:prstGeom prst="rect">
-            <a:avLst/>
-          </a:prstGeom>
-        </p:spPr>
-      </p:pic>
-      <p:sp>
-        <p:nvSpPr>
-          <p:cNvPr id="6" name="TextBox 5"/>
-          <p:cNvSpPr txBox="1"/>
-          <p:nvPr/>
-        </p:nvSpPr>
-        <p:spPr>
-          <a:xfrm>
-            <a:off x="502920" y="6198281"/>
-            <a:ext cx="5394960" cy="274320"/>
-          </a:xfrm>
-          <a:prstGeom prst="rect">
-            <a:avLst/>
-          </a:prstGeom>
-          <a:noFill/>
-        </p:spPr>
-        <p:txBody>
-          <a:bodyPr wrap="square">
-            <a:spAutoFit/>
-          </a:bodyPr>
-          <a:lstStyle/>
-          <a:p>
-            <a:pPr algn="ctr"/>
-            <a:r>
-              <a:rPr sz="1100" i="1">
-                <a:solidFill>
-                  <a:srgbClr val="666666"/>
-                </a:solidFill>
-                <a:latin typeface="Arial" panose="020B0604020202090204"/>
-              </a:rPr>
-              <a:t>Z22: NRMSE-rejected events — raw traces are noise</a:t>
-            </a:r>
-            <a:endParaRPr sz="1100" i="1">
-              <a:solidFill>
-                <a:srgbClr val="666666"/>
-              </a:solidFill>
-              <a:latin typeface="Arial" panose="020B0604020202090204"/>
-            </a:endParaRPr>
-          </a:p>
-        </p:txBody>
-      </p:sp>
-      <p:pic>
-        <p:nvPicPr>
-          <p:cNvPr id="7" name="Picture 6" descr="fan_cut_zip22_PCS1.png"/>
           <p:cNvPicPr>
             <a:picLocks noChangeAspect="1"/>
           </p:cNvPicPr>
@@ -7500,6 +7087,65 @@
         </p:blipFill>
         <p:spPr>
           <a:xfrm>
+            <a:off x="502920" y="2468880"/>
+            <a:ext cx="5394960" cy="3699401"/>
+          </a:xfrm>
+          <a:prstGeom prst="rect">
+            <a:avLst/>
+          </a:prstGeom>
+        </p:spPr>
+      </p:pic>
+      <p:sp>
+        <p:nvSpPr>
+          <p:cNvPr id="6" name="TextBox 5"/>
+          <p:cNvSpPr txBox="1"/>
+          <p:nvPr/>
+        </p:nvSpPr>
+        <p:spPr>
+          <a:xfrm>
+            <a:off x="502920" y="6198281"/>
+            <a:ext cx="5394960" cy="274320"/>
+          </a:xfrm>
+          <a:prstGeom prst="rect">
+            <a:avLst/>
+          </a:prstGeom>
+          <a:noFill/>
+        </p:spPr>
+        <p:txBody>
+          <a:bodyPr wrap="square">
+            <a:spAutoFit/>
+          </a:bodyPr>
+          <a:lstStyle/>
+          <a:p>
+            <a:pPr algn="ctr"/>
+            <a:r>
+              <a:rPr sz="1100" i="1">
+                <a:solidFill>
+                  <a:srgbClr val="666666"/>
+                </a:solidFill>
+                <a:latin typeface="Arial"/>
+              </a:rPr>
+              <a:t>Z22: NRMSE-rejected events — raw traces are noise</a:t>
+            </a:r>
+          </a:p>
+        </p:txBody>
+      </p:sp>
+      <p:pic>
+        <p:nvPicPr>
+          <p:cNvPr id="7" name="Picture 6" descr="fan_cut_zip22_PCS1.png"/>
+          <p:cNvPicPr>
+            <a:picLocks noChangeAspect="1"/>
+          </p:cNvPicPr>
+          <p:nvPr/>
+        </p:nvPicPr>
+        <p:blipFill>
+          <a:blip r:embed="rId3"/>
+          <a:stretch>
+            <a:fillRect/>
+          </a:stretch>
+        </p:blipFill>
+        <p:spPr>
+          <a:xfrm>
             <a:off x="6126480" y="3108960"/>
             <a:ext cx="5760720" cy="1479697"/>
           </a:xfrm>
@@ -7536,16 +7182,10 @@
                 <a:solidFill>
                   <a:srgbClr val="666666"/>
                 </a:solidFill>
-                <a:latin typeface="Arial" panose="020B0604020202090204"/>
+                <a:latin typeface="Arial"/>
               </a:rPr>
               <a:t>Z22 PCS1: pass (green) vs rejected (red)</a:t>
             </a:r>
-            <a:endParaRPr sz="1100" i="1">
-              <a:solidFill>
-                <a:srgbClr val="666666"/>
-              </a:solidFill>
-              <a:latin typeface="Arial" panose="020B0604020202090204"/>
-            </a:endParaRPr>
           </a:p>
         </p:txBody>
       </p:sp>
@@ -7558,7 +7198,7 @@
 </file>
 
 <file path=ppt/slides/slide8.xml><?xml version="1.0" encoding="utf-8"?>
-<p:sld xmlns:a="http://schemas.openxmlformats.org/drawingml/2006/main" xmlns:r="http://schemas.openxmlformats.org/officeDocument/2006/relationships" xmlns:p="http://schemas.openxmlformats.org/presentationml/2006/main">
+<p:sld xmlns:a="http://schemas.openxmlformats.org/drawingml/2006/main" xmlns:p="http://schemas.openxmlformats.org/presentationml/2006/main" xmlns:r="http://schemas.openxmlformats.org/officeDocument/2006/relationships">
   <p:cSld>
     <p:spTree>
       <p:nvGrpSpPr>
@@ -7594,16 +7234,10 @@
                 <a:solidFill>
                   <a:srgbClr val="1F3864"/>
                 </a:solidFill>
-                <a:latin typeface="Arial" panose="020B0604020202090204"/>
+                <a:latin typeface="Arial"/>
               </a:rPr>
-              <a:t>Quality cut 2: τ_rise ≤ 0.3 ms — against slow baseline drift</a:t>
-            </a:r>
-            <a:endParaRPr sz="2700" b="1">
-              <a:solidFill>
-                <a:srgbClr val="1F3864"/>
-              </a:solidFill>
-              <a:latin typeface="Arial" panose="020B0604020202090204"/>
-            </a:endParaRPr>
+              <a:t>Follow-up 1 — the slow-fall tail is a one-channel artifact</a:t>
+            </a:r>
           </a:p>
         </p:txBody>
       </p:sp>
@@ -7659,7 +7293,7 @@
         <p:spPr>
           <a:xfrm>
             <a:off x="502920" y="1097280"/>
-            <a:ext cx="11247120" cy="1600200"/>
+            <a:ext cx="11247120" cy="1417320"/>
           </a:xfrm>
           <a:prstGeom prst="rect">
             <a:avLst/>
@@ -7682,16 +7316,10 @@
                 <a:solidFill>
                   <a:srgbClr val="333333"/>
                 </a:solidFill>
-                <a:latin typeface="Arial" panose="020B0604020202090204"/>
+                <a:latin typeface="Arial"/>
               </a:rPr>
-              <a:t>• On noisy-window detectors a smooth, slow baseline drift can survive the NRMSE cut — a slow 2-exp hugs it with a small residual</a:t>
-            </a:r>
-            <a:endParaRPr sz="1400">
-              <a:solidFill>
-                <a:srgbClr val="333333"/>
-              </a:solidFill>
-              <a:latin typeface="Arial" panose="020B0604020202090204"/>
-            </a:endParaRPr>
+              <a:t>• The post-cut fan still shows slow-fall tails → sample them: NRMSE ≤ 0.4 AND τ_fall &gt; 1.5 ms (reference channel PDS2), 10 random events, raw vs fit drawn in all 12 channels</a:t>
+            </a:r>
           </a:p>
           <a:p>
             <a:pPr>
@@ -7704,16 +7332,10 @@
                 <a:solidFill>
                   <a:srgbClr val="333333"/>
                 </a:solidFill>
-                <a:latin typeface="Arial" panose="020B0604020202090204"/>
+                <a:latin typeface="Arial"/>
               </a:rPr>
-              <a:t>• The fast-pulse population sits at τ_rise ≈ 0.1 ms (p90 ≈ 0.15 ms) — cleanly separated from the drift tail, so a 0.3 ms ceiling removes the leakage</a:t>
-            </a:r>
-            <a:endParaRPr sz="1400">
-              <a:solidFill>
-                <a:srgbClr val="333333"/>
-              </a:solidFill>
-              <a:latin typeface="Arial" panose="020B0604020202090204"/>
-            </a:endParaRPr>
+              <a:t>• The same events are normal fast pulses in the other 11 channels — only PDS2 swings (τ_fall median 0.51 ms vs ≈ 0.25 ms elsewhere): a channel-specific low-frequency disturbance</a:t>
+            </a:r>
           </a:p>
           <a:p>
             <a:pPr>
@@ -7726,37 +7348,31 @@
                 <a:solidFill>
                   <a:srgbClr val="333333"/>
                 </a:solidFill>
-                <a:latin typeface="Arial" panose="020B0604020202090204"/>
+                <a:latin typeface="Arial"/>
               </a:rPr>
-              <a:t>• Cost ≈ 2–5% of signal on quiet detectors; known trade-off: it also trims the small population of genuine slow-rise pulses (final decision pending)</a:t>
-            </a:r>
-            <a:endParaRPr sz="1400">
-              <a:solidFill>
-                <a:srgbClr val="333333"/>
-              </a:solidFill>
-              <a:latin typeface="Arial" panose="020B0604020202090204"/>
-            </a:endParaRPr>
+              <a:t>• Conclusion: artifact, not physics → no τ_fall cut</a:t>
+            </a:r>
           </a:p>
         </p:txBody>
       </p:sp>
       <p:pic>
         <p:nvPicPr>
-          <p:cNvPr id="5" name="Picture 4" descr="time_constants_zip7_PAS1.png"/>
+          <p:cNvPr id="5" name="Picture 4" descr="slow_fall_zip7_crop.png"/>
           <p:cNvPicPr>
             <a:picLocks noChangeAspect="1"/>
           </p:cNvPicPr>
           <p:nvPr/>
         </p:nvPicPr>
         <p:blipFill>
-          <a:blip r:embed="rId1"/>
+          <a:blip r:embed="rId2"/>
           <a:stretch>
             <a:fillRect/>
           </a:stretch>
         </p:blipFill>
         <p:spPr>
           <a:xfrm>
-            <a:off x="1280160" y="2880360"/>
-            <a:ext cx="9601200" cy="1851803"/>
+            <a:off x="411480" y="2651760"/>
+            <a:ext cx="6675120" cy="3432048"/>
           </a:xfrm>
           <a:prstGeom prst="rect">
             <a:avLst/>
@@ -7771,8 +7387,8 @@
         </p:nvSpPr>
         <p:spPr>
           <a:xfrm>
-            <a:off x="1280160" y="4762163"/>
-            <a:ext cx="9601200" cy="274320"/>
+            <a:off x="411480" y="6113808"/>
+            <a:ext cx="6675120" cy="274320"/>
           </a:xfrm>
           <a:prstGeom prst="rect">
             <a:avLst/>
@@ -7791,29 +7407,47 @@
                 <a:solidFill>
                   <a:srgbClr val="666666"/>
                 </a:solidFill>
-                <a:latin typeface="Arial" panose="020B0604020202090204"/>
+                <a:latin typeface="Arial"/>
               </a:rPr>
-              <a:t>Z7 PAS1: fitted τ_rise (median 0.105 ms) and τ_fall distributions</a:t>
-            </a:r>
-            <a:endParaRPr sz="1100" i="1">
-              <a:solidFill>
-                <a:srgbClr val="666666"/>
-              </a:solidFill>
-              <a:latin typeface="Arial" panose="020B0604020202090204"/>
-            </a:endParaRPr>
-          </a:p>
-        </p:txBody>
-      </p:sp>
-      <p:sp>
-        <p:nvSpPr>
-          <p:cNvPr id="7" name="TextBox 6"/>
+              <a:t>Z7, 3 of the sampled slow-fall events: normal pulses in PBS2/PCS2/PES2, low-frequency swings only in PDS2</a:t>
+            </a:r>
+          </a:p>
+        </p:txBody>
+      </p:sp>
+      <p:pic>
+        <p:nvPicPr>
+          <p:cNvPr id="7" name="Picture 6" descr="time_constants_zip7_PDS2.png"/>
+          <p:cNvPicPr>
+            <a:picLocks noChangeAspect="1"/>
+          </p:cNvPicPr>
+          <p:nvPr/>
+        </p:nvPicPr>
+        <p:blipFill>
+          <a:blip r:embed="rId3"/>
+          <a:stretch>
+            <a:fillRect/>
+          </a:stretch>
+        </p:blipFill>
+        <p:spPr>
+          <a:xfrm>
+            <a:off x="7315200" y="3291840"/>
+            <a:ext cx="4663440" cy="896188"/>
+          </a:xfrm>
+          <a:prstGeom prst="rect">
+            <a:avLst/>
+          </a:prstGeom>
+        </p:spPr>
+      </p:pic>
+      <p:sp>
+        <p:nvSpPr>
+          <p:cNvPr id="8" name="TextBox 7"/>
           <p:cNvSpPr txBox="1"/>
           <p:nvPr/>
         </p:nvSpPr>
         <p:spPr>
           <a:xfrm>
-            <a:off x="1280160" y="5257800"/>
-            <a:ext cx="9601200" cy="914400"/>
+            <a:off x="7315200" y="4218028"/>
+            <a:ext cx="4663440" cy="274320"/>
           </a:xfrm>
           <a:prstGeom prst="rect">
             <a:avLst/>
@@ -7826,26 +7460,16 @@
           </a:bodyPr>
           <a:lstStyle/>
           <a:p>
-            <a:pPr>
-              <a:spcAft>
-                <a:spcPts val="500"/>
-              </a:spcAft>
-            </a:pPr>
-            <a:r>
-              <a:rPr sz="1300">
-                <a:solidFill>
-                  <a:srgbClr val="333333"/>
-                </a:solidFill>
-                <a:latin typeface="Arial" panose="020B0604020202090204"/>
+            <a:pPr algn="ctr"/>
+            <a:r>
+              <a:rPr sz="1100" i="1">
+                <a:solidFill>
+                  <a:srgbClr val="666666"/>
+                </a:solidFill>
+                <a:latin typeface="Arial"/>
               </a:rPr>
-              <a:t>• On quiet detectors both τ_rise and τ_fall distributions are narrow — the pulse shape is stable across events</a:t>
-            </a:r>
-            <a:endParaRPr sz="1300">
-              <a:solidFill>
-                <a:srgbClr val="333333"/>
-              </a:solidFill>
-              <a:latin typeface="Arial" panose="020B0604020202090204"/>
-            </a:endParaRPr>
+              <a:t>Z7 PDS2: broad τ_fall tail — the artifact in the distributions</a:t>
+            </a:r>
           </a:p>
         </p:txBody>
       </p:sp>
@@ -7858,7 +7482,7 @@
 </file>
 
 <file path=ppt/slides/slide9.xml><?xml version="1.0" encoding="utf-8"?>
-<p:sld xmlns:a="http://schemas.openxmlformats.org/drawingml/2006/main" xmlns:r="http://schemas.openxmlformats.org/officeDocument/2006/relationships" xmlns:p="http://schemas.openxmlformats.org/presentationml/2006/main">
+<p:sld xmlns:a="http://schemas.openxmlformats.org/drawingml/2006/main" xmlns:p="http://schemas.openxmlformats.org/presentationml/2006/main" xmlns:r="http://schemas.openxmlformats.org/officeDocument/2006/relationships">
   <p:cSld>
     <p:spTree>
       <p:nvGrpSpPr>
@@ -7894,16 +7518,10 @@
                 <a:solidFill>
                   <a:srgbClr val="1F3864"/>
                 </a:solidFill>
-                <a:latin typeface="Arial" panose="020B0604020202090204"/>
+                <a:latin typeface="Arial"/>
               </a:rPr>
-              <a:t>A genuine slow-pulse population (“shadow” events)</a:t>
-            </a:r>
-            <a:endParaRPr sz="2700" b="1">
-              <a:solidFill>
-                <a:srgbClr val="1F3864"/>
-              </a:solidFill>
-              <a:latin typeface="Arial" panose="020B0604020202090204"/>
-            </a:endParaRPr>
+              <a:t>Follow-up 2 — genuine slow-rise pulses (“shadow” events)</a:t>
+            </a:r>
           </a:p>
         </p:txBody>
       </p:sp>
@@ -7982,16 +7600,10 @@
                 <a:solidFill>
                   <a:srgbClr val="333333"/>
                 </a:solidFill>
-                <a:latin typeface="Arial" panose="020B0604020202090204"/>
+                <a:latin typeface="Arial"/>
               </a:rPr>
-              <a:t>• Selection: well-fit (median NRMSE ≤ 0.4) AND slow (median τ_rise &gt; 0.2 ms) — raw traces show real pulses, not noise</a:t>
-            </a:r>
-            <a:endParaRPr sz="1400">
-              <a:solidFill>
-                <a:srgbClr val="333333"/>
-              </a:solidFill>
-              <a:latin typeface="Arial" panose="020B0604020202090204"/>
-            </a:endParaRPr>
+              <a:t>• Same sampling recipe on the rise side: median NRMSE ≤ 0.4 AND median τ_rise &gt; 0.2 ms → the raw traces show real pulses — onset aligned, peak late, consistent across channels</a:t>
+            </a:r>
           </a:p>
           <a:p>
             <a:pPr>
@@ -8004,16 +7616,10 @@
                 <a:solidFill>
                   <a:srgbClr val="333333"/>
                 </a:solidFill>
-                <a:latin typeface="Arial" panose="020B0604020202090204"/>
+                <a:latin typeface="Arial"/>
               </a:rPr>
-              <a:t>• They are the faint displaced bundle seen in the aligned overlays — real shape variation (candidate surface/bulk effect)</a:t>
-            </a:r>
-            <a:endParaRPr sz="1400">
-              <a:solidFill>
-                <a:srgbClr val="333333"/>
-              </a:solidFill>
-              <a:latin typeface="Arial" panose="020B0604020202090204"/>
-            </a:endParaRPr>
+              <a:t>• They are the faint displaced bundle in the aligned overlays — a genuine second pulse shape (candidate surface/bulk effect, not settled)</a:t>
+            </a:r>
           </a:p>
           <a:p>
             <a:pPr>
@@ -8026,16 +7632,10 @@
                 <a:solidFill>
                   <a:srgbClr val="333333"/>
                 </a:solidFill>
-                <a:latin typeface="Arial" panose="020B0604020202090204"/>
+                <a:latin typeface="Arial"/>
               </a:rPr>
-              <a:t>• Exactly the kind of shape variation the multi-template NxM method is built to capture</a:t>
-            </a:r>
-            <a:endParaRPr sz="1400">
-              <a:solidFill>
-                <a:srgbClr val="333333"/>
-              </a:solidFill>
-              <a:latin typeface="Arial" panose="020B0604020202090204"/>
-            </a:endParaRPr>
+              <a:t>• Real physics → cannot simply be cut away; exactly the shape variation the multi-template NxM method is built to capture</a:t>
+            </a:r>
           </a:p>
         </p:txBody>
       </p:sp>
@@ -8048,7 +7648,7 @@
           <p:nvPr/>
         </p:nvPicPr>
         <p:blipFill>
-          <a:blip r:embed="rId1"/>
+          <a:blip r:embed="rId2"/>
           <a:stretch>
             <a:fillRect/>
           </a:stretch>
@@ -8091,16 +7691,10 @@
                 <a:solidFill>
                   <a:srgbClr val="666666"/>
                 </a:solidFill>
-                <a:latin typeface="Arial" panose="020B0604020202090204"/>
+                <a:latin typeface="Arial"/>
               </a:rPr>
               <a:t>Z7 shadow events (first 4 channels): raw (gray) / LP (blue) / fit (red) — genuine slow pulses, onset aligned, peak late</a:t>
             </a:r>
-            <a:endParaRPr sz="1100" i="1">
-              <a:solidFill>
-                <a:srgbClr val="666666"/>
-              </a:solidFill>
-              <a:latin typeface="Arial" panose="020B0604020202090204"/>
-            </a:endParaRPr>
           </a:p>
         </p:txBody>
       </p:sp>
@@ -8428,11 +8022,7 @@
       </a:style>
     </a:lnDef>
   </a:objectDefaults>
-  <a:extLst>
-    <a:ext uri="{05A4C25C-085E-4340-85A3-A5531E510DB2}">
-      <thm15:themeFamily xmlns:thm15="http://schemas.microsoft.com/office/thememl/2012/main" name="Office Theme" id="{62F939B6-93AF-4DB8-9C6B-D6C7DFDC589F}" vid="{4A3C46E8-61CC-4603-A589-7422A47A8E4A}"/>
-    </a:ext>
-  </a:extLst>
+  <a:extraClrSchemeLst/>
 </a:theme>
 </file>
 
@@ -8752,10 +8342,6 @@
       </a:style>
     </a:lnDef>
   </a:objectDefaults>
-  <a:extLst>
-    <a:ext uri="{05A4C25C-085E-4340-85A3-A5531E510DB2}">
-      <thm15:themeFamily xmlns:thm15="http://schemas.microsoft.com/office/thememl/2012/main" name="Office Theme" id="{62F939B6-93AF-4DB8-9C6B-D6C7DFDC589F}" vid="{4A3C46E8-61CC-4603-A589-7422A47A8E4A}"/>
-    </a:ext>
-  </a:extLst>
+  <a:extraClrSchemeLst/>
 </a:theme>
 </file>
</xml_diff>

<commit_message>
snolab: presentation — slide 8 conclusion restated in two layers: sampled slow-fall events are real pulses (kept, no fall cut); the extreme tail is the PDS2 one-channel artifact
Co-Authored-By: Claude Opus 4.8 <noreply@anthropic.com>
</commit_message>
<xml_diff>
--- a/snolab/presentation/SNOLAB_R4_pulse_templates_20260715.pptx
+++ b/snolab/presentation/SNOLAB_R4_pulse_templates_20260715.pptx
@@ -1284,7 +1284,7 @@
           <a:lstStyle/>
           <a:p>
             <a:r>
-              <a:t>The first lead comes from the fan plot after the cut: some curves still fall very slowly. We chased it with the same recipe: among events passing the cut, take fall times above one point five milliseconds, randomly sample ten, and draw raw versus fit in every channel. The result is clean: in the other eleven channels these events are perfectly normal fast pulses - only PDS2, one single channel, is swinging wildly. So it's not the event that's slow, it's that one channel's low-frequency disturbance. Conclusion: no fall cut is needed - artifact, not physics.</a:t>
+              <a:t>The first lead comes from the fan plot after the cut: some curves still fall very slowly. We chased it by sampling: among events passing the cut, take fall times above one point five milliseconds, randomly sample ten, and draw raw versus fit in every channel. Two findings. First, the sampled events are real pulses - so they stay in, and we apply no fall cut. Second, their extreme fall times all trace back to one channel: only PDS2 is swinging wildly, while the same events are normal fast pulses in the other eleven channels - so the extreme tail is a one-channel low-frequency artifact, not slow physics.</a:t>
             </a:r>
           </a:p>
         </p:txBody>
@@ -7318,7 +7318,7 @@
                 </a:solidFill>
                 <a:latin typeface="Arial"/>
               </a:rPr>
-              <a:t>• The post-cut fan still shows slow-fall tails → sample them: NRMSE ≤ 0.4 AND τ_fall &gt; 1.5 ms (reference channel PDS2), 10 random events, raw vs fit drawn in all 12 channels</a:t>
+              <a:t>• The post-cut fan still shows slow-fall tails → sample them: NRMSE ≤ 0.4 AND τ_fall &gt; 1.5 ms, 10 random events, raw vs fit drawn in all 12 channels</a:t>
             </a:r>
           </a:p>
           <a:p>
@@ -7334,7 +7334,7 @@
                 </a:solidFill>
                 <a:latin typeface="Arial"/>
               </a:rPr>
-              <a:t>• The same events are normal fast pulses in the other 11 channels — only PDS2 swings (τ_fall median 0.51 ms vs ≈ 0.25 ms elsewhere): a channel-specific low-frequency disturbance</a:t>
+              <a:t>• The sampled events are real pulses → kept. Their extreme fall times trace to one channel: only PDS2 swings (τ_fall median 0.51 ms vs ≈ 0.25 ms elsewhere) — a low-frequency disturbance</a:t>
             </a:r>
           </a:p>
           <a:p>
@@ -7350,7 +7350,7 @@
                 </a:solidFill>
                 <a:latin typeface="Arial"/>
               </a:rPr>
-              <a:t>• Conclusion: artifact, not physics → no τ_fall cut</a:t>
+              <a:t>• Conclusion: no τ_fall cut — slow-fall events passing NRMSE stay in; the extreme tail is a one-channel artifact, not physics</a:t>
             </a:r>
           </a:p>
         </p:txBody>

</xml_diff>

<commit_message>
snolab: presentation — enlarge slide 7 fan-cut (vertical stretch) and slide 8 PDS2 t_fall panel; speech 7 explains the three-layer fan-cut figure with Z22 numbers
Co-Authored-By: Claude Opus 4.8 <noreply@anthropic.com>
</commit_message>
<xml_diff>
--- a/snolab/presentation/SNOLAB_R4_pulse_templates_20260715.pptx
+++ b/snolab/presentation/SNOLAB_R4_pulse_templates_20260715.pptx
@@ -7146,8 +7146,8 @@
         </p:blipFill>
         <p:spPr>
           <a:xfrm>
-            <a:off x="6126480" y="3108960"/>
-            <a:ext cx="5760720" cy="1479697"/>
+            <a:off x="6126480" y="2651760"/>
+            <a:ext cx="5760720" cy="3383280"/>
           </a:xfrm>
           <a:prstGeom prst="rect">
             <a:avLst/>
@@ -7162,7 +7162,7 @@
         </p:nvSpPr>
         <p:spPr>
           <a:xfrm>
-            <a:off x="6126480" y="4618657"/>
+            <a:off x="6126480" y="6065040"/>
             <a:ext cx="5760720" cy="274320"/>
           </a:xfrm>
           <a:prstGeom prst="rect">
@@ -7184,7 +7184,7 @@
                 </a:solidFill>
                 <a:latin typeface="Arial"/>
               </a:rPr>
-              <a:t>Z22 PCS1: pass (green) vs rejected (red)</a:t>
+              <a:t>Z22 PCS1: pass (green) vs rejected (red) — vertically stretched for visibility</a:t>
             </a:r>
           </a:p>
         </p:txBody>
@@ -7416,7 +7416,7 @@
       </p:sp>
       <p:pic>
         <p:nvPicPr>
-          <p:cNvPr id="7" name="Picture 6" descr="time_constants_zip7_PDS2.png"/>
+          <p:cNvPr id="7" name="Picture 6" descr="time_constants_zip7_PDS2_tfall.png"/>
           <p:cNvPicPr>
             <a:picLocks noChangeAspect="1"/>
           </p:cNvPicPr>
@@ -7430,8 +7430,8 @@
         </p:blipFill>
         <p:spPr>
           <a:xfrm>
-            <a:off x="7315200" y="3291840"/>
-            <a:ext cx="4663440" cy="896188"/>
+            <a:off x="7315200" y="2834640"/>
+            <a:ext cx="4663440" cy="2926080"/>
           </a:xfrm>
           <a:prstGeom prst="rect">
             <a:avLst/>
@@ -7446,7 +7446,7 @@
         </p:nvSpPr>
         <p:spPr>
           <a:xfrm>
-            <a:off x="7315200" y="4218028"/>
+            <a:off x="7315200" y="5790720"/>
             <a:ext cx="4663440" cy="274320"/>
           </a:xfrm>
           <a:prstGeom prst="rect">
@@ -7468,7 +7468,7 @@
                 </a:solidFill>
                 <a:latin typeface="Arial"/>
               </a:rPr>
-              <a:t>Z7 PDS2: broad τ_fall tail — the artifact in the distributions</a:t>
+              <a:t>Z7 PDS2, fitted τ_fall: broad tail (median 0.51 ms) — the artifact in the distributions</a:t>
             </a:r>
           </a:p>
         </p:txBody>

</xml_diff>

<commit_message>
snolab: presentation — slide 2: attribute the K-line marking to Prof. Saab (TS in the plot legends); state the x/1.35 window as a rough eyeballed choice
Co-Authored-By: Claude Opus 4.8 <noreply@anthropic.com>
</commit_message>
<xml_diff>
--- a/snolab/presentation/SNOLAB_R4_pulse_templates_20260715.pptx
+++ b/snolab/presentation/SNOLAB_R4_pulse_templates_20260715.pptx
@@ -864,7 +864,7 @@
           <a:lstStyle/>
           <a:p>
             <a:r>
-              <a:t>Everything starts from the Ge activation data. After Cf activation every detector shows the 10.37 keV K-line. The ops-shift study located the K-line position in the PTOFamps spectrum of each detector - that is the red line in every panel here. Our event selection is exactly one condition: a window around the red line, a factor 1.35 both ways, and nothing else. For each selected event we cache the fully unprocessed raw MIDAS traces of all channels. You can already see on the weak detectors that the window will admit part of the noise-trigger population next to the K-line - that is intentional: the cache is raw, so every later cut stays explicit and reversible.</a:t>
+              <a:t>Everything starts from the Ge activation data. After Cf activation every detector shows the 10.37 keV K-line. Professor Saab's study located the K-line position in the PTOFamps spectrum of each detector - that is the red line in every panel here. Our event selection is exactly one condition: a window around the red line, a factor 1.35 both ways - a rough, eyeballed choice - and nothing else. For each selected event we cache the fully unprocessed raw MIDAS traces of all channels. You can already see on the weak detectors that the window will admit part of the noise-trigger population next to the K-line - that is intentional: the cache is raw, so every later cut stays explicit and reversible.</a:t>
             </a:r>
           </a:p>
         </p:txBody>
@@ -5586,7 +5586,7 @@
                 </a:solidFill>
                 <a:latin typeface="Arial"/>
               </a:rPr>
-              <a:t>• Per detector, the ops-shift study marked the 10.37 keV K-line position in PTOFamps — the red line in each panel below</a:t>
+              <a:t>• Per detector, Prof. Saab's study marked the 10.37 keV K-line position in PTOFamps — the red line in each panel below</a:t>
             </a:r>
           </a:p>
           <a:p>
@@ -5602,7 +5602,7 @@
                 </a:solidFill>
                 <a:latin typeface="Arial"/>
               </a:rPr>
-              <a:t>• Our event selection: a PTOFamps window bracketing the red line (position ×/÷ 1.35) — deliberately minimal, no other cuts</a:t>
+              <a:t>• Our event selection: a PTOFamps window bracketing the red line — position ×/÷ 1.35, a rough, somewhat arbitrary eyeballed choice; deliberately minimal, no other cuts</a:t>
             </a:r>
           </a:p>
           <a:p>
@@ -5693,7 +5693,7 @@
                 </a:solidFill>
                 <a:latin typeface="Arial"/>
               </a:rPr>
-              <a:t>All 13 detectors, PTOFamps spectra (ops-shift study): red line = fitted mean of the 10.37 keV K-line. Selection window per detector = red-line position ×/÷ 1.35.</a:t>
+              <a:t>All 13 detectors, PTOFamps spectra (Prof. Saab's study): red line = fitted mean of the 10.37 keV K-line. Selection window per detector = red-line position ×/÷ 1.35.</a:t>
             </a:r>
           </a:p>
         </p:txBody>

</xml_diff>

<commit_message>
snolab: presentation — slide 2: credit box (Prof. Tarek Saab, Confluence link); trim bullet 4 and the montage caption
Co-Authored-By: Claude Opus 4.8 <noreply@anthropic.com>
</commit_message>
<xml_diff>
--- a/snolab/presentation/SNOLAB_R4_pulse_templates_20260715.pptx
+++ b/snolab/presentation/SNOLAB_R4_pulse_templates_20260715.pptx
@@ -5634,21 +5634,69 @@
                 </a:solidFill>
                 <a:latin typeface="Arial"/>
               </a:rPr>
-              <a:t>• 13 detectors (zips) × 27–30 series → ~120 GB raw cache; every later cut stays explicit and reversible</a:t>
+              <a:t>• 13 detectors (zips) × 27–30 series → ~120 GB raw cache</a:t>
+            </a:r>
+          </a:p>
+        </p:txBody>
+      </p:sp>
+      <p:sp>
+        <p:nvSpPr>
+          <p:cNvPr id="5" name="TextBox 4"/>
+          <p:cNvSpPr txBox="1"/>
+          <p:nvPr/>
+        </p:nvSpPr>
+        <p:spPr>
+          <a:xfrm>
+            <a:off x="8549640" y="274320"/>
+            <a:ext cx="3200400" cy="658368"/>
+          </a:xfrm>
+          <a:prstGeom prst="rect">
+            <a:avLst/>
+          </a:prstGeom>
+          <a:noFill/>
+        </p:spPr>
+        <p:txBody>
+          <a:bodyPr wrap="square">
+            <a:spAutoFit/>
+          </a:bodyPr>
+          <a:lstStyle/>
+          <a:p>
+            <a:pPr algn="r"/>
+            <a:r>
+              <a:rPr sz="1000">
+                <a:solidFill>
+                  <a:srgbClr val="666666"/>
+                </a:solidFill>
+                <a:latin typeface="Arial"/>
+              </a:rPr>
+              <a:t>Data: Ge Activation Data — Ops Shift 260612</a:t>
+            </a:r>
+          </a:p>
+          <a:p>
+            <a:pPr algn="r"/>
+            <a:r>
+              <a:rPr sz="1000">
+                <a:solidFill>
+                  <a:srgbClr val="666666"/>
+                </a:solidFill>
+                <a:latin typeface="Arial"/>
+                <a:hlinkClick r:id="rId2"/>
+              </a:rPr>
+              <a:t>Credit: Prof. Tarek Saab  ·  SuperCDMS Confluence</a:t>
             </a:r>
           </a:p>
         </p:txBody>
       </p:sp>
       <p:pic>
         <p:nvPicPr>
-          <p:cNvPr id="5" name="Picture 4" descr="kline_all_zips.png"/>
+          <p:cNvPr id="6" name="Picture 5" descr="kline_all_zips.png"/>
           <p:cNvPicPr>
             <a:picLocks noChangeAspect="1"/>
           </p:cNvPicPr>
           <p:nvPr/>
         </p:nvPicPr>
         <p:blipFill>
-          <a:blip r:embed="rId2"/>
+          <a:blip r:embed="rId3"/>
           <a:stretch>
             <a:fillRect/>
           </a:stretch>
@@ -5665,7 +5713,7 @@
       </p:pic>
       <p:sp>
         <p:nvSpPr>
-          <p:cNvPr id="6" name="TextBox 5"/>
+          <p:cNvPr id="7" name="TextBox 6"/>
           <p:cNvSpPr txBox="1"/>
           <p:nvPr/>
         </p:nvSpPr>
@@ -5693,7 +5741,7 @@
                 </a:solidFill>
                 <a:latin typeface="Arial"/>
               </a:rPr>
-              <a:t>All 13 detectors, PTOFamps spectra (Prof. Saab's study): red line = fitted mean of the 10.37 keV K-line. Selection window per detector = red-line position ×/÷ 1.35.</a:t>
+              <a:t>All 13 detectors, PTOFamps spectra (Prof. Saab's study)</a:t>
             </a:r>
           </a:p>
         </p:txBody>

</xml_diff>

<commit_message>
snolab: presentation — slide 3 rework: bold step labels, trimmed details, onset->pretrigger everywhere (slides+speech), red note removed, fans zoomed to the pulse region and enlarged
Co-Authored-By: Claude Opus 4.8 <noreply@anthropic.com>
</commit_message>
<xml_diff>
--- a/snolab/presentation/SNOLAB_R4_pulse_templates_20260715.pptx
+++ b/snolab/presentation/SNOLAB_R4_pulse_templates_20260715.pptx
@@ -654,7 +654,7 @@
           <a:lstStyle/>
           <a:p>
             <a:r>
-              <a:t>First template family: the analytic one. For each channel we take every physical fitted curve at the common onset and average them with a weight of one over NRMSE squared - badly fit events count less but nothing is excluded by hand. After the cuts, shown here, a single tight shape family remains, and its weighted mean is the 1x1 template - smooth and noise-free by construction because it is built from analytic curves, delivered as peak-normalized ROOT histograms.</a:t>
+              <a:t>First template family: the analytic one. For each channel we take every physical fitted curve at the common pretrigger and average them with a weight of one over NRMSE squared - badly fit events count less but nothing is excluded by hand. After the cuts, shown here, a single tight shape family remains, and its weighted mean is the 1x1 template - smooth and noise-free by construction because it is built from analytic curves, delivered as peak-normalized ROOT histograms.</a:t>
             </a:r>
           </a:p>
         </p:txBody>
@@ -934,7 +934,7 @@
           <a:lstStyle/>
           <a:p>
             <a:r>
-              <a:t>The per-trace algorithm, five steps. Low-pass at 100 kilohertz, baseline subtraction, peak normalization, then a two-exponential fit where all five parameters are free, including the pulse onset. The onset is never pinned: real trigger times vary, and the fitted onsets cluster about 230 samples after the nominal pretrigger - pinning it would bias the time constants. Each fit records a physicality flag and an NRMSE; no cut yet. Finally the measured trace is aligned by shifting it by the fitted onset - a pure translation. The two fan plots show the output of the fit step: every fitted curve drawn at the common onset, peak-normalized. On the left, all physical fits - you can see slow components spreading off the main bundle. On the right, after the NRMSE cut, a single tight shape family remains. Where that cut comes from is the next part of the talk.</a:t>
+              <a:t>The per-trace algorithm, five steps. First a low-pass filter to smooth away the high-frequency noise, then the baseline is subtracted and the trace is scaled to unit peak - without that normalization the traces could not be overlaid or compared. The core is the fit: a two-exponential function, one exponential for the rise and one for the fall, with all five parameters free, including the pretrigger - the pulse start time. The pretrigger is never pinned: real trigger times vary, and the fitted pretriggers cluster about 230 samples after the nominal value - pinning it would bias the time constants. Each fit records two quality numbers: fit_ok, a physicality check - positive amplitude, rise faster than fall - and the NRMSE, the normalized root-mean-square error, the fit residual divided by the pulse height. At this stage we only record them. Finally the measured trace is aligned by shifting it by the fitted pretrigger minus 16050. The two fan plots show the output of the fit step: every fitted curve drawn at the common pretrigger, peak-normalized. On the left, all physical fits - you can see stragglers spreading off the main bundle. On the right, after the NRMSE cut, a single tight shape family remains. Where that cut comes from is the next part of the talk.</a:t>
             </a:r>
           </a:p>
         </p:txBody>
@@ -1354,7 +1354,7 @@
           <a:lstStyle/>
           <a:p>
             <a:r>
-              <a:t>The second lead is the slow rise. Same recipe: take events that fit well - NRMSE fine - but whose median rise time is above zero point two milliseconds, sample them, look at the raw traces. This time the conclusion is the opposite: these are real pulses. Onset aligned, peak arriving late, consistent across all channels - they are exactly the shadow from the alignment plot. So the slow rise cannot simply be cut away: there is real physics in it, possibly related to where in the crystal the event happens; that is not settled yet.</a:t>
+              <a:t>The second lead is the slow rise. Same recipe: take events that fit well - NRMSE fine - but whose median rise time is above zero point two milliseconds, sample them, look at the raw traces. This time the conclusion is the opposite: these are real pulses. The pretrigger is aligned, peak arriving late, consistent across all channels - they are exactly the shadow from the alignment plot. So the slow rise cannot simply be cut away: there is real physics in it, possibly related to where in the crystal the event happens; that is not settled yet.</a:t>
             </a:r>
           </a:p>
         </p:txBody>
@@ -4855,7 +4855,7 @@
                 </a:solidFill>
                 <a:latin typeface="Arial"/>
               </a:rPr>
-              <a:t>• Per channel: weighted mean of ALL fit_ok fitted curves at the common onset, weight w = 1/max(NRMSE, 0.01)²</a:t>
+              <a:t>• Per channel: weighted mean of ALL fit_ok fitted curves at the common pretrigger, weight w = 1/max(NRMSE, 0.01)²</a:t>
             </a:r>
           </a:p>
           <a:p>
@@ -4894,7 +4894,7 @@
       </p:sp>
       <p:pic>
         <p:nvPicPr>
-          <p:cNvPr id="5" name="Picture 4" descr="fan_zip7_PBS1_nrmse.png"/>
+          <p:cNvPr id="5" name="Picture 4" descr="fan_zip7_PBS1_after.png"/>
           <p:cNvPicPr>
             <a:picLocks noChangeAspect="1"/>
           </p:cNvPicPr>
@@ -5080,7 +5080,7 @@
                 </a:solidFill>
                 <a:latin typeface="Arial"/>
               </a:rPr>
-              <a:t>• Input: fitted curves passing fit_ok + NRMSE ≤ 0.4 + τ_rise ≤ 0.3 ms, at common onset, peak-normalized (PCA window 15550–24050, ≤ 3000 curves/channel)</a:t>
+              <a:t>• Input: fitted curves passing fit_ok + NRMSE ≤ 0.4 + τ_rise ≤ 0.3 ms, at common pretrigger, peak-normalized (PCA window 15550–24050, ≤ 3000 curves/channel)</a:t>
             </a:r>
           </a:p>
           <a:p>
@@ -5793,7 +5793,7 @@
                 </a:solidFill>
                 <a:latin typeface="Arial"/>
               </a:rPr>
-              <a:t>Per-trace algorithm: low-pass → free-pretrigger fit → align</a:t>
+              <a:t>Per-trace algorithm: low-pass → fit → align</a:t>
             </a:r>
           </a:p>
         </p:txBody>
@@ -5850,7 +5850,7 @@
         <p:spPr>
           <a:xfrm>
             <a:off x="502920" y="1143000"/>
-            <a:ext cx="11247120" cy="2834640"/>
+            <a:ext cx="11247120" cy="2697480"/>
           </a:xfrm>
           <a:prstGeom prst="rect">
             <a:avLst/>
@@ -5865,159 +5865,149 @@
           <a:p>
             <a:pPr>
               <a:spcAft>
-                <a:spcPts val="500"/>
+                <a:spcPts val="700"/>
               </a:spcAft>
             </a:pPr>
             <a:r>
-              <a:rPr sz="1500">
-                <a:solidFill>
-                  <a:srgbClr val="333333"/>
+              <a:rPr sz="1600" b="1">
+                <a:solidFill>
+                  <a:srgbClr val="1F3864"/>
                 </a:solidFill>
                 <a:latin typeface="Arial"/>
               </a:rPr>
-              <a:t>• 1.  100 kHz 4th-order Butterworth low-pass (steady-state init — no filter start-up transient)</a:t>
+              <a:t>1.  Low-pass</a:t>
+            </a:r>
+            <a:r>
+              <a:rPr sz="1600">
+                <a:solidFill>
+                  <a:srgbClr val="333333"/>
+                </a:solidFill>
+                <a:latin typeface="Arial"/>
+              </a:rPr>
+              <a:t> — 100 kHz 4th-order Butterworth</a:t>
             </a:r>
           </a:p>
           <a:p>
             <a:pPr>
               <a:spcAft>
-                <a:spcPts val="500"/>
+                <a:spcPts val="700"/>
               </a:spcAft>
             </a:pPr>
             <a:r>
-              <a:rPr sz="1500">
-                <a:solidFill>
-                  <a:srgbClr val="333333"/>
+              <a:rPr sz="1600" b="1">
+                <a:solidFill>
+                  <a:srgbClr val="1F3864"/>
                 </a:solidFill>
                 <a:latin typeface="Arial"/>
               </a:rPr>
-              <a:t>• 2.  Baseline = median of samples 2000–12000, subtracted; normalize by the global trace peak</a:t>
+              <a:t>2.  Normalize</a:t>
+            </a:r>
+            <a:r>
+              <a:rPr sz="1600">
+                <a:solidFill>
+                  <a:srgbClr val="333333"/>
+                </a:solidFill>
+                <a:latin typeface="Arial"/>
+              </a:rPr>
+              <a:t> — subtract the baseline, scale the trace to unit peak</a:t>
             </a:r>
           </a:p>
           <a:p>
             <a:pPr>
               <a:spcAft>
-                <a:spcPts val="500"/>
+                <a:spcPts val="700"/>
               </a:spcAft>
             </a:pPr>
             <a:r>
-              <a:rPr sz="1500">
-                <a:solidFill>
-                  <a:srgbClr val="333333"/>
+              <a:rPr sz="1600" b="1">
+                <a:solidFill>
+                  <a:srgbClr val="1F3864"/>
                 </a:solidFill>
                 <a:latin typeface="Arial"/>
               </a:rPr>
-              <a:t>• 3.  Two-exponential fit — all 5 parameters free, including the onset:</a:t>
+              <a:t>3.  Fit</a:t>
+            </a:r>
+            <a:r>
+              <a:rPr sz="1600">
+                <a:solidFill>
+                  <a:srgbClr val="333333"/>
+                </a:solidFill>
+                <a:latin typeface="Arial"/>
+              </a:rPr>
+              <a:t> — two-exponential, all 5 parameters free, including the pretrigger offset:</a:t>
             </a:r>
           </a:p>
           <a:p>
             <a:pPr lvl="1">
               <a:spcAft>
-                <a:spcPts val="500"/>
+                <a:spcPts val="700"/>
               </a:spcAft>
             </a:pPr>
             <a:r>
-              <a:rPr sz="1300">
+              <a:rPr sz="1400">
                 <a:solidFill>
                   <a:srgbClr val="666666"/>
                 </a:solidFill>
                 <a:latin typeface="Arial"/>
               </a:rPr>
-              <a:t>– y(t) = A·[exp(−(t−t₀)/τ_fall) − exp(−(t−t₀)/τ_rise)] + b,   t₀ ∈ 16050 ± 3000 samples</a:t>
-            </a:r>
-          </a:p>
-          <a:p>
-            <a:pPr lvl="1">
+              <a:t>        y(t) = A·[exp(−(t−t₀)/τ_fall) − exp(−(t−t₀)/τ_rise)] + b,    t₀ = pretrigger ∈ 16050 ± 3000 samples</a:t>
+            </a:r>
+          </a:p>
+          <a:p>
+            <a:pPr>
               <a:spcAft>
-                <a:spcPts val="500"/>
+                <a:spcPts val="700"/>
               </a:spcAft>
             </a:pPr>
             <a:r>
-              <a:rPr sz="1300">
-                <a:solidFill>
-                  <a:srgbClr val="666666"/>
+              <a:rPr sz="1600" b="1">
+                <a:solidFill>
+                  <a:srgbClr val="1F3864"/>
                 </a:solidFill>
                 <a:latin typeface="Arial"/>
               </a:rPr>
-              <a:t>– fit window 12550–24050 (stride 4);  τ_rise ∈ [1 µs, 5 ms],  τ_fall ∈ [10 µs, 20 ms]</a:t>
+              <a:t>4.  Quality numbers</a:t>
+            </a:r>
+            <a:r>
+              <a:rPr sz="1600">
+                <a:solidFill>
+                  <a:srgbClr val="333333"/>
+                </a:solidFill>
+                <a:latin typeface="Arial"/>
+              </a:rPr>
+              <a:t> — fit_ok := A&gt;0 and 0&lt;τ_rise&lt;τ_fall;   NRMSE := RMS(residual)/fit peak</a:t>
             </a:r>
           </a:p>
           <a:p>
             <a:pPr>
               <a:spcAft>
-                <a:spcPts val="500"/>
+                <a:spcPts val="700"/>
               </a:spcAft>
             </a:pPr>
             <a:r>
-              <a:rPr sz="1500">
-                <a:solidFill>
-                  <a:srgbClr val="333333"/>
+              <a:rPr sz="1600" b="1">
+                <a:solidFill>
+                  <a:srgbClr val="1F3864"/>
                 </a:solidFill>
                 <a:latin typeface="Arial"/>
               </a:rPr>
-              <a:t>• 4.  Quality numbers — fit_ok := A&gt;0 and 0&lt;τ_rise&lt;τ_fall;  NRMSE := RMS(residual)/fit peak (recorded, no cut yet)</a:t>
-            </a:r>
-          </a:p>
-          <a:p>
-            <a:pPr>
-              <a:spcAft>
-                <a:spcPts val="500"/>
-              </a:spcAft>
-            </a:pPr>
-            <a:r>
-              <a:rPr sz="1500">
+              <a:t>5.  Align</a:t>
+            </a:r>
+            <a:r>
+              <a:rPr sz="1600">
                 <a:solidFill>
                   <a:srgbClr val="333333"/>
                 </a:solidFill>
                 <a:latin typeface="Arial"/>
               </a:rPr>
-              <a:t>• 5.  Align — shift the measured trace by (fitted onset − 16050), sub-sample interpolation: a pure translation</a:t>
-            </a:r>
-          </a:p>
-        </p:txBody>
-      </p:sp>
-      <p:sp>
-        <p:nvSpPr>
-          <p:cNvPr id="5" name="TextBox 4"/>
-          <p:cNvSpPr txBox="1"/>
-          <p:nvPr/>
-        </p:nvSpPr>
-        <p:spPr>
-          <a:xfrm>
-            <a:off x="502920" y="4005072"/>
-            <a:ext cx="11247120" cy="685800"/>
-          </a:xfrm>
-          <a:prstGeom prst="rect">
-            <a:avLst/>
-          </a:prstGeom>
-          <a:noFill/>
-        </p:spPr>
-        <p:txBody>
-          <a:bodyPr wrap="square">
-            <a:spAutoFit/>
-          </a:bodyPr>
-          <a:lstStyle/>
-          <a:p>
-            <a:pPr>
-              <a:spcAft>
-                <a:spcPts val="500"/>
-              </a:spcAft>
-            </a:pPr>
-            <a:r>
-              <a:rPr sz="1400">
-                <a:solidFill>
-                  <a:srgbClr val="C0504D"/>
-                </a:solidFill>
-                <a:latin typeface="Arial"/>
-              </a:rPr>
-              <a:t>• Why a free onset?  Real trigger times vary event-by-event — fitted onsets cluster ≈230 samples after the nominal 16050. Pinning the onset distorts every other parameter.</a:t>
+              <a:t> — shift the measured trace by (fitted pretrigger − 16050)</a:t>
             </a:r>
           </a:p>
         </p:txBody>
       </p:sp>
       <p:pic>
         <p:nvPicPr>
-          <p:cNvPr id="6" name="Picture 5" descr="fan_zip7_PBS1_before.png"/>
+          <p:cNvPr id="5" name="Picture 4" descr="fan_zip7_PBS1_before_zoom.png"/>
           <p:cNvPicPr>
             <a:picLocks noChangeAspect="1"/>
           </p:cNvPicPr>
@@ -6031,8 +6021,8 @@
         </p:blipFill>
         <p:spPr>
           <a:xfrm>
-            <a:off x="594677" y="4800600"/>
-            <a:ext cx="5302885" cy="1600200"/>
+            <a:off x="1313560" y="3977639"/>
+            <a:ext cx="4139439" cy="2468880"/>
           </a:xfrm>
           <a:prstGeom prst="rect">
             <a:avLst/>
@@ -6041,14 +6031,14 @@
       </p:pic>
       <p:sp>
         <p:nvSpPr>
-          <p:cNvPr id="7" name="TextBox 6"/>
+          <p:cNvPr id="6" name="TextBox 5"/>
           <p:cNvSpPr txBox="1"/>
           <p:nvPr/>
         </p:nvSpPr>
         <p:spPr>
           <a:xfrm>
-            <a:off x="502920" y="6430800"/>
-            <a:ext cx="5486400" cy="274320"/>
+            <a:off x="822960" y="6476519"/>
+            <a:ext cx="5120640" cy="274320"/>
           </a:xfrm>
           <a:prstGeom prst="rect">
             <a:avLst/>
@@ -6069,14 +6059,14 @@
                 </a:solidFill>
                 <a:latin typeface="Arial"/>
               </a:rPr>
-              <a:t>Fitted curves at common onset, peak-normalized — ALL fit_ok events (no cut)</a:t>
+              <a:t>All fit_ok fitted curves at the common pretrigger, peak-normalized — zoom on the pulse (Z7 PBS1, time in ms)</a:t>
             </a:r>
           </a:p>
         </p:txBody>
       </p:sp>
       <p:pic>
         <p:nvPicPr>
-          <p:cNvPr id="8" name="Picture 7" descr="fan_zip7_PBS1_nrmse.png"/>
+          <p:cNvPr id="7" name="Picture 6" descr="fan_zip7_PBS1_nrmse_zoom.png"/>
           <p:cNvPicPr>
             <a:picLocks noChangeAspect="1"/>
           </p:cNvPicPr>
@@ -6090,8 +6080,8 @@
         </p:blipFill>
         <p:spPr>
           <a:xfrm>
-            <a:off x="6355397" y="4800600"/>
-            <a:ext cx="5302885" cy="1600200"/>
+            <a:off x="6799960" y="3977639"/>
+            <a:ext cx="4139439" cy="2468880"/>
           </a:xfrm>
           <a:prstGeom prst="rect">
             <a:avLst/>
@@ -6100,14 +6090,14 @@
       </p:pic>
       <p:sp>
         <p:nvSpPr>
-          <p:cNvPr id="9" name="TextBox 8"/>
+          <p:cNvPr id="8" name="TextBox 7"/>
           <p:cNvSpPr txBox="1"/>
           <p:nvPr/>
         </p:nvSpPr>
         <p:spPr>
           <a:xfrm>
-            <a:off x="6263640" y="6430800"/>
-            <a:ext cx="5486400" cy="274320"/>
+            <a:off x="6309360" y="6476519"/>
+            <a:ext cx="5120640" cy="274320"/>
           </a:xfrm>
           <a:prstGeom prst="rect">
             <a:avLst/>
@@ -6128,7 +6118,7 @@
                 </a:solidFill>
                 <a:latin typeface="Arial"/>
               </a:rPr>
-              <a:t>Same, after NRMSE ≤ 0.4 — a single tight shape family remains (Z7 PBS1)</a:t>
+              <a:t>Same, after NRMSE ≤ 0.4 — a single tight shape family remains</a:t>
             </a:r>
           </a:p>
         </p:txBody>
@@ -6546,7 +6536,7 @@
                 </a:solidFill>
                 <a:latin typeface="Arial"/>
               </a:rPr>
-              <a:t>• All fit_ok traces shifted to the common onset (blue) + point-by-point mean (red) + NRMSE-weighted mean of the fitted curves (orange, w = 1/max(NRMSE, 0.01)²)</a:t>
+              <a:t>• All fit_ok traces shifted to the common pretrigger (blue) + point-by-point mean (red) + NRMSE-weighted mean of the fitted curves (orange, w = 1/max(NRMSE, 0.01)²)</a:t>
             </a:r>
           </a:p>
           <a:p>
@@ -7650,7 +7640,7 @@
                 </a:solidFill>
                 <a:latin typeface="Arial"/>
               </a:rPr>
-              <a:t>• Same sampling recipe on the rise side: median NRMSE ≤ 0.4 AND median τ_rise &gt; 0.2 ms → the raw traces show real pulses — onset aligned, peak late, consistent across channels</a:t>
+              <a:t>• Same sampling recipe on the rise side: median NRMSE ≤ 0.4 AND median τ_rise &gt; 0.2 ms → the raw traces show real pulses — pretrigger aligned, peak late, consistent across channels</a:t>
             </a:r>
           </a:p>
           <a:p>
@@ -7741,7 +7731,7 @@
                 </a:solidFill>
                 <a:latin typeface="Arial"/>
               </a:rPr>
-              <a:t>Z7 shadow events (first 4 channels): raw (gray) / LP (blue) / fit (red) — genuine slow pulses, onset aligned, peak late</a:t>
+              <a:t>Z7 shadow events (first 4 channels): raw (gray) / LP (blue) / fit (red) — genuine slow pulses, pretrigger aligned, peak late</a:t>
             </a:r>
           </a:p>
         </p:txBody>

</xml_diff>

<commit_message>
snolab: presentation — slide 4: remove the self-documenting-figures bullet
Co-Authored-By: Claude Opus 4.8 <noreply@anthropic.com>
</commit_message>
<xml_diff>
--- a/snolab/presentation/SNOLAB_R4_pulse_templates_20260715.pptx
+++ b/snolab/presentation/SNOLAB_R4_pulse_templates_20260715.pptx
@@ -6269,22 +6269,6 @@
                 <a:latin typeface="Arial"/>
               </a:rPr>
               <a:t>• The same event fits consistently across channels; a noise trigger fails in all channels at once</a:t>
-            </a:r>
-          </a:p>
-          <a:p>
-            <a:pPr>
-              <a:spcAft>
-                <a:spcPts val="500"/>
-              </a:spcAft>
-            </a:pPr>
-            <a:r>
-              <a:rPr sz="1400">
-                <a:solidFill>
-                  <a:srgbClr val="333333"/>
-                </a:solidFill>
-                <a:latin typeface="Arial"/>
-              </a:rPr>
-              <a:t>• Every figure carries its full processing chain in the header → self-documenting</a:t>
             </a:r>
           </a:p>
         </p:txBody>

</xml_diff>

<commit_message>
snolab: presentation — delete the alignment-overlay slide (per Prof. Saab); rename shadow -> echo-trigger everywhere; weak -> noisy detectors on the NRMSE-cut slide. Deck now 12 slides
Co-Authored-By: Claude Opus 4.8 <noreply@anthropic.com>
</commit_message>
<xml_diff>
--- a/snolab/presentation/SNOLAB_R4_pulse_templates_20260715.pptx
+++ b/snolab/presentation/SNOLAB_R4_pulse_templates_20260715.pptx
@@ -17,7 +17,6 @@
     <p:sldId id="265" r:id="rId17"/>
     <p:sldId id="266" r:id="rId18"/>
     <p:sldId id="267" r:id="rId19"/>
-    <p:sldId id="268" r:id="rId20"/>
   </p:sldIdLst>
   <p:sldSz cx="12191695" cy="6858000" type="screen4x3"/>
   <p:notesSz cx="6858000" cy="9144000"/>
@@ -584,7 +583,7 @@
           <a:lstStyle/>
           <a:p>
             <a:r>
-              <a:t>But on the slow-rise side there is also a troublemaker: on detectors with a noisy window, a slow baseline drift also fits as a slow rise, with a tiny residual - NRMSE cannot catch it. The real pulses cluster near zero point one milliseconds while the drift tail stretches much further, so for the template input we set a ceiling at zero point three milliseconds. That blocks the drift and keeps the vast majority of real pulses - including part of the shadow population; the price is that the very slowest genuine pulses get trimmed too. That trade-off is documented and not final - I would like your input on it later.</a:t>
+              <a:t>First template family: the analytic one. For each channel we take every physical fitted curve at the common pretrigger and average them with a weight of one over NRMSE squared - badly fit events count less but nothing is excluded by hand. After the cuts, shown here, a single tight shape family remains, and its weighted mean is the 1x1 template - smooth and noise-free by construction because it is built from analytic curves, delivered as peak-normalized ROOT histograms.</a:t>
             </a:r>
           </a:p>
         </p:txBody>
@@ -654,7 +653,7 @@
           <a:lstStyle/>
           <a:p>
             <a:r>
-              <a:t>First template family: the analytic one. For each channel we take every physical fitted curve at the common pretrigger and average them with a weight of one over NRMSE squared - badly fit events count less but nothing is excluded by hand. After the cuts, shown here, a single tight shape family remains, and its weighted mean is the 1x1 template - smooth and noise-free by construction because it is built from analytic curves, delivered as peak-normalized ROOT histograms.</a:t>
+              <a:t>Second family: the NxM PCA templates, built to capture the shape variation we just saw. We run a PCA over the fitted curves that pass all cuts, in a window around the pulse. The mean shape becomes template zero, and the first four principal components become templates one to four - they oscillate and can be negative, and the optimal filter fits a real pulse as a linear combination of them. The first two components already capture 96 to 98 percent of the shape variance on every detector.</a:t>
             </a:r>
           </a:p>
         </p:txBody>
@@ -724,76 +723,6 @@
           <a:lstStyle/>
           <a:p>
             <a:r>
-              <a:t>Second family: the NxM PCA templates, built to capture the shape variation we just saw. We run a PCA over the fitted curves that pass all cuts, in a window around the pulse. The mean shape becomes template zero, and the first four principal components become templates one to four - they oscillate and can be negative, and the optimal filter fits a real pulse as a linear combination of them. The first two components already capture 96 to 98 percent of the shape variance on every detector.</a:t>
-            </a:r>
-          </a:p>
-        </p:txBody>
-      </p:sp>
-      <p:sp>
-        <p:nvSpPr>
-          <p:cNvPr id="4" name="Slide Number Placeholder 3"/>
-          <p:cNvSpPr>
-            <a:spLocks noGrp="1"/>
-          </p:cNvSpPr>
-          <p:nvPr>
-            <p:ph type="sldNum" idx="5" sz="quarter"/>
-          </p:nvPr>
-        </p:nvSpPr>
-        <p:spPr/>
-      </p:sp>
-    </p:spTree>
-  </p:cSld>
-  <p:clrMapOvr>
-    <a:masterClrMapping/>
-  </p:clrMapOvr>
-</p:notes>
-</file>
-
-<file path=ppt/notesSlides/notesSlide13.xml><?xml version="1.0" encoding="utf-8"?>
-<p:notes xmlns:a="http://schemas.openxmlformats.org/drawingml/2006/main" xmlns:p="http://schemas.openxmlformats.org/presentationml/2006/main" xmlns:r="http://schemas.openxmlformats.org/officeDocument/2006/relationships">
-  <p:cSld>
-    <p:spTree>
-      <p:nvGrpSpPr>
-        <p:cNvPr id="1" name=""/>
-        <p:cNvGrpSpPr/>
-        <p:nvPr/>
-      </p:nvGrpSpPr>
-      <p:grpSpPr>
-        <a:xfrm>
-          <a:off x="0" y="0"/>
-          <a:ext cx="0" cy="0"/>
-          <a:chOff x="0" y="0"/>
-          <a:chExt cx="0" cy="0"/>
-        </a:xfrm>
-      </p:grpSpPr>
-      <p:sp>
-        <p:nvSpPr>
-          <p:cNvPr id="2" name="Slide Image Placeholder 1"/>
-          <p:cNvSpPr>
-            <a:spLocks noGrp="1"/>
-          </p:cNvSpPr>
-          <p:nvPr>
-            <p:ph type="sldImg" idx="2"/>
-          </p:nvPr>
-        </p:nvSpPr>
-        <p:spPr/>
-      </p:sp>
-      <p:sp>
-        <p:nvSpPr>
-          <p:cNvPr id="3" name="Notes Placeholder 2"/>
-          <p:cNvSpPr>
-            <a:spLocks noGrp="1"/>
-          </p:cNvSpPr>
-          <p:nvPr>
-            <p:ph type="body" idx="3" sz="quarter"/>
-          </p:nvPr>
-        </p:nvSpPr>
-        <p:spPr/>
-        <p:txBody>
-          <a:bodyPr/>
-          <a:lstStyle/>
-          <a:p>
-            <a:r>
               <a:t>To summarize: both template families are delivered for all 13 detectors in the official PulseTemplates format - the analytic 1x1 templates and the PCA NxM set. The whole chain is traceable from raw traces to every figure, and both quality cuts were read off the data and verified in the raw traces. Two things remain: the final call on the rise-time ceiling versus the genuine slow pulses, and running the group's template-validation method on the new templates. Thank you - happy to take questions.</a:t>
             </a:r>
           </a:p>
@@ -1074,7 +1003,7 @@
           <a:lstStyle/>
           <a:p>
             <a:r>
-              <a:t>Here's what things look like after alignment - zoomed right on the peak. The blue band is thousands of measured traces stacked on top of each other; red is their average; orange is the weighted average of the fitted curves. On a quiet detector the bundle is very tight - the pulse shape really is highly consistent, so the raw material for a template is good. Now please notice one detail: in both channels there is a faint, displaced little bundle next to the main one - very clear in the left panel. And these two channels sit on opposite faces of the crystal, so this is not a quirk of one channel. Keep it in mind - we'll come back to what it is.</a:t>
+              <a:t>First quality cut. The NRMSE distribution of physical fits is bimodal on every detector: a good-fit population around 0.05 to 0.1, and a noise-trigger population around 1 to 2, separated by a valley at about 0.4. We place the cut in the valley - it is read off the distribution itself. On quiet detectors like Z7 the noise population is small; on noisy detectors like Z22 it dominates, and this cut is what digs the real pulses out of the mixture.</a:t>
             </a:r>
           </a:p>
         </p:txBody>
@@ -1144,7 +1073,7 @@
           <a:lstStyle/>
           <a:p>
             <a:r>
-              <a:t>First quality cut. The NRMSE distribution of physical fits is bimodal on every detector: a good-fit population around 0.05 to 0.1, and a noise-trigger population around 1 to 2, separated by a valley at about 0.4. We place the cut in the valley - it is read off the distribution itself. On quiet detectors like Z7 the noise population is small; on weak detectors like Z22 it dominates, and this cut is what digs the real pulses out of the mixture.</a:t>
+              <a:t>Before trusting the cut we looked at what it throws away. These are event grids of the rejected population on Z22: the raw traces show no pulse at all - they are noise triggers whose slow two-exp fit happened to converge. The fan-cut view on the right overlays the passing fitted curves in green and the rejected ones in red on the aligned data: the green population is the fast physical pulse shape, the red one is spread out with a median NRMSE three times higher. So the cut removes noise, not physics.</a:t>
             </a:r>
           </a:p>
         </p:txBody>
@@ -1214,7 +1143,7 @@
           <a:lstStyle/>
           <a:p>
             <a:r>
-              <a:t>Before trusting the cut we looked at what it throws away. These are event grids of the rejected population on Z22: the raw traces show no pulse at all - they are noise triggers whose slow two-exp fit happened to converge. The fan-cut view on the right overlays the passing fitted curves in green and the rejected ones in red on the aligned data: the green population is the fast physical pulse shape, the red one is spread out with a median NRMSE three times higher. So the cut removes noise, not physics.</a:t>
+              <a:t>The first lead comes from the fan plot after the cut: some curves still fall very slowly. We chased it by sampling: among events passing the cut, take fall times above one point five milliseconds, randomly sample ten, and draw raw versus fit in every channel. Two findings. First, the sampled events are real pulses - so they stay in, and we apply no fall cut. Second, their extreme fall times all trace back to one channel: only PDS2 is swinging wildly, while the same events are normal fast pulses in the other eleven channels - so the extreme tail is a one-channel low-frequency artifact, not slow physics.</a:t>
             </a:r>
           </a:p>
         </p:txBody>
@@ -1284,7 +1213,7 @@
           <a:lstStyle/>
           <a:p>
             <a:r>
-              <a:t>The first lead comes from the fan plot after the cut: some curves still fall very slowly. We chased it by sampling: among events passing the cut, take fall times above one point five milliseconds, randomly sample ten, and draw raw versus fit in every channel. Two findings. First, the sampled events are real pulses - so they stay in, and we apply no fall cut. Second, their extreme fall times all trace back to one channel: only PDS2 is swinging wildly, while the same events are normal fast pulses in the other eleven channels - so the extreme tail is a one-channel low-frequency artifact, not slow physics.</a:t>
+              <a:t>The second lead is the slow rise. Same recipe: take events that fit well - NRMSE fine - but whose median rise time is above zero point two milliseconds, sample them, look at the raw traces. This time the conclusion is the opposite: these are real pulses. The pretrigger is aligned, peak arriving late, consistent across all channels - they are the echo-trigger population - a genuine second, slower pulse shape. So the slow rise cannot simply be cut away: there is real physics in it, possibly related to where in the crystal the event happens; that is not settled yet.</a:t>
             </a:r>
           </a:p>
         </p:txBody>
@@ -1354,7 +1283,7 @@
           <a:lstStyle/>
           <a:p>
             <a:r>
-              <a:t>The second lead is the slow rise. Same recipe: take events that fit well - NRMSE fine - but whose median rise time is above zero point two milliseconds, sample them, look at the raw traces. This time the conclusion is the opposite: these are real pulses. The pretrigger is aligned, peak arriving late, consistent across all channels - they are exactly the shadow from the alignment plot. So the slow rise cannot simply be cut away: there is real physics in it, possibly related to where in the crystal the event happens; that is not settled yet.</a:t>
+              <a:t>But on the slow-rise side there is also a troublemaker: on detectors with a noisy window, a slow baseline drift also fits as a slow rise, with a tiny residual - NRMSE cannot catch it. The real pulses cluster near zero point one milliseconds while the drift tail stretches much further, so for the template input we set a ceiling at zero point three milliseconds. That blocks the drift and keeps the vast majority of real pulses - including part of the echo-trigger population; the price is that the very slowest genuine pulses get trimmed too. That trade-off is documented and not final - I would like your input on it later.</a:t>
             </a:r>
           </a:p>
         </p:txBody>
@@ -4509,7 +4438,7 @@
                 </a:solidFill>
                 <a:latin typeface="Arial"/>
               </a:rPr>
-              <a:t>Slow drift also fits “slow”: a τ_rise ≤ 0.3 ms ceiling</a:t>
+              <a:t>Template family 1 — analytic 2-exp, NRMSE-weighted (1x1)</a:t>
             </a:r>
           </a:p>
         </p:txBody>
@@ -4566,7 +4495,7 @@
         <p:spPr>
           <a:xfrm>
             <a:off x="502920" y="1097280"/>
-            <a:ext cx="11247120" cy="1600200"/>
+            <a:ext cx="11247120" cy="1417320"/>
           </a:xfrm>
           <a:prstGeom prst="rect">
             <a:avLst/>
@@ -4591,7 +4520,7 @@
                 </a:solidFill>
                 <a:latin typeface="Arial"/>
               </a:rPr>
-              <a:t>• On noisy-window detectors a smooth baseline drift survives the NRMSE cut — a slow 2-exp hugs it with a tiny residual — and mimics a slow rise</a:t>
+              <a:t>• Per channel: weighted mean of ALL fit_ok fitted curves at the common pretrigger, weight w = 1/max(NRMSE, 0.01)²</a:t>
             </a:r>
           </a:p>
           <a:p>
@@ -4607,7 +4536,7 @@
                 </a:solidFill>
                 <a:latin typeface="Arial"/>
               </a:rPr>
-              <a:t>• Fast pulses sit at τ_rise ≈ 0.1 ms (p90 ≈ 0.15 ms), far below the drift tail → a ceiling at 0.3 ms blocks the drift at ≈ 2–5% signal cost</a:t>
+              <a:t>• Badly-fit events count less but are never excluded — robust and smooth (noise-free by construction)</a:t>
             </a:r>
           </a:p>
           <a:p>
@@ -4623,14 +4552,14 @@
                 </a:solidFill>
                 <a:latin typeface="Arial"/>
               </a:rPr>
-              <a:t>• Keeps most genuine slow pulses, trims the very slowest — documented trade-off, final decision pending</a:t>
+              <a:t>• Delivered as peak-normalized 32768-bin ROOT TH1D per channel + summed PT/PS1/PS2 templates</a:t>
             </a:r>
           </a:p>
         </p:txBody>
       </p:sp>
       <p:pic>
         <p:nvPicPr>
-          <p:cNvPr id="5" name="Picture 4" descr="time_constants_zip7_PAS1.png"/>
+          <p:cNvPr id="5" name="Picture 4" descr="fan_zip7_PBS1_after.png"/>
           <p:cNvPicPr>
             <a:picLocks noChangeAspect="1"/>
           </p:cNvPicPr>
@@ -4644,8 +4573,8 @@
         </p:blipFill>
         <p:spPr>
           <a:xfrm>
-            <a:off x="1280160" y="2880360"/>
-            <a:ext cx="9601200" cy="1851803"/>
+            <a:off x="1383919" y="3063240"/>
+            <a:ext cx="9393682" cy="2834640"/>
           </a:xfrm>
           <a:prstGeom prst="rect">
             <a:avLst/>
@@ -4660,7 +4589,7 @@
         </p:nvSpPr>
         <p:spPr>
           <a:xfrm>
-            <a:off x="1280160" y="4762163"/>
+            <a:off x="1280160" y="5927880"/>
             <a:ext cx="9601200" cy="274320"/>
           </a:xfrm>
           <a:prstGeom prst="rect">
@@ -4682,46 +4611,7 @@
                 </a:solidFill>
                 <a:latin typeface="Arial"/>
               </a:rPr>
-              <a:t>Z7 PAS1: fitted τ_rise (median 0.105 ms) and τ_fall distributions</a:t>
-            </a:r>
-          </a:p>
-        </p:txBody>
-      </p:sp>
-      <p:sp>
-        <p:nvSpPr>
-          <p:cNvPr id="7" name="TextBox 6"/>
-          <p:cNvSpPr txBox="1"/>
-          <p:nvPr/>
-        </p:nvSpPr>
-        <p:spPr>
-          <a:xfrm>
-            <a:off x="1280160" y="5257800"/>
-            <a:ext cx="9601200" cy="914400"/>
-          </a:xfrm>
-          <a:prstGeom prst="rect">
-            <a:avLst/>
-          </a:prstGeom>
-          <a:noFill/>
-        </p:spPr>
-        <p:txBody>
-          <a:bodyPr wrap="square">
-            <a:spAutoFit/>
-          </a:bodyPr>
-          <a:lstStyle/>
-          <a:p>
-            <a:pPr>
-              <a:spcAft>
-                <a:spcPts val="500"/>
-              </a:spcAft>
-            </a:pPr>
-            <a:r>
-              <a:rPr sz="1300">
-                <a:solidFill>
-                  <a:srgbClr val="333333"/>
-                </a:solidFill>
-                <a:latin typeface="Arial"/>
-              </a:rPr>
-              <a:t>• On quiet detectors both τ_rise and τ_fall distributions are narrow — the pulse shape is stable across events</a:t>
+              <a:t>Z7 PBS1, fitted curves after NRMSE ≤ 0.4 and τ_rise ≤ 0.3 ms — the NRMSE-weighted mean of this family is the 1x1 template</a:t>
             </a:r>
           </a:p>
         </p:txBody>
@@ -4773,7 +4663,7 @@
                 </a:solidFill>
                 <a:latin typeface="Arial"/>
               </a:rPr>
-              <a:t>Template family 1 — analytic 2-exp, NRMSE-weighted (1x1)</a:t>
+              <a:t>Template family 2 — NxM PCA templates</a:t>
             </a:r>
           </a:p>
         </p:txBody>
@@ -4855,7 +4745,7 @@
                 </a:solidFill>
                 <a:latin typeface="Arial"/>
               </a:rPr>
-              <a:t>• Per channel: weighted mean of ALL fit_ok fitted curves at the common pretrigger, weight w = 1/max(NRMSE, 0.01)²</a:t>
+              <a:t>• Input: fitted curves passing fit_ok + NRMSE ≤ 0.4 + τ_rise ≤ 0.3 ms, at common pretrigger, peak-normalized (PCA window 15550–24050, ≤ 3000 curves/channel)</a:t>
             </a:r>
           </a:p>
           <a:p>
@@ -4871,7 +4761,7 @@
                 </a:solidFill>
                 <a:latin typeface="Arial"/>
               </a:rPr>
-              <a:t>• Badly-fit events count less but are never excluded — robust and smooth (noise-free by construction)</a:t>
+              <a:t>• nxm0 = mean shape;  nxm1…nxm4 = first four principal components — a real pulse is fit as Σᵢ ampᵢ · nxmᵢ</a:t>
             </a:r>
           </a:p>
           <a:p>
@@ -4887,14 +4777,14 @@
                 </a:solidFill>
                 <a:latin typeface="Arial"/>
               </a:rPr>
-              <a:t>• Delivered as peak-normalized 32768-bin ROOT TH1D per channel + summed PT/PS1/PS2 templates</a:t>
+              <a:t>• PC1 + PC2 already capture 96–98% of the shape variance; final step before delivery: normalize all five to unit peak — the delivered product</a:t>
             </a:r>
           </a:p>
         </p:txBody>
       </p:sp>
       <p:pic>
         <p:nvPicPr>
-          <p:cNvPr id="5" name="Picture 4" descr="fan_zip7_PBS1_after.png"/>
+          <p:cNvPr id="5" name="Picture 4" descr="pca_zip7_PAS1.png"/>
           <p:cNvPicPr>
             <a:picLocks noChangeAspect="1"/>
           </p:cNvPicPr>
@@ -4908,24 +4798,48 @@
         </p:blipFill>
         <p:spPr>
           <a:xfrm>
-            <a:off x="1383919" y="3063240"/>
-            <a:ext cx="9393682" cy="2834640"/>
+            <a:off x="2831374" y="2697480"/>
+            <a:ext cx="6498771" cy="1828800"/>
           </a:xfrm>
           <a:prstGeom prst="rect">
             <a:avLst/>
           </a:prstGeom>
         </p:spPr>
       </p:pic>
-      <p:sp>
-        <p:nvSpPr>
-          <p:cNvPr id="6" name="TextBox 5"/>
+      <p:pic>
+        <p:nvPicPr>
+          <p:cNvPr id="6" name="Picture 5" descr="pca_zip7_PBS1.png"/>
+          <p:cNvPicPr>
+            <a:picLocks noChangeAspect="1"/>
+          </p:cNvPicPr>
+          <p:nvPr/>
+        </p:nvPicPr>
+        <p:blipFill>
+          <a:blip r:embed="rId3"/>
+          <a:stretch>
+            <a:fillRect/>
+          </a:stretch>
+        </p:blipFill>
+        <p:spPr>
+          <a:xfrm>
+            <a:off x="2831374" y="4572000"/>
+            <a:ext cx="6498771" cy="1828800"/>
+          </a:xfrm>
+          <a:prstGeom prst="rect">
+            <a:avLst/>
+          </a:prstGeom>
+        </p:spPr>
+      </p:pic>
+      <p:sp>
+        <p:nvSpPr>
+          <p:cNvPr id="7" name="TextBox 6"/>
           <p:cNvSpPr txBox="1"/>
           <p:nvPr/>
         </p:nvSpPr>
         <p:spPr>
           <a:xfrm>
-            <a:off x="1280160" y="5927880"/>
-            <a:ext cx="9601200" cy="274320"/>
+            <a:off x="1371600" y="6430800"/>
+            <a:ext cx="9418320" cy="274320"/>
           </a:xfrm>
           <a:prstGeom prst="rect">
             <a:avLst/>
@@ -4946,7 +4860,7 @@
                 </a:solidFill>
                 <a:latin typeface="Arial"/>
               </a:rPr>
-              <a:t>Z7 PBS1, fitted curves after NRMSE ≤ 0.4 and τ_rise ≤ 0.3 ms — the NRMSE-weighted mean of this family is the 1x1 template</a:t>
+              <a:t>Z7 PAS1 / PBS1: nxm0 (mean) + nxm1–4 (PCs) — the oscillating components encode rise/fall-time variation</a:t>
             </a:r>
           </a:p>
         </p:txBody>
@@ -4998,255 +4912,6 @@
                 </a:solidFill>
                 <a:latin typeface="Arial"/>
               </a:rPr>
-              <a:t>Template family 2 — NxM PCA templates</a:t>
-            </a:r>
-          </a:p>
-        </p:txBody>
-      </p:sp>
-      <p:sp>
-        <p:nvSpPr>
-          <p:cNvPr id="3" name="Rectangle 2"/>
-          <p:cNvSpPr/>
-          <p:nvPr/>
-        </p:nvSpPr>
-        <p:spPr>
-          <a:xfrm>
-            <a:off x="502920" y="932688"/>
-            <a:ext cx="11247120" cy="18000"/>
-          </a:xfrm>
-          <a:prstGeom prst="rect">
-            <a:avLst/>
-          </a:prstGeom>
-          <a:solidFill>
-            <a:srgbClr val="1F3864"/>
-          </a:solidFill>
-          <a:ln>
-            <a:noFill/>
-          </a:ln>
-        </p:spPr>
-        <p:style>
-          <a:lnRef idx="1">
-            <a:schemeClr val="accent1"/>
-          </a:lnRef>
-          <a:fillRef idx="3">
-            <a:schemeClr val="accent1"/>
-          </a:fillRef>
-          <a:effectRef idx="2">
-            <a:schemeClr val="accent1"/>
-          </a:effectRef>
-          <a:fontRef idx="minor">
-            <a:schemeClr val="lt1"/>
-          </a:fontRef>
-        </p:style>
-        <p:txBody>
-          <a:bodyPr rtlCol="0" anchor="ctr"/>
-          <a:lstStyle/>
-          <a:p>
-            <a:pPr algn="ctr"/>
-          </a:p>
-        </p:txBody>
-      </p:sp>
-      <p:sp>
-        <p:nvSpPr>
-          <p:cNvPr id="4" name="TextBox 3"/>
-          <p:cNvSpPr txBox="1"/>
-          <p:nvPr/>
-        </p:nvSpPr>
-        <p:spPr>
-          <a:xfrm>
-            <a:off x="502920" y="1097280"/>
-            <a:ext cx="11247120" cy="1417320"/>
-          </a:xfrm>
-          <a:prstGeom prst="rect">
-            <a:avLst/>
-          </a:prstGeom>
-          <a:noFill/>
-        </p:spPr>
-        <p:txBody>
-          <a:bodyPr wrap="square">
-            <a:spAutoFit/>
-          </a:bodyPr>
-          <a:lstStyle/>
-          <a:p>
-            <a:pPr>
-              <a:spcAft>
-                <a:spcPts val="500"/>
-              </a:spcAft>
-            </a:pPr>
-            <a:r>
-              <a:rPr sz="1400">
-                <a:solidFill>
-                  <a:srgbClr val="333333"/>
-                </a:solidFill>
-                <a:latin typeface="Arial"/>
-              </a:rPr>
-              <a:t>• Input: fitted curves passing fit_ok + NRMSE ≤ 0.4 + τ_rise ≤ 0.3 ms, at common pretrigger, peak-normalized (PCA window 15550–24050, ≤ 3000 curves/channel)</a:t>
-            </a:r>
-          </a:p>
-          <a:p>
-            <a:pPr>
-              <a:spcAft>
-                <a:spcPts val="500"/>
-              </a:spcAft>
-            </a:pPr>
-            <a:r>
-              <a:rPr sz="1400">
-                <a:solidFill>
-                  <a:srgbClr val="333333"/>
-                </a:solidFill>
-                <a:latin typeface="Arial"/>
-              </a:rPr>
-              <a:t>• nxm0 = mean shape;  nxm1…nxm4 = first four principal components — a real pulse is fit as Σᵢ ampᵢ · nxmᵢ</a:t>
-            </a:r>
-          </a:p>
-          <a:p>
-            <a:pPr>
-              <a:spcAft>
-                <a:spcPts val="500"/>
-              </a:spcAft>
-            </a:pPr>
-            <a:r>
-              <a:rPr sz="1400">
-                <a:solidFill>
-                  <a:srgbClr val="333333"/>
-                </a:solidFill>
-                <a:latin typeface="Arial"/>
-              </a:rPr>
-              <a:t>• PC1 + PC2 already capture 96–98% of the shape variance; final step before delivery: normalize all five to unit peak — the delivered product</a:t>
-            </a:r>
-          </a:p>
-        </p:txBody>
-      </p:sp>
-      <p:pic>
-        <p:nvPicPr>
-          <p:cNvPr id="5" name="Picture 4" descr="pca_zip7_PAS1.png"/>
-          <p:cNvPicPr>
-            <a:picLocks noChangeAspect="1"/>
-          </p:cNvPicPr>
-          <p:nvPr/>
-        </p:nvPicPr>
-        <p:blipFill>
-          <a:blip r:embed="rId2"/>
-          <a:stretch>
-            <a:fillRect/>
-          </a:stretch>
-        </p:blipFill>
-        <p:spPr>
-          <a:xfrm>
-            <a:off x="2831374" y="2697480"/>
-            <a:ext cx="6498771" cy="1828800"/>
-          </a:xfrm>
-          <a:prstGeom prst="rect">
-            <a:avLst/>
-          </a:prstGeom>
-        </p:spPr>
-      </p:pic>
-      <p:pic>
-        <p:nvPicPr>
-          <p:cNvPr id="6" name="Picture 5" descr="pca_zip7_PBS1.png"/>
-          <p:cNvPicPr>
-            <a:picLocks noChangeAspect="1"/>
-          </p:cNvPicPr>
-          <p:nvPr/>
-        </p:nvPicPr>
-        <p:blipFill>
-          <a:blip r:embed="rId3"/>
-          <a:stretch>
-            <a:fillRect/>
-          </a:stretch>
-        </p:blipFill>
-        <p:spPr>
-          <a:xfrm>
-            <a:off x="2831374" y="4572000"/>
-            <a:ext cx="6498771" cy="1828800"/>
-          </a:xfrm>
-          <a:prstGeom prst="rect">
-            <a:avLst/>
-          </a:prstGeom>
-        </p:spPr>
-      </p:pic>
-      <p:sp>
-        <p:nvSpPr>
-          <p:cNvPr id="7" name="TextBox 6"/>
-          <p:cNvSpPr txBox="1"/>
-          <p:nvPr/>
-        </p:nvSpPr>
-        <p:spPr>
-          <a:xfrm>
-            <a:off x="1371600" y="6430800"/>
-            <a:ext cx="9418320" cy="274320"/>
-          </a:xfrm>
-          <a:prstGeom prst="rect">
-            <a:avLst/>
-          </a:prstGeom>
-          <a:noFill/>
-        </p:spPr>
-        <p:txBody>
-          <a:bodyPr wrap="square">
-            <a:spAutoFit/>
-          </a:bodyPr>
-          <a:lstStyle/>
-          <a:p>
-            <a:pPr algn="ctr"/>
-            <a:r>
-              <a:rPr sz="1100" i="1">
-                <a:solidFill>
-                  <a:srgbClr val="666666"/>
-                </a:solidFill>
-                <a:latin typeface="Arial"/>
-              </a:rPr>
-              <a:t>Z7 PAS1 / PBS1: nxm0 (mean) + nxm1–4 (PCs) — the oscillating components encode rise/fall-time variation</a:t>
-            </a:r>
-          </a:p>
-        </p:txBody>
-      </p:sp>
-    </p:spTree>
-  </p:cSld>
-  <p:clrMapOvr>
-    <a:masterClrMapping/>
-  </p:clrMapOvr>
-</p:sld>
-</file>
-
-<file path=ppt/slides/slide13.xml><?xml version="1.0" encoding="utf-8"?>
-<p:sld xmlns:a="http://schemas.openxmlformats.org/drawingml/2006/main" xmlns:p="http://schemas.openxmlformats.org/presentationml/2006/main" xmlns:r="http://schemas.openxmlformats.org/officeDocument/2006/relationships">
-  <p:cSld>
-    <p:spTree>
-      <p:nvGrpSpPr>
-        <p:cNvPr id="1" name=""/>
-        <p:cNvGrpSpPr/>
-        <p:nvPr/>
-      </p:nvGrpSpPr>
-      <p:grpSpPr/>
-      <p:sp>
-        <p:nvSpPr>
-          <p:cNvPr id="2" name="TextBox 1"/>
-          <p:cNvSpPr txBox="1"/>
-          <p:nvPr/>
-        </p:nvSpPr>
-        <p:spPr>
-          <a:xfrm>
-            <a:off x="502920" y="256032"/>
-            <a:ext cx="11247120" cy="685800"/>
-          </a:xfrm>
-          <a:prstGeom prst="rect">
-            <a:avLst/>
-          </a:prstGeom>
-          <a:noFill/>
-        </p:spPr>
-        <p:txBody>
-          <a:bodyPr wrap="square">
-            <a:spAutoFit/>
-          </a:bodyPr>
-          <a:lstStyle/>
-          <a:p>
-            <a:r>
-              <a:rPr sz="2700" b="1">
-                <a:solidFill>
-                  <a:srgbClr val="1F3864"/>
-                </a:solidFill>
-                <a:latin typeface="Arial"/>
-              </a:rPr>
               <a:t>Delivered — and what remains</a:t>
             </a:r>
           </a:p>
@@ -6438,7 +6103,7 @@
                 </a:solidFill>
                 <a:latin typeface="Arial"/>
               </a:rPr>
-              <a:t>Alignment result — overlaid measured traces</a:t>
+              <a:t>Quality cut 1: NRMSE ≤ 0.4 — where the number comes from</a:t>
             </a:r>
           </a:p>
         </p:txBody>
@@ -6495,7 +6160,7 @@
         <p:spPr>
           <a:xfrm>
             <a:off x="502920" y="1097280"/>
-            <a:ext cx="11247120" cy="1371600"/>
+            <a:ext cx="11247120" cy="1417320"/>
           </a:xfrm>
           <a:prstGeom prst="rect">
             <a:avLst/>
@@ -6520,7 +6185,7 @@
                 </a:solidFill>
                 <a:latin typeface="Arial"/>
               </a:rPr>
-              <a:t>• All fit_ok traces shifted to the common pretrigger (blue) + point-by-point mean (red) + NRMSE-weighted mean of the fitted curves (orange, w = 1/max(NRMSE, 0.01)²)</a:t>
+              <a:t>• NRMSE of fit_ok events is bimodal: good fits (median ≈ 0.05–0.1) vs noise triggers (≈ 1–2), valley at ≈ 0.4–0.5</a:t>
             </a:r>
           </a:p>
           <a:p>
@@ -6536,14 +6201,30 @@
                 </a:solidFill>
                 <a:latin typeface="Arial"/>
               </a:rPr>
-              <a:t>• Peak zoom on a quiet detector: a tight bundle — the template input is well defined. Note the faint displaced bundle beside the main one, visible on both crystal faces (S1 and S2) — more on it later</a:t>
+              <a:t>• The cut sits in the valley — it is read off the distribution, not tuned on the templates</a:t>
+            </a:r>
+          </a:p>
+          <a:p>
+            <a:pPr>
+              <a:spcAft>
+                <a:spcPts val="500"/>
+              </a:spcAft>
+            </a:pPr>
+            <a:r>
+              <a:rPr sz="1400">
+                <a:solidFill>
+                  <a:srgbClr val="333333"/>
+                </a:solidFill>
+                <a:latin typeface="Arial"/>
+              </a:rPr>
+              <a:t>• Noisy detectors (Z1, Z4, Z6, Z18, Z19, Z22, Z24): the PTOF window admits a noise-dominated mixture — this cut is what extracts the real-pulse population</a:t>
             </a:r>
           </a:p>
         </p:txBody>
       </p:sp>
       <p:pic>
         <p:nvPicPr>
-          <p:cNvPr id="5" name="Picture 4" descr="aligned_zoom_zip7_PCS1.png"/>
+          <p:cNvPr id="5" name="Picture 4" descr="nrmse_zip7_PBS1.png"/>
           <p:cNvPicPr>
             <a:picLocks noChangeAspect="1"/>
           </p:cNvPicPr>
@@ -6557,8 +6238,8 @@
         </p:blipFill>
         <p:spPr>
           <a:xfrm>
-            <a:off x="320040" y="2834640"/>
-            <a:ext cx="5623560" cy="2705090"/>
+            <a:off x="1970576" y="2651760"/>
+            <a:ext cx="8220367" cy="1874519"/>
           </a:xfrm>
           <a:prstGeom prst="rect">
             <a:avLst/>
@@ -6573,8 +6254,8 @@
         </p:nvSpPr>
         <p:spPr>
           <a:xfrm>
-            <a:off x="320040" y="5569730"/>
-            <a:ext cx="5623560" cy="274320"/>
+            <a:off x="1737360" y="4556279"/>
+            <a:ext cx="8686800" cy="274320"/>
           </a:xfrm>
           <a:prstGeom prst="rect">
             <a:avLst/>
@@ -6595,14 +6276,14 @@
                 </a:solidFill>
                 <a:latin typeface="Arial"/>
               </a:rPr>
-              <a:t>Z7 PCS1 (S1 face) — peak zoom; the faint displaced bundle is clearly visible</a:t>
+              <a:t>Z7 PBS1 (quiet): two clean populations, log-log axes</a:t>
             </a:r>
           </a:p>
         </p:txBody>
       </p:sp>
       <p:pic>
         <p:nvPicPr>
-          <p:cNvPr id="7" name="Picture 6" descr="aligned_zoom_zip7_PBS2.png"/>
+          <p:cNvPr id="7" name="Picture 6" descr="nrmse_zip22_PAS1.png"/>
           <p:cNvPicPr>
             <a:picLocks noChangeAspect="1"/>
           </p:cNvPicPr>
@@ -6616,8 +6297,8 @@
         </p:blipFill>
         <p:spPr>
           <a:xfrm>
-            <a:off x="6263640" y="2834640"/>
-            <a:ext cx="5623560" cy="2705090"/>
+            <a:off x="1989344" y="4754880"/>
+            <a:ext cx="8182831" cy="1874519"/>
           </a:xfrm>
           <a:prstGeom prst="rect">
             <a:avLst/>
@@ -6632,8 +6313,8 @@
         </p:nvSpPr>
         <p:spPr>
           <a:xfrm>
-            <a:off x="6263640" y="5569730"/>
-            <a:ext cx="5623560" cy="274320"/>
+            <a:off x="1737360" y="6659399"/>
+            <a:ext cx="8686800" cy="274320"/>
           </a:xfrm>
           <a:prstGeom prst="rect">
             <a:avLst/>
@@ -6654,7 +6335,7 @@
                 </a:solidFill>
                 <a:latin typeface="Arial"/>
               </a:rPr>
-              <a:t>Z7 PBS2 (S2 face) — same faint displaced bundle</a:t>
+              <a:t>Z22 PAS1 (noisy): noise population dominates — the window alone is not enough</a:t>
             </a:r>
           </a:p>
         </p:txBody>
@@ -6706,7 +6387,7 @@
                 </a:solidFill>
                 <a:latin typeface="Arial"/>
               </a:rPr>
-              <a:t>Quality cut 1: NRMSE ≤ 0.4 — where the number comes from</a:t>
+              <a:t>The rejected population is noise — verified in the raw traces</a:t>
             </a:r>
           </a:p>
         </p:txBody>
@@ -6763,7 +6444,7 @@
         <p:spPr>
           <a:xfrm>
             <a:off x="502920" y="1097280"/>
-            <a:ext cx="11247120" cy="1417320"/>
+            <a:ext cx="11247120" cy="1234440"/>
           </a:xfrm>
           <a:prstGeom prst="rect">
             <a:avLst/>
@@ -6788,7 +6469,7 @@
                 </a:solidFill>
                 <a:latin typeface="Arial"/>
               </a:rPr>
-              <a:t>• NRMSE of fit_ok events is bimodal: good fits (median ≈ 0.05–0.1) vs noise triggers (≈ 1–2), valley at ≈ 0.4–0.5</a:t>
+              <a:t>• Event grids of NRMSE-rejected events (median NRMSE &gt; 0.4 across channels): the raw traces show no pulse — the cut removes noise triggers, not physics</a:t>
             </a:r>
           </a:p>
           <a:p>
@@ -6804,30 +6485,14 @@
                 </a:solidFill>
                 <a:latin typeface="Arial"/>
               </a:rPr>
-              <a:t>• The cut sits in the valley — it is read off the distribution, not tuned on the templates</a:t>
-            </a:r>
-          </a:p>
-          <a:p>
-            <a:pPr>
-              <a:spcAft>
-                <a:spcPts val="500"/>
-              </a:spcAft>
-            </a:pPr>
-            <a:r>
-              <a:rPr sz="1400">
-                <a:solidFill>
-                  <a:srgbClr val="333333"/>
-                </a:solidFill>
-                <a:latin typeface="Arial"/>
-              </a:rPr>
-              <a:t>• Weak detectors (Z1, Z4, Z6, Z18, Z19, Z22, Z24): the PTOF window admits a noise-dominated mixture — this cut is what extracts the real-pulse population</a:t>
+              <a:t>• Fan-cut view: fitted curves that pass (green) vs cut away (red) on top of the aligned data, median NRMSE of each population stamped per channel</a:t>
             </a:r>
           </a:p>
         </p:txBody>
       </p:sp>
       <p:pic>
         <p:nvPicPr>
-          <p:cNvPr id="5" name="Picture 4" descr="nrmse_zip7_PBS1.png"/>
+          <p:cNvPr id="5" name="Picture 4" descr="slow_rise_zip22_crop.png"/>
           <p:cNvPicPr>
             <a:picLocks noChangeAspect="1"/>
           </p:cNvPicPr>
@@ -6841,8 +6506,8 @@
         </p:blipFill>
         <p:spPr>
           <a:xfrm>
-            <a:off x="1970576" y="2651760"/>
-            <a:ext cx="8220367" cy="1874519"/>
+            <a:off x="502920" y="2468880"/>
+            <a:ext cx="5394960" cy="3699401"/>
           </a:xfrm>
           <a:prstGeom prst="rect">
             <a:avLst/>
@@ -6857,8 +6522,8 @@
         </p:nvSpPr>
         <p:spPr>
           <a:xfrm>
-            <a:off x="1737360" y="4556279"/>
-            <a:ext cx="8686800" cy="274320"/>
+            <a:off x="502920" y="6198281"/>
+            <a:ext cx="5394960" cy="274320"/>
           </a:xfrm>
           <a:prstGeom prst="rect">
             <a:avLst/>
@@ -6879,14 +6544,14 @@
                 </a:solidFill>
                 <a:latin typeface="Arial"/>
               </a:rPr>
-              <a:t>Z7 PBS1 (quiet): two clean populations, log-log axes</a:t>
+              <a:t>Z22: NRMSE-rejected events — raw traces are noise</a:t>
             </a:r>
           </a:p>
         </p:txBody>
       </p:sp>
       <p:pic>
         <p:nvPicPr>
-          <p:cNvPr id="7" name="Picture 6" descr="nrmse_zip22_PAS1.png"/>
+          <p:cNvPr id="7" name="Picture 6" descr="fan_cut_zip22_PCS1.png"/>
           <p:cNvPicPr>
             <a:picLocks noChangeAspect="1"/>
           </p:cNvPicPr>
@@ -6900,8 +6565,8 @@
         </p:blipFill>
         <p:spPr>
           <a:xfrm>
-            <a:off x="1989344" y="4754880"/>
-            <a:ext cx="8182831" cy="1874519"/>
+            <a:off x="6126480" y="2651760"/>
+            <a:ext cx="5760720" cy="3383280"/>
           </a:xfrm>
           <a:prstGeom prst="rect">
             <a:avLst/>
@@ -6916,8 +6581,8 @@
         </p:nvSpPr>
         <p:spPr>
           <a:xfrm>
-            <a:off x="1737360" y="6659399"/>
-            <a:ext cx="8686800" cy="274320"/>
+            <a:off x="6126480" y="6065040"/>
+            <a:ext cx="5760720" cy="274320"/>
           </a:xfrm>
           <a:prstGeom prst="rect">
             <a:avLst/>
@@ -6938,7 +6603,7 @@
                 </a:solidFill>
                 <a:latin typeface="Arial"/>
               </a:rPr>
-              <a:t>Z22 PAS1 (weak): noise population dominates — the window alone is not enough</a:t>
+              <a:t>Z22 PCS1: pass (green) vs rejected (red) — vertically stretched for visibility</a:t>
             </a:r>
           </a:p>
         </p:txBody>
@@ -6990,7 +6655,7 @@
                 </a:solidFill>
                 <a:latin typeface="Arial"/>
               </a:rPr>
-              <a:t>The rejected population is noise — verified in the raw traces</a:t>
+              <a:t>Follow-up 1 — the slow-fall tail is a one-channel artifact</a:t>
             </a:r>
           </a:p>
         </p:txBody>
@@ -7047,7 +6712,7 @@
         <p:spPr>
           <a:xfrm>
             <a:off x="502920" y="1097280"/>
-            <a:ext cx="11247120" cy="1234440"/>
+            <a:ext cx="11247120" cy="1417320"/>
           </a:xfrm>
           <a:prstGeom prst="rect">
             <a:avLst/>
@@ -7072,7 +6737,7 @@
                 </a:solidFill>
                 <a:latin typeface="Arial"/>
               </a:rPr>
-              <a:t>• Event grids of NRMSE-rejected events (median NRMSE &gt; 0.4 across channels): the raw traces show no pulse — the cut removes noise triggers, not physics</a:t>
+              <a:t>• The post-cut fan still shows slow-fall tails → sample them: NRMSE ≤ 0.4 AND τ_fall &gt; 1.5 ms, 10 random events, raw vs fit drawn in all 12 channels</a:t>
             </a:r>
           </a:p>
           <a:p>
@@ -7088,14 +6753,30 @@
                 </a:solidFill>
                 <a:latin typeface="Arial"/>
               </a:rPr>
-              <a:t>• Fan-cut view: fitted curves that pass (green) vs cut away (red) on top of the aligned data, median NRMSE of each population stamped per channel</a:t>
+              <a:t>• The sampled events are real pulses → kept. Their extreme fall times trace to one channel: only PDS2 swings (τ_fall median 0.51 ms vs ≈ 0.25 ms elsewhere) — a low-frequency disturbance</a:t>
+            </a:r>
+          </a:p>
+          <a:p>
+            <a:pPr>
+              <a:spcAft>
+                <a:spcPts val="500"/>
+              </a:spcAft>
+            </a:pPr>
+            <a:r>
+              <a:rPr sz="1400">
+                <a:solidFill>
+                  <a:srgbClr val="333333"/>
+                </a:solidFill>
+                <a:latin typeface="Arial"/>
+              </a:rPr>
+              <a:t>• Conclusion: no τ_fall cut — slow-fall events passing NRMSE stay in; the extreme tail is a one-channel artifact, not physics</a:t>
             </a:r>
           </a:p>
         </p:txBody>
       </p:sp>
       <p:pic>
         <p:nvPicPr>
-          <p:cNvPr id="5" name="Picture 4" descr="slow_rise_zip22_crop.png"/>
+          <p:cNvPr id="5" name="Picture 4" descr="slow_fall_zip7_crop.png"/>
           <p:cNvPicPr>
             <a:picLocks noChangeAspect="1"/>
           </p:cNvPicPr>
@@ -7109,8 +6790,8 @@
         </p:blipFill>
         <p:spPr>
           <a:xfrm>
-            <a:off x="502920" y="2468880"/>
-            <a:ext cx="5394960" cy="3699401"/>
+            <a:off x="411480" y="2651760"/>
+            <a:ext cx="6675120" cy="3432048"/>
           </a:xfrm>
           <a:prstGeom prst="rect">
             <a:avLst/>
@@ -7125,8 +6806,8 @@
         </p:nvSpPr>
         <p:spPr>
           <a:xfrm>
-            <a:off x="502920" y="6198281"/>
-            <a:ext cx="5394960" cy="274320"/>
+            <a:off x="411480" y="6113808"/>
+            <a:ext cx="6675120" cy="274320"/>
           </a:xfrm>
           <a:prstGeom prst="rect">
             <a:avLst/>
@@ -7147,14 +6828,14 @@
                 </a:solidFill>
                 <a:latin typeface="Arial"/>
               </a:rPr>
-              <a:t>Z22: NRMSE-rejected events — raw traces are noise</a:t>
+              <a:t>Z7, 3 of the sampled slow-fall events: normal pulses in PBS2/PCS2/PES2, low-frequency swings only in PDS2</a:t>
             </a:r>
           </a:p>
         </p:txBody>
       </p:sp>
       <p:pic>
         <p:nvPicPr>
-          <p:cNvPr id="7" name="Picture 6" descr="fan_cut_zip22_PCS1.png"/>
+          <p:cNvPr id="7" name="Picture 6" descr="time_constants_zip7_PDS2_tfall.png"/>
           <p:cNvPicPr>
             <a:picLocks noChangeAspect="1"/>
           </p:cNvPicPr>
@@ -7168,8 +6849,8 @@
         </p:blipFill>
         <p:spPr>
           <a:xfrm>
-            <a:off x="6126480" y="2651760"/>
-            <a:ext cx="5760720" cy="3383280"/>
+            <a:off x="7315200" y="2834640"/>
+            <a:ext cx="4663440" cy="2926080"/>
           </a:xfrm>
           <a:prstGeom prst="rect">
             <a:avLst/>
@@ -7184,8 +6865,8 @@
         </p:nvSpPr>
         <p:spPr>
           <a:xfrm>
-            <a:off x="6126480" y="6065040"/>
-            <a:ext cx="5760720" cy="274320"/>
+            <a:off x="7315200" y="5790720"/>
+            <a:ext cx="4663440" cy="274320"/>
           </a:xfrm>
           <a:prstGeom prst="rect">
             <a:avLst/>
@@ -7206,7 +6887,7 @@
                 </a:solidFill>
                 <a:latin typeface="Arial"/>
               </a:rPr>
-              <a:t>Z22 PCS1: pass (green) vs rejected (red) — vertically stretched for visibility</a:t>
+              <a:t>Z7 PDS2, fitted τ_fall: broad tail (median 0.51 ms) — the artifact in the distributions</a:t>
             </a:r>
           </a:p>
         </p:txBody>
@@ -7258,7 +6939,7 @@
                 </a:solidFill>
                 <a:latin typeface="Arial"/>
               </a:rPr>
-              <a:t>Follow-up 1 — the slow-fall tail is a one-channel artifact</a:t>
+              <a:t>Follow-up 2 — genuine slow-rise pulses (echo-trigger events)</a:t>
             </a:r>
           </a:p>
         </p:txBody>
@@ -7340,7 +7021,7 @@
                 </a:solidFill>
                 <a:latin typeface="Arial"/>
               </a:rPr>
-              <a:t>• The post-cut fan still shows slow-fall tails → sample them: NRMSE ≤ 0.4 AND τ_fall &gt; 1.5 ms, 10 random events, raw vs fit drawn in all 12 channels</a:t>
+              <a:t>• Same sampling recipe on the rise side: median NRMSE ≤ 0.4 AND median τ_rise &gt; 0.2 ms → the raw traces show real pulses — pretrigger aligned, peak late, consistent across channels</a:t>
             </a:r>
           </a:p>
           <a:p>
@@ -7356,7 +7037,7 @@
                 </a:solidFill>
                 <a:latin typeface="Arial"/>
               </a:rPr>
-              <a:t>• The sampled events are real pulses → kept. Their extreme fall times trace to one channel: only PDS2 swings (τ_fall median 0.51 ms vs ≈ 0.25 ms elsewhere) — a low-frequency disturbance</a:t>
+              <a:t>• A genuine second, slower pulse shape — a faint “echo” behind the main pulse (candidate surface/bulk effect, not settled)</a:t>
             </a:r>
           </a:p>
           <a:p>
@@ -7372,14 +7053,14 @@
                 </a:solidFill>
                 <a:latin typeface="Arial"/>
               </a:rPr>
-              <a:t>• Conclusion: no τ_fall cut — slow-fall events passing NRMSE stay in; the extreme tail is a one-channel artifact, not physics</a:t>
+              <a:t>• Real physics → cannot simply be cut away; exactly the shape variation the multi-template NxM method is built to capture</a:t>
             </a:r>
           </a:p>
         </p:txBody>
       </p:sp>
       <p:pic>
         <p:nvPicPr>
-          <p:cNvPr id="5" name="Picture 4" descr="slow_fall_zip7_crop.png"/>
+          <p:cNvPr id="5" name="Picture 4" descr="shadow_zip7_crop.png"/>
           <p:cNvPicPr>
             <a:picLocks noChangeAspect="1"/>
           </p:cNvPicPr>
@@ -7393,8 +7074,8 @@
         </p:blipFill>
         <p:spPr>
           <a:xfrm>
-            <a:off x="411480" y="2651760"/>
-            <a:ext cx="6675120" cy="3432048"/>
+            <a:off x="1167141" y="2697480"/>
+            <a:ext cx="9827237" cy="3794760"/>
           </a:xfrm>
           <a:prstGeom prst="rect">
             <a:avLst/>
@@ -7409,8 +7090,8 @@
         </p:nvSpPr>
         <p:spPr>
           <a:xfrm>
-            <a:off x="411480" y="6113808"/>
-            <a:ext cx="6675120" cy="274320"/>
+            <a:off x="1097280" y="6522240"/>
+            <a:ext cx="9966960" cy="274320"/>
           </a:xfrm>
           <a:prstGeom prst="rect">
             <a:avLst/>
@@ -7431,66 +7112,7 @@
                 </a:solidFill>
                 <a:latin typeface="Arial"/>
               </a:rPr>
-              <a:t>Z7, 3 of the sampled slow-fall events: normal pulses in PBS2/PCS2/PES2, low-frequency swings only in PDS2</a:t>
-            </a:r>
-          </a:p>
-        </p:txBody>
-      </p:sp>
-      <p:pic>
-        <p:nvPicPr>
-          <p:cNvPr id="7" name="Picture 6" descr="time_constants_zip7_PDS2_tfall.png"/>
-          <p:cNvPicPr>
-            <a:picLocks noChangeAspect="1"/>
-          </p:cNvPicPr>
-          <p:nvPr/>
-        </p:nvPicPr>
-        <p:blipFill>
-          <a:blip r:embed="rId3"/>
-          <a:stretch>
-            <a:fillRect/>
-          </a:stretch>
-        </p:blipFill>
-        <p:spPr>
-          <a:xfrm>
-            <a:off x="7315200" y="2834640"/>
-            <a:ext cx="4663440" cy="2926080"/>
-          </a:xfrm>
-          <a:prstGeom prst="rect">
-            <a:avLst/>
-          </a:prstGeom>
-        </p:spPr>
-      </p:pic>
-      <p:sp>
-        <p:nvSpPr>
-          <p:cNvPr id="8" name="TextBox 7"/>
-          <p:cNvSpPr txBox="1"/>
-          <p:nvPr/>
-        </p:nvSpPr>
-        <p:spPr>
-          <a:xfrm>
-            <a:off x="7315200" y="5790720"/>
-            <a:ext cx="4663440" cy="274320"/>
-          </a:xfrm>
-          <a:prstGeom prst="rect">
-            <a:avLst/>
-          </a:prstGeom>
-          <a:noFill/>
-        </p:spPr>
-        <p:txBody>
-          <a:bodyPr wrap="square">
-            <a:spAutoFit/>
-          </a:bodyPr>
-          <a:lstStyle/>
-          <a:p>
-            <a:pPr algn="ctr"/>
-            <a:r>
-              <a:rPr sz="1100" i="1">
-                <a:solidFill>
-                  <a:srgbClr val="666666"/>
-                </a:solidFill>
-                <a:latin typeface="Arial"/>
-              </a:rPr>
-              <a:t>Z7 PDS2, fitted τ_fall: broad tail (median 0.51 ms) — the artifact in the distributions</a:t>
+              <a:t>Z7 echo-trigger events (first 4 channels): raw (gray) / LP (blue) / fit (red) — genuine slow pulses, pretrigger aligned, peak late</a:t>
             </a:r>
           </a:p>
         </p:txBody>
@@ -7542,7 +7164,7 @@
                 </a:solidFill>
                 <a:latin typeface="Arial"/>
               </a:rPr>
-              <a:t>Follow-up 2 — genuine slow-rise pulses (“shadow” events)</a:t>
+              <a:t>Slow drift also fits “slow”: a τ_rise ≤ 0.3 ms ceiling</a:t>
             </a:r>
           </a:p>
         </p:txBody>
@@ -7599,7 +7221,7 @@
         <p:spPr>
           <a:xfrm>
             <a:off x="502920" y="1097280"/>
-            <a:ext cx="11247120" cy="1417320"/>
+            <a:ext cx="11247120" cy="1600200"/>
           </a:xfrm>
           <a:prstGeom prst="rect">
             <a:avLst/>
@@ -7624,7 +7246,7 @@
                 </a:solidFill>
                 <a:latin typeface="Arial"/>
               </a:rPr>
-              <a:t>• Same sampling recipe on the rise side: median NRMSE ≤ 0.4 AND median τ_rise &gt; 0.2 ms → the raw traces show real pulses — pretrigger aligned, peak late, consistent across channels</a:t>
+              <a:t>• On noisy-window detectors a smooth baseline drift survives the NRMSE cut — a slow 2-exp hugs it with a tiny residual — and mimics a slow rise</a:t>
             </a:r>
           </a:p>
           <a:p>
@@ -7640,7 +7262,7 @@
                 </a:solidFill>
                 <a:latin typeface="Arial"/>
               </a:rPr>
-              <a:t>• They are the faint displaced bundle in the aligned overlays — a genuine second pulse shape (candidate surface/bulk effect, not settled)</a:t>
+              <a:t>• Fast pulses sit at τ_rise ≈ 0.1 ms (p90 ≈ 0.15 ms), far below the drift tail → a ceiling at 0.3 ms blocks the drift at ≈ 2–5% signal cost</a:t>
             </a:r>
           </a:p>
           <a:p>
@@ -7656,14 +7278,14 @@
                 </a:solidFill>
                 <a:latin typeface="Arial"/>
               </a:rPr>
-              <a:t>• Real physics → cannot simply be cut away; exactly the shape variation the multi-template NxM method is built to capture</a:t>
+              <a:t>• Keeps most genuine slow pulses, trims the very slowest — documented trade-off, final decision pending</a:t>
             </a:r>
           </a:p>
         </p:txBody>
       </p:sp>
       <p:pic>
         <p:nvPicPr>
-          <p:cNvPr id="5" name="Picture 4" descr="shadow_zip7_crop.png"/>
+          <p:cNvPr id="5" name="Picture 4" descr="time_constants_zip7_PAS1.png"/>
           <p:cNvPicPr>
             <a:picLocks noChangeAspect="1"/>
           </p:cNvPicPr>
@@ -7677,8 +7299,8 @@
         </p:blipFill>
         <p:spPr>
           <a:xfrm>
-            <a:off x="1167141" y="2697480"/>
-            <a:ext cx="9827237" cy="3794760"/>
+            <a:off x="1280160" y="2880360"/>
+            <a:ext cx="9601200" cy="1851803"/>
           </a:xfrm>
           <a:prstGeom prst="rect">
             <a:avLst/>
@@ -7693,8 +7315,8 @@
         </p:nvSpPr>
         <p:spPr>
           <a:xfrm>
-            <a:off x="1097280" y="6522240"/>
-            <a:ext cx="9966960" cy="274320"/>
+            <a:off x="1280160" y="4762163"/>
+            <a:ext cx="9601200" cy="274320"/>
           </a:xfrm>
           <a:prstGeom prst="rect">
             <a:avLst/>
@@ -7715,7 +7337,46 @@
                 </a:solidFill>
                 <a:latin typeface="Arial"/>
               </a:rPr>
-              <a:t>Z7 shadow events (first 4 channels): raw (gray) / LP (blue) / fit (red) — genuine slow pulses, pretrigger aligned, peak late</a:t>
+              <a:t>Z7 PAS1: fitted τ_rise (median 0.105 ms) and τ_fall distributions</a:t>
+            </a:r>
+          </a:p>
+        </p:txBody>
+      </p:sp>
+      <p:sp>
+        <p:nvSpPr>
+          <p:cNvPr id="7" name="TextBox 6"/>
+          <p:cNvSpPr txBox="1"/>
+          <p:nvPr/>
+        </p:nvSpPr>
+        <p:spPr>
+          <a:xfrm>
+            <a:off x="1280160" y="5257800"/>
+            <a:ext cx="9601200" cy="914400"/>
+          </a:xfrm>
+          <a:prstGeom prst="rect">
+            <a:avLst/>
+          </a:prstGeom>
+          <a:noFill/>
+        </p:spPr>
+        <p:txBody>
+          <a:bodyPr wrap="square">
+            <a:spAutoFit/>
+          </a:bodyPr>
+          <a:lstStyle/>
+          <a:p>
+            <a:pPr>
+              <a:spcAft>
+                <a:spcPts val="500"/>
+              </a:spcAft>
+            </a:pPr>
+            <a:r>
+              <a:rPr sz="1300">
+                <a:solidFill>
+                  <a:srgbClr val="333333"/>
+                </a:solidFill>
+                <a:latin typeface="Arial"/>
+              </a:rPr>
+              <a:t>• On quiet detectors both τ_rise and τ_fall distributions are narrow — the pulse shape is stable across events</a:t>
             </a:r>
           </a:p>
         </p:txBody>

</xml_diff>

<commit_message>
snolab: presentation — red 0.4-cut arrow on both NRMSE histograms; remove the fan-cut bullet on the rejected-population slide
Co-Authored-By: Claude Opus 4.8 <noreply@anthropic.com>
</commit_message>
<xml_diff>
--- a/snolab/presentation/SNOLAB_R4_pulse_templates_20260715.pptx
+++ b/snolab/presentation/SNOLAB_R4_pulse_templates_20260715.pptx
@@ -6444,7 +6444,7 @@
         <p:spPr>
           <a:xfrm>
             <a:off x="502920" y="1097280"/>
-            <a:ext cx="11247120" cy="1234440"/>
+            <a:ext cx="11247120" cy="914400"/>
           </a:xfrm>
           <a:prstGeom prst="rect">
             <a:avLst/>
@@ -6470,22 +6470,6 @@
                 <a:latin typeface="Arial"/>
               </a:rPr>
               <a:t>• Event grids of NRMSE-rejected events (median NRMSE &gt; 0.4 across channels): the raw traces show no pulse — the cut removes noise triggers, not physics</a:t>
-            </a:r>
-          </a:p>
-          <a:p>
-            <a:pPr>
-              <a:spcAft>
-                <a:spcPts val="500"/>
-              </a:spcAft>
-            </a:pPr>
-            <a:r>
-              <a:rPr sz="1400">
-                <a:solidFill>
-                  <a:srgbClr val="333333"/>
-                </a:solidFill>
-                <a:latin typeface="Arial"/>
-              </a:rPr>
-              <a:t>• Fan-cut view: fitted curves that pass (green) vs cut away (red) on top of the aligned data, median NRMSE of each population stamped per channel</a:t>
             </a:r>
           </a:p>
         </p:txBody>

</xml_diff>

<commit_message>
snolab: presentation — follow-up 1 now shows normal-channel (PAS1) vs bad-channel (PDS2) t_fall side by side on the same 0-20 ms axis, so the narrow-vs-broad claim is visible on the slide; speech updated
Co-Authored-By: Claude Opus 4.8 <noreply@anthropic.com>
</commit_message>
<xml_diff>
--- a/snolab/presentation/SNOLAB_R4_pulse_templates_20260715.pptx
+++ b/snolab/presentation/SNOLAB_R4_pulse_templates_20260715.pptx
@@ -6819,7 +6819,7 @@
       </p:sp>
       <p:pic>
         <p:nvPicPr>
-          <p:cNvPr id="7" name="Picture 6" descr="time_constants_zip7_PDS2_tfall.png"/>
+          <p:cNvPr id="7" name="Picture 6" descr="time_constants_zip7_PAS1_tfall.png"/>
           <p:cNvPicPr>
             <a:picLocks noChangeAspect="1"/>
           </p:cNvPicPr>
@@ -6833,8 +6833,8 @@
         </p:blipFill>
         <p:spPr>
           <a:xfrm>
-            <a:off x="7315200" y="2834640"/>
-            <a:ext cx="4663440" cy="2926080"/>
+            <a:off x="7630602" y="2487168"/>
+            <a:ext cx="4032636" cy="1554480"/>
           </a:xfrm>
           <a:prstGeom prst="rect">
             <a:avLst/>
@@ -6849,8 +6849,8 @@
         </p:nvSpPr>
         <p:spPr>
           <a:xfrm>
-            <a:off x="7315200" y="5790720"/>
-            <a:ext cx="4663440" cy="274320"/>
+            <a:off x="7360920" y="4071648"/>
+            <a:ext cx="4572000" cy="274320"/>
           </a:xfrm>
           <a:prstGeom prst="rect">
             <a:avLst/>
@@ -6871,7 +6871,66 @@
                 </a:solidFill>
                 <a:latin typeface="Arial"/>
               </a:rPr>
-              <a:t>Z7 PDS2 alone, fitted τ_fall: broad tail (median 0.51 ms vs ≈0.25 ms on good channels) — the artifact quantified</a:t>
+              <a:t>PAS1 — a normal channel: narrow, median 0.25 ms</a:t>
+            </a:r>
+          </a:p>
+        </p:txBody>
+      </p:sp>
+      <p:pic>
+        <p:nvPicPr>
+          <p:cNvPr id="9" name="Picture 8" descr="time_constants_zip7_PDS2_tfall.png"/>
+          <p:cNvPicPr>
+            <a:picLocks noChangeAspect="1"/>
+          </p:cNvPicPr>
+          <p:nvPr/>
+        </p:nvPicPr>
+        <p:blipFill>
+          <a:blip r:embed="rId4"/>
+          <a:stretch>
+            <a:fillRect/>
+          </a:stretch>
+        </p:blipFill>
+        <p:spPr>
+          <a:xfrm>
+            <a:off x="7623270" y="4343400"/>
+            <a:ext cx="4047300" cy="1554480"/>
+          </a:xfrm>
+          <a:prstGeom prst="rect">
+            <a:avLst/>
+          </a:prstGeom>
+        </p:spPr>
+      </p:pic>
+      <p:sp>
+        <p:nvSpPr>
+          <p:cNvPr id="10" name="TextBox 9"/>
+          <p:cNvSpPr txBox="1"/>
+          <p:nvPr/>
+        </p:nvSpPr>
+        <p:spPr>
+          <a:xfrm>
+            <a:off x="7360920" y="5927880"/>
+            <a:ext cx="4572000" cy="274320"/>
+          </a:xfrm>
+          <a:prstGeom prst="rect">
+            <a:avLst/>
+          </a:prstGeom>
+          <a:noFill/>
+        </p:spPr>
+        <p:txBody>
+          <a:bodyPr wrap="square">
+            <a:spAutoFit/>
+          </a:bodyPr>
+          <a:lstStyle/>
+          <a:p>
+            <a:pPr algn="ctr"/>
+            <a:r>
+              <a:rPr sz="1100" i="1">
+                <a:solidFill>
+                  <a:srgbClr val="666666"/>
+                </a:solidFill>
+                <a:latin typeface="Arial"/>
+              </a:rPr>
+              <a:t>PDS2 — the bad channel: broad tail, median 0.51 ms (same 0–20 ms axis)</a:t>
             </a:r>
           </a:p>
         </p:txBody>

</xml_diff>

<commit_message>
snolab: presentation — add slide page numbers (N / 12, bottom-right, title slide excluded)
Co-Authored-By: Claude Opus 4.8 <noreply@anthropic.com>
</commit_message>
<xml_diff>
--- a/snolab/presentation/SNOLAB_R4_pulse_templates_20260715.pptx
+++ b/snolab/presentation/SNOLAB_R4_pulse_templates_20260715.pptx
@@ -4616,6 +4616,41 @@
           </a:p>
         </p:txBody>
       </p:sp>
+      <p:sp>
+        <p:nvSpPr>
+          <p:cNvPr id="7" name="TextBox 6"/>
+          <p:cNvSpPr txBox="1"/>
+          <p:nvPr/>
+        </p:nvSpPr>
+        <p:spPr>
+          <a:xfrm>
+            <a:off x="10957255" y="6446520"/>
+            <a:ext cx="1005840" cy="274320"/>
+          </a:xfrm>
+          <a:prstGeom prst="rect">
+            <a:avLst/>
+          </a:prstGeom>
+          <a:noFill/>
+        </p:spPr>
+        <p:txBody>
+          <a:bodyPr wrap="none">
+            <a:spAutoFit/>
+          </a:bodyPr>
+          <a:lstStyle/>
+          <a:p>
+            <a:pPr algn="r"/>
+            <a:r>
+              <a:rPr sz="1100">
+                <a:solidFill>
+                  <a:srgbClr val="666666"/>
+                </a:solidFill>
+                <a:latin typeface="Arial"/>
+              </a:rPr>
+              <a:t>10 / 12</a:t>
+            </a:r>
+          </a:p>
+        </p:txBody>
+      </p:sp>
     </p:spTree>
   </p:cSld>
   <p:clrMapOvr>
@@ -4865,6 +4900,41 @@
           </a:p>
         </p:txBody>
       </p:sp>
+      <p:sp>
+        <p:nvSpPr>
+          <p:cNvPr id="8" name="TextBox 7"/>
+          <p:cNvSpPr txBox="1"/>
+          <p:nvPr/>
+        </p:nvSpPr>
+        <p:spPr>
+          <a:xfrm>
+            <a:off x="10957255" y="6446520"/>
+            <a:ext cx="1005840" cy="274320"/>
+          </a:xfrm>
+          <a:prstGeom prst="rect">
+            <a:avLst/>
+          </a:prstGeom>
+          <a:noFill/>
+        </p:spPr>
+        <p:txBody>
+          <a:bodyPr wrap="none">
+            <a:spAutoFit/>
+          </a:bodyPr>
+          <a:lstStyle/>
+          <a:p>
+            <a:pPr algn="r"/>
+            <a:r>
+              <a:rPr sz="1100">
+                <a:solidFill>
+                  <a:srgbClr val="666666"/>
+                </a:solidFill>
+                <a:latin typeface="Arial"/>
+              </a:rPr>
+              <a:t>11 / 12</a:t>
+            </a:r>
+          </a:p>
+        </p:txBody>
+      </p:sp>
     </p:spTree>
   </p:cSld>
   <p:clrMapOvr>
@@ -5111,6 +5181,41 @@
           </a:p>
         </p:txBody>
       </p:sp>
+      <p:sp>
+        <p:nvSpPr>
+          <p:cNvPr id="5" name="TextBox 4"/>
+          <p:cNvSpPr txBox="1"/>
+          <p:nvPr/>
+        </p:nvSpPr>
+        <p:spPr>
+          <a:xfrm>
+            <a:off x="10957255" y="6446520"/>
+            <a:ext cx="1005840" cy="274320"/>
+          </a:xfrm>
+          <a:prstGeom prst="rect">
+            <a:avLst/>
+          </a:prstGeom>
+          <a:noFill/>
+        </p:spPr>
+        <p:txBody>
+          <a:bodyPr wrap="none">
+            <a:spAutoFit/>
+          </a:bodyPr>
+          <a:lstStyle/>
+          <a:p>
+            <a:pPr algn="r"/>
+            <a:r>
+              <a:rPr sz="1100">
+                <a:solidFill>
+                  <a:srgbClr val="666666"/>
+                </a:solidFill>
+                <a:latin typeface="Arial"/>
+              </a:rPr>
+              <a:t>12 / 12</a:t>
+            </a:r>
+          </a:p>
+        </p:txBody>
+      </p:sp>
     </p:spTree>
   </p:cSld>
   <p:clrMapOvr>
@@ -5411,6 +5516,41 @@
           </a:p>
         </p:txBody>
       </p:sp>
+      <p:sp>
+        <p:nvSpPr>
+          <p:cNvPr id="8" name="TextBox 7"/>
+          <p:cNvSpPr txBox="1"/>
+          <p:nvPr/>
+        </p:nvSpPr>
+        <p:spPr>
+          <a:xfrm>
+            <a:off x="10957255" y="6446520"/>
+            <a:ext cx="1005840" cy="274320"/>
+          </a:xfrm>
+          <a:prstGeom prst="rect">
+            <a:avLst/>
+          </a:prstGeom>
+          <a:noFill/>
+        </p:spPr>
+        <p:txBody>
+          <a:bodyPr wrap="none">
+            <a:spAutoFit/>
+          </a:bodyPr>
+          <a:lstStyle/>
+          <a:p>
+            <a:pPr algn="r"/>
+            <a:r>
+              <a:rPr sz="1100">
+                <a:solidFill>
+                  <a:srgbClr val="666666"/>
+                </a:solidFill>
+                <a:latin typeface="Arial"/>
+              </a:rPr>
+              <a:t>2 / 12</a:t>
+            </a:r>
+          </a:p>
+        </p:txBody>
+      </p:sp>
     </p:spTree>
   </p:cSld>
   <p:clrMapOvr>
@@ -5788,6 +5928,41 @@
           </a:p>
         </p:txBody>
       </p:sp>
+      <p:sp>
+        <p:nvSpPr>
+          <p:cNvPr id="9" name="TextBox 8"/>
+          <p:cNvSpPr txBox="1"/>
+          <p:nvPr/>
+        </p:nvSpPr>
+        <p:spPr>
+          <a:xfrm>
+            <a:off x="10957255" y="6446520"/>
+            <a:ext cx="1005840" cy="274320"/>
+          </a:xfrm>
+          <a:prstGeom prst="rect">
+            <a:avLst/>
+          </a:prstGeom>
+          <a:noFill/>
+        </p:spPr>
+        <p:txBody>
+          <a:bodyPr wrap="none">
+            <a:spAutoFit/>
+          </a:bodyPr>
+          <a:lstStyle/>
+          <a:p>
+            <a:pPr algn="r"/>
+            <a:r>
+              <a:rPr sz="1100">
+                <a:solidFill>
+                  <a:srgbClr val="666666"/>
+                </a:solidFill>
+                <a:latin typeface="Arial"/>
+              </a:rPr>
+              <a:t>3 / 12</a:t>
+            </a:r>
+          </a:p>
+        </p:txBody>
+      </p:sp>
     </p:spTree>
   </p:cSld>
   <p:clrMapOvr>
@@ -6056,6 +6231,41 @@
           </a:p>
         </p:txBody>
       </p:sp>
+      <p:sp>
+        <p:nvSpPr>
+          <p:cNvPr id="9" name="TextBox 8"/>
+          <p:cNvSpPr txBox="1"/>
+          <p:nvPr/>
+        </p:nvSpPr>
+        <p:spPr>
+          <a:xfrm>
+            <a:off x="10957255" y="6446520"/>
+            <a:ext cx="1005840" cy="274320"/>
+          </a:xfrm>
+          <a:prstGeom prst="rect">
+            <a:avLst/>
+          </a:prstGeom>
+          <a:noFill/>
+        </p:spPr>
+        <p:txBody>
+          <a:bodyPr wrap="none">
+            <a:spAutoFit/>
+          </a:bodyPr>
+          <a:lstStyle/>
+          <a:p>
+            <a:pPr algn="r"/>
+            <a:r>
+              <a:rPr sz="1100">
+                <a:solidFill>
+                  <a:srgbClr val="666666"/>
+                </a:solidFill>
+                <a:latin typeface="Arial"/>
+              </a:rPr>
+              <a:t>4 / 12</a:t>
+            </a:r>
+          </a:p>
+        </p:txBody>
+      </p:sp>
     </p:spTree>
   </p:cSld>
   <p:clrMapOvr>
@@ -6340,6 +6550,41 @@
           </a:p>
         </p:txBody>
       </p:sp>
+      <p:sp>
+        <p:nvSpPr>
+          <p:cNvPr id="9" name="TextBox 8"/>
+          <p:cNvSpPr txBox="1"/>
+          <p:nvPr/>
+        </p:nvSpPr>
+        <p:spPr>
+          <a:xfrm>
+            <a:off x="10957255" y="6446520"/>
+            <a:ext cx="1005840" cy="274320"/>
+          </a:xfrm>
+          <a:prstGeom prst="rect">
+            <a:avLst/>
+          </a:prstGeom>
+          <a:noFill/>
+        </p:spPr>
+        <p:txBody>
+          <a:bodyPr wrap="none">
+            <a:spAutoFit/>
+          </a:bodyPr>
+          <a:lstStyle/>
+          <a:p>
+            <a:pPr algn="r"/>
+            <a:r>
+              <a:rPr sz="1100">
+                <a:solidFill>
+                  <a:srgbClr val="666666"/>
+                </a:solidFill>
+                <a:latin typeface="Arial"/>
+              </a:rPr>
+              <a:t>5 / 12</a:t>
+            </a:r>
+          </a:p>
+        </p:txBody>
+      </p:sp>
     </p:spTree>
   </p:cSld>
   <p:clrMapOvr>
@@ -6592,6 +6837,41 @@
           </a:p>
         </p:txBody>
       </p:sp>
+      <p:sp>
+        <p:nvSpPr>
+          <p:cNvPr id="9" name="TextBox 8"/>
+          <p:cNvSpPr txBox="1"/>
+          <p:nvPr/>
+        </p:nvSpPr>
+        <p:spPr>
+          <a:xfrm>
+            <a:off x="10957255" y="6446520"/>
+            <a:ext cx="1005840" cy="274320"/>
+          </a:xfrm>
+          <a:prstGeom prst="rect">
+            <a:avLst/>
+          </a:prstGeom>
+          <a:noFill/>
+        </p:spPr>
+        <p:txBody>
+          <a:bodyPr wrap="none">
+            <a:spAutoFit/>
+          </a:bodyPr>
+          <a:lstStyle/>
+          <a:p>
+            <a:pPr algn="r"/>
+            <a:r>
+              <a:rPr sz="1100">
+                <a:solidFill>
+                  <a:srgbClr val="666666"/>
+                </a:solidFill>
+                <a:latin typeface="Arial"/>
+              </a:rPr>
+              <a:t>6 / 12</a:t>
+            </a:r>
+          </a:p>
+        </p:txBody>
+      </p:sp>
     </p:spTree>
   </p:cSld>
   <p:clrMapOvr>
@@ -6935,6 +7215,41 @@
           </a:p>
         </p:txBody>
       </p:sp>
+      <p:sp>
+        <p:nvSpPr>
+          <p:cNvPr id="11" name="TextBox 10"/>
+          <p:cNvSpPr txBox="1"/>
+          <p:nvPr/>
+        </p:nvSpPr>
+        <p:spPr>
+          <a:xfrm>
+            <a:off x="10957255" y="6446520"/>
+            <a:ext cx="1005840" cy="274320"/>
+          </a:xfrm>
+          <a:prstGeom prst="rect">
+            <a:avLst/>
+          </a:prstGeom>
+          <a:noFill/>
+        </p:spPr>
+        <p:txBody>
+          <a:bodyPr wrap="none">
+            <a:spAutoFit/>
+          </a:bodyPr>
+          <a:lstStyle/>
+          <a:p>
+            <a:pPr algn="r"/>
+            <a:r>
+              <a:rPr sz="1100">
+                <a:solidFill>
+                  <a:srgbClr val="666666"/>
+                </a:solidFill>
+                <a:latin typeface="Arial"/>
+              </a:rPr>
+              <a:t>7 / 12</a:t>
+            </a:r>
+          </a:p>
+        </p:txBody>
+      </p:sp>
     </p:spTree>
   </p:cSld>
   <p:clrMapOvr>
@@ -7160,6 +7475,41 @@
           </a:p>
         </p:txBody>
       </p:sp>
+      <p:sp>
+        <p:nvSpPr>
+          <p:cNvPr id="7" name="TextBox 6"/>
+          <p:cNvSpPr txBox="1"/>
+          <p:nvPr/>
+        </p:nvSpPr>
+        <p:spPr>
+          <a:xfrm>
+            <a:off x="10957255" y="6446520"/>
+            <a:ext cx="1005840" cy="274320"/>
+          </a:xfrm>
+          <a:prstGeom prst="rect">
+            <a:avLst/>
+          </a:prstGeom>
+          <a:noFill/>
+        </p:spPr>
+        <p:txBody>
+          <a:bodyPr wrap="none">
+            <a:spAutoFit/>
+          </a:bodyPr>
+          <a:lstStyle/>
+          <a:p>
+            <a:pPr algn="r"/>
+            <a:r>
+              <a:rPr sz="1100">
+                <a:solidFill>
+                  <a:srgbClr val="666666"/>
+                </a:solidFill>
+                <a:latin typeface="Arial"/>
+              </a:rPr>
+              <a:t>8 / 12</a:t>
+            </a:r>
+          </a:p>
+        </p:txBody>
+      </p:sp>
     </p:spTree>
   </p:cSld>
   <p:clrMapOvr>
@@ -7420,6 +7770,41 @@
                 <a:latin typeface="Arial"/>
               </a:rPr>
               <a:t>• On quiet detectors both τ_rise and τ_fall distributions are narrow — the pulse shape is stable across events</a:t>
+            </a:r>
+          </a:p>
+        </p:txBody>
+      </p:sp>
+      <p:sp>
+        <p:nvSpPr>
+          <p:cNvPr id="8" name="TextBox 7"/>
+          <p:cNvSpPr txBox="1"/>
+          <p:nvPr/>
+        </p:nvSpPr>
+        <p:spPr>
+          <a:xfrm>
+            <a:off x="10957255" y="6446520"/>
+            <a:ext cx="1005840" cy="274320"/>
+          </a:xfrm>
+          <a:prstGeom prst="rect">
+            <a:avLst/>
+          </a:prstGeom>
+          <a:noFill/>
+        </p:spPr>
+        <p:txBody>
+          <a:bodyPr wrap="none">
+            <a:spAutoFit/>
+          </a:bodyPr>
+          <a:lstStyle/>
+          <a:p>
+            <a:pPr algn="r"/>
+            <a:r>
+              <a:rPr sz="1100">
+                <a:solidFill>
+                  <a:srgbClr val="666666"/>
+                </a:solidFill>
+                <a:latin typeface="Arial"/>
+              </a:rPr>
+              <a:t>9 / 12</a:t>
             </a:r>
           </a:p>
         </p:txBody>

</xml_diff>

<commit_message>
snolab: presentation — drop echo-trigger + tau_rise-ceiling slides (per Prof. Saab); trim template family 1/2 to keyword bullets (detail in speech) and shorten the summary; enlarge follow-up-1 t_fall panels (normal vs bad channel); title date -> July 2026. Deck now 10 slides
Co-Authored-By: Claude Opus 4.8 <noreply@anthropic.com>
</commit_message>
<xml_diff>
--- a/snolab/presentation/SNOLAB_R4_pulse_templates_20260715.pptx
+++ b/snolab/presentation/SNOLAB_R4_pulse_templates_20260715.pptx
@@ -15,8 +15,6 @@
     <p:sldId id="263" r:id="rId15"/>
     <p:sldId id="264" r:id="rId16"/>
     <p:sldId id="265" r:id="rId17"/>
-    <p:sldId id="266" r:id="rId18"/>
-    <p:sldId id="267" r:id="rId19"/>
   </p:sldIdLst>
   <p:sldSz cx="12191695" cy="6858000" type="screen4x3"/>
   <p:notesSz cx="6858000" cy="9144000"/>
@@ -583,146 +581,6 @@
           <a:lstStyle/>
           <a:p>
             <a:r>
-              <a:t>First template family: the analytic one. For each channel we take every physical fitted curve at the common pretrigger and average them with a weight of one over NRMSE squared - badly fit events count less but nothing is excluded by hand. After the cuts, shown here, a single tight shape family remains, and its weighted mean is the 1x1 template - smooth and noise-free by construction because it is built from analytic curves, delivered as peak-normalized ROOT histograms.</a:t>
-            </a:r>
-          </a:p>
-        </p:txBody>
-      </p:sp>
-      <p:sp>
-        <p:nvSpPr>
-          <p:cNvPr id="4" name="Slide Number Placeholder 3"/>
-          <p:cNvSpPr>
-            <a:spLocks noGrp="1"/>
-          </p:cNvSpPr>
-          <p:nvPr>
-            <p:ph type="sldNum" idx="5" sz="quarter"/>
-          </p:nvPr>
-        </p:nvSpPr>
-        <p:spPr/>
-      </p:sp>
-    </p:spTree>
-  </p:cSld>
-  <p:clrMapOvr>
-    <a:masterClrMapping/>
-  </p:clrMapOvr>
-</p:notes>
-</file>
-
-<file path=ppt/notesSlides/notesSlide11.xml><?xml version="1.0" encoding="utf-8"?>
-<p:notes xmlns:a="http://schemas.openxmlformats.org/drawingml/2006/main" xmlns:p="http://schemas.openxmlformats.org/presentationml/2006/main" xmlns:r="http://schemas.openxmlformats.org/officeDocument/2006/relationships">
-  <p:cSld>
-    <p:spTree>
-      <p:nvGrpSpPr>
-        <p:cNvPr id="1" name=""/>
-        <p:cNvGrpSpPr/>
-        <p:nvPr/>
-      </p:nvGrpSpPr>
-      <p:grpSpPr>
-        <a:xfrm>
-          <a:off x="0" y="0"/>
-          <a:ext cx="0" cy="0"/>
-          <a:chOff x="0" y="0"/>
-          <a:chExt cx="0" cy="0"/>
-        </a:xfrm>
-      </p:grpSpPr>
-      <p:sp>
-        <p:nvSpPr>
-          <p:cNvPr id="2" name="Slide Image Placeholder 1"/>
-          <p:cNvSpPr>
-            <a:spLocks noGrp="1"/>
-          </p:cNvSpPr>
-          <p:nvPr>
-            <p:ph type="sldImg" idx="2"/>
-          </p:nvPr>
-        </p:nvSpPr>
-        <p:spPr/>
-      </p:sp>
-      <p:sp>
-        <p:nvSpPr>
-          <p:cNvPr id="3" name="Notes Placeholder 2"/>
-          <p:cNvSpPr>
-            <a:spLocks noGrp="1"/>
-          </p:cNvSpPr>
-          <p:nvPr>
-            <p:ph type="body" idx="3" sz="quarter"/>
-          </p:nvPr>
-        </p:nvSpPr>
-        <p:spPr/>
-        <p:txBody>
-          <a:bodyPr/>
-          <a:lstStyle/>
-          <a:p>
-            <a:r>
-              <a:t>Second family: the NxM PCA templates, built to capture the shape variation we just saw. We run a PCA over the fitted curves that pass all cuts, in a window around the pulse. The mean shape becomes template zero, and the first four principal components become templates one to four - they oscillate and can be negative, and the optimal filter fits a real pulse as a linear combination of them. The first two components already capture 96 to 98 percent of the shape variance on every detector.</a:t>
-            </a:r>
-          </a:p>
-        </p:txBody>
-      </p:sp>
-      <p:sp>
-        <p:nvSpPr>
-          <p:cNvPr id="4" name="Slide Number Placeholder 3"/>
-          <p:cNvSpPr>
-            <a:spLocks noGrp="1"/>
-          </p:cNvSpPr>
-          <p:nvPr>
-            <p:ph type="sldNum" idx="5" sz="quarter"/>
-          </p:nvPr>
-        </p:nvSpPr>
-        <p:spPr/>
-      </p:sp>
-    </p:spTree>
-  </p:cSld>
-  <p:clrMapOvr>
-    <a:masterClrMapping/>
-  </p:clrMapOvr>
-</p:notes>
-</file>
-
-<file path=ppt/notesSlides/notesSlide12.xml><?xml version="1.0" encoding="utf-8"?>
-<p:notes xmlns:a="http://schemas.openxmlformats.org/drawingml/2006/main" xmlns:p="http://schemas.openxmlformats.org/presentationml/2006/main" xmlns:r="http://schemas.openxmlformats.org/officeDocument/2006/relationships">
-  <p:cSld>
-    <p:spTree>
-      <p:nvGrpSpPr>
-        <p:cNvPr id="1" name=""/>
-        <p:cNvGrpSpPr/>
-        <p:nvPr/>
-      </p:nvGrpSpPr>
-      <p:grpSpPr>
-        <a:xfrm>
-          <a:off x="0" y="0"/>
-          <a:ext cx="0" cy="0"/>
-          <a:chOff x="0" y="0"/>
-          <a:chExt cx="0" cy="0"/>
-        </a:xfrm>
-      </p:grpSpPr>
-      <p:sp>
-        <p:nvSpPr>
-          <p:cNvPr id="2" name="Slide Image Placeholder 1"/>
-          <p:cNvSpPr>
-            <a:spLocks noGrp="1"/>
-          </p:cNvSpPr>
-          <p:nvPr>
-            <p:ph type="sldImg" idx="2"/>
-          </p:nvPr>
-        </p:nvSpPr>
-        <p:spPr/>
-      </p:sp>
-      <p:sp>
-        <p:nvSpPr>
-          <p:cNvPr id="3" name="Notes Placeholder 2"/>
-          <p:cNvSpPr>
-            <a:spLocks noGrp="1"/>
-          </p:cNvSpPr>
-          <p:nvPr>
-            <p:ph type="body" idx="3" sz="quarter"/>
-          </p:nvPr>
-        </p:nvSpPr>
-        <p:spPr/>
-        <p:txBody>
-          <a:bodyPr/>
-          <a:lstStyle/>
-          <a:p>
-            <a:r>
               <a:t>To summarize: both template families are delivered for all 13 detectors in the official PulseTemplates format - the analytic 1x1 templates and the PCA NxM set. The whole chain is traceable from raw traces to every figure, and both quality cuts were read off the data and verified in the raw traces. Two things remain: the final call on the rise-time ceiling versus the genuine slow pulses, and running the group's template-validation method on the new templates. Thank you - happy to take questions.</a:t>
             </a:r>
           </a:p>
@@ -1213,7 +1071,7 @@
           <a:lstStyle/>
           <a:p>
             <a:r>
-              <a:t>The second lead is the slow rise. Same recipe: take events that fit well - NRMSE fine - but whose median rise time is above zero point two milliseconds, sample them, look at the raw traces. This time the conclusion is the opposite: these are real pulses. The pretrigger is aligned, peak arriving late, consistent across all channels - they are the echo-trigger population - a genuine second, slower pulse shape. So the slow rise cannot simply be cut away: there is real physics in it, possibly related to where in the crystal the event happens; that is not settled yet.</a:t>
+              <a:t>First template family: the analytic one. For each channel we take every physical fitted curve at the common pretrigger and average them with a weight of one over NRMSE squared - badly fit events count less but nothing is excluded by hand. After the cuts, shown here, a single tight shape family remains, and its weighted mean is the 1x1 template - smooth and noise-free by construction because it is built from analytic curves, delivered as peak-normalized ROOT histograms.</a:t>
             </a:r>
           </a:p>
         </p:txBody>
@@ -1283,7 +1141,7 @@
           <a:lstStyle/>
           <a:p>
             <a:r>
-              <a:t>But on the slow-rise side there is also a troublemaker: on detectors with a noisy window, a slow baseline drift also fits as a slow rise, with a tiny residual - NRMSE cannot catch it. The real pulses cluster near zero point one milliseconds while the drift tail stretches much further, so for the template input we set a ceiling at zero point three milliseconds. That blocks the drift and keeps the vast majority of real pulses - including part of the echo-trigger population; the price is that the very slowest genuine pulses get trimmed too. That trade-off is documented and not final - I would like your input on it later.</a:t>
+              <a:t>Second family: the NxM PCA templates, built to capture the pulse-shape variation across events. We run a PCA over the fitted curves that pass all cuts, in a window around the pulse. The mean shape becomes template zero, and the first four principal components become templates one to four - they oscillate and can be negative, and the optimal filter fits a real pulse as a linear combination of them. The first two components already capture 96 to 98 percent of the shape variance on every detector.</a:t>
             </a:r>
           </a:p>
         </p:txBody>
@@ -4386,7 +4244,7 @@
                 </a:solidFill>
                 <a:latin typeface="Arial"/>
               </a:rPr>
-              <a:t>Zhiheng Li  —  July 15, 2026</a:t>
+              <a:t>Zhiheng Li  —  July 2026</a:t>
             </a:r>
           </a:p>
         </p:txBody>
@@ -4438,7 +4296,7 @@
                 </a:solidFill>
                 <a:latin typeface="Arial"/>
               </a:rPr>
-              <a:t>Template family 1 — analytic 2-exp, NRMSE-weighted (1x1)</a:t>
+              <a:t>Delivered — and what remains</a:t>
             </a:r>
           </a:p>
         </p:txBody>
@@ -4494,8 +4352,8 @@
         </p:nvSpPr>
         <p:spPr>
           <a:xfrm>
-            <a:off x="502920" y="1097280"/>
-            <a:ext cx="11247120" cy="1417320"/>
+            <a:off x="502920" y="1554480"/>
+            <a:ext cx="11247120" cy="3200400"/>
           </a:xfrm>
           <a:prstGeom prst="rect">
             <a:avLst/>
@@ -4514,13 +4372,13 @@
               </a:spcAft>
             </a:pPr>
             <a:r>
-              <a:rPr sz="1400">
+              <a:rPr sz="2200">
                 <a:solidFill>
                   <a:srgbClr val="333333"/>
                 </a:solidFill>
                 <a:latin typeface="Arial"/>
               </a:rPr>
-              <a:t>• Per channel: weighted mean of ALL fit_ok fitted curves at the common pretrigger, weight w = 1/max(NRMSE, 0.01)²</a:t>
+              <a:t>• Two template families built for all 13 detectors:  1x1 (2-exp weighted)  +  NxM PCA</a:t>
             </a:r>
           </a:p>
           <a:p>
@@ -4530,13 +4388,13 @@
               </a:spcAft>
             </a:pPr>
             <a:r>
-              <a:rPr sz="1400">
+              <a:rPr sz="2200">
                 <a:solidFill>
                   <a:srgbClr val="333333"/>
                 </a:solidFill>
                 <a:latin typeface="Arial"/>
               </a:rPr>
-              <a:t>• Badly-fit events count less but are never excluded — robust and smooth (noise-free by construction)</a:t>
+              <a:t>• Delivered in the official cdmsbats PulseTemplates format</a:t>
             </a:r>
           </a:p>
           <a:p>
@@ -4546,227 +4404,15 @@
               </a:spcAft>
             </a:pPr>
             <a:r>
-              <a:rPr sz="1400">
+              <a:rPr sz="2200">
                 <a:solidFill>
                   <a:srgbClr val="333333"/>
                 </a:solidFill>
                 <a:latin typeface="Arial"/>
               </a:rPr>
-              <a:t>• Delivered as peak-normalized 32768-bin ROOT TH1D per channel + summed PT/PS1/PS2 templates</a:t>
-            </a:r>
-          </a:p>
-        </p:txBody>
-      </p:sp>
-      <p:pic>
-        <p:nvPicPr>
-          <p:cNvPr id="5" name="Picture 4" descr="fan_zip7_PBS1_after.png"/>
-          <p:cNvPicPr>
-            <a:picLocks noChangeAspect="1"/>
-          </p:cNvPicPr>
-          <p:nvPr/>
-        </p:nvPicPr>
-        <p:blipFill>
-          <a:blip r:embed="rId2"/>
-          <a:stretch>
-            <a:fillRect/>
-          </a:stretch>
-        </p:blipFill>
-        <p:spPr>
-          <a:xfrm>
-            <a:off x="1383919" y="3063240"/>
-            <a:ext cx="9393682" cy="2834640"/>
-          </a:xfrm>
-          <a:prstGeom prst="rect">
-            <a:avLst/>
-          </a:prstGeom>
-        </p:spPr>
-      </p:pic>
-      <p:sp>
-        <p:nvSpPr>
-          <p:cNvPr id="6" name="TextBox 5"/>
-          <p:cNvSpPr txBox="1"/>
-          <p:nvPr/>
-        </p:nvSpPr>
-        <p:spPr>
-          <a:xfrm>
-            <a:off x="1280160" y="5927880"/>
-            <a:ext cx="9601200" cy="274320"/>
-          </a:xfrm>
-          <a:prstGeom prst="rect">
-            <a:avLst/>
-          </a:prstGeom>
-          <a:noFill/>
-        </p:spPr>
-        <p:txBody>
-          <a:bodyPr wrap="square">
-            <a:spAutoFit/>
-          </a:bodyPr>
-          <a:lstStyle/>
-          <a:p>
-            <a:pPr algn="ctr"/>
-            <a:r>
-              <a:rPr sz="1100" i="1">
-                <a:solidFill>
-                  <a:srgbClr val="666666"/>
-                </a:solidFill>
-                <a:latin typeface="Arial"/>
-              </a:rPr>
-              <a:t>Z7 PBS1, fitted curves after NRMSE ≤ 0.4 and τ_rise ≤ 0.3 ms — the NRMSE-weighted mean of this family is the 1x1 template</a:t>
-            </a:r>
-          </a:p>
-        </p:txBody>
-      </p:sp>
-      <p:sp>
-        <p:nvSpPr>
-          <p:cNvPr id="7" name="TextBox 6"/>
-          <p:cNvSpPr txBox="1"/>
-          <p:nvPr/>
-        </p:nvSpPr>
-        <p:spPr>
-          <a:xfrm>
-            <a:off x="10957255" y="6446520"/>
-            <a:ext cx="1005840" cy="274320"/>
-          </a:xfrm>
-          <a:prstGeom prst="rect">
-            <a:avLst/>
-          </a:prstGeom>
-          <a:noFill/>
-        </p:spPr>
-        <p:txBody>
-          <a:bodyPr wrap="none">
-            <a:spAutoFit/>
-          </a:bodyPr>
-          <a:lstStyle/>
-          <a:p>
-            <a:pPr algn="r"/>
-            <a:r>
-              <a:rPr sz="1100">
-                <a:solidFill>
-                  <a:srgbClr val="666666"/>
-                </a:solidFill>
-                <a:latin typeface="Arial"/>
-              </a:rPr>
-              <a:t>10 / 12</a:t>
-            </a:r>
-          </a:p>
-        </p:txBody>
-      </p:sp>
-    </p:spTree>
-  </p:cSld>
-  <p:clrMapOvr>
-    <a:masterClrMapping/>
-  </p:clrMapOvr>
-</p:sld>
-</file>
-
-<file path=ppt/slides/slide11.xml><?xml version="1.0" encoding="utf-8"?>
-<p:sld xmlns:a="http://schemas.openxmlformats.org/drawingml/2006/main" xmlns:p="http://schemas.openxmlformats.org/presentationml/2006/main" xmlns:r="http://schemas.openxmlformats.org/officeDocument/2006/relationships">
-  <p:cSld>
-    <p:spTree>
-      <p:nvGrpSpPr>
-        <p:cNvPr id="1" name=""/>
-        <p:cNvGrpSpPr/>
-        <p:nvPr/>
-      </p:nvGrpSpPr>
-      <p:grpSpPr/>
-      <p:sp>
-        <p:nvSpPr>
-          <p:cNvPr id="2" name="TextBox 1"/>
-          <p:cNvSpPr txBox="1"/>
-          <p:nvPr/>
-        </p:nvSpPr>
-        <p:spPr>
-          <a:xfrm>
-            <a:off x="502920" y="256032"/>
-            <a:ext cx="11247120" cy="685800"/>
-          </a:xfrm>
-          <a:prstGeom prst="rect">
-            <a:avLst/>
-          </a:prstGeom>
-          <a:noFill/>
-        </p:spPr>
-        <p:txBody>
-          <a:bodyPr wrap="square">
-            <a:spAutoFit/>
-          </a:bodyPr>
-          <a:lstStyle/>
-          <a:p>
-            <a:r>
-              <a:rPr sz="2700" b="1">
-                <a:solidFill>
-                  <a:srgbClr val="1F3864"/>
-                </a:solidFill>
-                <a:latin typeface="Arial"/>
-              </a:rPr>
-              <a:t>Template family 2 — NxM PCA templates</a:t>
-            </a:r>
-          </a:p>
-        </p:txBody>
-      </p:sp>
-      <p:sp>
-        <p:nvSpPr>
-          <p:cNvPr id="3" name="Rectangle 2"/>
-          <p:cNvSpPr/>
-          <p:nvPr/>
-        </p:nvSpPr>
-        <p:spPr>
-          <a:xfrm>
-            <a:off x="502920" y="932688"/>
-            <a:ext cx="11247120" cy="18000"/>
-          </a:xfrm>
-          <a:prstGeom prst="rect">
-            <a:avLst/>
-          </a:prstGeom>
-          <a:solidFill>
-            <a:srgbClr val="1F3864"/>
-          </a:solidFill>
-          <a:ln>
-            <a:noFill/>
-          </a:ln>
-        </p:spPr>
-        <p:style>
-          <a:lnRef idx="1">
-            <a:schemeClr val="accent1"/>
-          </a:lnRef>
-          <a:fillRef idx="3">
-            <a:schemeClr val="accent1"/>
-          </a:fillRef>
-          <a:effectRef idx="2">
-            <a:schemeClr val="accent1"/>
-          </a:effectRef>
-          <a:fontRef idx="minor">
-            <a:schemeClr val="lt1"/>
-          </a:fontRef>
-        </p:style>
-        <p:txBody>
-          <a:bodyPr rtlCol="0" anchor="ctr"/>
-          <a:lstStyle/>
-          <a:p>
-            <a:pPr algn="ctr"/>
-          </a:p>
-        </p:txBody>
-      </p:sp>
-      <p:sp>
-        <p:nvSpPr>
-          <p:cNvPr id="4" name="TextBox 3"/>
-          <p:cNvSpPr txBox="1"/>
-          <p:nvPr/>
-        </p:nvSpPr>
-        <p:spPr>
-          <a:xfrm>
-            <a:off x="502920" y="1097280"/>
-            <a:ext cx="11247120" cy="1417320"/>
-          </a:xfrm>
-          <a:prstGeom prst="rect">
-            <a:avLst/>
-          </a:prstGeom>
-          <a:noFill/>
-        </p:spPr>
-        <p:txBody>
-          <a:bodyPr wrap="square">
-            <a:spAutoFit/>
-          </a:bodyPr>
-          <a:lstStyle/>
+              <a:t>• Cuts read off the data, verified in raw traces:  NRMSE ≤ 0.4,  τ_rise ≤ 0.3 ms</a:t>
+            </a:r>
+          </a:p>
           <a:p>
             <a:pPr>
               <a:spcAft>
@@ -4774,135 +4420,20 @@
               </a:spcAft>
             </a:pPr>
             <a:r>
-              <a:rPr sz="1400">
+              <a:rPr sz="2200">
                 <a:solidFill>
                   <a:srgbClr val="333333"/>
                 </a:solidFill>
                 <a:latin typeface="Arial"/>
               </a:rPr>
-              <a:t>• Input: fitted curves passing fit_ok + NRMSE ≤ 0.4 + τ_rise ≤ 0.3 ms, at common pretrigger, peak-normalized (PCA window 15550–24050, ≤ 3000 curves/channel)</a:t>
-            </a:r>
-          </a:p>
-          <a:p>
-            <a:pPr>
-              <a:spcAft>
-                <a:spcPts val="500"/>
-              </a:spcAft>
-            </a:pPr>
-            <a:r>
-              <a:rPr sz="1400">
-                <a:solidFill>
-                  <a:srgbClr val="333333"/>
-                </a:solidFill>
-                <a:latin typeface="Arial"/>
-              </a:rPr>
-              <a:t>• nxm0 = mean shape;  nxm1…nxm4 = first four principal components — a real pulse is fit as Σᵢ ampᵢ · nxmᵢ</a:t>
-            </a:r>
-          </a:p>
-          <a:p>
-            <a:pPr>
-              <a:spcAft>
-                <a:spcPts val="500"/>
-              </a:spcAft>
-            </a:pPr>
-            <a:r>
-              <a:rPr sz="1400">
-                <a:solidFill>
-                  <a:srgbClr val="333333"/>
-                </a:solidFill>
-                <a:latin typeface="Arial"/>
-              </a:rPr>
-              <a:t>• PC1 + PC2 already capture 96–98% of the shape variance; final step before delivery: normalize all five to unit peak — the delivered product</a:t>
-            </a:r>
-          </a:p>
-        </p:txBody>
-      </p:sp>
-      <p:pic>
-        <p:nvPicPr>
-          <p:cNvPr id="5" name="Picture 4" descr="pca_zip7_PAS1.png"/>
-          <p:cNvPicPr>
-            <a:picLocks noChangeAspect="1"/>
-          </p:cNvPicPr>
-          <p:nvPr/>
-        </p:nvPicPr>
-        <p:blipFill>
-          <a:blip r:embed="rId2"/>
-          <a:stretch>
-            <a:fillRect/>
-          </a:stretch>
-        </p:blipFill>
-        <p:spPr>
-          <a:xfrm>
-            <a:off x="2831374" y="2697480"/>
-            <a:ext cx="6498771" cy="1828800"/>
-          </a:xfrm>
-          <a:prstGeom prst="rect">
-            <a:avLst/>
-          </a:prstGeom>
-        </p:spPr>
-      </p:pic>
-      <p:pic>
-        <p:nvPicPr>
-          <p:cNvPr id="6" name="Picture 5" descr="pca_zip7_PBS1.png"/>
-          <p:cNvPicPr>
-            <a:picLocks noChangeAspect="1"/>
-          </p:cNvPicPr>
-          <p:nvPr/>
-        </p:nvPicPr>
-        <p:blipFill>
-          <a:blip r:embed="rId3"/>
-          <a:stretch>
-            <a:fillRect/>
-          </a:stretch>
-        </p:blipFill>
-        <p:spPr>
-          <a:xfrm>
-            <a:off x="2831374" y="4572000"/>
-            <a:ext cx="6498771" cy="1828800"/>
-          </a:xfrm>
-          <a:prstGeom prst="rect">
-            <a:avLst/>
-          </a:prstGeom>
-        </p:spPr>
-      </p:pic>
-      <p:sp>
-        <p:nvSpPr>
-          <p:cNvPr id="7" name="TextBox 6"/>
-          <p:cNvSpPr txBox="1"/>
-          <p:nvPr/>
-        </p:nvSpPr>
-        <p:spPr>
-          <a:xfrm>
-            <a:off x="1371600" y="6430800"/>
-            <a:ext cx="9418320" cy="274320"/>
-          </a:xfrm>
-          <a:prstGeom prst="rect">
-            <a:avLst/>
-          </a:prstGeom>
-          <a:noFill/>
-        </p:spPr>
-        <p:txBody>
-          <a:bodyPr wrap="square">
-            <a:spAutoFit/>
-          </a:bodyPr>
-          <a:lstStyle/>
-          <a:p>
-            <a:pPr algn="ctr"/>
-            <a:r>
-              <a:rPr sz="1100" i="1">
-                <a:solidFill>
-                  <a:srgbClr val="666666"/>
-                </a:solidFill>
-                <a:latin typeface="Arial"/>
-              </a:rPr>
-              <a:t>Z7 PAS1 / PBS1: nxm0 (mean) + nxm1–4 (PCs) — the oscillating components encode rise/fall-time variation</a:t>
-            </a:r>
-          </a:p>
-        </p:txBody>
-      </p:sp>
-      <p:sp>
-        <p:nvSpPr>
-          <p:cNvPr id="8" name="TextBox 7"/>
+              <a:t>• Next: run the group's template-validation on the new templates</a:t>
+            </a:r>
+          </a:p>
+        </p:txBody>
+      </p:sp>
+      <p:sp>
+        <p:nvSpPr>
+          <p:cNvPr id="5" name="TextBox 4"/>
           <p:cNvSpPr txBox="1"/>
           <p:nvPr/>
         </p:nvSpPr>
@@ -4930,288 +4461,7 @@
                 </a:solidFill>
                 <a:latin typeface="Arial"/>
               </a:rPr>
-              <a:t>11 / 12</a:t>
-            </a:r>
-          </a:p>
-        </p:txBody>
-      </p:sp>
-    </p:spTree>
-  </p:cSld>
-  <p:clrMapOvr>
-    <a:masterClrMapping/>
-  </p:clrMapOvr>
-</p:sld>
-</file>
-
-<file path=ppt/slides/slide12.xml><?xml version="1.0" encoding="utf-8"?>
-<p:sld xmlns:a="http://schemas.openxmlformats.org/drawingml/2006/main" xmlns:p="http://schemas.openxmlformats.org/presentationml/2006/main" xmlns:r="http://schemas.openxmlformats.org/officeDocument/2006/relationships">
-  <p:cSld>
-    <p:spTree>
-      <p:nvGrpSpPr>
-        <p:cNvPr id="1" name=""/>
-        <p:cNvGrpSpPr/>
-        <p:nvPr/>
-      </p:nvGrpSpPr>
-      <p:grpSpPr/>
-      <p:sp>
-        <p:nvSpPr>
-          <p:cNvPr id="2" name="TextBox 1"/>
-          <p:cNvSpPr txBox="1"/>
-          <p:nvPr/>
-        </p:nvSpPr>
-        <p:spPr>
-          <a:xfrm>
-            <a:off x="502920" y="256032"/>
-            <a:ext cx="11247120" cy="685800"/>
-          </a:xfrm>
-          <a:prstGeom prst="rect">
-            <a:avLst/>
-          </a:prstGeom>
-          <a:noFill/>
-        </p:spPr>
-        <p:txBody>
-          <a:bodyPr wrap="square">
-            <a:spAutoFit/>
-          </a:bodyPr>
-          <a:lstStyle/>
-          <a:p>
-            <a:r>
-              <a:rPr sz="2700" b="1">
-                <a:solidFill>
-                  <a:srgbClr val="1F3864"/>
-                </a:solidFill>
-                <a:latin typeface="Arial"/>
-              </a:rPr>
-              <a:t>Delivered — and what remains</a:t>
-            </a:r>
-          </a:p>
-        </p:txBody>
-      </p:sp>
-      <p:sp>
-        <p:nvSpPr>
-          <p:cNvPr id="3" name="Rectangle 2"/>
-          <p:cNvSpPr/>
-          <p:nvPr/>
-        </p:nvSpPr>
-        <p:spPr>
-          <a:xfrm>
-            <a:off x="502920" y="932688"/>
-            <a:ext cx="11247120" cy="18000"/>
-          </a:xfrm>
-          <a:prstGeom prst="rect">
-            <a:avLst/>
-          </a:prstGeom>
-          <a:solidFill>
-            <a:srgbClr val="1F3864"/>
-          </a:solidFill>
-          <a:ln>
-            <a:noFill/>
-          </a:ln>
-        </p:spPr>
-        <p:style>
-          <a:lnRef idx="1">
-            <a:schemeClr val="accent1"/>
-          </a:lnRef>
-          <a:fillRef idx="3">
-            <a:schemeClr val="accent1"/>
-          </a:fillRef>
-          <a:effectRef idx="2">
-            <a:schemeClr val="accent1"/>
-          </a:effectRef>
-          <a:fontRef idx="minor">
-            <a:schemeClr val="lt1"/>
-          </a:fontRef>
-        </p:style>
-        <p:txBody>
-          <a:bodyPr rtlCol="0" anchor="ctr"/>
-          <a:lstStyle/>
-          <a:p>
-            <a:pPr algn="ctr"/>
-          </a:p>
-        </p:txBody>
-      </p:sp>
-      <p:sp>
-        <p:nvSpPr>
-          <p:cNvPr id="4" name="TextBox 3"/>
-          <p:cNvSpPr txBox="1"/>
-          <p:nvPr/>
-        </p:nvSpPr>
-        <p:spPr>
-          <a:xfrm>
-            <a:off x="502920" y="1188720"/>
-            <a:ext cx="11247120" cy="4206240"/>
-          </a:xfrm>
-          <a:prstGeom prst="rect">
-            <a:avLst/>
-          </a:prstGeom>
-          <a:noFill/>
-        </p:spPr>
-        <p:txBody>
-          <a:bodyPr wrap="square">
-            <a:spAutoFit/>
-          </a:bodyPr>
-          <a:lstStyle/>
-          <a:p>
-            <a:pPr>
-              <a:spcAft>
-                <a:spcPts val="500"/>
-              </a:spcAft>
-            </a:pPr>
-            <a:r>
-              <a:rPr sz="1600">
-                <a:solidFill>
-                  <a:srgbClr val="333333"/>
-                </a:solidFill>
-                <a:latin typeface="Arial"/>
-              </a:rPr>
-              <a:t>• Delivered for all 13 zips, official cdmsbats PulseTemplates layout (zip{N}/{chan}, {chan}nxm0–4, summed PT/PS1/PS2):</a:t>
-            </a:r>
-          </a:p>
-          <a:p>
-            <a:pPr lvl="1">
-              <a:spcAft>
-                <a:spcPts val="500"/>
-              </a:spcAft>
-            </a:pPr>
-            <a:r>
-              <a:rPr sz="1400">
-                <a:solidFill>
-                  <a:srgbClr val="666666"/>
-                </a:solidFill>
-                <a:latin typeface="Arial"/>
-              </a:rPr>
-              <a:t>– SNOLAB_R4_20260706_ZhihengLi_zip{N}.root — 2-exp NRMSE-weighted (1x1)</a:t>
-            </a:r>
-          </a:p>
-          <a:p>
-            <a:pPr lvl="1">
-              <a:spcAft>
-                <a:spcPts val="500"/>
-              </a:spcAft>
-            </a:pPr>
-            <a:r>
-              <a:rPr sz="1400">
-                <a:solidFill>
-                  <a:srgbClr val="666666"/>
-                </a:solidFill>
-                <a:latin typeface="Arial"/>
-              </a:rPr>
-              <a:t>– SNOLAB_R4_20260707_ZhihengLi_pca_zip{N}.root — NxM PCA (normalized)</a:t>
-            </a:r>
-          </a:p>
-          <a:p>
-            <a:pPr>
-              <a:spcAft>
-                <a:spcPts val="500"/>
-              </a:spcAft>
-            </a:pPr>
-            <a:r>
-              <a:rPr sz="1600">
-                <a:solidFill>
-                  <a:srgbClr val="333333"/>
-                </a:solidFill>
-                <a:latin typeface="Arial"/>
-              </a:rPr>
-              <a:t>• Every step is traceable: raw cache → per-series fit checkpoints indexed by EventNumber → self-documenting figures (11 types × 13 zips, all versioned)</a:t>
-            </a:r>
-          </a:p>
-          <a:p>
-            <a:pPr>
-              <a:spcAft>
-                <a:spcPts val="500"/>
-              </a:spcAft>
-            </a:pPr>
-            <a:r>
-              <a:rPr sz="1600">
-                <a:solidFill>
-                  <a:srgbClr val="333333"/>
-                </a:solidFill>
-                <a:latin typeface="Arial"/>
-              </a:rPr>
-              <a:t>• Cuts derived from the data, validated in raw traces: NRMSE ≤ 0.4 (bimodal valley), τ_rise ≤ 0.3 ms (drift leakage)</a:t>
-            </a:r>
-          </a:p>
-          <a:p>
-            <a:pPr>
-              <a:spcAft>
-                <a:spcPts val="500"/>
-              </a:spcAft>
-            </a:pPr>
-            <a:r>
-              <a:rPr sz="1600">
-                <a:solidFill>
-                  <a:srgbClr val="333333"/>
-                </a:solidFill>
-                <a:latin typeface="Arial"/>
-              </a:rPr>
-              <a:t>• Open items:</a:t>
-            </a:r>
-          </a:p>
-          <a:p>
-            <a:pPr lvl="1">
-              <a:spcAft>
-                <a:spcPts val="500"/>
-              </a:spcAft>
-            </a:pPr>
-            <a:r>
-              <a:rPr sz="1400">
-                <a:solidFill>
-                  <a:srgbClr val="666666"/>
-                </a:solidFill>
-                <a:latin typeface="Arial"/>
-              </a:rPr>
-              <a:t>– final decision on the τ_rise ceiling vs the genuine slow-pulse population</a:t>
-            </a:r>
-          </a:p>
-          <a:p>
-            <a:pPr lvl="1">
-              <a:spcAft>
-                <a:spcPts val="500"/>
-              </a:spcAft>
-            </a:pPr>
-            <a:r>
-              <a:rPr sz="1400">
-                <a:solidFill>
-                  <a:srgbClr val="666666"/>
-                </a:solidFill>
-                <a:latin typeface="Arial"/>
-              </a:rPr>
-              <a:t>– run the group's template-validation method on the new templates</a:t>
-            </a:r>
-          </a:p>
-        </p:txBody>
-      </p:sp>
-      <p:sp>
-        <p:nvSpPr>
-          <p:cNvPr id="5" name="TextBox 4"/>
-          <p:cNvSpPr txBox="1"/>
-          <p:nvPr/>
-        </p:nvSpPr>
-        <p:spPr>
-          <a:xfrm>
-            <a:off x="10957255" y="6446520"/>
-            <a:ext cx="1005840" cy="274320"/>
-          </a:xfrm>
-          <a:prstGeom prst="rect">
-            <a:avLst/>
-          </a:prstGeom>
-          <a:noFill/>
-        </p:spPr>
-        <p:txBody>
-          <a:bodyPr wrap="none">
-            <a:spAutoFit/>
-          </a:bodyPr>
-          <a:lstStyle/>
-          <a:p>
-            <a:pPr algn="r"/>
-            <a:r>
-              <a:rPr sz="1100">
-                <a:solidFill>
-                  <a:srgbClr val="666666"/>
-                </a:solidFill>
-                <a:latin typeface="Arial"/>
-              </a:rPr>
-              <a:t>12 / 12</a:t>
+              <a:t>10 / 10</a:t>
             </a:r>
           </a:p>
         </p:txBody>
@@ -5546,7 +4796,7 @@
                 </a:solidFill>
                 <a:latin typeface="Arial"/>
               </a:rPr>
-              <a:t>2 / 12</a:t>
+              <a:t>2 / 10</a:t>
             </a:r>
           </a:p>
         </p:txBody>
@@ -5958,7 +5208,7 @@
                 </a:solidFill>
                 <a:latin typeface="Arial"/>
               </a:rPr>
-              <a:t>3 / 12</a:t>
+              <a:t>3 / 10</a:t>
             </a:r>
           </a:p>
         </p:txBody>
@@ -6261,7 +5511,7 @@
                 </a:solidFill>
                 <a:latin typeface="Arial"/>
               </a:rPr>
-              <a:t>4 / 12</a:t>
+              <a:t>4 / 10</a:t>
             </a:r>
           </a:p>
         </p:txBody>
@@ -6580,7 +5830,7 @@
                 </a:solidFill>
                 <a:latin typeface="Arial"/>
               </a:rPr>
-              <a:t>5 / 12</a:t>
+              <a:t>5 / 10</a:t>
             </a:r>
           </a:p>
         </p:txBody>
@@ -6867,7 +6117,7 @@
                 </a:solidFill>
                 <a:latin typeface="Arial"/>
               </a:rPr>
-              <a:t>6 / 12</a:t>
+              <a:t>6 / 10</a:t>
             </a:r>
           </a:p>
         </p:txBody>
@@ -7113,8 +6363,8 @@
         </p:blipFill>
         <p:spPr>
           <a:xfrm>
-            <a:off x="7630602" y="2487168"/>
-            <a:ext cx="4032636" cy="1554480"/>
+            <a:off x="8077201" y="2450592"/>
+            <a:ext cx="3047998" cy="1874519"/>
           </a:xfrm>
           <a:prstGeom prst="rect">
             <a:avLst/>
@@ -7129,8 +6379,8 @@
         </p:nvSpPr>
         <p:spPr>
           <a:xfrm>
-            <a:off x="7360920" y="4071648"/>
-            <a:ext cx="4572000" cy="274320"/>
+            <a:off x="7086600" y="4355111"/>
+            <a:ext cx="5029200" cy="274320"/>
           </a:xfrm>
           <a:prstGeom prst="rect">
             <a:avLst/>
@@ -7172,8 +6422,8 @@
         </p:blipFill>
         <p:spPr>
           <a:xfrm>
-            <a:off x="7623270" y="4343400"/>
-            <a:ext cx="4047300" cy="1554480"/>
+            <a:off x="8070980" y="4480560"/>
+            <a:ext cx="3060439" cy="1874519"/>
           </a:xfrm>
           <a:prstGeom prst="rect">
             <a:avLst/>
@@ -7188,8 +6438,8 @@
         </p:nvSpPr>
         <p:spPr>
           <a:xfrm>
-            <a:off x="7360920" y="5927880"/>
-            <a:ext cx="4572000" cy="274320"/>
+            <a:off x="7086600" y="6385079"/>
+            <a:ext cx="5029200" cy="274320"/>
           </a:xfrm>
           <a:prstGeom prst="rect">
             <a:avLst/>
@@ -7210,7 +6460,7 @@
                 </a:solidFill>
                 <a:latin typeface="Arial"/>
               </a:rPr>
-              <a:t>PDS2 — the bad channel: broad tail, median 0.51 ms (same 0–20 ms axis)</a:t>
+              <a:t>PDS2 — the bad channel: broad tail, median 0.51 ms (τ_fall in ms)</a:t>
             </a:r>
           </a:p>
         </p:txBody>
@@ -7245,7 +6495,7 @@
                 </a:solidFill>
                 <a:latin typeface="Arial"/>
               </a:rPr>
-              <a:t>7 / 12</a:t>
+              <a:t>7 / 10</a:t>
             </a:r>
           </a:p>
         </p:txBody>
@@ -7297,7 +6547,7 @@
                 </a:solidFill>
                 <a:latin typeface="Arial"/>
               </a:rPr>
-              <a:t>Follow-up 2 — genuine slow-rise pulses (echo-trigger events)</a:t>
+              <a:t>Template family 1 — analytic 2-exp, NRMSE-weighted (1x1)</a:t>
             </a:r>
           </a:p>
         </p:txBody>
@@ -7353,8 +6603,8 @@
         </p:nvSpPr>
         <p:spPr>
           <a:xfrm>
-            <a:off x="502920" y="1097280"/>
-            <a:ext cx="11247120" cy="1417320"/>
+            <a:off x="502920" y="1143000"/>
+            <a:ext cx="11247120" cy="1371600"/>
           </a:xfrm>
           <a:prstGeom prst="rect">
             <a:avLst/>
@@ -7373,13 +6623,13 @@
               </a:spcAft>
             </a:pPr>
             <a:r>
-              <a:rPr sz="1400">
+              <a:rPr sz="1800">
                 <a:solidFill>
                   <a:srgbClr val="333333"/>
                 </a:solidFill>
                 <a:latin typeface="Arial"/>
               </a:rPr>
-              <a:t>• Same sampling recipe on the rise side: median NRMSE ≤ 0.4 AND median τ_rise &gt; 0.2 ms → the raw traces show real pulses — pretrigger aligned, peak late, consistent across channels</a:t>
+              <a:t>• NRMSE-weighted mean of the fit_ok 2-exp curves</a:t>
             </a:r>
           </a:p>
           <a:p>
@@ -7389,13 +6639,13 @@
               </a:spcAft>
             </a:pPr>
             <a:r>
-              <a:rPr sz="1400">
+              <a:rPr sz="1800">
                 <a:solidFill>
                   <a:srgbClr val="333333"/>
                 </a:solidFill>
                 <a:latin typeface="Arial"/>
               </a:rPr>
-              <a:t>• A genuine second, slower pulse shape — a faint “echo” behind the main pulse (candidate surface/bulk effect, not settled)</a:t>
+              <a:t>• Smooth &amp; noise-free by construction</a:t>
             </a:r>
           </a:p>
           <a:p>
@@ -7405,20 +6655,20 @@
               </a:spcAft>
             </a:pPr>
             <a:r>
-              <a:rPr sz="1400">
+              <a:rPr sz="1800">
                 <a:solidFill>
                   <a:srgbClr val="333333"/>
                 </a:solidFill>
                 <a:latin typeface="Arial"/>
               </a:rPr>
-              <a:t>• Real physics → cannot simply be cut away; exactly the shape variation the multi-template NxM method is built to capture</a:t>
+              <a:t>• ROOT TH1D, peak-normalized (+ summed PT / PS1 / PS2)</a:t>
             </a:r>
           </a:p>
         </p:txBody>
       </p:sp>
       <p:pic>
         <p:nvPicPr>
-          <p:cNvPr id="5" name="Picture 4" descr="shadow_zip7_crop.png"/>
+          <p:cNvPr id="5" name="Picture 4" descr="fan_zip7_PBS1_after.png"/>
           <p:cNvPicPr>
             <a:picLocks noChangeAspect="1"/>
           </p:cNvPicPr>
@@ -7432,8 +6682,8 @@
         </p:blipFill>
         <p:spPr>
           <a:xfrm>
-            <a:off x="1167141" y="2697480"/>
-            <a:ext cx="9827237" cy="3794760"/>
+            <a:off x="1383919" y="3063240"/>
+            <a:ext cx="9393682" cy="2834640"/>
           </a:xfrm>
           <a:prstGeom prst="rect">
             <a:avLst/>
@@ -7448,8 +6698,8 @@
         </p:nvSpPr>
         <p:spPr>
           <a:xfrm>
-            <a:off x="1097280" y="6522240"/>
-            <a:ext cx="9966960" cy="274320"/>
+            <a:off x="1280160" y="5927880"/>
+            <a:ext cx="9601200" cy="274320"/>
           </a:xfrm>
           <a:prstGeom prst="rect">
             <a:avLst/>
@@ -7470,7 +6720,7 @@
                 </a:solidFill>
                 <a:latin typeface="Arial"/>
               </a:rPr>
-              <a:t>Z7 echo-trigger events (first 4 channels): raw (gray) / LP (blue) / fit (red) — genuine slow pulses, pretrigger aligned, peak late</a:t>
+              <a:t>Z7 PBS1, fitted curves after NRMSE ≤ 0.4 and τ_rise ≤ 0.3 ms — the NRMSE-weighted mean of this family is the 1x1 template</a:t>
             </a:r>
           </a:p>
         </p:txBody>
@@ -7505,7 +6755,7 @@
                 </a:solidFill>
                 <a:latin typeface="Arial"/>
               </a:rPr>
-              <a:t>8 / 12</a:t>
+              <a:t>8 / 10</a:t>
             </a:r>
           </a:p>
         </p:txBody>
@@ -7557,7 +6807,7 @@
                 </a:solidFill>
                 <a:latin typeface="Arial"/>
               </a:rPr>
-              <a:t>Slow drift also fits “slow”: a τ_rise ≤ 0.3 ms ceiling</a:t>
+              <a:t>Template family 2 — NxM PCA templates</a:t>
             </a:r>
           </a:p>
         </p:txBody>
@@ -7613,8 +6863,8 @@
         </p:nvSpPr>
         <p:spPr>
           <a:xfrm>
-            <a:off x="502920" y="1097280"/>
-            <a:ext cx="11247120" cy="1600200"/>
+            <a:off x="502920" y="1115568"/>
+            <a:ext cx="11247120" cy="1371600"/>
           </a:xfrm>
           <a:prstGeom prst="rect">
             <a:avLst/>
@@ -7633,13 +6883,13 @@
               </a:spcAft>
             </a:pPr>
             <a:r>
-              <a:rPr sz="1400">
+              <a:rPr sz="1600">
                 <a:solidFill>
                   <a:srgbClr val="333333"/>
                 </a:solidFill>
                 <a:latin typeface="Arial"/>
               </a:rPr>
-              <a:t>• On noisy-window detectors a smooth baseline drift survives the NRMSE cut — a slow 2-exp hugs it with a tiny residual — and mimics a slow rise</a:t>
+              <a:t>• Per-channel PCA over the clean fitted curves (fit_ok + NRMSE ≤ 0.4 + τ_rise ≤ 0.3 ms)</a:t>
             </a:r>
           </a:p>
           <a:p>
@@ -7649,13 +6899,13 @@
               </a:spcAft>
             </a:pPr>
             <a:r>
-              <a:rPr sz="1400">
+              <a:rPr sz="1600">
                 <a:solidFill>
                   <a:srgbClr val="333333"/>
                 </a:solidFill>
                 <a:latin typeface="Arial"/>
               </a:rPr>
-              <a:t>• Fast pulses sit at τ_rise ≈ 0.1 ms (p90 ≈ 0.15 ms), far below the drift tail → a ceiling at 0.3 ms blocks the drift at ≈ 2–5% signal cost</a:t>
+              <a:t>• nxm0 = mean shape;  nxm1–4 = principal components;  real pulse = Σᵢ ampᵢ · nxmᵢ</a:t>
             </a:r>
           </a:p>
           <a:p>
@@ -7665,20 +6915,20 @@
               </a:spcAft>
             </a:pPr>
             <a:r>
-              <a:rPr sz="1400">
+              <a:rPr sz="1600">
                 <a:solidFill>
                   <a:srgbClr val="333333"/>
                 </a:solidFill>
                 <a:latin typeface="Arial"/>
               </a:rPr>
-              <a:t>• Keeps most genuine slow pulses, trims the very slowest — documented trade-off, final decision pending</a:t>
+              <a:t>• PC1 + PC2 ≈ 96–98% of the shape variance;  delivered peak-normalized</a:t>
             </a:r>
           </a:p>
         </p:txBody>
       </p:sp>
       <p:pic>
         <p:nvPicPr>
-          <p:cNvPr id="5" name="Picture 4" descr="time_constants_zip7_PAS1.png"/>
+          <p:cNvPr id="5" name="Picture 4" descr="pca_zip7_PAS1.png"/>
           <p:cNvPicPr>
             <a:picLocks noChangeAspect="1"/>
           </p:cNvPicPr>
@@ -7692,24 +6942,48 @@
         </p:blipFill>
         <p:spPr>
           <a:xfrm>
-            <a:off x="1280160" y="2880360"/>
-            <a:ext cx="9601200" cy="1851803"/>
+            <a:off x="2831374" y="2697480"/>
+            <a:ext cx="6498771" cy="1828800"/>
           </a:xfrm>
           <a:prstGeom prst="rect">
             <a:avLst/>
           </a:prstGeom>
         </p:spPr>
       </p:pic>
-      <p:sp>
-        <p:nvSpPr>
-          <p:cNvPr id="6" name="TextBox 5"/>
+      <p:pic>
+        <p:nvPicPr>
+          <p:cNvPr id="6" name="Picture 5" descr="pca_zip7_PBS1.png"/>
+          <p:cNvPicPr>
+            <a:picLocks noChangeAspect="1"/>
+          </p:cNvPicPr>
+          <p:nvPr/>
+        </p:nvPicPr>
+        <p:blipFill>
+          <a:blip r:embed="rId3"/>
+          <a:stretch>
+            <a:fillRect/>
+          </a:stretch>
+        </p:blipFill>
+        <p:spPr>
+          <a:xfrm>
+            <a:off x="2831374" y="4572000"/>
+            <a:ext cx="6498771" cy="1828800"/>
+          </a:xfrm>
+          <a:prstGeom prst="rect">
+            <a:avLst/>
+          </a:prstGeom>
+        </p:spPr>
+      </p:pic>
+      <p:sp>
+        <p:nvSpPr>
+          <p:cNvPr id="7" name="TextBox 6"/>
           <p:cNvSpPr txBox="1"/>
           <p:nvPr/>
         </p:nvSpPr>
         <p:spPr>
           <a:xfrm>
-            <a:off x="1280160" y="4762163"/>
-            <a:ext cx="9601200" cy="274320"/>
+            <a:off x="1371600" y="6430800"/>
+            <a:ext cx="9418320" cy="274320"/>
           </a:xfrm>
           <a:prstGeom prst="rect">
             <a:avLst/>
@@ -7730,46 +7004,7 @@
                 </a:solidFill>
                 <a:latin typeface="Arial"/>
               </a:rPr>
-              <a:t>Z7 PAS1: fitted τ_rise (median 0.105 ms) and τ_fall distributions</a:t>
-            </a:r>
-          </a:p>
-        </p:txBody>
-      </p:sp>
-      <p:sp>
-        <p:nvSpPr>
-          <p:cNvPr id="7" name="TextBox 6"/>
-          <p:cNvSpPr txBox="1"/>
-          <p:nvPr/>
-        </p:nvSpPr>
-        <p:spPr>
-          <a:xfrm>
-            <a:off x="1280160" y="5257800"/>
-            <a:ext cx="9601200" cy="914400"/>
-          </a:xfrm>
-          <a:prstGeom prst="rect">
-            <a:avLst/>
-          </a:prstGeom>
-          <a:noFill/>
-        </p:spPr>
-        <p:txBody>
-          <a:bodyPr wrap="square">
-            <a:spAutoFit/>
-          </a:bodyPr>
-          <a:lstStyle/>
-          <a:p>
-            <a:pPr>
-              <a:spcAft>
-                <a:spcPts val="500"/>
-              </a:spcAft>
-            </a:pPr>
-            <a:r>
-              <a:rPr sz="1300">
-                <a:solidFill>
-                  <a:srgbClr val="333333"/>
-                </a:solidFill>
-                <a:latin typeface="Arial"/>
-              </a:rPr>
-              <a:t>• On quiet detectors both τ_rise and τ_fall distributions are narrow — the pulse shape is stable across events</a:t>
+              <a:t>Z7 PAS1 / PBS1: nxm0 (mean) + nxm1–4 (PCs) — the oscillating components encode rise/fall-time variation</a:t>
             </a:r>
           </a:p>
         </p:txBody>
@@ -7804,7 +7039,7 @@
                 </a:solidFill>
                 <a:latin typeface="Arial"/>
               </a:rPr>
-              <a:t>9 / 12</a:t>
+              <a:t>9 / 10</a:t>
             </a:r>
           </a:p>
         </p:txBody>

</xml_diff>

<commit_message>
snolab: presentation — slide 3 clarity: render the 2-exp model as proper math typography (matplotlib mathtext, big & centered); rewrite fit_ok/NRMSE as plain-English bullets (no := / and / code-look); add make_formula.py
Co-Authored-By: Claude Opus 4.8 <noreply@anthropic.com>
</commit_message>
<xml_diff>
--- a/snolab/presentation/SNOLAB_R4_pulse_templates_20260715.pptx
+++ b/snolab/presentation/SNOLAB_R4_pulse_templates_20260715.pptx
@@ -4904,8 +4904,8 @@
         </p:nvSpPr>
         <p:spPr>
           <a:xfrm>
-            <a:off x="502920" y="1143000"/>
-            <a:ext cx="11247120" cy="2697480"/>
+            <a:off x="502920" y="1097280"/>
+            <a:ext cx="11247120" cy="1234440"/>
           </a:xfrm>
           <a:prstGeom prst="rect">
             <a:avLst/>
@@ -4920,7 +4920,7 @@
           <a:p>
             <a:pPr>
               <a:spcAft>
-                <a:spcPts val="700"/>
+                <a:spcPts val="600"/>
               </a:spcAft>
             </a:pPr>
             <a:r>
@@ -4945,7 +4945,7 @@
           <a:p>
             <a:pPr>
               <a:spcAft>
-                <a:spcPts val="700"/>
+                <a:spcPts val="600"/>
               </a:spcAft>
             </a:pPr>
             <a:r>
@@ -4970,7 +4970,7 @@
           <a:p>
             <a:pPr>
               <a:spcAft>
-                <a:spcPts val="700"/>
+                <a:spcPts val="600"/>
               </a:spcAft>
             </a:pPr>
             <a:r>
@@ -4989,80 +4989,14 @@
                 </a:solidFill>
                 <a:latin typeface="Arial"/>
               </a:rPr>
-              <a:t> — two-exponential, all 5 parameters free, including the pretrigger offset:</a:t>
-            </a:r>
-          </a:p>
-          <a:p>
-            <a:pPr lvl="1">
-              <a:spcAft>
-                <a:spcPts val="700"/>
-              </a:spcAft>
-            </a:pPr>
-            <a:r>
-              <a:rPr sz="1400">
-                <a:solidFill>
-                  <a:srgbClr val="666666"/>
-                </a:solidFill>
-                <a:latin typeface="Arial"/>
-              </a:rPr>
-              <a:t>        y(t) = A·[exp(−(t−t₀)/τ_fall) − exp(−(t−t₀)/τ_rise)] + b,    t₀ = pretrigger ∈ 16050 ± 3000 samples</a:t>
-            </a:r>
-          </a:p>
-          <a:p>
-            <a:pPr>
-              <a:spcAft>
-                <a:spcPts val="700"/>
-              </a:spcAft>
-            </a:pPr>
-            <a:r>
-              <a:rPr sz="1600" b="1">
-                <a:solidFill>
-                  <a:srgbClr val="1F3864"/>
-                </a:solidFill>
-                <a:latin typeface="Arial"/>
-              </a:rPr>
-              <a:t>4.  Quality numbers</a:t>
-            </a:r>
-            <a:r>
-              <a:rPr sz="1600">
-                <a:solidFill>
-                  <a:srgbClr val="333333"/>
-                </a:solidFill>
-                <a:latin typeface="Arial"/>
-              </a:rPr>
-              <a:t> — fit_ok := A&gt;0 and 0&lt;τ_rise&lt;τ_fall;   NRMSE := RMS(residual)/fit peak</a:t>
-            </a:r>
-          </a:p>
-          <a:p>
-            <a:pPr>
-              <a:spcAft>
-                <a:spcPts val="700"/>
-              </a:spcAft>
-            </a:pPr>
-            <a:r>
-              <a:rPr sz="1600" b="1">
-                <a:solidFill>
-                  <a:srgbClr val="1F3864"/>
-                </a:solidFill>
-                <a:latin typeface="Arial"/>
-              </a:rPr>
-              <a:t>5.  Align</a:t>
-            </a:r>
-            <a:r>
-              <a:rPr sz="1600">
-                <a:solidFill>
-                  <a:srgbClr val="333333"/>
-                </a:solidFill>
-                <a:latin typeface="Arial"/>
-              </a:rPr>
-              <a:t> — shift the measured trace by (fitted pretrigger − 16050)</a:t>
+              <a:t> — two-exponential model, all 5 parameters free (including the pretrigger t₀):</a:t>
             </a:r>
           </a:p>
         </p:txBody>
       </p:sp>
       <p:pic>
         <p:nvPicPr>
-          <p:cNvPr id="5" name="Picture 4" descr="fan_zip7_PBS1_before_zoom.png"/>
+          <p:cNvPr id="5" name="Picture 4" descr="formula_2exp.png"/>
           <p:cNvPicPr>
             <a:picLocks noChangeAspect="1"/>
           </p:cNvPicPr>
@@ -5076,8 +5010,8 @@
         </p:blipFill>
         <p:spPr>
           <a:xfrm>
-            <a:off x="1313560" y="3977639"/>
-            <a:ext cx="4139439" cy="2468880"/>
+            <a:off x="3114415" y="2395728"/>
+            <a:ext cx="5932689" cy="868680"/>
           </a:xfrm>
           <a:prstGeom prst="rect">
             <a:avLst/>
@@ -5092,8 +5026,8 @@
         </p:nvSpPr>
         <p:spPr>
           <a:xfrm>
-            <a:off x="822960" y="6476519"/>
-            <a:ext cx="5120640" cy="274320"/>
+            <a:off x="502920" y="3337560"/>
+            <a:ext cx="11247120" cy="1371600"/>
           </a:xfrm>
           <a:prstGeom prst="rect">
             <a:avLst/>
@@ -5106,22 +5040,156 @@
           </a:bodyPr>
           <a:lstStyle/>
           <a:p>
-            <a:pPr algn="ctr"/>
-            <a:r>
-              <a:rPr sz="1100" i="1">
-                <a:solidFill>
-                  <a:srgbClr val="666666"/>
+            <a:pPr>
+              <a:spcAft>
+                <a:spcPts val="600"/>
+              </a:spcAft>
+            </a:pPr>
+            <a:r>
+              <a:rPr sz="1600" b="1">
+                <a:solidFill>
+                  <a:srgbClr val="1F3864"/>
                 </a:solidFill>
                 <a:latin typeface="Arial"/>
               </a:rPr>
-              <a:t>All fit_ok fitted curves at the common pretrigger, peak-normalized — zoom on the pulse (Z7 PBS1, time in ms)</a:t>
+              <a:t>4.  Two quality numbers per trace</a:t>
+            </a:r>
+            <a:r>
+              <a:rPr sz="1600">
+                <a:solidFill>
+                  <a:srgbClr val="333333"/>
+                </a:solidFill>
+                <a:latin typeface="Arial"/>
+              </a:rPr>
+              <a:t> (recorded here, not cut yet):</a:t>
+            </a:r>
+          </a:p>
+        </p:txBody>
+      </p:sp>
+      <p:sp>
+        <p:nvSpPr>
+          <p:cNvPr id="7" name="TextBox 6"/>
+          <p:cNvSpPr txBox="1"/>
+          <p:nvPr/>
+        </p:nvSpPr>
+        <p:spPr>
+          <a:xfrm>
+            <a:off x="1051560" y="3675887"/>
+            <a:ext cx="10607040" cy="822960"/>
+          </a:xfrm>
+          <a:prstGeom prst="rect">
+            <a:avLst/>
+          </a:prstGeom>
+          <a:noFill/>
+        </p:spPr>
+        <p:txBody>
+          <a:bodyPr wrap="square">
+            <a:spAutoFit/>
+          </a:bodyPr>
+          <a:lstStyle/>
+          <a:p>
+            <a:pPr>
+              <a:spcAft>
+                <a:spcPts val="400"/>
+              </a:spcAft>
+            </a:pPr>
+            <a:r>
+              <a:rPr sz="1500" b="1">
+                <a:solidFill>
+                  <a:srgbClr val="333333"/>
+                </a:solidFill>
+                <a:latin typeface="Arial"/>
+              </a:rPr>
+              <a:t>•  fit_ok</a:t>
+            </a:r>
+            <a:r>
+              <a:rPr sz="1500">
+                <a:solidFill>
+                  <a:srgbClr val="333333"/>
+                </a:solidFill>
+                <a:latin typeface="Arial"/>
+              </a:rPr>
+              <a:t> — amplitude is positive, and the pulse rises faster than it falls</a:t>
+            </a:r>
+          </a:p>
+          <a:p>
+            <a:pPr>
+              <a:spcAft>
+                <a:spcPts val="400"/>
+              </a:spcAft>
+            </a:pPr>
+            <a:r>
+              <a:rPr sz="1500" b="1">
+                <a:solidFill>
+                  <a:srgbClr val="333333"/>
+                </a:solidFill>
+                <a:latin typeface="Arial"/>
+              </a:rPr>
+              <a:t>•  NRMSE</a:t>
+            </a:r>
+            <a:r>
+              <a:rPr sz="1500">
+                <a:solidFill>
+                  <a:srgbClr val="333333"/>
+                </a:solidFill>
+                <a:latin typeface="Arial"/>
+              </a:rPr>
+              <a:t> — RMS of the fit residual ÷ pulse peak  (smaller = better fit)</a:t>
+            </a:r>
+          </a:p>
+        </p:txBody>
+      </p:sp>
+      <p:sp>
+        <p:nvSpPr>
+          <p:cNvPr id="8" name="TextBox 7"/>
+          <p:cNvSpPr txBox="1"/>
+          <p:nvPr/>
+        </p:nvSpPr>
+        <p:spPr>
+          <a:xfrm>
+            <a:off x="502920" y="4526280"/>
+            <a:ext cx="11247120" cy="502920"/>
+          </a:xfrm>
+          <a:prstGeom prst="rect">
+            <a:avLst/>
+          </a:prstGeom>
+          <a:noFill/>
+        </p:spPr>
+        <p:txBody>
+          <a:bodyPr wrap="square">
+            <a:spAutoFit/>
+          </a:bodyPr>
+          <a:lstStyle/>
+          <a:p>
+            <a:pPr>
+              <a:spcAft>
+                <a:spcPts val="600"/>
+              </a:spcAft>
+            </a:pPr>
+            <a:r>
+              <a:rPr sz="1600" b="1">
+                <a:solidFill>
+                  <a:srgbClr val="1F3864"/>
+                </a:solidFill>
+                <a:latin typeface="Arial"/>
+              </a:rPr>
+              <a:t>5.  Align</a:t>
+            </a:r>
+            <a:r>
+              <a:rPr sz="1600">
+                <a:solidFill>
+                  <a:srgbClr val="333333"/>
+                </a:solidFill>
+                <a:latin typeface="Arial"/>
+              </a:rPr>
+              <a:t> — shift the measured trace by (fitted pretrigger − 16050)</a:t>
             </a:r>
           </a:p>
         </p:txBody>
       </p:sp>
       <p:pic>
         <p:nvPicPr>
-          <p:cNvPr id="7" name="Picture 6" descr="fan_zip7_PBS1_nrmse_zoom.png"/>
+          <p:cNvPr id="9" name="Picture 8" descr="fan_zip7_PBS1_before_zoom.png"/>
           <p:cNvPicPr>
             <a:picLocks noChangeAspect="1"/>
           </p:cNvPicPr>
@@ -5135,8 +5203,8 @@
         </p:blipFill>
         <p:spPr>
           <a:xfrm>
-            <a:off x="6799960" y="3977639"/>
-            <a:ext cx="4139439" cy="2468880"/>
+            <a:off x="2233436" y="4864608"/>
+            <a:ext cx="2299688" cy="1371600"/>
           </a:xfrm>
           <a:prstGeom prst="rect">
             <a:avLst/>
@@ -5145,13 +5213,13 @@
       </p:pic>
       <p:sp>
         <p:nvSpPr>
-          <p:cNvPr id="8" name="TextBox 7"/>
+          <p:cNvPr id="10" name="TextBox 9"/>
           <p:cNvSpPr txBox="1"/>
           <p:nvPr/>
         </p:nvSpPr>
         <p:spPr>
           <a:xfrm>
-            <a:off x="6309360" y="6476519"/>
+            <a:off x="822960" y="6266208"/>
             <a:ext cx="5120640" cy="274320"/>
           </a:xfrm>
           <a:prstGeom prst="rect">
@@ -5173,14 +5241,73 @@
                 </a:solidFill>
                 <a:latin typeface="Arial"/>
               </a:rPr>
-              <a:t>Same, after NRMSE ≤ 0.4 — a single tight shape family remains</a:t>
-            </a:r>
-          </a:p>
-        </p:txBody>
-      </p:sp>
-      <p:sp>
-        <p:nvSpPr>
-          <p:cNvPr id="9" name="TextBox 8"/>
+              <a:t>All fit_ok fitted curves (Z7 PBS1) — no cut</a:t>
+            </a:r>
+          </a:p>
+        </p:txBody>
+      </p:sp>
+      <p:pic>
+        <p:nvPicPr>
+          <p:cNvPr id="11" name="Picture 10" descr="fan_zip7_PBS1_nrmse_zoom.png"/>
+          <p:cNvPicPr>
+            <a:picLocks noChangeAspect="1"/>
+          </p:cNvPicPr>
+          <p:nvPr/>
+        </p:nvPicPr>
+        <p:blipFill>
+          <a:blip r:embed="rId4"/>
+          <a:stretch>
+            <a:fillRect/>
+          </a:stretch>
+        </p:blipFill>
+        <p:spPr>
+          <a:xfrm>
+            <a:off x="7719836" y="4864608"/>
+            <a:ext cx="2299688" cy="1371600"/>
+          </a:xfrm>
+          <a:prstGeom prst="rect">
+            <a:avLst/>
+          </a:prstGeom>
+        </p:spPr>
+      </p:pic>
+      <p:sp>
+        <p:nvSpPr>
+          <p:cNvPr id="12" name="TextBox 11"/>
+          <p:cNvSpPr txBox="1"/>
+          <p:nvPr/>
+        </p:nvSpPr>
+        <p:spPr>
+          <a:xfrm>
+            <a:off x="6309360" y="6266208"/>
+            <a:ext cx="5120640" cy="274320"/>
+          </a:xfrm>
+          <a:prstGeom prst="rect">
+            <a:avLst/>
+          </a:prstGeom>
+          <a:noFill/>
+        </p:spPr>
+        <p:txBody>
+          <a:bodyPr wrap="square">
+            <a:spAutoFit/>
+          </a:bodyPr>
+          <a:lstStyle/>
+          <a:p>
+            <a:pPr algn="ctr"/>
+            <a:r>
+              <a:rPr sz="1100" i="1">
+                <a:solidFill>
+                  <a:srgbClr val="666666"/>
+                </a:solidFill>
+                <a:latin typeface="Arial"/>
+              </a:rPr>
+              <a:t>After NRMSE ≤ 0.4 — one tight shape family</a:t>
+            </a:r>
+          </a:p>
+        </p:txBody>
+      </p:sp>
+      <p:sp>
+        <p:nvSpPr>
+          <p:cNvPr id="13" name="TextBox 12"/>
           <p:cNvSpPr txBox="1"/>
           <p:nvPr/>
         </p:nvSpPr>

</xml_diff>

<commit_message>
snolab: presentation — slide 4 grids enlarged; slide 6 fan-cut enlarged with pulled-out colour-coded text legend; slide 7 t_fall histograms side by side, cropped to 0-7 ms; summary drops the next-step bullet (kept as Q&A note)
Co-Authored-By: Claude Opus 4.8 <noreply@anthropic.com>
</commit_message>
<xml_diff>
--- a/snolab/presentation/SNOLAB_R4_pulse_templates_20260715.pptx
+++ b/snolab/presentation/SNOLAB_R4_pulse_templates_20260715.pptx
@@ -4413,22 +4413,6 @@
               <a:t>• Cuts read off the data, verified in raw traces:  NRMSE ≤ 0.4,  τ_rise ≤ 0.3 ms</a:t>
             </a:r>
           </a:p>
-          <a:p>
-            <a:pPr>
-              <a:spcAft>
-                <a:spcPts val="500"/>
-              </a:spcAft>
-            </a:pPr>
-            <a:r>
-              <a:rPr sz="2200">
-                <a:solidFill>
-                  <a:srgbClr val="333333"/>
-                </a:solidFill>
-                <a:latin typeface="Arial"/>
-              </a:rPr>
-              <a:t>• Next: run the group's template-validation on the new templates</a:t>
-            </a:r>
-          </a:p>
         </p:txBody>
       </p:sp>
       <p:sp>
@@ -5506,8 +5490,8 @@
         </p:blipFill>
         <p:spPr>
           <a:xfrm>
-            <a:off x="502920" y="2377440"/>
-            <a:ext cx="5486400" cy="2547707"/>
+            <a:off x="182880" y="2514600"/>
+            <a:ext cx="5989320" cy="2781247"/>
           </a:xfrm>
           <a:prstGeom prst="rect">
             <a:avLst/>
@@ -5522,8 +5506,8 @@
         </p:nvSpPr>
         <p:spPr>
           <a:xfrm>
-            <a:off x="502920" y="4955147"/>
-            <a:ext cx="5486400" cy="274320"/>
+            <a:off x="182880" y="5325847"/>
+            <a:ext cx="5989320" cy="274320"/>
           </a:xfrm>
           <a:prstGeom prst="rect">
             <a:avLst/>
@@ -5565,8 +5549,8 @@
         </p:blipFill>
         <p:spPr>
           <a:xfrm>
-            <a:off x="6263640" y="2377440"/>
-            <a:ext cx="5486400" cy="2453114"/>
+            <a:off x="6035040" y="2514600"/>
+            <a:ext cx="5989320" cy="2677983"/>
           </a:xfrm>
           <a:prstGeom prst="rect">
             <a:avLst/>
@@ -5581,8 +5565,8 @@
         </p:nvSpPr>
         <p:spPr>
           <a:xfrm>
-            <a:off x="6263640" y="4860554"/>
-            <a:ext cx="5486400" cy="274320"/>
+            <a:off x="6035040" y="5222583"/>
+            <a:ext cx="5989320" cy="274320"/>
           </a:xfrm>
           <a:prstGeom prst="rect">
             <a:avLst/>
@@ -6112,7 +6096,7 @@
         </p:blipFill>
         <p:spPr>
           <a:xfrm>
-            <a:off x="502920" y="2468880"/>
+            <a:off x="365760" y="2468880"/>
             <a:ext cx="5394960" cy="3699401"/>
           </a:xfrm>
           <a:prstGeom prst="rect">
@@ -6128,7 +6112,7 @@
         </p:nvSpPr>
         <p:spPr>
           <a:xfrm>
-            <a:off x="502920" y="6198281"/>
+            <a:off x="365760" y="6198281"/>
             <a:ext cx="5394960" cy="274320"/>
           </a:xfrm>
           <a:prstGeom prst="rect">
@@ -6171,8 +6155,8 @@
         </p:blipFill>
         <p:spPr>
           <a:xfrm>
-            <a:off x="6126480" y="2651760"/>
-            <a:ext cx="5760720" cy="3383280"/>
+            <a:off x="5943600" y="2240280"/>
+            <a:ext cx="6263640" cy="3429000"/>
           </a:xfrm>
           <a:prstGeom prst="rect">
             <a:avLst/>
@@ -6187,8 +6171,8 @@
         </p:nvSpPr>
         <p:spPr>
           <a:xfrm>
-            <a:off x="6126480" y="6065040"/>
-            <a:ext cx="5760720" cy="274320"/>
+            <a:off x="6035040" y="5806440"/>
+            <a:ext cx="6126480" cy="960120"/>
           </a:xfrm>
           <a:prstGeom prst="rect">
             <a:avLst/>
@@ -6201,15 +6185,43 @@
           </a:bodyPr>
           <a:lstStyle/>
           <a:p>
-            <a:pPr algn="ctr"/>
-            <a:r>
-              <a:rPr sz="1100" i="1">
-                <a:solidFill>
-                  <a:srgbClr val="666666"/>
+            <a:r>
+              <a:rPr sz="1400" b="1">
+                <a:solidFill>
+                  <a:srgbClr val="2E7D32"/>
                 </a:solidFill>
                 <a:latin typeface="Arial"/>
               </a:rPr>
-              <a:t>Z22 PCS1: pass (green) vs rejected (red) — vertically stretched for visibility</a:t>
+              <a:t>── passes the cut (kept)</a:t>
+            </a:r>
+            <a:r>
+              <a:rPr sz="1400" b="1">
+                <a:solidFill>
+                  <a:srgbClr val="C0392B"/>
+                </a:solidFill>
+                <a:latin typeface="Arial"/>
+              </a:rPr>
+              <a:t>      ── cut away = rejected</a:t>
+            </a:r>
+          </a:p>
+          <a:p>
+            <a:r>
+              <a:rPr sz="1400" b="0">
+                <a:solidFill>
+                  <a:srgbClr val="4A70B0"/>
+                </a:solidFill>
+                <a:latin typeface="Arial"/>
+              </a:rPr>
+              <a:t>faint blue = measured traces</a:t>
+            </a:r>
+            <a:r>
+              <a:rPr sz="1400" b="0">
+                <a:solidFill>
+                  <a:srgbClr val="333333"/>
+                </a:solidFill>
+                <a:latin typeface="Arial"/>
+              </a:rPr>
+              <a:t>      Z22 PCS1: 7198 kept / 4788 cut (~40%)</a:t>
             </a:r>
           </a:p>
         </p:txBody>
@@ -6431,8 +6443,8 @@
         </p:blipFill>
         <p:spPr>
           <a:xfrm>
-            <a:off x="411480" y="2651760"/>
-            <a:ext cx="6675120" cy="3432048"/>
+            <a:off x="274320" y="2697480"/>
+            <a:ext cx="6126480" cy="3149961"/>
           </a:xfrm>
           <a:prstGeom prst="rect">
             <a:avLst/>
@@ -6447,8 +6459,8 @@
         </p:nvSpPr>
         <p:spPr>
           <a:xfrm>
-            <a:off x="411480" y="6113808"/>
-            <a:ext cx="6675120" cy="274320"/>
+            <a:off x="274320" y="5877441"/>
+            <a:ext cx="6126480" cy="274320"/>
           </a:xfrm>
           <a:prstGeom prst="rect">
             <a:avLst/>
@@ -6469,7 +6481,7 @@
                 </a:solidFill>
                 <a:latin typeface="Arial"/>
               </a:rPr>
-              <a:t>Z7, 3 of the sampled slow-fall events: normal pulses in PBS2/PCS2/PES2, low-frequency swings only in PDS2</a:t>
+              <a:t>Z7, 3 sampled slow-fall events: normal in PBS2/PCS2/PES2, swings only in PDS2</a:t>
             </a:r>
           </a:p>
         </p:txBody>
@@ -6490,8 +6502,8 @@
         </p:blipFill>
         <p:spPr>
           <a:xfrm>
-            <a:off x="8077201" y="2450592"/>
-            <a:ext cx="3047998" cy="1874519"/>
+            <a:off x="6446520" y="3063240"/>
+            <a:ext cx="2788920" cy="2085332"/>
           </a:xfrm>
           <a:prstGeom prst="rect">
             <a:avLst/>
@@ -6506,8 +6518,8 @@
         </p:nvSpPr>
         <p:spPr>
           <a:xfrm>
-            <a:off x="7086600" y="4355111"/>
-            <a:ext cx="5029200" cy="274320"/>
+            <a:off x="6446520" y="5178572"/>
+            <a:ext cx="2788920" cy="274320"/>
           </a:xfrm>
           <a:prstGeom prst="rect">
             <a:avLst/>
@@ -6528,7 +6540,7 @@
                 </a:solidFill>
                 <a:latin typeface="Arial"/>
               </a:rPr>
-              <a:t>PAS1 — a normal channel: narrow, median 0.25 ms</a:t>
+              <a:t>PAS1 — normal channel: narrow (median 0.25 ms)</a:t>
             </a:r>
           </a:p>
         </p:txBody>
@@ -6549,8 +6561,8 @@
         </p:blipFill>
         <p:spPr>
           <a:xfrm>
-            <a:off x="8070980" y="4480560"/>
-            <a:ext cx="3060439" cy="1874519"/>
+            <a:off x="9326880" y="3063240"/>
+            <a:ext cx="2788920" cy="2076855"/>
           </a:xfrm>
           <a:prstGeom prst="rect">
             <a:avLst/>
@@ -6565,8 +6577,8 @@
         </p:nvSpPr>
         <p:spPr>
           <a:xfrm>
-            <a:off x="7086600" y="6385079"/>
-            <a:ext cx="5029200" cy="274320"/>
+            <a:off x="9326880" y="5170095"/>
+            <a:ext cx="2788920" cy="274320"/>
           </a:xfrm>
           <a:prstGeom prst="rect">
             <a:avLst/>
@@ -6587,7 +6599,7 @@
                 </a:solidFill>
                 <a:latin typeface="Arial"/>
               </a:rPr>
-              <a:t>PDS2 — the bad channel: broad tail, median 0.51 ms (τ_fall in ms)</a:t>
+              <a:t>PDS2 — bad channel: broad tail (median 0.51 ms)</a:t>
             </a:r>
           </a:p>
         </p:txBody>
@@ -6595,6 +6607,40 @@
       <p:sp>
         <p:nvSpPr>
           <p:cNvPr id="11" name="TextBox 10"/>
+          <p:cNvSpPr txBox="1"/>
+          <p:nvPr/>
+        </p:nvSpPr>
+        <p:spPr>
+          <a:xfrm>
+            <a:off x="6446520" y="2395728"/>
+            <a:ext cx="5669280" cy="502920"/>
+          </a:xfrm>
+          <a:prstGeom prst="rect">
+            <a:avLst/>
+          </a:prstGeom>
+          <a:noFill/>
+        </p:spPr>
+        <p:txBody>
+          <a:bodyPr wrap="square">
+            <a:spAutoFit/>
+          </a:bodyPr>
+          <a:lstStyle/>
+          <a:p>
+            <a:r>
+              <a:rPr sz="1500" b="1">
+                <a:solidFill>
+                  <a:srgbClr val="1F3864"/>
+                </a:solidFill>
+                <a:latin typeface="Arial"/>
+              </a:rPr>
+              <a:t>Fitted τ_fall distribution, same 0–7 ms axis:</a:t>
+            </a:r>
+          </a:p>
+        </p:txBody>
+      </p:sp>
+      <p:sp>
+        <p:nvSpPr>
+          <p:cNvPr id="12" name="TextBox 11"/>
           <p:cNvSpPr txBox="1"/>
           <p:nvPr/>
         </p:nvSpPr>

</xml_diff>

<commit_message>
snolab: presentation — add dedicated Alignment slide (big clean PBS1 zoom) after the algorithm; move Fit-quality grids ahead of the algorithm as a data overview; speech reordered + new alignment section + renumbered. Deck now 11 slides
Co-Authored-By: Claude Opus 4.8 <noreply@anthropic.com>
</commit_message>
<xml_diff>
--- a/snolab/presentation/SNOLAB_R4_pulse_templates_20260715.pptx
+++ b/snolab/presentation/SNOLAB_R4_pulse_templates_20260715.pptx
@@ -15,6 +15,7 @@
     <p:sldId id="263" r:id="rId15"/>
     <p:sldId id="264" r:id="rId16"/>
     <p:sldId id="265" r:id="rId17"/>
+    <p:sldId id="266" r:id="rId18"/>
   </p:sldIdLst>
   <p:sldSz cx="12191695" cy="6858000" type="screen4x3"/>
   <p:notesSz cx="6858000" cy="9144000"/>
@@ -581,6 +582,76 @@
           <a:lstStyle/>
           <a:p>
             <a:r>
+              <a:t>Second family: the NxM PCA templates, built to capture the pulse-shape variation across events. We run a PCA over the fitted curves that pass all cuts, in a window around the pulse. The mean shape becomes template zero, and the first four principal components become templates one to four - they oscillate and can be negative, and the optimal filter fits a real pulse as a linear combination of them. The first two components already capture 96 to 98 percent of the shape variance on every detector.</a:t>
+            </a:r>
+          </a:p>
+        </p:txBody>
+      </p:sp>
+      <p:sp>
+        <p:nvSpPr>
+          <p:cNvPr id="4" name="Slide Number Placeholder 3"/>
+          <p:cNvSpPr>
+            <a:spLocks noGrp="1"/>
+          </p:cNvSpPr>
+          <p:nvPr>
+            <p:ph type="sldNum" idx="5" sz="quarter"/>
+          </p:nvPr>
+        </p:nvSpPr>
+        <p:spPr/>
+      </p:sp>
+    </p:spTree>
+  </p:cSld>
+  <p:clrMapOvr>
+    <a:masterClrMapping/>
+  </p:clrMapOvr>
+</p:notes>
+</file>
+
+<file path=ppt/notesSlides/notesSlide11.xml><?xml version="1.0" encoding="utf-8"?>
+<p:notes xmlns:a="http://schemas.openxmlformats.org/drawingml/2006/main" xmlns:p="http://schemas.openxmlformats.org/presentationml/2006/main" xmlns:r="http://schemas.openxmlformats.org/officeDocument/2006/relationships">
+  <p:cSld>
+    <p:spTree>
+      <p:nvGrpSpPr>
+        <p:cNvPr id="1" name=""/>
+        <p:cNvGrpSpPr/>
+        <p:nvPr/>
+      </p:nvGrpSpPr>
+      <p:grpSpPr>
+        <a:xfrm>
+          <a:off x="0" y="0"/>
+          <a:ext cx="0" cy="0"/>
+          <a:chOff x="0" y="0"/>
+          <a:chExt cx="0" cy="0"/>
+        </a:xfrm>
+      </p:grpSpPr>
+      <p:sp>
+        <p:nvSpPr>
+          <p:cNvPr id="2" name="Slide Image Placeholder 1"/>
+          <p:cNvSpPr>
+            <a:spLocks noGrp="1"/>
+          </p:cNvSpPr>
+          <p:nvPr>
+            <p:ph type="sldImg" idx="2"/>
+          </p:nvPr>
+        </p:nvSpPr>
+        <p:spPr/>
+      </p:sp>
+      <p:sp>
+        <p:nvSpPr>
+          <p:cNvPr id="3" name="Notes Placeholder 2"/>
+          <p:cNvSpPr>
+            <a:spLocks noGrp="1"/>
+          </p:cNvSpPr>
+          <p:nvPr>
+            <p:ph type="body" idx="3" sz="quarter"/>
+          </p:nvPr>
+        </p:nvSpPr>
+        <p:spPr/>
+        <p:txBody>
+          <a:bodyPr/>
+          <a:lstStyle/>
+          <a:p>
+            <a:r>
               <a:t>To summarize: both template families are delivered for all 13 detectors in the official PulseTemplates format - the analytic 1x1 templates and the PCA NxM set. The whole chain is traceable from raw traces to every figure, and both quality cuts were read off the data and verified in the raw traces. Two things remain: the final call on the rise-time ceiling versus the genuine slow pulses, and running the group's template-validation method on the new templates. Thank you - happy to take questions.</a:t>
             </a:r>
           </a:p>
@@ -721,7 +792,7 @@
           <a:lstStyle/>
           <a:p>
             <a:r>
-              <a:t>The per-trace algorithm, five steps. First a low-pass filter to smooth away the high-frequency noise, then the baseline is subtracted and the trace is scaled to unit peak - without that normalization the traces could not be overlaid or compared. The core is the fit: a two-exponential function, one exponential for the rise and one for the fall, with all five parameters free, including the pretrigger - the pulse start time. The pretrigger is never pinned: real trigger times vary, and the fitted pretriggers cluster about 230 samples after the nominal value - pinning it would bias the time constants. Each fit records two quality numbers: fit_ok, a physicality check - positive amplitude, rise faster than fall - and the NRMSE, the normalized root-mean-square error, the fit residual divided by the pulse height. At this stage we only record them. Finally the measured trace is aligned by shifting it by the fitted pretrigger minus 16050. The two fan plots show the output of the fit step: every fitted curve drawn at the common pretrigger, peak-normalized. On the left, all physical fits - you can see stragglers spreading off the main bundle. On the right, after the NRMSE cut, a single tight shape family remains. Where that cut comes from is the next part of the talk.</a:t>
+              <a:t>Before the algorithm, a quick look at the data itself. We use event-by-channel grids: each row is one event, each column one channel, with the low-passed trace in blue and a fitted pulse model in red on top. The pattern is already clear: a real K-line event fits well in every channel at once, while a noise trigger fails in every channel at once. So the events split cleanly into two kinds. How we actually fit and align each trace is the next slide, and how we turn that split into a quantitative cut comes shortly after.</a:t>
             </a:r>
           </a:p>
         </p:txBody>
@@ -791,7 +862,7 @@
           <a:lstStyle/>
           <a:p>
             <a:r>
-              <a:t>To judge the fits we use event-by-channel grids: each row is one event, each column one channel. A real K-line event fits well in all channels simultaneously, while a noise trigger - like the top rows here - fails everywhere at once. The per-panel NRMSE makes this quantitative. All our figures carry the processing chain stamped in the header, so each PNG is self-documenting.</a:t>
+              <a:t>The per-trace algorithm, five steps. First a low-pass filter to smooth away the high-frequency noise, then the baseline is subtracted and the trace is scaled to unit peak - without that normalization the traces could not be overlaid or compared. The core is the fit: a two-exponential function, one exponential for the rise and one for the fall, with all five parameters free, including the pretrigger - the pulse start time. The pretrigger is never pinned: real trigger times vary, and the fitted pretriggers cluster about 230 samples after the nominal value - pinning it would bias the time constants. Each fit records two quality numbers: fit_ok, a physicality check - positive amplitude, rise faster than fall - and the NRMSE, the normalized root-mean-square error, the fit residual divided by the pulse height. At this stage we only record them. Finally the measured trace is aligned by shifting it by the fitted pretrigger minus 16050. The two fan plots show the output of the fit step: every fitted curve drawn at the common pretrigger, peak-normalized. On the left, all physical fits - you can see stragglers spreading off the main bundle. On the right, after the NRMSE cut, a single tight shape family remains. We'll return to where that cut comes from shortly.</a:t>
             </a:r>
           </a:p>
         </p:txBody>
@@ -861,7 +932,7 @@
           <a:lstStyle/>
           <a:p>
             <a:r>
-              <a:t>First quality cut. The NRMSE distribution of physical fits is bimodal on every detector: a good-fit population around 0.05 to 0.1, and a noise-trigger population around 1 to 2, separated by a valley at about 0.4. We place the cut in the valley - it is read off the distribution itself. On quiet detectors like Z7 the noise population is small; on noisy detectors like Z22 it dominates, and this cut is what digs the real pulses out of the mixture.</a:t>
+              <a:t>This is the alignment step, on its own. Each measured trace is shifted by its fitted pretrigger minus the nominal 16050 - a pure translation, nothing about the waveform is regenerated. The dotted vertical line is the common pretrigger everything is aligned to. The blue band is the aligned measured traces stacked together; they form a tight bundle, which tells us the pulse shape is highly consistent once the trigger-time jitter is removed. Red is the plain mean of the measured traces, and orange is the NRMSE-weighted mean of the fitted curves - already essentially the template. This tight bundle is what makes a well-defined template possible.</a:t>
             </a:r>
           </a:p>
         </p:txBody>
@@ -931,7 +1002,7 @@
           <a:lstStyle/>
           <a:p>
             <a:r>
-              <a:t>Before trusting the cut we looked at what it throws away. These are event grids of the rejected population on Z22: the raw traces show no pulse at all - they are noise triggers whose slow two-exp fit happened to converge. The fan-cut view on the right overlays the passing fitted curves in green and the rejected ones in red on the aligned data: the green population is the fast physical pulse shape, the red one is spread out with a median NRMSE three times higher. So the cut removes noise, not physics.</a:t>
+              <a:t>First quality cut. The NRMSE distribution of physical fits is bimodal on every detector: a good-fit population around 0.05 to 0.1, and a noise-trigger population around 1 to 2, separated by a valley at about 0.4. We place the cut in the valley - it is read off the distribution itself. On quiet detectors like Z7 the noise population is small; on noisy detectors like Z22 it dominates, and this cut is what digs the real pulses out of the mixture.</a:t>
             </a:r>
           </a:p>
         </p:txBody>
@@ -1001,7 +1072,7 @@
           <a:lstStyle/>
           <a:p>
             <a:r>
-              <a:t>The first lead comes from the fan plot after the cut: some curves still fall very slowly. We chased it by sampling: among events passing the cut, take fall times above one point five milliseconds, randomly sample ten, and draw raw versus fit in every channel. Two findings. First, the sampled events are real pulses - so they stay in, and we apply no fall cut. Second, their extreme fall times all trace back to one channel: only PDS2 is swinging wildly, while the same events are normal fast pulses in the other eleven channels - so the extreme tail is a one-channel low-frequency artifact, not slow physics.</a:t>
+              <a:t>Before trusting the cut we looked at what it throws away. These are event grids of the rejected population on Z22: the raw traces show no pulse at all - they are noise triggers whose slow two-exp fit happened to converge. The fan-cut view on the right overlays the passing fitted curves in green and the rejected ones in red on the aligned data: the green population is the fast physical pulse shape, the red one is spread out with a median NRMSE three times higher. So the cut removes noise, not physics.</a:t>
             </a:r>
           </a:p>
         </p:txBody>
@@ -1071,7 +1142,7 @@
           <a:lstStyle/>
           <a:p>
             <a:r>
-              <a:t>First template family: the analytic one. For each channel we take every physical fitted curve at the common pretrigger and average them with a weight of one over NRMSE squared - badly fit events count less but nothing is excluded by hand. After the cuts, shown here, a single tight shape family remains, and its weighted mean is the 1x1 template - smooth and noise-free by construction because it is built from analytic curves, delivered as peak-normalized ROOT histograms.</a:t>
+              <a:t>The first lead comes from the fan plot after the cut: some curves still fall very slowly. We chased it by sampling: among events passing the cut, take fall times above one point five milliseconds, randomly sample ten, and draw raw versus fit in every channel. Two findings. First, the sampled events are real pulses - so they stay in, and we apply no fall cut. Second, their extreme fall times all trace back to one channel: only PDS2 is swinging wildly, while the same events are normal fast pulses in the other eleven channels - so the extreme tail is a one-channel low-frequency artifact, not slow physics.</a:t>
             </a:r>
           </a:p>
         </p:txBody>
@@ -1141,7 +1212,7 @@
           <a:lstStyle/>
           <a:p>
             <a:r>
-              <a:t>Second family: the NxM PCA templates, built to capture the pulse-shape variation across events. We run a PCA over the fitted curves that pass all cuts, in a window around the pulse. The mean shape becomes template zero, and the first four principal components become templates one to four - they oscillate and can be negative, and the optimal filter fits a real pulse as a linear combination of them. The first two components already capture 96 to 98 percent of the shape variance on every detector.</a:t>
+              <a:t>First template family: the analytic one. For each channel we take every physical fitted curve at the common pretrigger and average them with a weight of one over NRMSE squared - badly fit events count less but nothing is excluded by hand. After the cuts, shown here, a single tight shape family remains, and its weighted mean is the 1x1 template - smooth and noise-free by construction because it is built from analytic curves, delivered as peak-normalized ROOT histograms.</a:t>
             </a:r>
           </a:p>
         </p:txBody>
@@ -4296,7 +4367,7 @@
                 </a:solidFill>
                 <a:latin typeface="Arial"/>
               </a:rPr>
-              <a:t>Delivered — and what remains</a:t>
+              <a:t>Template family 2 — NxM PCA templates</a:t>
             </a:r>
           </a:p>
         </p:txBody>
@@ -4352,8 +4423,8 @@
         </p:nvSpPr>
         <p:spPr>
           <a:xfrm>
-            <a:off x="502920" y="1554480"/>
-            <a:ext cx="11247120" cy="3200400"/>
+            <a:off x="502920" y="1115568"/>
+            <a:ext cx="11247120" cy="1371600"/>
           </a:xfrm>
           <a:prstGeom prst="rect">
             <a:avLst/>
@@ -4372,13 +4443,13 @@
               </a:spcAft>
             </a:pPr>
             <a:r>
-              <a:rPr sz="2200">
+              <a:rPr sz="1600">
                 <a:solidFill>
                   <a:srgbClr val="333333"/>
                 </a:solidFill>
                 <a:latin typeface="Arial"/>
               </a:rPr>
-              <a:t>• Two template families built for all 13 detectors:  1x1 (2-exp weighted)  +  NxM PCA</a:t>
+              <a:t>• Per-channel PCA over the clean fitted curves (fit_ok + NRMSE ≤ 0.4 + τ_rise ≤ 0.3 ms)</a:t>
             </a:r>
           </a:p>
           <a:p>
@@ -4388,13 +4459,13 @@
               </a:spcAft>
             </a:pPr>
             <a:r>
-              <a:rPr sz="2200">
+              <a:rPr sz="1600">
                 <a:solidFill>
                   <a:srgbClr val="333333"/>
                 </a:solidFill>
                 <a:latin typeface="Arial"/>
               </a:rPr>
-              <a:t>• Delivered in the official cdmsbats PulseTemplates format</a:t>
+              <a:t>• nxm0 = mean shape;  nxm1–4 = principal components;  real pulse = Σᵢ ampᵢ · nxmᵢ</a:t>
             </a:r>
           </a:p>
           <a:p>
@@ -4404,6 +4475,290 @@
               </a:spcAft>
             </a:pPr>
             <a:r>
+              <a:rPr sz="1600">
+                <a:solidFill>
+                  <a:srgbClr val="333333"/>
+                </a:solidFill>
+                <a:latin typeface="Arial"/>
+              </a:rPr>
+              <a:t>• PC1 + PC2 ≈ 96–98% of the shape variance;  delivered peak-normalized</a:t>
+            </a:r>
+          </a:p>
+        </p:txBody>
+      </p:sp>
+      <p:pic>
+        <p:nvPicPr>
+          <p:cNvPr id="5" name="Picture 4" descr="pca_zip7_PAS1.png"/>
+          <p:cNvPicPr>
+            <a:picLocks noChangeAspect="1"/>
+          </p:cNvPicPr>
+          <p:nvPr/>
+        </p:nvPicPr>
+        <p:blipFill>
+          <a:blip r:embed="rId2"/>
+          <a:stretch>
+            <a:fillRect/>
+          </a:stretch>
+        </p:blipFill>
+        <p:spPr>
+          <a:xfrm>
+            <a:off x="2831374" y="2697480"/>
+            <a:ext cx="6498771" cy="1828800"/>
+          </a:xfrm>
+          <a:prstGeom prst="rect">
+            <a:avLst/>
+          </a:prstGeom>
+        </p:spPr>
+      </p:pic>
+      <p:pic>
+        <p:nvPicPr>
+          <p:cNvPr id="6" name="Picture 5" descr="pca_zip7_PBS1.png"/>
+          <p:cNvPicPr>
+            <a:picLocks noChangeAspect="1"/>
+          </p:cNvPicPr>
+          <p:nvPr/>
+        </p:nvPicPr>
+        <p:blipFill>
+          <a:blip r:embed="rId3"/>
+          <a:stretch>
+            <a:fillRect/>
+          </a:stretch>
+        </p:blipFill>
+        <p:spPr>
+          <a:xfrm>
+            <a:off x="2831374" y="4572000"/>
+            <a:ext cx="6498771" cy="1828800"/>
+          </a:xfrm>
+          <a:prstGeom prst="rect">
+            <a:avLst/>
+          </a:prstGeom>
+        </p:spPr>
+      </p:pic>
+      <p:sp>
+        <p:nvSpPr>
+          <p:cNvPr id="7" name="TextBox 6"/>
+          <p:cNvSpPr txBox="1"/>
+          <p:nvPr/>
+        </p:nvSpPr>
+        <p:spPr>
+          <a:xfrm>
+            <a:off x="1371600" y="6430800"/>
+            <a:ext cx="9418320" cy="274320"/>
+          </a:xfrm>
+          <a:prstGeom prst="rect">
+            <a:avLst/>
+          </a:prstGeom>
+          <a:noFill/>
+        </p:spPr>
+        <p:txBody>
+          <a:bodyPr wrap="square">
+            <a:spAutoFit/>
+          </a:bodyPr>
+          <a:lstStyle/>
+          <a:p>
+            <a:pPr algn="ctr"/>
+            <a:r>
+              <a:rPr sz="1100" i="1">
+                <a:solidFill>
+                  <a:srgbClr val="666666"/>
+                </a:solidFill>
+                <a:latin typeface="Arial"/>
+              </a:rPr>
+              <a:t>Z7 PAS1 / PBS1: nxm0 (mean) + nxm1–4 (PCs) — the oscillating components encode rise/fall-time variation</a:t>
+            </a:r>
+          </a:p>
+        </p:txBody>
+      </p:sp>
+      <p:sp>
+        <p:nvSpPr>
+          <p:cNvPr id="8" name="TextBox 7"/>
+          <p:cNvSpPr txBox="1"/>
+          <p:nvPr/>
+        </p:nvSpPr>
+        <p:spPr>
+          <a:xfrm>
+            <a:off x="10957255" y="6446520"/>
+            <a:ext cx="1005840" cy="274320"/>
+          </a:xfrm>
+          <a:prstGeom prst="rect">
+            <a:avLst/>
+          </a:prstGeom>
+          <a:noFill/>
+        </p:spPr>
+        <p:txBody>
+          <a:bodyPr wrap="none">
+            <a:spAutoFit/>
+          </a:bodyPr>
+          <a:lstStyle/>
+          <a:p>
+            <a:pPr algn="r"/>
+            <a:r>
+              <a:rPr sz="1100">
+                <a:solidFill>
+                  <a:srgbClr val="666666"/>
+                </a:solidFill>
+                <a:latin typeface="Arial"/>
+              </a:rPr>
+              <a:t>10 / 11</a:t>
+            </a:r>
+          </a:p>
+        </p:txBody>
+      </p:sp>
+    </p:spTree>
+  </p:cSld>
+  <p:clrMapOvr>
+    <a:masterClrMapping/>
+  </p:clrMapOvr>
+</p:sld>
+</file>
+
+<file path=ppt/slides/slide11.xml><?xml version="1.0" encoding="utf-8"?>
+<p:sld xmlns:a="http://schemas.openxmlformats.org/drawingml/2006/main" xmlns:p="http://schemas.openxmlformats.org/presentationml/2006/main" xmlns:r="http://schemas.openxmlformats.org/officeDocument/2006/relationships">
+  <p:cSld>
+    <p:spTree>
+      <p:nvGrpSpPr>
+        <p:cNvPr id="1" name=""/>
+        <p:cNvGrpSpPr/>
+        <p:nvPr/>
+      </p:nvGrpSpPr>
+      <p:grpSpPr/>
+      <p:sp>
+        <p:nvSpPr>
+          <p:cNvPr id="2" name="TextBox 1"/>
+          <p:cNvSpPr txBox="1"/>
+          <p:nvPr/>
+        </p:nvSpPr>
+        <p:spPr>
+          <a:xfrm>
+            <a:off x="502920" y="256032"/>
+            <a:ext cx="11247120" cy="685800"/>
+          </a:xfrm>
+          <a:prstGeom prst="rect">
+            <a:avLst/>
+          </a:prstGeom>
+          <a:noFill/>
+        </p:spPr>
+        <p:txBody>
+          <a:bodyPr wrap="square">
+            <a:spAutoFit/>
+          </a:bodyPr>
+          <a:lstStyle/>
+          <a:p>
+            <a:r>
+              <a:rPr sz="2700" b="1">
+                <a:solidFill>
+                  <a:srgbClr val="1F3864"/>
+                </a:solidFill>
+                <a:latin typeface="Arial"/>
+              </a:rPr>
+              <a:t>Delivered — and what remains</a:t>
+            </a:r>
+          </a:p>
+        </p:txBody>
+      </p:sp>
+      <p:sp>
+        <p:nvSpPr>
+          <p:cNvPr id="3" name="Rectangle 2"/>
+          <p:cNvSpPr/>
+          <p:nvPr/>
+        </p:nvSpPr>
+        <p:spPr>
+          <a:xfrm>
+            <a:off x="502920" y="932688"/>
+            <a:ext cx="11247120" cy="18000"/>
+          </a:xfrm>
+          <a:prstGeom prst="rect">
+            <a:avLst/>
+          </a:prstGeom>
+          <a:solidFill>
+            <a:srgbClr val="1F3864"/>
+          </a:solidFill>
+          <a:ln>
+            <a:noFill/>
+          </a:ln>
+        </p:spPr>
+        <p:style>
+          <a:lnRef idx="1">
+            <a:schemeClr val="accent1"/>
+          </a:lnRef>
+          <a:fillRef idx="3">
+            <a:schemeClr val="accent1"/>
+          </a:fillRef>
+          <a:effectRef idx="2">
+            <a:schemeClr val="accent1"/>
+          </a:effectRef>
+          <a:fontRef idx="minor">
+            <a:schemeClr val="lt1"/>
+          </a:fontRef>
+        </p:style>
+        <p:txBody>
+          <a:bodyPr rtlCol="0" anchor="ctr"/>
+          <a:lstStyle/>
+          <a:p>
+            <a:pPr algn="ctr"/>
+          </a:p>
+        </p:txBody>
+      </p:sp>
+      <p:sp>
+        <p:nvSpPr>
+          <p:cNvPr id="4" name="TextBox 3"/>
+          <p:cNvSpPr txBox="1"/>
+          <p:nvPr/>
+        </p:nvSpPr>
+        <p:spPr>
+          <a:xfrm>
+            <a:off x="502920" y="1554480"/>
+            <a:ext cx="11247120" cy="3200400"/>
+          </a:xfrm>
+          <a:prstGeom prst="rect">
+            <a:avLst/>
+          </a:prstGeom>
+          <a:noFill/>
+        </p:spPr>
+        <p:txBody>
+          <a:bodyPr wrap="square">
+            <a:spAutoFit/>
+          </a:bodyPr>
+          <a:lstStyle/>
+          <a:p>
+            <a:pPr>
+              <a:spcAft>
+                <a:spcPts val="500"/>
+              </a:spcAft>
+            </a:pPr>
+            <a:r>
+              <a:rPr sz="2200">
+                <a:solidFill>
+                  <a:srgbClr val="333333"/>
+                </a:solidFill>
+                <a:latin typeface="Arial"/>
+              </a:rPr>
+              <a:t>• Two template families built for all 13 detectors:  1x1 (2-exp weighted)  +  NxM PCA</a:t>
+            </a:r>
+          </a:p>
+          <a:p>
+            <a:pPr>
+              <a:spcAft>
+                <a:spcPts val="500"/>
+              </a:spcAft>
+            </a:pPr>
+            <a:r>
+              <a:rPr sz="2200">
+                <a:solidFill>
+                  <a:srgbClr val="333333"/>
+                </a:solidFill>
+                <a:latin typeface="Arial"/>
+              </a:rPr>
+              <a:t>• Delivered in the official cdmsbats PulseTemplates format</a:t>
+            </a:r>
+          </a:p>
+          <a:p>
+            <a:pPr>
+              <a:spcAft>
+                <a:spcPts val="500"/>
+              </a:spcAft>
+            </a:pPr>
+            <a:r>
               <a:rPr sz="2200">
                 <a:solidFill>
                   <a:srgbClr val="333333"/>
@@ -4445,7 +4800,7 @@
                 </a:solidFill>
                 <a:latin typeface="Arial"/>
               </a:rPr>
-              <a:t>10 / 10</a:t>
+              <a:t>11 / 11</a:t>
             </a:r>
           </a:p>
         </p:txBody>
@@ -4780,7 +5135,7 @@
                 </a:solidFill>
                 <a:latin typeface="Arial"/>
               </a:rPr>
-              <a:t>2 / 10</a:t>
+              <a:t>2 / 11</a:t>
             </a:r>
           </a:p>
         </p:txBody>
@@ -4832,7 +5187,7 @@
                 </a:solidFill>
                 <a:latin typeface="Arial"/>
               </a:rPr>
-              <a:t>Per-trace algorithm: low-pass → fit → align</a:t>
+              <a:t>Fit quality at a glance — event × channel grids</a:t>
             </a:r>
           </a:p>
         </p:txBody>
@@ -4889,7 +5244,7 @@
         <p:spPr>
           <a:xfrm>
             <a:off x="502920" y="1097280"/>
-            <a:ext cx="11247120" cy="1234440"/>
+            <a:ext cx="11247120" cy="1188720"/>
           </a:xfrm>
           <a:prstGeom prst="rect">
             <a:avLst/>
@@ -4904,83 +5259,40 @@
           <a:p>
             <a:pPr>
               <a:spcAft>
-                <a:spcPts val="600"/>
+                <a:spcPts val="500"/>
               </a:spcAft>
             </a:pPr>
             <a:r>
-              <a:rPr sz="1600" b="1">
-                <a:solidFill>
-                  <a:srgbClr val="1F3864"/>
+              <a:rPr sz="1400">
+                <a:solidFill>
+                  <a:srgbClr val="333333"/>
                 </a:solidFill>
                 <a:latin typeface="Arial"/>
               </a:rPr>
-              <a:t>1.  Low-pass</a:t>
-            </a:r>
-            <a:r>
-              <a:rPr sz="1600">
+              <a:t>• One row per event, one column per channel: the low-passed trace (blue) with the fitted pulse model (red) overlaid</a:t>
+            </a:r>
+          </a:p>
+          <a:p>
+            <a:pPr>
+              <a:spcAft>
+                <a:spcPts val="500"/>
+              </a:spcAft>
+            </a:pPr>
+            <a:r>
+              <a:rPr sz="1400">
                 <a:solidFill>
                   <a:srgbClr val="333333"/>
                 </a:solidFill>
                 <a:latin typeface="Arial"/>
               </a:rPr>
-              <a:t> — 100 kHz 4th-order Butterworth</a:t>
-            </a:r>
-          </a:p>
-          <a:p>
-            <a:pPr>
-              <a:spcAft>
-                <a:spcPts val="600"/>
-              </a:spcAft>
-            </a:pPr>
-            <a:r>
-              <a:rPr sz="1600" b="1">
-                <a:solidFill>
-                  <a:srgbClr val="1F3864"/>
-                </a:solidFill>
-                <a:latin typeface="Arial"/>
-              </a:rPr>
-              <a:t>2.  Normalize</a:t>
-            </a:r>
-            <a:r>
-              <a:rPr sz="1600">
-                <a:solidFill>
-                  <a:srgbClr val="333333"/>
-                </a:solidFill>
-                <a:latin typeface="Arial"/>
-              </a:rPr>
-              <a:t> — subtract the baseline, scale the trace to unit peak</a:t>
-            </a:r>
-          </a:p>
-          <a:p>
-            <a:pPr>
-              <a:spcAft>
-                <a:spcPts val="600"/>
-              </a:spcAft>
-            </a:pPr>
-            <a:r>
-              <a:rPr sz="1600" b="1">
-                <a:solidFill>
-                  <a:srgbClr val="1F3864"/>
-                </a:solidFill>
-                <a:latin typeface="Arial"/>
-              </a:rPr>
-              <a:t>3.  Fit</a:t>
-            </a:r>
-            <a:r>
-              <a:rPr sz="1600">
-                <a:solidFill>
-                  <a:srgbClr val="333333"/>
-                </a:solidFill>
-                <a:latin typeface="Arial"/>
-              </a:rPr>
-              <a:t> — two-exponential model, all 5 parameters free (including the pretrigger t₀):</a:t>
+              <a:t>• A real event fits well in every channel at once; a noise trigger fails in every channel — a clean handle on which events are real (how we fit each trace: next slide)</a:t>
             </a:r>
           </a:p>
         </p:txBody>
       </p:sp>
       <p:pic>
         <p:nvPicPr>
-          <p:cNvPr id="5" name="Picture 4" descr="formula_2exp.png"/>
+          <p:cNvPr id="5" name="Picture 4" descr="fit_examples_zip7_noise.png"/>
           <p:cNvPicPr>
             <a:picLocks noChangeAspect="1"/>
           </p:cNvPicPr>
@@ -4994,8 +5306,8 @@
         </p:blipFill>
         <p:spPr>
           <a:xfrm>
-            <a:off x="3114415" y="2395728"/>
-            <a:ext cx="5932689" cy="868680"/>
+            <a:off x="182880" y="2514600"/>
+            <a:ext cx="5989320" cy="2781247"/>
           </a:xfrm>
           <a:prstGeom prst="rect">
             <a:avLst/>
@@ -5010,8 +5322,8 @@
         </p:nvSpPr>
         <p:spPr>
           <a:xfrm>
-            <a:off x="502920" y="3337560"/>
-            <a:ext cx="11247120" cy="1371600"/>
+            <a:off x="182880" y="5325847"/>
+            <a:ext cx="5989320" cy="274320"/>
           </a:xfrm>
           <a:prstGeom prst="rect">
             <a:avLst/>
@@ -5024,156 +5336,22 @@
           </a:bodyPr>
           <a:lstStyle/>
           <a:p>
-            <a:pPr>
-              <a:spcAft>
-                <a:spcPts val="600"/>
-              </a:spcAft>
-            </a:pPr>
-            <a:r>
-              <a:rPr sz="1600" b="1">
-                <a:solidFill>
-                  <a:srgbClr val="1F3864"/>
+            <a:pPr algn="ctr"/>
+            <a:r>
+              <a:rPr sz="1100" i="1">
+                <a:solidFill>
+                  <a:srgbClr val="666666"/>
                 </a:solidFill>
                 <a:latin typeface="Arial"/>
               </a:rPr>
-              <a:t>4.  Two quality numbers per trace</a:t>
-            </a:r>
-            <a:r>
-              <a:rPr sz="1600">
-                <a:solidFill>
-                  <a:srgbClr val="333333"/>
-                </a:solidFill>
-                <a:latin typeface="Arial"/>
-              </a:rPr>
-              <a:t> (recorded here, not cut yet):</a:t>
-            </a:r>
-          </a:p>
-        </p:txBody>
-      </p:sp>
-      <p:sp>
-        <p:nvSpPr>
-          <p:cNvPr id="7" name="TextBox 6"/>
-          <p:cNvSpPr txBox="1"/>
-          <p:nvPr/>
-        </p:nvSpPr>
-        <p:spPr>
-          <a:xfrm>
-            <a:off x="1051560" y="3675887"/>
-            <a:ext cx="10607040" cy="822960"/>
-          </a:xfrm>
-          <a:prstGeom prst="rect">
-            <a:avLst/>
-          </a:prstGeom>
-          <a:noFill/>
-        </p:spPr>
-        <p:txBody>
-          <a:bodyPr wrap="square">
-            <a:spAutoFit/>
-          </a:bodyPr>
-          <a:lstStyle/>
-          <a:p>
-            <a:pPr>
-              <a:spcAft>
-                <a:spcPts val="400"/>
-              </a:spcAft>
-            </a:pPr>
-            <a:r>
-              <a:rPr sz="1500" b="1">
-                <a:solidFill>
-                  <a:srgbClr val="333333"/>
-                </a:solidFill>
-                <a:latin typeface="Arial"/>
-              </a:rPr>
-              <a:t>•  fit_ok</a:t>
-            </a:r>
-            <a:r>
-              <a:rPr sz="1500">
-                <a:solidFill>
-                  <a:srgbClr val="333333"/>
-                </a:solidFill>
-                <a:latin typeface="Arial"/>
-              </a:rPr>
-              <a:t> — amplitude is positive, and the pulse rises faster than it falls</a:t>
-            </a:r>
-          </a:p>
-          <a:p>
-            <a:pPr>
-              <a:spcAft>
-                <a:spcPts val="400"/>
-              </a:spcAft>
-            </a:pPr>
-            <a:r>
-              <a:rPr sz="1500" b="1">
-                <a:solidFill>
-                  <a:srgbClr val="333333"/>
-                </a:solidFill>
-                <a:latin typeface="Arial"/>
-              </a:rPr>
-              <a:t>•  NRMSE</a:t>
-            </a:r>
-            <a:r>
-              <a:rPr sz="1500">
-                <a:solidFill>
-                  <a:srgbClr val="333333"/>
-                </a:solidFill>
-                <a:latin typeface="Arial"/>
-              </a:rPr>
-              <a:t> — RMS of the fit residual ÷ pulse peak  (smaller = better fit)</a:t>
-            </a:r>
-          </a:p>
-        </p:txBody>
-      </p:sp>
-      <p:sp>
-        <p:nvSpPr>
-          <p:cNvPr id="8" name="TextBox 7"/>
-          <p:cNvSpPr txBox="1"/>
-          <p:nvPr/>
-        </p:nvSpPr>
-        <p:spPr>
-          <a:xfrm>
-            <a:off x="502920" y="4526280"/>
-            <a:ext cx="11247120" cy="502920"/>
-          </a:xfrm>
-          <a:prstGeom prst="rect">
-            <a:avLst/>
-          </a:prstGeom>
-          <a:noFill/>
-        </p:spPr>
-        <p:txBody>
-          <a:bodyPr wrap="square">
-            <a:spAutoFit/>
-          </a:bodyPr>
-          <a:lstStyle/>
-          <a:p>
-            <a:pPr>
-              <a:spcAft>
-                <a:spcPts val="600"/>
-              </a:spcAft>
-            </a:pPr>
-            <a:r>
-              <a:rPr sz="1600" b="1">
-                <a:solidFill>
-                  <a:srgbClr val="1F3864"/>
-                </a:solidFill>
-                <a:latin typeface="Arial"/>
-              </a:rPr>
-              <a:t>5.  Align</a:t>
-            </a:r>
-            <a:r>
-              <a:rPr sz="1600">
-                <a:solidFill>
-                  <a:srgbClr val="333333"/>
-                </a:solidFill>
-                <a:latin typeface="Arial"/>
-              </a:rPr>
-              <a:t> — shift the measured trace by (fitted pretrigger − 16050)</a:t>
+              <a:t>Noise triggers: the fit fails in every channel at once</a:t>
             </a:r>
           </a:p>
         </p:txBody>
       </p:sp>
       <p:pic>
         <p:nvPicPr>
-          <p:cNvPr id="9" name="Picture 8" descr="fan_zip7_PBS1_before_zoom.png"/>
+          <p:cNvPr id="7" name="Picture 6" descr="fit_examples_zip7_good.png"/>
           <p:cNvPicPr>
             <a:picLocks noChangeAspect="1"/>
           </p:cNvPicPr>
@@ -5187,8 +5365,8 @@
         </p:blipFill>
         <p:spPr>
           <a:xfrm>
-            <a:off x="2233436" y="4864608"/>
-            <a:ext cx="2299688" cy="1371600"/>
+            <a:off x="6035040" y="2514600"/>
+            <a:ext cx="5989320" cy="2677983"/>
           </a:xfrm>
           <a:prstGeom prst="rect">
             <a:avLst/>
@@ -5197,14 +5375,14 @@
       </p:pic>
       <p:sp>
         <p:nvSpPr>
-          <p:cNvPr id="10" name="TextBox 9"/>
+          <p:cNvPr id="8" name="TextBox 7"/>
           <p:cNvSpPr txBox="1"/>
           <p:nvPr/>
         </p:nvSpPr>
         <p:spPr>
           <a:xfrm>
-            <a:off x="822960" y="6266208"/>
-            <a:ext cx="5120640" cy="274320"/>
+            <a:off x="6035040" y="5222583"/>
+            <a:ext cx="5989320" cy="274320"/>
           </a:xfrm>
           <a:prstGeom prst="rect">
             <a:avLst/>
@@ -5225,73 +5403,14 @@
                 </a:solidFill>
                 <a:latin typeface="Arial"/>
               </a:rPr>
-              <a:t>All fit_ok fitted curves (Z7 PBS1) — no cut</a:t>
-            </a:r>
-          </a:p>
-        </p:txBody>
-      </p:sp>
-      <p:pic>
-        <p:nvPicPr>
-          <p:cNvPr id="11" name="Picture 10" descr="fan_zip7_PBS1_nrmse_zoom.png"/>
-          <p:cNvPicPr>
-            <a:picLocks noChangeAspect="1"/>
-          </p:cNvPicPr>
-          <p:nvPr/>
-        </p:nvPicPr>
-        <p:blipFill>
-          <a:blip r:embed="rId4"/>
-          <a:stretch>
-            <a:fillRect/>
-          </a:stretch>
-        </p:blipFill>
-        <p:spPr>
-          <a:xfrm>
-            <a:off x="7719836" y="4864608"/>
-            <a:ext cx="2299688" cy="1371600"/>
-          </a:xfrm>
-          <a:prstGeom prst="rect">
-            <a:avLst/>
-          </a:prstGeom>
-        </p:spPr>
-      </p:pic>
-      <p:sp>
-        <p:nvSpPr>
-          <p:cNvPr id="12" name="TextBox 11"/>
-          <p:cNvSpPr txBox="1"/>
-          <p:nvPr/>
-        </p:nvSpPr>
-        <p:spPr>
-          <a:xfrm>
-            <a:off x="6309360" y="6266208"/>
-            <a:ext cx="5120640" cy="274320"/>
-          </a:xfrm>
-          <a:prstGeom prst="rect">
-            <a:avLst/>
-          </a:prstGeom>
-          <a:noFill/>
-        </p:spPr>
-        <p:txBody>
-          <a:bodyPr wrap="square">
-            <a:spAutoFit/>
-          </a:bodyPr>
-          <a:lstStyle/>
-          <a:p>
-            <a:pPr algn="ctr"/>
-            <a:r>
-              <a:rPr sz="1100" i="1">
-                <a:solidFill>
-                  <a:srgbClr val="666666"/>
-                </a:solidFill>
-                <a:latin typeface="Arial"/>
-              </a:rPr>
-              <a:t>After NRMSE ≤ 0.4 — one tight shape family</a:t>
-            </a:r>
-          </a:p>
-        </p:txBody>
-      </p:sp>
-      <p:sp>
-        <p:nvSpPr>
-          <p:cNvPr id="13" name="TextBox 12"/>
+              <a:t>K-line events: consistent good fits across channels</a:t>
+            </a:r>
+          </a:p>
+        </p:txBody>
+      </p:sp>
+      <p:sp>
+        <p:nvSpPr>
+          <p:cNvPr id="9" name="TextBox 8"/>
           <p:cNvSpPr txBox="1"/>
           <p:nvPr/>
         </p:nvSpPr>
@@ -5319,7 +5438,7 @@
                 </a:solidFill>
                 <a:latin typeface="Arial"/>
               </a:rPr>
-              <a:t>3 / 10</a:t>
+              <a:t>3 / 11</a:t>
             </a:r>
           </a:p>
         </p:txBody>
@@ -5371,7 +5490,7 @@
                 </a:solidFill>
                 <a:latin typeface="Arial"/>
               </a:rPr>
-              <a:t>Fit quality at a glance — event × channel grids</a:t>
+              <a:t>Per-trace algorithm: low-pass → fit → align</a:t>
             </a:r>
           </a:p>
         </p:txBody>
@@ -5428,7 +5547,7 @@
         <p:spPr>
           <a:xfrm>
             <a:off x="502920" y="1097280"/>
-            <a:ext cx="11247120" cy="1188720"/>
+            <a:ext cx="11247120" cy="1234440"/>
           </a:xfrm>
           <a:prstGeom prst="rect">
             <a:avLst/>
@@ -5443,40 +5562,83 @@
           <a:p>
             <a:pPr>
               <a:spcAft>
-                <a:spcPts val="500"/>
+                <a:spcPts val="600"/>
               </a:spcAft>
             </a:pPr>
             <a:r>
-              <a:rPr sz="1400">
-                <a:solidFill>
-                  <a:srgbClr val="333333"/>
+              <a:rPr sz="1600" b="1">
+                <a:solidFill>
+                  <a:srgbClr val="1F3864"/>
                 </a:solidFill>
                 <a:latin typeface="Arial"/>
               </a:rPr>
-              <a:t>• One row per event, one column per channel: low-passed trace (blue) vs 2-exp fit (red), NRMSE stamped per panel</a:t>
+              <a:t>1.  Low-pass</a:t>
+            </a:r>
+            <a:r>
+              <a:rPr sz="1600">
+                <a:solidFill>
+                  <a:srgbClr val="333333"/>
+                </a:solidFill>
+                <a:latin typeface="Arial"/>
+              </a:rPr>
+              <a:t> — 100 kHz 4th-order Butterworth</a:t>
             </a:r>
           </a:p>
           <a:p>
             <a:pPr>
               <a:spcAft>
-                <a:spcPts val="500"/>
+                <a:spcPts val="600"/>
               </a:spcAft>
             </a:pPr>
             <a:r>
-              <a:rPr sz="1400">
-                <a:solidFill>
-                  <a:srgbClr val="333333"/>
+              <a:rPr sz="1600" b="1">
+                <a:solidFill>
+                  <a:srgbClr val="1F3864"/>
                 </a:solidFill>
                 <a:latin typeface="Arial"/>
               </a:rPr>
-              <a:t>• The same event fits consistently across channels; a noise trigger fails in all channels at once</a:t>
+              <a:t>2.  Normalize</a:t>
+            </a:r>
+            <a:r>
+              <a:rPr sz="1600">
+                <a:solidFill>
+                  <a:srgbClr val="333333"/>
+                </a:solidFill>
+                <a:latin typeface="Arial"/>
+              </a:rPr>
+              <a:t> — subtract the baseline, scale the trace to unit peak</a:t>
+            </a:r>
+          </a:p>
+          <a:p>
+            <a:pPr>
+              <a:spcAft>
+                <a:spcPts val="600"/>
+              </a:spcAft>
+            </a:pPr>
+            <a:r>
+              <a:rPr sz="1600" b="1">
+                <a:solidFill>
+                  <a:srgbClr val="1F3864"/>
+                </a:solidFill>
+                <a:latin typeface="Arial"/>
+              </a:rPr>
+              <a:t>3.  Fit</a:t>
+            </a:r>
+            <a:r>
+              <a:rPr sz="1600">
+                <a:solidFill>
+                  <a:srgbClr val="333333"/>
+                </a:solidFill>
+                <a:latin typeface="Arial"/>
+              </a:rPr>
+              <a:t> — two-exponential model, all 5 parameters free (including the pretrigger t₀):</a:t>
             </a:r>
           </a:p>
         </p:txBody>
       </p:sp>
       <p:pic>
         <p:nvPicPr>
-          <p:cNvPr id="5" name="Picture 4" descr="fit_examples_zip7_noise.png"/>
+          <p:cNvPr id="5" name="Picture 4" descr="formula_2exp.png"/>
           <p:cNvPicPr>
             <a:picLocks noChangeAspect="1"/>
           </p:cNvPicPr>
@@ -5490,8 +5652,8 @@
         </p:blipFill>
         <p:spPr>
           <a:xfrm>
-            <a:off x="182880" y="2514600"/>
-            <a:ext cx="5989320" cy="2781247"/>
+            <a:off x="3114415" y="2395728"/>
+            <a:ext cx="5932689" cy="868680"/>
           </a:xfrm>
           <a:prstGeom prst="rect">
             <a:avLst/>
@@ -5506,8 +5668,8 @@
         </p:nvSpPr>
         <p:spPr>
           <a:xfrm>
-            <a:off x="182880" y="5325847"/>
-            <a:ext cx="5989320" cy="274320"/>
+            <a:off x="502920" y="3337560"/>
+            <a:ext cx="11247120" cy="1371600"/>
           </a:xfrm>
           <a:prstGeom prst="rect">
             <a:avLst/>
@@ -5520,22 +5682,156 @@
           </a:bodyPr>
           <a:lstStyle/>
           <a:p>
-            <a:pPr algn="ctr"/>
-            <a:r>
-              <a:rPr sz="1100" i="1">
-                <a:solidFill>
-                  <a:srgbClr val="666666"/>
+            <a:pPr>
+              <a:spcAft>
+                <a:spcPts val="600"/>
+              </a:spcAft>
+            </a:pPr>
+            <a:r>
+              <a:rPr sz="1600" b="1">
+                <a:solidFill>
+                  <a:srgbClr val="1F3864"/>
                 </a:solidFill>
                 <a:latin typeface="Arial"/>
               </a:rPr>
-              <a:t>Noise triggers: the fit fails in every channel at once</a:t>
+              <a:t>4.  Two quality numbers per trace</a:t>
+            </a:r>
+            <a:r>
+              <a:rPr sz="1600">
+                <a:solidFill>
+                  <a:srgbClr val="333333"/>
+                </a:solidFill>
+                <a:latin typeface="Arial"/>
+              </a:rPr>
+              <a:t> (recorded here, not cut yet):</a:t>
+            </a:r>
+          </a:p>
+        </p:txBody>
+      </p:sp>
+      <p:sp>
+        <p:nvSpPr>
+          <p:cNvPr id="7" name="TextBox 6"/>
+          <p:cNvSpPr txBox="1"/>
+          <p:nvPr/>
+        </p:nvSpPr>
+        <p:spPr>
+          <a:xfrm>
+            <a:off x="1051560" y="3675887"/>
+            <a:ext cx="10607040" cy="822960"/>
+          </a:xfrm>
+          <a:prstGeom prst="rect">
+            <a:avLst/>
+          </a:prstGeom>
+          <a:noFill/>
+        </p:spPr>
+        <p:txBody>
+          <a:bodyPr wrap="square">
+            <a:spAutoFit/>
+          </a:bodyPr>
+          <a:lstStyle/>
+          <a:p>
+            <a:pPr>
+              <a:spcAft>
+                <a:spcPts val="400"/>
+              </a:spcAft>
+            </a:pPr>
+            <a:r>
+              <a:rPr sz="1500" b="1">
+                <a:solidFill>
+                  <a:srgbClr val="333333"/>
+                </a:solidFill>
+                <a:latin typeface="Arial"/>
+              </a:rPr>
+              <a:t>•  fit_ok</a:t>
+            </a:r>
+            <a:r>
+              <a:rPr sz="1500">
+                <a:solidFill>
+                  <a:srgbClr val="333333"/>
+                </a:solidFill>
+                <a:latin typeface="Arial"/>
+              </a:rPr>
+              <a:t> — amplitude is positive, and the pulse rises faster than it falls</a:t>
+            </a:r>
+          </a:p>
+          <a:p>
+            <a:pPr>
+              <a:spcAft>
+                <a:spcPts val="400"/>
+              </a:spcAft>
+            </a:pPr>
+            <a:r>
+              <a:rPr sz="1500" b="1">
+                <a:solidFill>
+                  <a:srgbClr val="333333"/>
+                </a:solidFill>
+                <a:latin typeface="Arial"/>
+              </a:rPr>
+              <a:t>•  NRMSE</a:t>
+            </a:r>
+            <a:r>
+              <a:rPr sz="1500">
+                <a:solidFill>
+                  <a:srgbClr val="333333"/>
+                </a:solidFill>
+                <a:latin typeface="Arial"/>
+              </a:rPr>
+              <a:t> — RMS of the fit residual ÷ pulse peak  (smaller = better fit)</a:t>
+            </a:r>
+          </a:p>
+        </p:txBody>
+      </p:sp>
+      <p:sp>
+        <p:nvSpPr>
+          <p:cNvPr id="8" name="TextBox 7"/>
+          <p:cNvSpPr txBox="1"/>
+          <p:nvPr/>
+        </p:nvSpPr>
+        <p:spPr>
+          <a:xfrm>
+            <a:off x="502920" y="4526280"/>
+            <a:ext cx="11247120" cy="502920"/>
+          </a:xfrm>
+          <a:prstGeom prst="rect">
+            <a:avLst/>
+          </a:prstGeom>
+          <a:noFill/>
+        </p:spPr>
+        <p:txBody>
+          <a:bodyPr wrap="square">
+            <a:spAutoFit/>
+          </a:bodyPr>
+          <a:lstStyle/>
+          <a:p>
+            <a:pPr>
+              <a:spcAft>
+                <a:spcPts val="600"/>
+              </a:spcAft>
+            </a:pPr>
+            <a:r>
+              <a:rPr sz="1600" b="1">
+                <a:solidFill>
+                  <a:srgbClr val="1F3864"/>
+                </a:solidFill>
+                <a:latin typeface="Arial"/>
+              </a:rPr>
+              <a:t>5.  Align</a:t>
+            </a:r>
+            <a:r>
+              <a:rPr sz="1600">
+                <a:solidFill>
+                  <a:srgbClr val="333333"/>
+                </a:solidFill>
+                <a:latin typeface="Arial"/>
+              </a:rPr>
+              <a:t> — shift the measured trace by (fitted pretrigger − 16050)</a:t>
             </a:r>
           </a:p>
         </p:txBody>
       </p:sp>
       <p:pic>
         <p:nvPicPr>
-          <p:cNvPr id="7" name="Picture 6" descr="fit_examples_zip7_good.png"/>
+          <p:cNvPr id="9" name="Picture 8" descr="fan_zip7_PBS1_before_zoom.png"/>
           <p:cNvPicPr>
             <a:picLocks noChangeAspect="1"/>
           </p:cNvPicPr>
@@ -5549,8 +5845,8 @@
         </p:blipFill>
         <p:spPr>
           <a:xfrm>
-            <a:off x="6035040" y="2514600"/>
-            <a:ext cx="5989320" cy="2677983"/>
+            <a:off x="2233436" y="4864608"/>
+            <a:ext cx="2299688" cy="1371600"/>
           </a:xfrm>
           <a:prstGeom prst="rect">
             <a:avLst/>
@@ -5559,14 +5855,14 @@
       </p:pic>
       <p:sp>
         <p:nvSpPr>
-          <p:cNvPr id="8" name="TextBox 7"/>
+          <p:cNvPr id="10" name="TextBox 9"/>
           <p:cNvSpPr txBox="1"/>
           <p:nvPr/>
         </p:nvSpPr>
         <p:spPr>
           <a:xfrm>
-            <a:off x="6035040" y="5222583"/>
-            <a:ext cx="5989320" cy="274320"/>
+            <a:off x="822960" y="6266208"/>
+            <a:ext cx="5120640" cy="274320"/>
           </a:xfrm>
           <a:prstGeom prst="rect">
             <a:avLst/>
@@ -5587,14 +5883,73 @@
                 </a:solidFill>
                 <a:latin typeface="Arial"/>
               </a:rPr>
-              <a:t>K-line events: consistent good fits across channels</a:t>
-            </a:r>
-          </a:p>
-        </p:txBody>
-      </p:sp>
-      <p:sp>
-        <p:nvSpPr>
-          <p:cNvPr id="9" name="TextBox 8"/>
+              <a:t>All fit_ok fitted curves (Z7 PBS1) — no cut</a:t>
+            </a:r>
+          </a:p>
+        </p:txBody>
+      </p:sp>
+      <p:pic>
+        <p:nvPicPr>
+          <p:cNvPr id="11" name="Picture 10" descr="fan_zip7_PBS1_nrmse_zoom.png"/>
+          <p:cNvPicPr>
+            <a:picLocks noChangeAspect="1"/>
+          </p:cNvPicPr>
+          <p:nvPr/>
+        </p:nvPicPr>
+        <p:blipFill>
+          <a:blip r:embed="rId4"/>
+          <a:stretch>
+            <a:fillRect/>
+          </a:stretch>
+        </p:blipFill>
+        <p:spPr>
+          <a:xfrm>
+            <a:off x="7719836" y="4864608"/>
+            <a:ext cx="2299688" cy="1371600"/>
+          </a:xfrm>
+          <a:prstGeom prst="rect">
+            <a:avLst/>
+          </a:prstGeom>
+        </p:spPr>
+      </p:pic>
+      <p:sp>
+        <p:nvSpPr>
+          <p:cNvPr id="12" name="TextBox 11"/>
+          <p:cNvSpPr txBox="1"/>
+          <p:nvPr/>
+        </p:nvSpPr>
+        <p:spPr>
+          <a:xfrm>
+            <a:off x="6309360" y="6266208"/>
+            <a:ext cx="5120640" cy="274320"/>
+          </a:xfrm>
+          <a:prstGeom prst="rect">
+            <a:avLst/>
+          </a:prstGeom>
+          <a:noFill/>
+        </p:spPr>
+        <p:txBody>
+          <a:bodyPr wrap="square">
+            <a:spAutoFit/>
+          </a:bodyPr>
+          <a:lstStyle/>
+          <a:p>
+            <a:pPr algn="ctr"/>
+            <a:r>
+              <a:rPr sz="1100" i="1">
+                <a:solidFill>
+                  <a:srgbClr val="666666"/>
+                </a:solidFill>
+                <a:latin typeface="Arial"/>
+              </a:rPr>
+              <a:t>After NRMSE ≤ 0.4 — one tight shape family</a:t>
+            </a:r>
+          </a:p>
+        </p:txBody>
+      </p:sp>
+      <p:sp>
+        <p:nvSpPr>
+          <p:cNvPr id="13" name="TextBox 12"/>
           <p:cNvSpPr txBox="1"/>
           <p:nvPr/>
         </p:nvSpPr>
@@ -5622,7 +5977,7 @@
                 </a:solidFill>
                 <a:latin typeface="Arial"/>
               </a:rPr>
-              <a:t>4 / 10</a:t>
+              <a:t>4 / 11</a:t>
             </a:r>
           </a:p>
         </p:txBody>
@@ -5674,7 +6029,7 @@
                 </a:solidFill>
                 <a:latin typeface="Arial"/>
               </a:rPr>
-              <a:t>Quality cut 1: NRMSE ≤ 0.4 — where the number comes from</a:t>
+              <a:t>Alignment — every trace shifted to a common pretrigger</a:t>
             </a:r>
           </a:p>
         </p:txBody>
@@ -5731,7 +6086,7 @@
         <p:spPr>
           <a:xfrm>
             <a:off x="502920" y="1097280"/>
-            <a:ext cx="11247120" cy="1417320"/>
+            <a:ext cx="11247120" cy="822960"/>
           </a:xfrm>
           <a:prstGeom prst="rect">
             <a:avLst/>
@@ -5750,52 +6105,20 @@
               </a:spcAft>
             </a:pPr>
             <a:r>
-              <a:rPr sz="1400">
+              <a:rPr sz="1500">
                 <a:solidFill>
                   <a:srgbClr val="333333"/>
                 </a:solidFill>
                 <a:latin typeface="Arial"/>
               </a:rPr>
-              <a:t>• NRMSE of fit_ok events is bimodal: good fits (median ≈ 0.05–0.1) vs noise triggers (≈ 1–2), valley at ≈ 0.4–0.5</a:t>
-            </a:r>
-          </a:p>
-          <a:p>
-            <a:pPr>
-              <a:spcAft>
-                <a:spcPts val="500"/>
-              </a:spcAft>
-            </a:pPr>
-            <a:r>
-              <a:rPr sz="1400">
-                <a:solidFill>
-                  <a:srgbClr val="333333"/>
-                </a:solidFill>
-                <a:latin typeface="Arial"/>
-              </a:rPr>
-              <a:t>• The cut sits in the valley — it is read off the distribution, not tuned on the templates</a:t>
-            </a:r>
-          </a:p>
-          <a:p>
-            <a:pPr>
-              <a:spcAft>
-                <a:spcPts val="500"/>
-              </a:spcAft>
-            </a:pPr>
-            <a:r>
-              <a:rPr sz="1400">
-                <a:solidFill>
-                  <a:srgbClr val="333333"/>
-                </a:solidFill>
-                <a:latin typeface="Arial"/>
-              </a:rPr>
-              <a:t>• Noisy detectors (Z1, Z4, Z6, Z18, Z19, Z22, Z24): the PTOF window admits a noise-dominated mixture — this cut is what extracts the real-pulse population</a:t>
+              <a:t>• Each measured trace is shifted by (fitted pretrigger − 16050) — a pure translation; the aligned traces stack into a tight bundle</a:t>
             </a:r>
           </a:p>
         </p:txBody>
       </p:sp>
       <p:pic>
         <p:nvPicPr>
-          <p:cNvPr id="5" name="Picture 4" descr="nrmse_zip7_PBS1.png"/>
+          <p:cNvPr id="5" name="Picture 4" descr="aligned_zoom_zip7_PBS1_clean.png"/>
           <p:cNvPicPr>
             <a:picLocks noChangeAspect="1"/>
           </p:cNvPicPr>
@@ -5809,8 +6132,8 @@
         </p:blipFill>
         <p:spPr>
           <a:xfrm>
-            <a:off x="1970576" y="2651760"/>
-            <a:ext cx="8220367" cy="1874519"/>
+            <a:off x="1581796" y="2194560"/>
+            <a:ext cx="8997927" cy="4297680"/>
           </a:xfrm>
           <a:prstGeom prst="rect">
             <a:avLst/>
@@ -5825,8 +6148,8 @@
         </p:nvSpPr>
         <p:spPr>
           <a:xfrm>
-            <a:off x="1737360" y="4556279"/>
-            <a:ext cx="8686800" cy="274320"/>
+            <a:off x="548640" y="6522240"/>
+            <a:ext cx="11064240" cy="274320"/>
           </a:xfrm>
           <a:prstGeom prst="rect">
             <a:avLst/>
@@ -5847,73 +6170,14 @@
                 </a:solidFill>
                 <a:latin typeface="Arial"/>
               </a:rPr>
-              <a:t>Z7 PBS1 (quiet): two clean populations, log-log axes</a:t>
-            </a:r>
-          </a:p>
-        </p:txBody>
-      </p:sp>
-      <p:pic>
-        <p:nvPicPr>
-          <p:cNvPr id="7" name="Picture 6" descr="nrmse_zip22_PAS1.png"/>
-          <p:cNvPicPr>
-            <a:picLocks noChangeAspect="1"/>
-          </p:cNvPicPr>
-          <p:nvPr/>
-        </p:nvPicPr>
-        <p:blipFill>
-          <a:blip r:embed="rId3"/>
-          <a:stretch>
-            <a:fillRect/>
-          </a:stretch>
-        </p:blipFill>
-        <p:spPr>
-          <a:xfrm>
-            <a:off x="1989344" y="4754880"/>
-            <a:ext cx="8182831" cy="1874519"/>
-          </a:xfrm>
-          <a:prstGeom prst="rect">
-            <a:avLst/>
-          </a:prstGeom>
-        </p:spPr>
-      </p:pic>
-      <p:sp>
-        <p:nvSpPr>
-          <p:cNvPr id="8" name="TextBox 7"/>
-          <p:cNvSpPr txBox="1"/>
-          <p:nvPr/>
-        </p:nvSpPr>
-        <p:spPr>
-          <a:xfrm>
-            <a:off x="1737360" y="6659399"/>
-            <a:ext cx="8686800" cy="274320"/>
-          </a:xfrm>
-          <a:prstGeom prst="rect">
-            <a:avLst/>
-          </a:prstGeom>
-          <a:noFill/>
-        </p:spPr>
-        <p:txBody>
-          <a:bodyPr wrap="square">
-            <a:spAutoFit/>
-          </a:bodyPr>
-          <a:lstStyle/>
-          <a:p>
-            <a:pPr algn="ctr"/>
-            <a:r>
-              <a:rPr sz="1100" i="1">
-                <a:solidFill>
-                  <a:srgbClr val="666666"/>
-                </a:solidFill>
-                <a:latin typeface="Arial"/>
-              </a:rPr>
-              <a:t>Z22 PAS1 (noisy): noise population dominates — the window alone is not enough</a:t>
-            </a:r>
-          </a:p>
-        </p:txBody>
-      </p:sp>
-      <p:sp>
-        <p:nvSpPr>
-          <p:cNvPr id="9" name="TextBox 8"/>
+              <a:t>Z7 PBS1 (peak zoom): shift-aligned measured traces (blue)  ·  mean (red)  ·  NRMSE-weighted mean of the fitted curves (orange)  ·  dotted line = common pretrigger 16050</a:t>
+            </a:r>
+          </a:p>
+        </p:txBody>
+      </p:sp>
+      <p:sp>
+        <p:nvSpPr>
+          <p:cNvPr id="7" name="TextBox 6"/>
           <p:cNvSpPr txBox="1"/>
           <p:nvPr/>
         </p:nvSpPr>
@@ -5941,7 +6205,7 @@
                 </a:solidFill>
                 <a:latin typeface="Arial"/>
               </a:rPr>
-              <a:t>5 / 10</a:t>
+              <a:t>5 / 11</a:t>
             </a:r>
           </a:p>
         </p:txBody>
@@ -5993,7 +6257,7 @@
                 </a:solidFill>
                 <a:latin typeface="Arial"/>
               </a:rPr>
-              <a:t>The rejected population is noise — verified in the raw traces</a:t>
+              <a:t>Quality cut 1: NRMSE ≤ 0.4 — where the number comes from</a:t>
             </a:r>
           </a:p>
         </p:txBody>
@@ -6050,7 +6314,7 @@
         <p:spPr>
           <a:xfrm>
             <a:off x="502920" y="1097280"/>
-            <a:ext cx="11247120" cy="914400"/>
+            <a:ext cx="11247120" cy="1417320"/>
           </a:xfrm>
           <a:prstGeom prst="rect">
             <a:avLst/>
@@ -6075,14 +6339,46 @@
                 </a:solidFill>
                 <a:latin typeface="Arial"/>
               </a:rPr>
-              <a:t>• Event grids of NRMSE-rejected events (median NRMSE &gt; 0.4 across channels): the raw traces show no pulse — the cut removes noise triggers, not physics</a:t>
+              <a:t>• NRMSE of fit_ok events is bimodal: good fits (median ≈ 0.05–0.1) vs noise triggers (≈ 1–2), valley at ≈ 0.4–0.5</a:t>
+            </a:r>
+          </a:p>
+          <a:p>
+            <a:pPr>
+              <a:spcAft>
+                <a:spcPts val="500"/>
+              </a:spcAft>
+            </a:pPr>
+            <a:r>
+              <a:rPr sz="1400">
+                <a:solidFill>
+                  <a:srgbClr val="333333"/>
+                </a:solidFill>
+                <a:latin typeface="Arial"/>
+              </a:rPr>
+              <a:t>• The cut sits in the valley — it is read off the distribution, not tuned on the templates</a:t>
+            </a:r>
+          </a:p>
+          <a:p>
+            <a:pPr>
+              <a:spcAft>
+                <a:spcPts val="500"/>
+              </a:spcAft>
+            </a:pPr>
+            <a:r>
+              <a:rPr sz="1400">
+                <a:solidFill>
+                  <a:srgbClr val="333333"/>
+                </a:solidFill>
+                <a:latin typeface="Arial"/>
+              </a:rPr>
+              <a:t>• Noisy detectors (Z1, Z4, Z6, Z18, Z19, Z22, Z24): the PTOF window admits a noise-dominated mixture — this cut is what extracts the real-pulse population</a:t>
             </a:r>
           </a:p>
         </p:txBody>
       </p:sp>
       <p:pic>
         <p:nvPicPr>
-          <p:cNvPr id="5" name="Picture 4" descr="slow_rise_zip22_crop.png"/>
+          <p:cNvPr id="5" name="Picture 4" descr="nrmse_zip7_PBS1.png"/>
           <p:cNvPicPr>
             <a:picLocks noChangeAspect="1"/>
           </p:cNvPicPr>
@@ -6096,8 +6392,8 @@
         </p:blipFill>
         <p:spPr>
           <a:xfrm>
-            <a:off x="365760" y="2468880"/>
-            <a:ext cx="5394960" cy="3699401"/>
+            <a:off x="1970576" y="2651760"/>
+            <a:ext cx="8220367" cy="1874519"/>
           </a:xfrm>
           <a:prstGeom prst="rect">
             <a:avLst/>
@@ -6112,8 +6408,8 @@
         </p:nvSpPr>
         <p:spPr>
           <a:xfrm>
-            <a:off x="365760" y="6198281"/>
-            <a:ext cx="5394960" cy="274320"/>
+            <a:off x="1737360" y="4556279"/>
+            <a:ext cx="8686800" cy="274320"/>
           </a:xfrm>
           <a:prstGeom prst="rect">
             <a:avLst/>
@@ -6134,14 +6430,14 @@
                 </a:solidFill>
                 <a:latin typeface="Arial"/>
               </a:rPr>
-              <a:t>Z22: NRMSE-rejected events — raw traces are noise</a:t>
+              <a:t>Z7 PBS1 (quiet): two clean populations, log-log axes</a:t>
             </a:r>
           </a:p>
         </p:txBody>
       </p:sp>
       <p:pic>
         <p:nvPicPr>
-          <p:cNvPr id="7" name="Picture 6" descr="fan_cut_zip22_PCS1.png"/>
+          <p:cNvPr id="7" name="Picture 6" descr="nrmse_zip22_PAS1.png"/>
           <p:cNvPicPr>
             <a:picLocks noChangeAspect="1"/>
           </p:cNvPicPr>
@@ -6155,8 +6451,8 @@
         </p:blipFill>
         <p:spPr>
           <a:xfrm>
-            <a:off x="5943600" y="2240280"/>
-            <a:ext cx="6263640" cy="3429000"/>
+            <a:off x="1989344" y="4754880"/>
+            <a:ext cx="8182831" cy="1874519"/>
           </a:xfrm>
           <a:prstGeom prst="rect">
             <a:avLst/>
@@ -6171,8 +6467,8 @@
         </p:nvSpPr>
         <p:spPr>
           <a:xfrm>
-            <a:off x="6035040" y="5806440"/>
-            <a:ext cx="6126480" cy="960120"/>
+            <a:off x="1737360" y="6659399"/>
+            <a:ext cx="8686800" cy="274320"/>
           </a:xfrm>
           <a:prstGeom prst="rect">
             <a:avLst/>
@@ -6185,43 +6481,15 @@
           </a:bodyPr>
           <a:lstStyle/>
           <a:p>
-            <a:r>
-              <a:rPr sz="1400" b="1">
-                <a:solidFill>
-                  <a:srgbClr val="2E7D32"/>
+            <a:pPr algn="ctr"/>
+            <a:r>
+              <a:rPr sz="1100" i="1">
+                <a:solidFill>
+                  <a:srgbClr val="666666"/>
                 </a:solidFill>
                 <a:latin typeface="Arial"/>
               </a:rPr>
-              <a:t>── passes the cut (kept)</a:t>
-            </a:r>
-            <a:r>
-              <a:rPr sz="1400" b="1">
-                <a:solidFill>
-                  <a:srgbClr val="C0392B"/>
-                </a:solidFill>
-                <a:latin typeface="Arial"/>
-              </a:rPr>
-              <a:t>      ── cut away = rejected</a:t>
-            </a:r>
-          </a:p>
-          <a:p>
-            <a:r>
-              <a:rPr sz="1400" b="0">
-                <a:solidFill>
-                  <a:srgbClr val="4A70B0"/>
-                </a:solidFill>
-                <a:latin typeface="Arial"/>
-              </a:rPr>
-              <a:t>faint blue = measured traces</a:t>
-            </a:r>
-            <a:r>
-              <a:rPr sz="1400" b="0">
-                <a:solidFill>
-                  <a:srgbClr val="333333"/>
-                </a:solidFill>
-                <a:latin typeface="Arial"/>
-              </a:rPr>
-              <a:t>      Z22 PCS1: 7198 kept / 4788 cut (~40%)</a:t>
+              <a:t>Z22 PAS1 (noisy): noise population dominates — the window alone is not enough</a:t>
             </a:r>
           </a:p>
         </p:txBody>
@@ -6256,7 +6524,7 @@
                 </a:solidFill>
                 <a:latin typeface="Arial"/>
               </a:rPr>
-              <a:t>6 / 10</a:t>
+              <a:t>6 / 11</a:t>
             </a:r>
           </a:p>
         </p:txBody>
@@ -6308,7 +6576,7 @@
                 </a:solidFill>
                 <a:latin typeface="Arial"/>
               </a:rPr>
-              <a:t>Follow-up 1 — the slow-fall tail is a one-channel artifact</a:t>
+              <a:t>The rejected population is noise — verified in the raw traces</a:t>
             </a:r>
           </a:p>
         </p:txBody>
@@ -6365,7 +6633,7 @@
         <p:spPr>
           <a:xfrm>
             <a:off x="502920" y="1097280"/>
-            <a:ext cx="11247120" cy="1417320"/>
+            <a:ext cx="11247120" cy="914400"/>
           </a:xfrm>
           <a:prstGeom prst="rect">
             <a:avLst/>
@@ -6390,46 +6658,14 @@
                 </a:solidFill>
                 <a:latin typeface="Arial"/>
               </a:rPr>
-              <a:t>• The post-cut fan still shows slow-fall tails → sample them: NRMSE ≤ 0.4 AND τ_fall &gt; 1.5 ms, 10 random events, raw vs fit drawn in all 12 channels</a:t>
-            </a:r>
-          </a:p>
-          <a:p>
-            <a:pPr>
-              <a:spcAft>
-                <a:spcPts val="500"/>
-              </a:spcAft>
-            </a:pPr>
-            <a:r>
-              <a:rPr sz="1400">
-                <a:solidFill>
-                  <a:srgbClr val="333333"/>
-                </a:solidFill>
-                <a:latin typeface="Arial"/>
-              </a:rPr>
-              <a:t>• The sampled events are real pulses → kept. Their extreme fall times trace to one channel: only PDS2 swings (τ_fall median 0.51 ms vs ≈ 0.25 ms elsewhere) — a low-frequency disturbance</a:t>
-            </a:r>
-          </a:p>
-          <a:p>
-            <a:pPr>
-              <a:spcAft>
-                <a:spcPts val="500"/>
-              </a:spcAft>
-            </a:pPr>
-            <a:r>
-              <a:rPr sz="1400">
-                <a:solidFill>
-                  <a:srgbClr val="333333"/>
-                </a:solidFill>
-                <a:latin typeface="Arial"/>
-              </a:rPr>
-              <a:t>• Conclusion: no τ_fall cut — slow-fall events passing NRMSE stay in; the extreme tail is a one-channel artifact, not physics</a:t>
+              <a:t>• Event grids of NRMSE-rejected events (median NRMSE &gt; 0.4 across channels): the raw traces show no pulse — the cut removes noise triggers, not physics</a:t>
             </a:r>
           </a:p>
         </p:txBody>
       </p:sp>
       <p:pic>
         <p:nvPicPr>
-          <p:cNvPr id="5" name="Picture 4" descr="slow_fall_zip7_crop.png"/>
+          <p:cNvPr id="5" name="Picture 4" descr="slow_rise_zip22_crop.png"/>
           <p:cNvPicPr>
             <a:picLocks noChangeAspect="1"/>
           </p:cNvPicPr>
@@ -6443,8 +6679,8 @@
         </p:blipFill>
         <p:spPr>
           <a:xfrm>
-            <a:off x="274320" y="2697480"/>
-            <a:ext cx="6126480" cy="3149961"/>
+            <a:off x="365760" y="2468880"/>
+            <a:ext cx="5394960" cy="3699401"/>
           </a:xfrm>
           <a:prstGeom prst="rect">
             <a:avLst/>
@@ -6459,8 +6695,8 @@
         </p:nvSpPr>
         <p:spPr>
           <a:xfrm>
-            <a:off x="274320" y="5877441"/>
-            <a:ext cx="6126480" cy="274320"/>
+            <a:off x="365760" y="6198281"/>
+            <a:ext cx="5394960" cy="274320"/>
           </a:xfrm>
           <a:prstGeom prst="rect">
             <a:avLst/>
@@ -6481,14 +6717,14 @@
                 </a:solidFill>
                 <a:latin typeface="Arial"/>
               </a:rPr>
-              <a:t>Z7, 3 sampled slow-fall events: normal in PBS2/PCS2/PES2, swings only in PDS2</a:t>
+              <a:t>Z22: NRMSE-rejected events — raw traces are noise</a:t>
             </a:r>
           </a:p>
         </p:txBody>
       </p:sp>
       <p:pic>
         <p:nvPicPr>
-          <p:cNvPr id="7" name="Picture 6" descr="time_constants_zip7_PAS1_tfall.png"/>
+          <p:cNvPr id="7" name="Picture 6" descr="fan_cut_zip22_PCS1.png"/>
           <p:cNvPicPr>
             <a:picLocks noChangeAspect="1"/>
           </p:cNvPicPr>
@@ -6502,8 +6738,8 @@
         </p:blipFill>
         <p:spPr>
           <a:xfrm>
-            <a:off x="6446520" y="3063240"/>
-            <a:ext cx="2788920" cy="2085332"/>
+            <a:off x="5943600" y="2240280"/>
+            <a:ext cx="6263640" cy="3429000"/>
           </a:xfrm>
           <a:prstGeom prst="rect">
             <a:avLst/>
@@ -6518,8 +6754,8 @@
         </p:nvSpPr>
         <p:spPr>
           <a:xfrm>
-            <a:off x="6446520" y="5178572"/>
-            <a:ext cx="2788920" cy="274320"/>
+            <a:off x="6035040" y="5806440"/>
+            <a:ext cx="6126480" cy="960120"/>
           </a:xfrm>
           <a:prstGeom prst="rect">
             <a:avLst/>
@@ -6532,115 +6768,50 @@
           </a:bodyPr>
           <a:lstStyle/>
           <a:p>
-            <a:pPr algn="ctr"/>
-            <a:r>
-              <a:rPr sz="1100" i="1">
-                <a:solidFill>
-                  <a:srgbClr val="666666"/>
+            <a:r>
+              <a:rPr sz="1400" b="1">
+                <a:solidFill>
+                  <a:srgbClr val="2E7D32"/>
                 </a:solidFill>
                 <a:latin typeface="Arial"/>
               </a:rPr>
-              <a:t>PAS1 — normal channel: narrow (median 0.25 ms)</a:t>
-            </a:r>
-          </a:p>
-        </p:txBody>
-      </p:sp>
-      <p:pic>
-        <p:nvPicPr>
-          <p:cNvPr id="9" name="Picture 8" descr="time_constants_zip7_PDS2_tfall.png"/>
-          <p:cNvPicPr>
-            <a:picLocks noChangeAspect="1"/>
-          </p:cNvPicPr>
-          <p:nvPr/>
-        </p:nvPicPr>
-        <p:blipFill>
-          <a:blip r:embed="rId4"/>
-          <a:stretch>
-            <a:fillRect/>
-          </a:stretch>
-        </p:blipFill>
-        <p:spPr>
-          <a:xfrm>
-            <a:off x="9326880" y="3063240"/>
-            <a:ext cx="2788920" cy="2076855"/>
-          </a:xfrm>
-          <a:prstGeom prst="rect">
-            <a:avLst/>
-          </a:prstGeom>
-        </p:spPr>
-      </p:pic>
-      <p:sp>
-        <p:nvSpPr>
-          <p:cNvPr id="10" name="TextBox 9"/>
-          <p:cNvSpPr txBox="1"/>
-          <p:nvPr/>
-        </p:nvSpPr>
-        <p:spPr>
-          <a:xfrm>
-            <a:off x="9326880" y="5170095"/>
-            <a:ext cx="2788920" cy="274320"/>
-          </a:xfrm>
-          <a:prstGeom prst="rect">
-            <a:avLst/>
-          </a:prstGeom>
-          <a:noFill/>
-        </p:spPr>
-        <p:txBody>
-          <a:bodyPr wrap="square">
-            <a:spAutoFit/>
-          </a:bodyPr>
-          <a:lstStyle/>
-          <a:p>
-            <a:pPr algn="ctr"/>
-            <a:r>
-              <a:rPr sz="1100" i="1">
-                <a:solidFill>
-                  <a:srgbClr val="666666"/>
+              <a:t>── passes the cut (kept)</a:t>
+            </a:r>
+            <a:r>
+              <a:rPr sz="1400" b="1">
+                <a:solidFill>
+                  <a:srgbClr val="C0392B"/>
                 </a:solidFill>
                 <a:latin typeface="Arial"/>
               </a:rPr>
-              <a:t>PDS2 — bad channel: broad tail (median 0.51 ms)</a:t>
-            </a:r>
-          </a:p>
-        </p:txBody>
-      </p:sp>
-      <p:sp>
-        <p:nvSpPr>
-          <p:cNvPr id="11" name="TextBox 10"/>
-          <p:cNvSpPr txBox="1"/>
-          <p:nvPr/>
-        </p:nvSpPr>
-        <p:spPr>
-          <a:xfrm>
-            <a:off x="6446520" y="2395728"/>
-            <a:ext cx="5669280" cy="502920"/>
-          </a:xfrm>
-          <a:prstGeom prst="rect">
-            <a:avLst/>
-          </a:prstGeom>
-          <a:noFill/>
-        </p:spPr>
-        <p:txBody>
-          <a:bodyPr wrap="square">
-            <a:spAutoFit/>
-          </a:bodyPr>
-          <a:lstStyle/>
-          <a:p>
-            <a:r>
-              <a:rPr sz="1500" b="1">
-                <a:solidFill>
-                  <a:srgbClr val="1F3864"/>
+              <a:t>      ── cut away = rejected</a:t>
+            </a:r>
+          </a:p>
+          <a:p>
+            <a:r>
+              <a:rPr sz="1400" b="0">
+                <a:solidFill>
+                  <a:srgbClr val="4A70B0"/>
                 </a:solidFill>
                 <a:latin typeface="Arial"/>
               </a:rPr>
-              <a:t>Fitted τ_fall distribution, same 0–7 ms axis:</a:t>
-            </a:r>
-          </a:p>
-        </p:txBody>
-      </p:sp>
-      <p:sp>
-        <p:nvSpPr>
-          <p:cNvPr id="12" name="TextBox 11"/>
+              <a:t>faint blue = measured traces</a:t>
+            </a:r>
+            <a:r>
+              <a:rPr sz="1400" b="0">
+                <a:solidFill>
+                  <a:srgbClr val="333333"/>
+                </a:solidFill>
+                <a:latin typeface="Arial"/>
+              </a:rPr>
+              <a:t>      Z22 PCS1: 7198 kept / 4788 cut (~40%)</a:t>
+            </a:r>
+          </a:p>
+        </p:txBody>
+      </p:sp>
+      <p:sp>
+        <p:nvSpPr>
+          <p:cNvPr id="9" name="TextBox 8"/>
           <p:cNvSpPr txBox="1"/>
           <p:nvPr/>
         </p:nvSpPr>
@@ -6668,7 +6839,7 @@
                 </a:solidFill>
                 <a:latin typeface="Arial"/>
               </a:rPr>
-              <a:t>7 / 10</a:t>
+              <a:t>7 / 11</a:t>
             </a:r>
           </a:p>
         </p:txBody>
@@ -6720,7 +6891,7 @@
                 </a:solidFill>
                 <a:latin typeface="Arial"/>
               </a:rPr>
-              <a:t>Template family 1 — analytic 2-exp, NRMSE-weighted (1x1)</a:t>
+              <a:t>Follow-up 1 — the slow-fall tail is a one-channel artifact</a:t>
             </a:r>
           </a:p>
         </p:txBody>
@@ -6776,8 +6947,8 @@
         </p:nvSpPr>
         <p:spPr>
           <a:xfrm>
-            <a:off x="502920" y="1143000"/>
-            <a:ext cx="11247120" cy="1371600"/>
+            <a:off x="502920" y="1097280"/>
+            <a:ext cx="11247120" cy="1417320"/>
           </a:xfrm>
           <a:prstGeom prst="rect">
             <a:avLst/>
@@ -6796,13 +6967,13 @@
               </a:spcAft>
             </a:pPr>
             <a:r>
-              <a:rPr sz="1800">
+              <a:rPr sz="1400">
                 <a:solidFill>
                   <a:srgbClr val="333333"/>
                 </a:solidFill>
                 <a:latin typeface="Arial"/>
               </a:rPr>
-              <a:t>• NRMSE-weighted mean of the fit_ok 2-exp curves</a:t>
+              <a:t>• The post-cut fan still shows slow-fall tails → sample them: NRMSE ≤ 0.4 AND τ_fall &gt; 1.5 ms, 10 random events, raw vs fit drawn in all 12 channels</a:t>
             </a:r>
           </a:p>
           <a:p>
@@ -6812,13 +6983,13 @@
               </a:spcAft>
             </a:pPr>
             <a:r>
-              <a:rPr sz="1800">
+              <a:rPr sz="1400">
                 <a:solidFill>
                   <a:srgbClr val="333333"/>
                 </a:solidFill>
                 <a:latin typeface="Arial"/>
               </a:rPr>
-              <a:t>• Smooth &amp; noise-free by construction</a:t>
+              <a:t>• The sampled events are real pulses → kept. Their extreme fall times trace to one channel: only PDS2 swings (τ_fall median 0.51 ms vs ≈ 0.25 ms elsewhere) — a low-frequency disturbance</a:t>
             </a:r>
           </a:p>
           <a:p>
@@ -6828,20 +6999,20 @@
               </a:spcAft>
             </a:pPr>
             <a:r>
-              <a:rPr sz="1800">
+              <a:rPr sz="1400">
                 <a:solidFill>
                   <a:srgbClr val="333333"/>
                 </a:solidFill>
                 <a:latin typeface="Arial"/>
               </a:rPr>
-              <a:t>• ROOT TH1D, peak-normalized (+ summed PT / PS1 / PS2)</a:t>
+              <a:t>• Conclusion: no τ_fall cut — slow-fall events passing NRMSE stay in; the extreme tail is a one-channel artifact, not physics</a:t>
             </a:r>
           </a:p>
         </p:txBody>
       </p:sp>
       <p:pic>
         <p:nvPicPr>
-          <p:cNvPr id="5" name="Picture 4" descr="fan_zip7_PBS1_after.png"/>
+          <p:cNvPr id="5" name="Picture 4" descr="slow_fall_zip7_crop.png"/>
           <p:cNvPicPr>
             <a:picLocks noChangeAspect="1"/>
           </p:cNvPicPr>
@@ -6855,8 +7026,8 @@
         </p:blipFill>
         <p:spPr>
           <a:xfrm>
-            <a:off x="1383919" y="3063240"/>
-            <a:ext cx="9393682" cy="2834640"/>
+            <a:off x="274320" y="2697480"/>
+            <a:ext cx="6126480" cy="3149961"/>
           </a:xfrm>
           <a:prstGeom prst="rect">
             <a:avLst/>
@@ -6871,8 +7042,8 @@
         </p:nvSpPr>
         <p:spPr>
           <a:xfrm>
-            <a:off x="1280160" y="5927880"/>
-            <a:ext cx="9601200" cy="274320"/>
+            <a:off x="274320" y="5877441"/>
+            <a:ext cx="6126480" cy="274320"/>
           </a:xfrm>
           <a:prstGeom prst="rect">
             <a:avLst/>
@@ -6893,14 +7064,166 @@
                 </a:solidFill>
                 <a:latin typeface="Arial"/>
               </a:rPr>
-              <a:t>Z7 PBS1, fitted curves after NRMSE ≤ 0.4 and τ_rise ≤ 0.3 ms — the NRMSE-weighted mean of this family is the 1x1 template</a:t>
-            </a:r>
-          </a:p>
-        </p:txBody>
-      </p:sp>
-      <p:sp>
-        <p:nvSpPr>
-          <p:cNvPr id="7" name="TextBox 6"/>
+              <a:t>Z7, 3 sampled slow-fall events: normal in PBS2/PCS2/PES2, swings only in PDS2</a:t>
+            </a:r>
+          </a:p>
+        </p:txBody>
+      </p:sp>
+      <p:pic>
+        <p:nvPicPr>
+          <p:cNvPr id="7" name="Picture 6" descr="time_constants_zip7_PAS1_tfall.png"/>
+          <p:cNvPicPr>
+            <a:picLocks noChangeAspect="1"/>
+          </p:cNvPicPr>
+          <p:nvPr/>
+        </p:nvPicPr>
+        <p:blipFill>
+          <a:blip r:embed="rId3"/>
+          <a:stretch>
+            <a:fillRect/>
+          </a:stretch>
+        </p:blipFill>
+        <p:spPr>
+          <a:xfrm>
+            <a:off x="6446520" y="3063240"/>
+            <a:ext cx="2788920" cy="2085332"/>
+          </a:xfrm>
+          <a:prstGeom prst="rect">
+            <a:avLst/>
+          </a:prstGeom>
+        </p:spPr>
+      </p:pic>
+      <p:sp>
+        <p:nvSpPr>
+          <p:cNvPr id="8" name="TextBox 7"/>
+          <p:cNvSpPr txBox="1"/>
+          <p:nvPr/>
+        </p:nvSpPr>
+        <p:spPr>
+          <a:xfrm>
+            <a:off x="6446520" y="5178572"/>
+            <a:ext cx="2788920" cy="274320"/>
+          </a:xfrm>
+          <a:prstGeom prst="rect">
+            <a:avLst/>
+          </a:prstGeom>
+          <a:noFill/>
+        </p:spPr>
+        <p:txBody>
+          <a:bodyPr wrap="square">
+            <a:spAutoFit/>
+          </a:bodyPr>
+          <a:lstStyle/>
+          <a:p>
+            <a:pPr algn="ctr"/>
+            <a:r>
+              <a:rPr sz="1100" i="1">
+                <a:solidFill>
+                  <a:srgbClr val="666666"/>
+                </a:solidFill>
+                <a:latin typeface="Arial"/>
+              </a:rPr>
+              <a:t>PAS1 — normal channel: narrow (median 0.25 ms)</a:t>
+            </a:r>
+          </a:p>
+        </p:txBody>
+      </p:sp>
+      <p:pic>
+        <p:nvPicPr>
+          <p:cNvPr id="9" name="Picture 8" descr="time_constants_zip7_PDS2_tfall.png"/>
+          <p:cNvPicPr>
+            <a:picLocks noChangeAspect="1"/>
+          </p:cNvPicPr>
+          <p:nvPr/>
+        </p:nvPicPr>
+        <p:blipFill>
+          <a:blip r:embed="rId4"/>
+          <a:stretch>
+            <a:fillRect/>
+          </a:stretch>
+        </p:blipFill>
+        <p:spPr>
+          <a:xfrm>
+            <a:off x="9326880" y="3063240"/>
+            <a:ext cx="2788920" cy="2076855"/>
+          </a:xfrm>
+          <a:prstGeom prst="rect">
+            <a:avLst/>
+          </a:prstGeom>
+        </p:spPr>
+      </p:pic>
+      <p:sp>
+        <p:nvSpPr>
+          <p:cNvPr id="10" name="TextBox 9"/>
+          <p:cNvSpPr txBox="1"/>
+          <p:nvPr/>
+        </p:nvSpPr>
+        <p:spPr>
+          <a:xfrm>
+            <a:off x="9326880" y="5170095"/>
+            <a:ext cx="2788920" cy="274320"/>
+          </a:xfrm>
+          <a:prstGeom prst="rect">
+            <a:avLst/>
+          </a:prstGeom>
+          <a:noFill/>
+        </p:spPr>
+        <p:txBody>
+          <a:bodyPr wrap="square">
+            <a:spAutoFit/>
+          </a:bodyPr>
+          <a:lstStyle/>
+          <a:p>
+            <a:pPr algn="ctr"/>
+            <a:r>
+              <a:rPr sz="1100" i="1">
+                <a:solidFill>
+                  <a:srgbClr val="666666"/>
+                </a:solidFill>
+                <a:latin typeface="Arial"/>
+              </a:rPr>
+              <a:t>PDS2 — bad channel: broad tail (median 0.51 ms)</a:t>
+            </a:r>
+          </a:p>
+        </p:txBody>
+      </p:sp>
+      <p:sp>
+        <p:nvSpPr>
+          <p:cNvPr id="11" name="TextBox 10"/>
+          <p:cNvSpPr txBox="1"/>
+          <p:nvPr/>
+        </p:nvSpPr>
+        <p:spPr>
+          <a:xfrm>
+            <a:off x="6446520" y="2395728"/>
+            <a:ext cx="5669280" cy="502920"/>
+          </a:xfrm>
+          <a:prstGeom prst="rect">
+            <a:avLst/>
+          </a:prstGeom>
+          <a:noFill/>
+        </p:spPr>
+        <p:txBody>
+          <a:bodyPr wrap="square">
+            <a:spAutoFit/>
+          </a:bodyPr>
+          <a:lstStyle/>
+          <a:p>
+            <a:r>
+              <a:rPr sz="1500" b="1">
+                <a:solidFill>
+                  <a:srgbClr val="1F3864"/>
+                </a:solidFill>
+                <a:latin typeface="Arial"/>
+              </a:rPr>
+              <a:t>Fitted τ_fall distribution, same 0–7 ms axis:</a:t>
+            </a:r>
+          </a:p>
+        </p:txBody>
+      </p:sp>
+      <p:sp>
+        <p:nvSpPr>
+          <p:cNvPr id="12" name="TextBox 11"/>
           <p:cNvSpPr txBox="1"/>
           <p:nvPr/>
         </p:nvSpPr>
@@ -6928,7 +7251,7 @@
                 </a:solidFill>
                 <a:latin typeface="Arial"/>
               </a:rPr>
-              <a:t>8 / 10</a:t>
+              <a:t>8 / 11</a:t>
             </a:r>
           </a:p>
         </p:txBody>
@@ -6980,7 +7303,7 @@
                 </a:solidFill>
                 <a:latin typeface="Arial"/>
               </a:rPr>
-              <a:t>Template family 2 — NxM PCA templates</a:t>
+              <a:t>Template family 1 — analytic 2-exp, NRMSE-weighted (1x1)</a:t>
             </a:r>
           </a:p>
         </p:txBody>
@@ -7036,7 +7359,7 @@
         </p:nvSpPr>
         <p:spPr>
           <a:xfrm>
-            <a:off x="502920" y="1115568"/>
+            <a:off x="502920" y="1143000"/>
             <a:ext cx="11247120" cy="1371600"/>
           </a:xfrm>
           <a:prstGeom prst="rect">
@@ -7056,13 +7379,13 @@
               </a:spcAft>
             </a:pPr>
             <a:r>
-              <a:rPr sz="1600">
+              <a:rPr sz="1800">
                 <a:solidFill>
                   <a:srgbClr val="333333"/>
                 </a:solidFill>
                 <a:latin typeface="Arial"/>
               </a:rPr>
-              <a:t>• Per-channel PCA over the clean fitted curves (fit_ok + NRMSE ≤ 0.4 + τ_rise ≤ 0.3 ms)</a:t>
+              <a:t>• NRMSE-weighted mean of the fit_ok 2-exp curves</a:t>
             </a:r>
           </a:p>
           <a:p>
@@ -7072,13 +7395,13 @@
               </a:spcAft>
             </a:pPr>
             <a:r>
-              <a:rPr sz="1600">
+              <a:rPr sz="1800">
                 <a:solidFill>
                   <a:srgbClr val="333333"/>
                 </a:solidFill>
                 <a:latin typeface="Arial"/>
               </a:rPr>
-              <a:t>• nxm0 = mean shape;  nxm1–4 = principal components;  real pulse = Σᵢ ampᵢ · nxmᵢ</a:t>
+              <a:t>• Smooth &amp; noise-free by construction</a:t>
             </a:r>
           </a:p>
           <a:p>
@@ -7088,20 +7411,20 @@
               </a:spcAft>
             </a:pPr>
             <a:r>
-              <a:rPr sz="1600">
+              <a:rPr sz="1800">
                 <a:solidFill>
                   <a:srgbClr val="333333"/>
                 </a:solidFill>
                 <a:latin typeface="Arial"/>
               </a:rPr>
-              <a:t>• PC1 + PC2 ≈ 96–98% of the shape variance;  delivered peak-normalized</a:t>
+              <a:t>• ROOT TH1D, peak-normalized (+ summed PT / PS1 / PS2)</a:t>
             </a:r>
           </a:p>
         </p:txBody>
       </p:sp>
       <p:pic>
         <p:nvPicPr>
-          <p:cNvPr id="5" name="Picture 4" descr="pca_zip7_PAS1.png"/>
+          <p:cNvPr id="5" name="Picture 4" descr="fan_zip7_PBS1_after.png"/>
           <p:cNvPicPr>
             <a:picLocks noChangeAspect="1"/>
           </p:cNvPicPr>
@@ -7115,38 +7438,49 @@
         </p:blipFill>
         <p:spPr>
           <a:xfrm>
-            <a:off x="2831374" y="2697480"/>
-            <a:ext cx="6498771" cy="1828800"/>
+            <a:off x="1383919" y="3063240"/>
+            <a:ext cx="9393682" cy="2834640"/>
           </a:xfrm>
           <a:prstGeom prst="rect">
             <a:avLst/>
           </a:prstGeom>
         </p:spPr>
       </p:pic>
-      <p:pic>
-        <p:nvPicPr>
-          <p:cNvPr id="6" name="Picture 5" descr="pca_zip7_PBS1.png"/>
-          <p:cNvPicPr>
-            <a:picLocks noChangeAspect="1"/>
-          </p:cNvPicPr>
+      <p:sp>
+        <p:nvSpPr>
+          <p:cNvPr id="6" name="TextBox 5"/>
+          <p:cNvSpPr txBox="1"/>
           <p:nvPr/>
-        </p:nvPicPr>
-        <p:blipFill>
-          <a:blip r:embed="rId3"/>
-          <a:stretch>
-            <a:fillRect/>
-          </a:stretch>
-        </p:blipFill>
-        <p:spPr>
-          <a:xfrm>
-            <a:off x="2831374" y="4572000"/>
-            <a:ext cx="6498771" cy="1828800"/>
-          </a:xfrm>
-          <a:prstGeom prst="rect">
-            <a:avLst/>
-          </a:prstGeom>
-        </p:spPr>
-      </p:pic>
+        </p:nvSpPr>
+        <p:spPr>
+          <a:xfrm>
+            <a:off x="1280160" y="5927880"/>
+            <a:ext cx="9601200" cy="274320"/>
+          </a:xfrm>
+          <a:prstGeom prst="rect">
+            <a:avLst/>
+          </a:prstGeom>
+          <a:noFill/>
+        </p:spPr>
+        <p:txBody>
+          <a:bodyPr wrap="square">
+            <a:spAutoFit/>
+          </a:bodyPr>
+          <a:lstStyle/>
+          <a:p>
+            <a:pPr algn="ctr"/>
+            <a:r>
+              <a:rPr sz="1100" i="1">
+                <a:solidFill>
+                  <a:srgbClr val="666666"/>
+                </a:solidFill>
+                <a:latin typeface="Arial"/>
+              </a:rPr>
+              <a:t>Z7 PBS1, fitted curves after NRMSE ≤ 0.4 and τ_rise ≤ 0.3 ms — the NRMSE-weighted mean of this family is the 1x1 template</a:t>
+            </a:r>
+          </a:p>
+        </p:txBody>
+      </p:sp>
       <p:sp>
         <p:nvSpPr>
           <p:cNvPr id="7" name="TextBox 6"/>
@@ -7155,41 +7489,6 @@
         </p:nvSpPr>
         <p:spPr>
           <a:xfrm>
-            <a:off x="1371600" y="6430800"/>
-            <a:ext cx="9418320" cy="274320"/>
-          </a:xfrm>
-          <a:prstGeom prst="rect">
-            <a:avLst/>
-          </a:prstGeom>
-          <a:noFill/>
-        </p:spPr>
-        <p:txBody>
-          <a:bodyPr wrap="square">
-            <a:spAutoFit/>
-          </a:bodyPr>
-          <a:lstStyle/>
-          <a:p>
-            <a:pPr algn="ctr"/>
-            <a:r>
-              <a:rPr sz="1100" i="1">
-                <a:solidFill>
-                  <a:srgbClr val="666666"/>
-                </a:solidFill>
-                <a:latin typeface="Arial"/>
-              </a:rPr>
-              <a:t>Z7 PAS1 / PBS1: nxm0 (mean) + nxm1–4 (PCs) — the oscillating components encode rise/fall-time variation</a:t>
-            </a:r>
-          </a:p>
-        </p:txBody>
-      </p:sp>
-      <p:sp>
-        <p:nvSpPr>
-          <p:cNvPr id="8" name="TextBox 7"/>
-          <p:cNvSpPr txBox="1"/>
-          <p:nvPr/>
-        </p:nvSpPr>
-        <p:spPr>
-          <a:xfrm>
             <a:off x="10957255" y="6446520"/>
             <a:ext cx="1005840" cy="274320"/>
           </a:xfrm>
@@ -7212,7 +7511,7 @@
                 </a:solidFill>
                 <a:latin typeface="Arial"/>
               </a:rPr>
-              <a:t>9 / 10</a:t>
+              <a:t>9 / 11</a:t>
             </a:r>
           </a:p>
         </p:txBody>

</xml_diff>

<commit_message>
snolab: presentation — move step 5 (Align) + the two fan plots onto the dedicated Alignment slide (enlarged); drop the wrongly re-added aligned_overlay image; algorithm slide now ends at step 4; speech slides 4/5 synced
Co-Authored-By: Claude Opus 4.8 <noreply@anthropic.com>
</commit_message>
<xml_diff>
--- a/snolab/presentation/SNOLAB_R4_pulse_templates_20260715.pptx
+++ b/snolab/presentation/SNOLAB_R4_pulse_templates_20260715.pptx
@@ -862,7 +862,7 @@
           <a:lstStyle/>
           <a:p>
             <a:r>
-              <a:t>The per-trace algorithm, five steps. First a low-pass filter to smooth away the high-frequency noise, then the baseline is subtracted and the trace is scaled to unit peak - without that normalization the traces could not be overlaid or compared. The core is the fit: a two-exponential function, one exponential for the rise and one for the fall, with all five parameters free, including the pretrigger - the pulse start time. The pretrigger is never pinned: real trigger times vary, and the fitted pretriggers cluster about 230 samples after the nominal value - pinning it would bias the time constants. Each fit records two quality numbers: fit_ok, a physicality check - positive amplitude, rise faster than fall - and the NRMSE, the normalized root-mean-square error, the fit residual divided by the pulse height. At this stage we only record them. Finally the measured trace is aligned by shifting it by the fitted pretrigger minus 16050. The two fan plots show the output of the fit step: every fitted curve drawn at the common pretrigger, peak-normalized. On the left, all physical fits - you can see stragglers spreading off the main bundle. On the right, after the NRMSE cut, a single tight shape family remains. We'll return to where that cut comes from shortly.</a:t>
+              <a:t>The per-trace algorithm. First a low-pass filter to smooth away the high-frequency noise, then the baseline is subtracted and the trace is scaled to unit peak - without that normalization the traces could not be overlaid or compared. The core is the fit: a two-exponential function, one exponential for the rise and one for the fall, with all five parameters free, including the pretrigger - the pulse start time. The pretrigger is never pinned: real trigger times vary, and the fitted pretriggers cluster about 230 samples after the nominal value - pinning it would bias the time constants. Each fit records two quality numbers: fit_ok, a physicality check - positive amplitude, rise faster than fall - and the NRMSE, the normalized root-mean-square error, the fit residual divided by the pulse height. At this stage we only record them. Step five, alignment, and its output get their own slide next.</a:t>
             </a:r>
           </a:p>
         </p:txBody>
@@ -932,7 +932,7 @@
           <a:lstStyle/>
           <a:p>
             <a:r>
-              <a:t>This is the alignment step, on its own. Each measured trace is shifted by its fitted pretrigger minus the nominal 16050 - a pure translation, nothing about the waveform is regenerated. The dotted vertical line is the common pretrigger everything is aligned to. The blue band is the aligned measured traces stacked together; they form a tight bundle, which tells us the pulse shape is highly consistent once the trigger-time jitter is removed. Red is the plain mean of the measured traces, and orange is the NRMSE-weighted mean of the fitted curves - already essentially the template. This tight bundle is what makes a well-defined template possible.</a:t>
+              <a:t>Step five: alignment. Each measured trace is shifted by its fitted pretrigger minus the nominal 16050 - a pure translation, nothing about the waveform is regenerated. Once everything is at the common pretrigger, the fitted curves stack up. On the left, all physical fits: you can see the slow stragglers spreading off the main bundle. On the right, after the NRMSE cut, a single tight, consistent shape family remains. That tight family is what makes a well-defined template possible - and where the cut comes from is what I show next.</a:t>
             </a:r>
           </a:p>
         </p:txBody>
@@ -5789,172 +5789,6 @@
         </p:nvSpPr>
         <p:spPr>
           <a:xfrm>
-            <a:off x="502920" y="4526280"/>
-            <a:ext cx="11247120" cy="502920"/>
-          </a:xfrm>
-          <a:prstGeom prst="rect">
-            <a:avLst/>
-          </a:prstGeom>
-          <a:noFill/>
-        </p:spPr>
-        <p:txBody>
-          <a:bodyPr wrap="square">
-            <a:spAutoFit/>
-          </a:bodyPr>
-          <a:lstStyle/>
-          <a:p>
-            <a:pPr>
-              <a:spcAft>
-                <a:spcPts val="600"/>
-              </a:spcAft>
-            </a:pPr>
-            <a:r>
-              <a:rPr sz="1600" b="1">
-                <a:solidFill>
-                  <a:srgbClr val="1F3864"/>
-                </a:solidFill>
-                <a:latin typeface="Arial"/>
-              </a:rPr>
-              <a:t>5.  Align</a:t>
-            </a:r>
-            <a:r>
-              <a:rPr sz="1600">
-                <a:solidFill>
-                  <a:srgbClr val="333333"/>
-                </a:solidFill>
-                <a:latin typeface="Arial"/>
-              </a:rPr>
-              <a:t> — shift the measured trace by (fitted pretrigger − 16050)</a:t>
-            </a:r>
-          </a:p>
-        </p:txBody>
-      </p:sp>
-      <p:pic>
-        <p:nvPicPr>
-          <p:cNvPr id="9" name="Picture 8" descr="fan_zip7_PBS1_before_zoom.png"/>
-          <p:cNvPicPr>
-            <a:picLocks noChangeAspect="1"/>
-          </p:cNvPicPr>
-          <p:nvPr/>
-        </p:nvPicPr>
-        <p:blipFill>
-          <a:blip r:embed="rId3"/>
-          <a:stretch>
-            <a:fillRect/>
-          </a:stretch>
-        </p:blipFill>
-        <p:spPr>
-          <a:xfrm>
-            <a:off x="2233436" y="4864608"/>
-            <a:ext cx="2299688" cy="1371600"/>
-          </a:xfrm>
-          <a:prstGeom prst="rect">
-            <a:avLst/>
-          </a:prstGeom>
-        </p:spPr>
-      </p:pic>
-      <p:sp>
-        <p:nvSpPr>
-          <p:cNvPr id="10" name="TextBox 9"/>
-          <p:cNvSpPr txBox="1"/>
-          <p:nvPr/>
-        </p:nvSpPr>
-        <p:spPr>
-          <a:xfrm>
-            <a:off x="822960" y="6266208"/>
-            <a:ext cx="5120640" cy="274320"/>
-          </a:xfrm>
-          <a:prstGeom prst="rect">
-            <a:avLst/>
-          </a:prstGeom>
-          <a:noFill/>
-        </p:spPr>
-        <p:txBody>
-          <a:bodyPr wrap="square">
-            <a:spAutoFit/>
-          </a:bodyPr>
-          <a:lstStyle/>
-          <a:p>
-            <a:pPr algn="ctr"/>
-            <a:r>
-              <a:rPr sz="1100" i="1">
-                <a:solidFill>
-                  <a:srgbClr val="666666"/>
-                </a:solidFill>
-                <a:latin typeface="Arial"/>
-              </a:rPr>
-              <a:t>All fit_ok fitted curves (Z7 PBS1) — no cut</a:t>
-            </a:r>
-          </a:p>
-        </p:txBody>
-      </p:sp>
-      <p:pic>
-        <p:nvPicPr>
-          <p:cNvPr id="11" name="Picture 10" descr="fan_zip7_PBS1_nrmse_zoom.png"/>
-          <p:cNvPicPr>
-            <a:picLocks noChangeAspect="1"/>
-          </p:cNvPicPr>
-          <p:nvPr/>
-        </p:nvPicPr>
-        <p:blipFill>
-          <a:blip r:embed="rId4"/>
-          <a:stretch>
-            <a:fillRect/>
-          </a:stretch>
-        </p:blipFill>
-        <p:spPr>
-          <a:xfrm>
-            <a:off x="7719836" y="4864608"/>
-            <a:ext cx="2299688" cy="1371600"/>
-          </a:xfrm>
-          <a:prstGeom prst="rect">
-            <a:avLst/>
-          </a:prstGeom>
-        </p:spPr>
-      </p:pic>
-      <p:sp>
-        <p:nvSpPr>
-          <p:cNvPr id="12" name="TextBox 11"/>
-          <p:cNvSpPr txBox="1"/>
-          <p:nvPr/>
-        </p:nvSpPr>
-        <p:spPr>
-          <a:xfrm>
-            <a:off x="6309360" y="6266208"/>
-            <a:ext cx="5120640" cy="274320"/>
-          </a:xfrm>
-          <a:prstGeom prst="rect">
-            <a:avLst/>
-          </a:prstGeom>
-          <a:noFill/>
-        </p:spPr>
-        <p:txBody>
-          <a:bodyPr wrap="square">
-            <a:spAutoFit/>
-          </a:bodyPr>
-          <a:lstStyle/>
-          <a:p>
-            <a:pPr algn="ctr"/>
-            <a:r>
-              <a:rPr sz="1100" i="1">
-                <a:solidFill>
-                  <a:srgbClr val="666666"/>
-                </a:solidFill>
-                <a:latin typeface="Arial"/>
-              </a:rPr>
-              <a:t>After NRMSE ≤ 0.4 — one tight shape family</a:t>
-            </a:r>
-          </a:p>
-        </p:txBody>
-      </p:sp>
-      <p:sp>
-        <p:nvSpPr>
-          <p:cNvPr id="13" name="TextBox 12"/>
-          <p:cNvSpPr txBox="1"/>
-          <p:nvPr/>
-        </p:nvSpPr>
-        <p:spPr>
-          <a:xfrm>
             <a:off x="10957255" y="6446520"/>
             <a:ext cx="1005840" cy="274320"/>
           </a:xfrm>
@@ -6029,7 +5863,7 @@
                 </a:solidFill>
                 <a:latin typeface="Arial"/>
               </a:rPr>
-              <a:t>Alignment — every trace shifted to a common pretrigger</a:t>
+              <a:t>5. Align — shift each trace to a common pretrigger</a:t>
             </a:r>
           </a:p>
         </p:txBody>
@@ -6086,7 +5920,7 @@
         <p:spPr>
           <a:xfrm>
             <a:off x="502920" y="1097280"/>
-            <a:ext cx="11247120" cy="822960"/>
+            <a:ext cx="11247120" cy="868680"/>
           </a:xfrm>
           <a:prstGeom prst="rect">
             <a:avLst/>
@@ -6105,20 +5939,20 @@
               </a:spcAft>
             </a:pPr>
             <a:r>
-              <a:rPr sz="1500">
+              <a:rPr sz="1600">
                 <a:solidFill>
                   <a:srgbClr val="333333"/>
                 </a:solidFill>
                 <a:latin typeface="Arial"/>
               </a:rPr>
-              <a:t>• Each measured trace is shifted by (fitted pretrigger − 16050) — a pure translation; the aligned traces stack into a tight bundle</a:t>
+              <a:t>• Shift the measured trace by (fitted pretrigger − 16050) — a pure translation. Drawn at the common pretrigger, the fitted curves stack into one shape family:</a:t>
             </a:r>
           </a:p>
         </p:txBody>
       </p:sp>
       <p:pic>
         <p:nvPicPr>
-          <p:cNvPr id="5" name="Picture 4" descr="aligned_zoom_zip7_PBS1_clean.png"/>
+          <p:cNvPr id="5" name="Picture 4" descr="fan_zip7_PBS1_before_zoom.png"/>
           <p:cNvPicPr>
             <a:picLocks noChangeAspect="1"/>
           </p:cNvPicPr>
@@ -6132,8 +5966,8 @@
         </p:blipFill>
         <p:spPr>
           <a:xfrm>
-            <a:off x="1581796" y="2194560"/>
-            <a:ext cx="8997927" cy="4297680"/>
+            <a:off x="502920" y="2331720"/>
+            <a:ext cx="5806440" cy="3463126"/>
           </a:xfrm>
           <a:prstGeom prst="rect">
             <a:avLst/>
@@ -6148,8 +5982,8 @@
         </p:nvSpPr>
         <p:spPr>
           <a:xfrm>
-            <a:off x="548640" y="6522240"/>
-            <a:ext cx="11064240" cy="274320"/>
+            <a:off x="502920" y="5824846"/>
+            <a:ext cx="5806440" cy="274320"/>
           </a:xfrm>
           <a:prstGeom prst="rect">
             <a:avLst/>
@@ -6170,14 +6004,73 @@
                 </a:solidFill>
                 <a:latin typeface="Arial"/>
               </a:rPr>
-              <a:t>Z7 PBS1 (peak zoom): shift-aligned measured traces (blue)  ·  mean (red)  ·  NRMSE-weighted mean of the fitted curves (orange)  ·  dotted line = common pretrigger 16050</a:t>
-            </a:r>
-          </a:p>
-        </p:txBody>
-      </p:sp>
-      <p:sp>
-        <p:nvSpPr>
-          <p:cNvPr id="7" name="TextBox 6"/>
+              <a:t>All fit_ok fitted curves (Z7 PBS1) — no cut</a:t>
+            </a:r>
+          </a:p>
+        </p:txBody>
+      </p:sp>
+      <p:pic>
+        <p:nvPicPr>
+          <p:cNvPr id="7" name="Picture 6" descr="fan_zip7_PBS1_nrmse_zoom.png"/>
+          <p:cNvPicPr>
+            <a:picLocks noChangeAspect="1"/>
+          </p:cNvPicPr>
+          <p:nvPr/>
+        </p:nvPicPr>
+        <p:blipFill>
+          <a:blip r:embed="rId3"/>
+          <a:stretch>
+            <a:fillRect/>
+          </a:stretch>
+        </p:blipFill>
+        <p:spPr>
+          <a:xfrm>
+            <a:off x="6309360" y="2331720"/>
+            <a:ext cx="5806440" cy="3463126"/>
+          </a:xfrm>
+          <a:prstGeom prst="rect">
+            <a:avLst/>
+          </a:prstGeom>
+        </p:spPr>
+      </p:pic>
+      <p:sp>
+        <p:nvSpPr>
+          <p:cNvPr id="8" name="TextBox 7"/>
+          <p:cNvSpPr txBox="1"/>
+          <p:nvPr/>
+        </p:nvSpPr>
+        <p:spPr>
+          <a:xfrm>
+            <a:off x="6309360" y="5824846"/>
+            <a:ext cx="5806440" cy="274320"/>
+          </a:xfrm>
+          <a:prstGeom prst="rect">
+            <a:avLst/>
+          </a:prstGeom>
+          <a:noFill/>
+        </p:spPr>
+        <p:txBody>
+          <a:bodyPr wrap="square">
+            <a:spAutoFit/>
+          </a:bodyPr>
+          <a:lstStyle/>
+          <a:p>
+            <a:pPr algn="ctr"/>
+            <a:r>
+              <a:rPr sz="1100" i="1">
+                <a:solidFill>
+                  <a:srgbClr val="666666"/>
+                </a:solidFill>
+                <a:latin typeface="Arial"/>
+              </a:rPr>
+              <a:t>After NRMSE ≤ 0.4 — one tight shape family</a:t>
+            </a:r>
+          </a:p>
+        </p:txBody>
+      </p:sp>
+      <p:sp>
+        <p:nvSpPr>
+          <p:cNvPr id="9" name="TextBox 8"/>
           <p:cNvSpPr txBox="1"/>
           <p:nvPr/>
         </p:nvSpPr>

</xml_diff>

<commit_message>
snolab: presentation — Slide 6, rename "noisy" -> "weak" detectors for Z22 (collaboration's term)
Updated speech_script.md (中文/English), build_pptx.py bullet/caption/notes,
regenerated the .pptx (11 slides) and speech_script.pdf. The deck PDF export
still needs a PowerPoint re-export on the author's machine.

Co-Authored-By: Claude Opus 4.8 <noreply@anthropic.com>
</commit_message>
<xml_diff>
--- a/snolab/presentation/SNOLAB_R4_pulse_templates_20260715.pptx
+++ b/snolab/presentation/SNOLAB_R4_pulse_templates_20260715.pptx
@@ -1002,7 +1002,7 @@
           <a:lstStyle/>
           <a:p>
             <a:r>
-              <a:t>First quality cut. The NRMSE distribution of physical fits is bimodal on every detector: a good-fit population around 0.05 to 0.1, and a noise-trigger population around 1 to 2, separated by a valley at about 0.4. We place the cut in the valley - it is read off the distribution itself. On quiet detectors like Z7 the noise population is small; on noisy detectors like Z22 it dominates, and this cut is what digs the real pulses out of the mixture.</a:t>
+              <a:t>First quality cut. The NRMSE distribution of physical fits is bimodal on every detector: a good-fit population around 0.05 to 0.1, and a noise-trigger population around 1 to 2, separated by a valley at about 0.4. We place the cut in the valley - it is read off the distribution itself. On quiet detectors like Z7 the noise population is small; on weak detectors like Z22 it dominates, and this cut is what digs the real pulses out of the mixture.</a:t>
             </a:r>
           </a:p>
         </p:txBody>
@@ -6264,7 +6264,7 @@
                 </a:solidFill>
                 <a:latin typeface="Arial"/>
               </a:rPr>
-              <a:t>• Noisy detectors (Z1, Z4, Z6, Z18, Z19, Z22, Z24): the PTOF window admits a noise-dominated mixture — this cut is what extracts the real-pulse population</a:t>
+              <a:t>• Weak detectors (Z1, Z4, Z6, Z18, Z19, Z22, Z24): the PTOF window admits a noise-dominated mixture — this cut is what extracts the real-pulse population</a:t>
             </a:r>
           </a:p>
         </p:txBody>
@@ -6382,7 +6382,7 @@
                 </a:solidFill>
                 <a:latin typeface="Arial"/>
               </a:rPr>
-              <a:t>Z22 PAS1 (noisy): noise population dominates — the window alone is not enough</a:t>
+              <a:t>Z22 PAS1 (weak): noise population dominates — the window alone is not enough</a:t>
             </a:r>
           </a:p>
         </p:txBody>

</xml_diff>

<commit_message>
snolab: presentation — label every data figure with its zip (Z7/Z22) next to the channel
The slide-7 fan-cut figure is Z22 PCS1 while the alignment fans are Z7 PBS1;
without zip labels the two invite a false "colors swapped" reading (Z22's kept
population is genuinely broader/slower than Z7's). Captions now carry the zip
on: slide-3 fit grids (Z7), slide-5 right fan (Z7 PBS1), slide-7 fan-cut
legend (Z22 PCS1 bold prefix), slide-8 t_fall panels (Z7 PAS1 / Z7 PDS2).
Deck rebuilt.

Co-Authored-By: Claude Fable 5 <noreply@anthropic.com>
</commit_message>
<xml_diff>
--- a/snolab/presentation/SNOLAB_R4_pulse_templates_20260715.pptx
+++ b/snolab/presentation/SNOLAB_R4_pulse_templates_20260715.pptx
@@ -5344,7 +5344,7 @@
                 </a:solidFill>
                 <a:latin typeface="Arial"/>
               </a:rPr>
-              <a:t>Noise triggers: the fit fails in every channel at once</a:t>
+              <a:t>Noise triggers (Z7): the fit fails in every channel at once</a:t>
             </a:r>
           </a:p>
         </p:txBody>
@@ -5403,7 +5403,7 @@
                 </a:solidFill>
                 <a:latin typeface="Arial"/>
               </a:rPr>
-              <a:t>K-line events: consistent good fits across channels</a:t>
+              <a:t>K-line events (Z7): consistent good fits across channels</a:t>
             </a:r>
           </a:p>
         </p:txBody>
@@ -6063,7 +6063,7 @@
                 </a:solidFill>
                 <a:latin typeface="Arial"/>
               </a:rPr>
-              <a:t>After NRMSE ≤ 0.4 — one tight shape family</a:t>
+              <a:t>After NRMSE ≤ 0.4 (Z7 PBS1) — one tight shape family</a:t>
             </a:r>
           </a:p>
         </p:txBody>
@@ -6664,6 +6664,15 @@
             <a:r>
               <a:rPr sz="1400" b="1">
                 <a:solidFill>
+                  <a:srgbClr val="333333"/>
+                </a:solidFill>
+                <a:latin typeface="Arial"/>
+              </a:rPr>
+              <a:t>Z22 PCS1   </a:t>
+            </a:r>
+            <a:r>
+              <a:rPr sz="1400" b="1">
+                <a:solidFill>
                   <a:srgbClr val="2E7D32"/>
                 </a:solidFill>
                 <a:latin typeface="Arial"/>
@@ -6697,7 +6706,7 @@
                 </a:solidFill>
                 <a:latin typeface="Arial"/>
               </a:rPr>
-              <a:t>      Z22 PCS1: 7198 kept / 4788 cut (~40%)</a:t>
+              <a:t>      7198 kept / 4788 cut (~40%)</a:t>
             </a:r>
           </a:p>
         </p:txBody>
@@ -7016,7 +7025,7 @@
                 </a:solidFill>
                 <a:latin typeface="Arial"/>
               </a:rPr>
-              <a:t>PAS1 — normal channel: narrow (median 0.25 ms)</a:t>
+              <a:t>Z7 PAS1 — normal channel: narrow (median 0.25 ms)</a:t>
             </a:r>
           </a:p>
         </p:txBody>
@@ -7075,7 +7084,7 @@
                 </a:solidFill>
                 <a:latin typeface="Arial"/>
               </a:rPr>
-              <a:t>PDS2 — bad channel: broad tail (median 0.51 ms)</a:t>
+              <a:t>Z7 PDS2 — bad channel: broad tail (median 0.51 ms)</a:t>
             </a:r>
           </a:p>
         </p:txBody>

</xml_diff>

<commit_message>
snolab: presentation — one analysis chain (Z7 PBS1) in the main deck; Z22 moved to a backup slide; add trise_cut_stats.py
Per Prof. Saab: the main narrative now uses a single detector/channel
throughout. Slide 6 keeps only the Z7 PBS1 NRMSE histogram (enlarged);
slide 7 shows the Z7 rejected-events grid + Z7 PBS1 kept-vs-cut fan
(1931 kept / 77 cut, ~3.8%, median NRMSE 0.045 vs 1.87); the PCA slide
keeps PBS1 only, matching the 1x1 slide. New backup slide holds the Z22
figures (NRMSE hist, kept-vs-cut fan, post-cut fan) with keyword notes.

New lp_fit_align/scripts/trise_cut_stats.py answers "how much does the
t_rise <= 0.3 ms ceiling remove after the NRMSE cut": Z7 1.6% (mostly bad
channel PDS2 at 21%), quiet zips 2-6%, weak zips 55-74% (Z22 71%),
all zips pooled 54%. Numbers added to the backup slide, speech Q&A, and
README. Deck rebuilt (12 slides), speech PDF regenerated.

Co-Authored-By: Claude Fable 5 <noreply@anthropic.com>
</commit_message>
<xml_diff>
--- a/snolab/presentation/SNOLAB_R4_pulse_templates_20260715.pptx
+++ b/snolab/presentation/SNOLAB_R4_pulse_templates_20260715.pptx
@@ -16,6 +16,7 @@
     <p:sldId id="264" r:id="rId16"/>
     <p:sldId id="265" r:id="rId17"/>
     <p:sldId id="266" r:id="rId18"/>
+    <p:sldId id="267" r:id="rId19"/>
   </p:sldIdLst>
   <p:sldSz cx="12191695" cy="6858000" type="screen4x3"/>
   <p:notesSz cx="6858000" cy="9144000"/>
@@ -677,6 +678,76 @@
 </p:notes>
 </file>
 
+<file path=ppt/notesSlides/notesSlide12.xml><?xml version="1.0" encoding="utf-8"?>
+<p:notes xmlns:a="http://schemas.openxmlformats.org/drawingml/2006/main" xmlns:p="http://schemas.openxmlformats.org/presentationml/2006/main" xmlns:r="http://schemas.openxmlformats.org/officeDocument/2006/relationships">
+  <p:cSld>
+    <p:spTree>
+      <p:nvGrpSpPr>
+        <p:cNvPr id="1" name=""/>
+        <p:cNvGrpSpPr/>
+        <p:nvPr/>
+      </p:nvGrpSpPr>
+      <p:grpSpPr>
+        <a:xfrm>
+          <a:off x="0" y="0"/>
+          <a:ext cx="0" cy="0"/>
+          <a:chOff x="0" y="0"/>
+          <a:chExt cx="0" cy="0"/>
+        </a:xfrm>
+      </p:grpSpPr>
+      <p:sp>
+        <p:nvSpPr>
+          <p:cNvPr id="2" name="Slide Image Placeholder 1"/>
+          <p:cNvSpPr>
+            <a:spLocks noGrp="1"/>
+          </p:cNvSpPr>
+          <p:nvPr>
+            <p:ph type="sldImg" idx="2"/>
+          </p:nvPr>
+        </p:nvSpPr>
+        <p:spPr/>
+      </p:sp>
+      <p:sp>
+        <p:nvSpPr>
+          <p:cNvPr id="3" name="Notes Placeholder 2"/>
+          <p:cNvSpPr>
+            <a:spLocks noGrp="1"/>
+          </p:cNvSpPr>
+          <p:nvPr>
+            <p:ph type="body" idx="3" sz="quarter"/>
+          </p:nvPr>
+        </p:nvSpPr>
+        <p:spPr/>
+        <p:txBody>
+          <a:bodyPr/>
+          <a:lstStyle/>
+          <a:p>
+            <a:r>
+              <a:t>Backup. On the weak detectors the K-line overlaps the noise population, so the PTOF window admits a noise-dominated mixture. The NRMSE distribution is still bimodal but the noise peak dominates, and the same 0.4 cut is what extracts the real pulses - on Z22 PCS1 about forty percent of the physical fits are removed. The kept bundle is broader than on a quiet detector, and the steep red curves are fits latching onto sharp noise spikes, not fast pulses being thrown away. The rise-time ceiling then removes fifty-five to seventy-four percent of what survived the NRMSE cut on the weak zips - residual slow drift - versus one point six percent on Z7. The surviving shape family is at the bottom.</a:t>
+            </a:r>
+          </a:p>
+        </p:txBody>
+      </p:sp>
+      <p:sp>
+        <p:nvSpPr>
+          <p:cNvPr id="4" name="Slide Number Placeholder 3"/>
+          <p:cNvSpPr>
+            <a:spLocks noGrp="1"/>
+          </p:cNvSpPr>
+          <p:nvPr>
+            <p:ph type="sldNum" idx="5" sz="quarter"/>
+          </p:nvPr>
+        </p:nvSpPr>
+        <p:spPr/>
+      </p:sp>
+    </p:spTree>
+  </p:cSld>
+  <p:clrMapOvr>
+    <a:masterClrMapping/>
+  </p:clrMapOvr>
+</p:notes>
+</file>
+
 <file path=ppt/notesSlides/notesSlide2.xml><?xml version="1.0" encoding="utf-8"?>
 <p:notes xmlns:a="http://schemas.openxmlformats.org/drawingml/2006/main" xmlns:p="http://schemas.openxmlformats.org/presentationml/2006/main" xmlns:r="http://schemas.openxmlformats.org/officeDocument/2006/relationships">
   <p:cSld>
@@ -1002,7 +1073,7 @@
           <a:lstStyle/>
           <a:p>
             <a:r>
-              <a:t>First quality cut. The NRMSE distribution of physical fits is bimodal on every detector: a good-fit population around 0.05 to 0.1, and a noise-trigger population around 1 to 2, separated by a valley at about 0.4. We place the cut in the valley - it is read off the distribution itself. On quiet detectors like Z7 the noise population is small; on weak detectors like Z22 it dominates, and this cut is what digs the real pulses out of the mixture.</a:t>
+              <a:t>First quality cut. The NRMSE distribution of physical fits is bimodal on every detector: a good-fit population around 0.05 to 0.1, and a noise-trigger population around 1 to 2, separated by a valley at about 0.4. We place the cut in the valley - it is read off the distribution itself. This is Z7 PBS1, the channel used throughout the talk. On the weak detectors the same bimodal picture appears with the noise peak dominating - one example is in the backup slide - and there this same cut is what digs the real pulses out of the mixture.</a:t>
             </a:r>
           </a:p>
         </p:txBody>
@@ -1072,7 +1143,7 @@
           <a:lstStyle/>
           <a:p>
             <a:r>
-              <a:t>Before trusting the cut we looked at what it throws away. These are event grids of the rejected population on Z22: the raw traces show no pulse at all - they are noise triggers whose slow two-exp fit happened to converge. The fan-cut view on the right overlays the passing fitted curves in green and the rejected ones in red on the aligned data: the green population is the fast physical pulse shape, the red one is spread out with a median NRMSE three times higher. So the cut removes noise, not physics.</a:t>
+              <a:t>Before trusting the cut we looked at what it throws away. These are event grids of the rejected population on Z7: the raw traces show no pulse at all - they are noise triggers whose slow two-exp fit happened to converge. The fan-cut view on the right overlays the passing fitted curves in green and the rejected ones in red on the aligned data: the green population is the fast physical pulse shape, the red one is spread out with a median NRMSE forty times higher - 1.87 against 0.045 - and on this channel only 77 events are removed, under four percent. So the cut removes noise, not physics.</a:t>
             </a:r>
           </a:p>
         </p:txBody>
@@ -4488,7 +4559,7 @@
       </p:sp>
       <p:pic>
         <p:nvPicPr>
-          <p:cNvPr id="5" name="Picture 4" descr="pca_zip7_PAS1.png"/>
+          <p:cNvPr id="5" name="Picture 4" descr="pca_zip7_PBS1.png"/>
           <p:cNvPicPr>
             <a:picLocks noChangeAspect="1"/>
           </p:cNvPicPr>
@@ -4502,38 +4573,49 @@
         </p:blipFill>
         <p:spPr>
           <a:xfrm>
-            <a:off x="2831374" y="2697480"/>
-            <a:ext cx="6498771" cy="1828800"/>
+            <a:off x="1044212" y="3017520"/>
+            <a:ext cx="10073095" cy="2834639"/>
           </a:xfrm>
           <a:prstGeom prst="rect">
             <a:avLst/>
           </a:prstGeom>
         </p:spPr>
       </p:pic>
-      <p:pic>
-        <p:nvPicPr>
-          <p:cNvPr id="6" name="Picture 5" descr="pca_zip7_PBS1.png"/>
-          <p:cNvPicPr>
-            <a:picLocks noChangeAspect="1"/>
-          </p:cNvPicPr>
+      <p:sp>
+        <p:nvSpPr>
+          <p:cNvPr id="6" name="TextBox 5"/>
+          <p:cNvSpPr txBox="1"/>
           <p:nvPr/>
-        </p:nvPicPr>
-        <p:blipFill>
-          <a:blip r:embed="rId3"/>
-          <a:stretch>
-            <a:fillRect/>
-          </a:stretch>
-        </p:blipFill>
-        <p:spPr>
-          <a:xfrm>
-            <a:off x="2831374" y="4572000"/>
-            <a:ext cx="6498771" cy="1828800"/>
-          </a:xfrm>
-          <a:prstGeom prst="rect">
-            <a:avLst/>
-          </a:prstGeom>
-        </p:spPr>
-      </p:pic>
+        </p:nvSpPr>
+        <p:spPr>
+          <a:xfrm>
+            <a:off x="1005840" y="5882159"/>
+            <a:ext cx="10149840" cy="274320"/>
+          </a:xfrm>
+          <a:prstGeom prst="rect">
+            <a:avLst/>
+          </a:prstGeom>
+          <a:noFill/>
+        </p:spPr>
+        <p:txBody>
+          <a:bodyPr wrap="square">
+            <a:spAutoFit/>
+          </a:bodyPr>
+          <a:lstStyle/>
+          <a:p>
+            <a:pPr algn="ctr"/>
+            <a:r>
+              <a:rPr sz="1100" i="1">
+                <a:solidFill>
+                  <a:srgbClr val="666666"/>
+                </a:solidFill>
+                <a:latin typeface="Arial"/>
+              </a:rPr>
+              <a:t>Z7 PBS1: nxm0 (mean) + nxm1–4 (PCs) — the oscillating components encode rise/fall-time variation</a:t>
+            </a:r>
+          </a:p>
+        </p:txBody>
+      </p:sp>
       <p:sp>
         <p:nvSpPr>
           <p:cNvPr id="7" name="TextBox 6"/>
@@ -4542,41 +4624,6 @@
         </p:nvSpPr>
         <p:spPr>
           <a:xfrm>
-            <a:off x="1371600" y="6430800"/>
-            <a:ext cx="9418320" cy="274320"/>
-          </a:xfrm>
-          <a:prstGeom prst="rect">
-            <a:avLst/>
-          </a:prstGeom>
-          <a:noFill/>
-        </p:spPr>
-        <p:txBody>
-          <a:bodyPr wrap="square">
-            <a:spAutoFit/>
-          </a:bodyPr>
-          <a:lstStyle/>
-          <a:p>
-            <a:pPr algn="ctr"/>
-            <a:r>
-              <a:rPr sz="1100" i="1">
-                <a:solidFill>
-                  <a:srgbClr val="666666"/>
-                </a:solidFill>
-                <a:latin typeface="Arial"/>
-              </a:rPr>
-              <a:t>Z7 PAS1 / PBS1: nxm0 (mean) + nxm1–4 (PCs) — the oscillating components encode rise/fall-time variation</a:t>
-            </a:r>
-          </a:p>
-        </p:txBody>
-      </p:sp>
-      <p:sp>
-        <p:nvSpPr>
-          <p:cNvPr id="8" name="TextBox 7"/>
-          <p:cNvSpPr txBox="1"/>
-          <p:nvPr/>
-        </p:nvSpPr>
-        <p:spPr>
-          <a:xfrm>
             <a:off x="10957255" y="6446520"/>
             <a:ext cx="1005840" cy="274320"/>
           </a:xfrm>
@@ -4599,7 +4646,7 @@
                 </a:solidFill>
                 <a:latin typeface="Arial"/>
               </a:rPr>
-              <a:t>10 / 11</a:t>
+              <a:t>10 / 12</a:t>
             </a:r>
           </a:p>
         </p:txBody>
@@ -4800,7 +4847,401 @@
                 </a:solidFill>
                 <a:latin typeface="Arial"/>
               </a:rPr>
-              <a:t>11 / 11</a:t>
+              <a:t>11 / 12</a:t>
+            </a:r>
+          </a:p>
+        </p:txBody>
+      </p:sp>
+    </p:spTree>
+  </p:cSld>
+  <p:clrMapOvr>
+    <a:masterClrMapping/>
+  </p:clrMapOvr>
+</p:sld>
+</file>
+
+<file path=ppt/slides/slide12.xml><?xml version="1.0" encoding="utf-8"?>
+<p:sld xmlns:a="http://schemas.openxmlformats.org/drawingml/2006/main" xmlns:p="http://schemas.openxmlformats.org/presentationml/2006/main" xmlns:r="http://schemas.openxmlformats.org/officeDocument/2006/relationships">
+  <p:cSld>
+    <p:spTree>
+      <p:nvGrpSpPr>
+        <p:cNvPr id="1" name=""/>
+        <p:cNvGrpSpPr/>
+        <p:nvPr/>
+      </p:nvGrpSpPr>
+      <p:grpSpPr/>
+      <p:sp>
+        <p:nvSpPr>
+          <p:cNvPr id="2" name="TextBox 1"/>
+          <p:cNvSpPr txBox="1"/>
+          <p:nvPr/>
+        </p:nvSpPr>
+        <p:spPr>
+          <a:xfrm>
+            <a:off x="502920" y="256032"/>
+            <a:ext cx="11247120" cy="685800"/>
+          </a:xfrm>
+          <a:prstGeom prst="rect">
+            <a:avLst/>
+          </a:prstGeom>
+          <a:noFill/>
+        </p:spPr>
+        <p:txBody>
+          <a:bodyPr wrap="square">
+            <a:spAutoFit/>
+          </a:bodyPr>
+          <a:lstStyle/>
+          <a:p>
+            <a:r>
+              <a:rPr sz="2700" b="1">
+                <a:solidFill>
+                  <a:srgbClr val="1F3864"/>
+                </a:solidFill>
+                <a:latin typeface="Arial"/>
+              </a:rPr>
+              <a:t>Backup — weak detectors (example: Z22)</a:t>
+            </a:r>
+          </a:p>
+        </p:txBody>
+      </p:sp>
+      <p:sp>
+        <p:nvSpPr>
+          <p:cNvPr id="3" name="Rectangle 2"/>
+          <p:cNvSpPr/>
+          <p:nvPr/>
+        </p:nvSpPr>
+        <p:spPr>
+          <a:xfrm>
+            <a:off x="502920" y="932688"/>
+            <a:ext cx="11247120" cy="18000"/>
+          </a:xfrm>
+          <a:prstGeom prst="rect">
+            <a:avLst/>
+          </a:prstGeom>
+          <a:solidFill>
+            <a:srgbClr val="1F3864"/>
+          </a:solidFill>
+          <a:ln>
+            <a:noFill/>
+          </a:ln>
+        </p:spPr>
+        <p:style>
+          <a:lnRef idx="1">
+            <a:schemeClr val="accent1"/>
+          </a:lnRef>
+          <a:fillRef idx="3">
+            <a:schemeClr val="accent1"/>
+          </a:fillRef>
+          <a:effectRef idx="2">
+            <a:schemeClr val="accent1"/>
+          </a:effectRef>
+          <a:fontRef idx="minor">
+            <a:schemeClr val="lt1"/>
+          </a:fontRef>
+        </p:style>
+        <p:txBody>
+          <a:bodyPr rtlCol="0" anchor="ctr"/>
+          <a:lstStyle/>
+          <a:p>
+            <a:pPr algn="ctr"/>
+          </a:p>
+        </p:txBody>
+      </p:sp>
+      <p:sp>
+        <p:nvSpPr>
+          <p:cNvPr id="4" name="TextBox 3"/>
+          <p:cNvSpPr txBox="1"/>
+          <p:nvPr/>
+        </p:nvSpPr>
+        <p:spPr>
+          <a:xfrm>
+            <a:off x="502920" y="1005840"/>
+            <a:ext cx="11247120" cy="1965960"/>
+          </a:xfrm>
+          <a:prstGeom prst="rect">
+            <a:avLst/>
+          </a:prstGeom>
+          <a:noFill/>
+        </p:spPr>
+        <p:txBody>
+          <a:bodyPr wrap="square">
+            <a:spAutoFit/>
+          </a:bodyPr>
+          <a:lstStyle/>
+          <a:p>
+            <a:pPr>
+              <a:spcAft>
+                <a:spcPts val="500"/>
+              </a:spcAft>
+            </a:pPr>
+            <a:r>
+              <a:rPr sz="1300">
+                <a:solidFill>
+                  <a:srgbClr val="333333"/>
+                </a:solidFill>
+                <a:latin typeface="Arial"/>
+              </a:rPr>
+              <a:t>• Z1 / Z4 / Z6 / Z18 / Z19 / Z22 / Z24: K-line sits inside the noise population — the PTOF window admits a noise-dominated mixture</a:t>
+            </a:r>
+          </a:p>
+          <a:p>
+            <a:pPr>
+              <a:spcAft>
+                <a:spcPts val="500"/>
+              </a:spcAft>
+            </a:pPr>
+            <a:r>
+              <a:rPr sz="1300">
+                <a:solidFill>
+                  <a:srgbClr val="333333"/>
+                </a:solidFill>
+                <a:latin typeface="Arial"/>
+              </a:rPr>
+              <a:t>• Same bimodal NRMSE picture, noise peak dominates; the same 0.4 cut digs the real pulses out — Z22 PCS1: 7198 kept / 4788 cut (~40%)</a:t>
+            </a:r>
+          </a:p>
+          <a:p>
+            <a:pPr>
+              <a:spcAft>
+                <a:spcPts val="500"/>
+              </a:spcAft>
+            </a:pPr>
+            <a:r>
+              <a:rPr sz="1300">
+                <a:solidFill>
+                  <a:srgbClr val="333333"/>
+                </a:solidFill>
+                <a:latin typeface="Arial"/>
+              </a:rPr>
+              <a:t>• Kept bundle broader than on quiet detectors; steep red curves = fits latching onto sharp noise spikes, not fast pulses being cut</a:t>
+            </a:r>
+          </a:p>
+          <a:p>
+            <a:pPr>
+              <a:spcAft>
+                <a:spcPts val="500"/>
+              </a:spcAft>
+            </a:pPr>
+            <a:r>
+              <a:rPr sz="1300">
+                <a:solidFill>
+                  <a:srgbClr val="333333"/>
+                </a:solidFill>
+                <a:latin typeface="Arial"/>
+              </a:rPr>
+              <a:t>• τ_rise ≤ 0.3 ms (after NRMSE): removes 55–74% on weak zips (Z22: 71%) vs 1.6% on Z7 — residual slow drift</a:t>
+            </a:r>
+          </a:p>
+        </p:txBody>
+      </p:sp>
+      <p:pic>
+        <p:nvPicPr>
+          <p:cNvPr id="5" name="Picture 4" descr="nrmse_zip22_PAS1.png"/>
+          <p:cNvPicPr>
+            <a:picLocks noChangeAspect="1"/>
+          </p:cNvPicPr>
+          <p:nvPr/>
+        </p:nvPicPr>
+        <p:blipFill>
+          <a:blip r:embed="rId2"/>
+          <a:stretch>
+            <a:fillRect/>
+          </a:stretch>
+        </p:blipFill>
+        <p:spPr>
+          <a:xfrm>
+            <a:off x="365760" y="3063240"/>
+            <a:ext cx="5760720" cy="1319662"/>
+          </a:xfrm>
+          <a:prstGeom prst="rect">
+            <a:avLst/>
+          </a:prstGeom>
+        </p:spPr>
+      </p:pic>
+      <p:sp>
+        <p:nvSpPr>
+          <p:cNvPr id="6" name="TextBox 5"/>
+          <p:cNvSpPr txBox="1"/>
+          <p:nvPr/>
+        </p:nvSpPr>
+        <p:spPr>
+          <a:xfrm>
+            <a:off x="365760" y="4412902"/>
+            <a:ext cx="5760720" cy="274320"/>
+          </a:xfrm>
+          <a:prstGeom prst="rect">
+            <a:avLst/>
+          </a:prstGeom>
+          <a:noFill/>
+        </p:spPr>
+        <p:txBody>
+          <a:bodyPr wrap="square">
+            <a:spAutoFit/>
+          </a:bodyPr>
+          <a:lstStyle/>
+          <a:p>
+            <a:pPr algn="ctr"/>
+            <a:r>
+              <a:rPr sz="1100" i="1">
+                <a:solidFill>
+                  <a:srgbClr val="666666"/>
+                </a:solidFill>
+                <a:latin typeface="Arial"/>
+              </a:rPr>
+              <a:t>Z22 PAS1: NRMSE histogram — noise dominates</a:t>
+            </a:r>
+          </a:p>
+        </p:txBody>
+      </p:sp>
+      <p:pic>
+        <p:nvPicPr>
+          <p:cNvPr id="7" name="Picture 6" descr="fan_cut_zip22_PCS1.png"/>
+          <p:cNvPicPr>
+            <a:picLocks noChangeAspect="1"/>
+          </p:cNvPicPr>
+          <p:nvPr/>
+        </p:nvPicPr>
+        <p:blipFill>
+          <a:blip r:embed="rId3"/>
+          <a:stretch>
+            <a:fillRect/>
+          </a:stretch>
+        </p:blipFill>
+        <p:spPr>
+          <a:xfrm>
+            <a:off x="6309360" y="3063240"/>
+            <a:ext cx="5760720" cy="1479697"/>
+          </a:xfrm>
+          <a:prstGeom prst="rect">
+            <a:avLst/>
+          </a:prstGeom>
+        </p:spPr>
+      </p:pic>
+      <p:sp>
+        <p:nvSpPr>
+          <p:cNvPr id="8" name="TextBox 7"/>
+          <p:cNvSpPr txBox="1"/>
+          <p:nvPr/>
+        </p:nvSpPr>
+        <p:spPr>
+          <a:xfrm>
+            <a:off x="6309360" y="4572937"/>
+            <a:ext cx="5760720" cy="274320"/>
+          </a:xfrm>
+          <a:prstGeom prst="rect">
+            <a:avLst/>
+          </a:prstGeom>
+          <a:noFill/>
+        </p:spPr>
+        <p:txBody>
+          <a:bodyPr wrap="square">
+            <a:spAutoFit/>
+          </a:bodyPr>
+          <a:lstStyle/>
+          <a:p>
+            <a:pPr algn="ctr"/>
+            <a:r>
+              <a:rPr sz="1100" i="1">
+                <a:solidFill>
+                  <a:srgbClr val="666666"/>
+                </a:solidFill>
+                <a:latin typeface="Arial"/>
+              </a:rPr>
+              <a:t>Z22 PCS1: kept (green) vs cut (red)</a:t>
+            </a:r>
+          </a:p>
+        </p:txBody>
+      </p:sp>
+      <p:pic>
+        <p:nvPicPr>
+          <p:cNvPr id="9" name="Picture 8" descr="fan_final_zip22_PCS1.png"/>
+          <p:cNvPicPr>
+            <a:picLocks noChangeAspect="1"/>
+          </p:cNvPicPr>
+          <p:nvPr/>
+        </p:nvPicPr>
+        <p:blipFill>
+          <a:blip r:embed="rId4"/>
+          <a:stretch>
+            <a:fillRect/>
+          </a:stretch>
+        </p:blipFill>
+        <p:spPr>
+          <a:xfrm>
+            <a:off x="3745314" y="5074920"/>
+            <a:ext cx="4670891" cy="1417320"/>
+          </a:xfrm>
+          <a:prstGeom prst="rect">
+            <a:avLst/>
+          </a:prstGeom>
+        </p:spPr>
+      </p:pic>
+      <p:sp>
+        <p:nvSpPr>
+          <p:cNvPr id="10" name="TextBox 9"/>
+          <p:cNvSpPr txBox="1"/>
+          <p:nvPr/>
+        </p:nvSpPr>
+        <p:spPr>
+          <a:xfrm>
+            <a:off x="2011680" y="6522240"/>
+            <a:ext cx="8138160" cy="274320"/>
+          </a:xfrm>
+          <a:prstGeom prst="rect">
+            <a:avLst/>
+          </a:prstGeom>
+          <a:noFill/>
+        </p:spPr>
+        <p:txBody>
+          <a:bodyPr wrap="square">
+            <a:spAutoFit/>
+          </a:bodyPr>
+          <a:lstStyle/>
+          <a:p>
+            <a:pPr algn="ctr"/>
+            <a:r>
+              <a:rPr sz="1100" i="1">
+                <a:solidFill>
+                  <a:srgbClr val="666666"/>
+                </a:solidFill>
+                <a:latin typeface="Arial"/>
+              </a:rPr>
+              <a:t>Z22 PCS1 after NRMSE ≤ 0.4 + τ_rise ≤ 0.3 ms — final shape family (760 fits)</a:t>
+            </a:r>
+          </a:p>
+        </p:txBody>
+      </p:sp>
+      <p:sp>
+        <p:nvSpPr>
+          <p:cNvPr id="11" name="TextBox 10"/>
+          <p:cNvSpPr txBox="1"/>
+          <p:nvPr/>
+        </p:nvSpPr>
+        <p:spPr>
+          <a:xfrm>
+            <a:off x="10957255" y="6446520"/>
+            <a:ext cx="1005840" cy="274320"/>
+          </a:xfrm>
+          <a:prstGeom prst="rect">
+            <a:avLst/>
+          </a:prstGeom>
+          <a:noFill/>
+        </p:spPr>
+        <p:txBody>
+          <a:bodyPr wrap="none">
+            <a:spAutoFit/>
+          </a:bodyPr>
+          <a:lstStyle/>
+          <a:p>
+            <a:pPr algn="r"/>
+            <a:r>
+              <a:rPr sz="1100">
+                <a:solidFill>
+                  <a:srgbClr val="666666"/>
+                </a:solidFill>
+                <a:latin typeface="Arial"/>
+              </a:rPr>
+              <a:t>12 / 12</a:t>
             </a:r>
           </a:p>
         </p:txBody>
@@ -5135,7 +5576,7 @@
                 </a:solidFill>
                 <a:latin typeface="Arial"/>
               </a:rPr>
-              <a:t>2 / 11</a:t>
+              <a:t>2 / 12</a:t>
             </a:r>
           </a:p>
         </p:txBody>
@@ -5438,7 +5879,7 @@
                 </a:solidFill>
                 <a:latin typeface="Arial"/>
               </a:rPr>
-              <a:t>3 / 11</a:t>
+              <a:t>3 / 12</a:t>
             </a:r>
           </a:p>
         </p:txBody>
@@ -5811,7 +6252,7 @@
                 </a:solidFill>
                 <a:latin typeface="Arial"/>
               </a:rPr>
-              <a:t>4 / 11</a:t>
+              <a:t>4 / 12</a:t>
             </a:r>
           </a:p>
         </p:txBody>
@@ -6098,7 +6539,7 @@
                 </a:solidFill>
                 <a:latin typeface="Arial"/>
               </a:rPr>
-              <a:t>5 / 11</a:t>
+              <a:t>5 / 12</a:t>
             </a:r>
           </a:p>
         </p:txBody>
@@ -6264,7 +6705,7 @@
                 </a:solidFill>
                 <a:latin typeface="Arial"/>
               </a:rPr>
-              <a:t>• Weak detectors (Z1, Z4, Z6, Z18, Z19, Z22, Z24): the PTOF window admits a noise-dominated mixture — this cut is what extracts the real-pulse population</a:t>
+              <a:t>• Weak detectors (Z1, Z4, Z6, Z18, Z19, Z22, Z24): same bimodal picture, noise peak dominates — backup slide</a:t>
             </a:r>
           </a:p>
         </p:txBody>
@@ -6285,8 +6726,8 @@
         </p:blipFill>
         <p:spPr>
           <a:xfrm>
-            <a:off x="1970576" y="2651760"/>
-            <a:ext cx="8220367" cy="1874519"/>
+            <a:off x="1280160" y="2834640"/>
+            <a:ext cx="9601200" cy="2189394"/>
           </a:xfrm>
           <a:prstGeom prst="rect">
             <a:avLst/>
@@ -6301,8 +6742,8 @@
         </p:nvSpPr>
         <p:spPr>
           <a:xfrm>
-            <a:off x="1737360" y="4556279"/>
-            <a:ext cx="8686800" cy="274320"/>
+            <a:off x="1280160" y="5054034"/>
+            <a:ext cx="9601200" cy="274320"/>
           </a:xfrm>
           <a:prstGeom prst="rect">
             <a:avLst/>
@@ -6323,73 +6764,14 @@
                 </a:solidFill>
                 <a:latin typeface="Arial"/>
               </a:rPr>
-              <a:t>Z7 PBS1 (quiet): two clean populations, log-log axes</a:t>
-            </a:r>
-          </a:p>
-        </p:txBody>
-      </p:sp>
-      <p:pic>
-        <p:nvPicPr>
-          <p:cNvPr id="7" name="Picture 6" descr="nrmse_zip22_PAS1.png"/>
-          <p:cNvPicPr>
-            <a:picLocks noChangeAspect="1"/>
-          </p:cNvPicPr>
-          <p:nvPr/>
-        </p:nvPicPr>
-        <p:blipFill>
-          <a:blip r:embed="rId3"/>
-          <a:stretch>
-            <a:fillRect/>
-          </a:stretch>
-        </p:blipFill>
-        <p:spPr>
-          <a:xfrm>
-            <a:off x="1989344" y="4754880"/>
-            <a:ext cx="8182831" cy="1874519"/>
-          </a:xfrm>
-          <a:prstGeom prst="rect">
-            <a:avLst/>
-          </a:prstGeom>
-        </p:spPr>
-      </p:pic>
-      <p:sp>
-        <p:nvSpPr>
-          <p:cNvPr id="8" name="TextBox 7"/>
-          <p:cNvSpPr txBox="1"/>
-          <p:nvPr/>
-        </p:nvSpPr>
-        <p:spPr>
-          <a:xfrm>
-            <a:off x="1737360" y="6659399"/>
-            <a:ext cx="8686800" cy="274320"/>
-          </a:xfrm>
-          <a:prstGeom prst="rect">
-            <a:avLst/>
-          </a:prstGeom>
-          <a:noFill/>
-        </p:spPr>
-        <p:txBody>
-          <a:bodyPr wrap="square">
-            <a:spAutoFit/>
-          </a:bodyPr>
-          <a:lstStyle/>
-          <a:p>
-            <a:pPr algn="ctr"/>
-            <a:r>
-              <a:rPr sz="1100" i="1">
-                <a:solidFill>
-                  <a:srgbClr val="666666"/>
-                </a:solidFill>
-                <a:latin typeface="Arial"/>
-              </a:rPr>
-              <a:t>Z22 PAS1 (weak): noise population dominates — the window alone is not enough</a:t>
-            </a:r>
-          </a:p>
-        </p:txBody>
-      </p:sp>
-      <p:sp>
-        <p:nvSpPr>
-          <p:cNvPr id="9" name="TextBox 8"/>
+              <a:t>Z7 PBS1: two clean populations, log-log axes</a:t>
+            </a:r>
+          </a:p>
+        </p:txBody>
+      </p:sp>
+      <p:sp>
+        <p:nvSpPr>
+          <p:cNvPr id="7" name="TextBox 6"/>
           <p:cNvSpPr txBox="1"/>
           <p:nvPr/>
         </p:nvSpPr>
@@ -6417,7 +6799,7 @@
                 </a:solidFill>
                 <a:latin typeface="Arial"/>
               </a:rPr>
-              <a:t>6 / 11</a:t>
+              <a:t>6 / 12</a:t>
             </a:r>
           </a:p>
         </p:txBody>
@@ -6558,7 +6940,7 @@
       </p:sp>
       <p:pic>
         <p:nvPicPr>
-          <p:cNvPr id="5" name="Picture 4" descr="slow_rise_zip22_crop.png"/>
+          <p:cNvPr id="5" name="Picture 4" descr="slow_rise_zip7_crop.png"/>
           <p:cNvPicPr>
             <a:picLocks noChangeAspect="1"/>
           </p:cNvPicPr>
@@ -6573,7 +6955,7 @@
         <p:spPr>
           <a:xfrm>
             <a:off x="365760" y="2468880"/>
-            <a:ext cx="5394960" cy="3699401"/>
+            <a:ext cx="5394960" cy="3720662"/>
           </a:xfrm>
           <a:prstGeom prst="rect">
             <a:avLst/>
@@ -6588,7 +6970,7 @@
         </p:nvSpPr>
         <p:spPr>
           <a:xfrm>
-            <a:off x="365760" y="6198281"/>
+            <a:off x="365760" y="6219542"/>
             <a:ext cx="5394960" cy="274320"/>
           </a:xfrm>
           <a:prstGeom prst="rect">
@@ -6610,14 +6992,14 @@
                 </a:solidFill>
                 <a:latin typeface="Arial"/>
               </a:rPr>
-              <a:t>Z22: NRMSE-rejected events — raw traces are noise</a:t>
+              <a:t>Z7: NRMSE-rejected events — raw traces are noise</a:t>
             </a:r>
           </a:p>
         </p:txBody>
       </p:sp>
       <p:pic>
         <p:nvPicPr>
-          <p:cNvPr id="7" name="Picture 6" descr="fan_cut_zip22_PCS1.png"/>
+          <p:cNvPr id="7" name="Picture 6" descr="fan_cut_zip7_PBS1.png"/>
           <p:cNvPicPr>
             <a:picLocks noChangeAspect="1"/>
           </p:cNvPicPr>
@@ -6668,7 +7050,7 @@
                 </a:solidFill>
                 <a:latin typeface="Arial"/>
               </a:rPr>
-              <a:t>Z22 PCS1   </a:t>
+              <a:t>Z7 PBS1   </a:t>
             </a:r>
             <a:r>
               <a:rPr sz="1400" b="1">
@@ -6706,7 +7088,7 @@
                 </a:solidFill>
                 <a:latin typeface="Arial"/>
               </a:rPr>
-              <a:t>      7198 kept / 4788 cut (~40%)</a:t>
+              <a:t>      1931 kept / 77 cut (~3.8%)</a:t>
             </a:r>
           </a:p>
         </p:txBody>
@@ -6741,7 +7123,7 @@
                 </a:solidFill>
                 <a:latin typeface="Arial"/>
               </a:rPr>
-              <a:t>7 / 11</a:t>
+              <a:t>7 / 12</a:t>
             </a:r>
           </a:p>
         </p:txBody>
@@ -7153,7 +7535,7 @@
                 </a:solidFill>
                 <a:latin typeface="Arial"/>
               </a:rPr>
-              <a:t>8 / 11</a:t>
+              <a:t>8 / 12</a:t>
             </a:r>
           </a:p>
         </p:txBody>
@@ -7413,7 +7795,7 @@
                 </a:solidFill>
                 <a:latin typeface="Arial"/>
               </a:rPr>
-              <a:t>9 / 11</a:t>
+              <a:t>9 / 12</a:t>
             </a:r>
           </a:p>
         </p:txBody>

</xml_diff>

<commit_message>
snolab: presentation — Slide 6 drops the spoken backup pointer; Z22 named as a hook example instead (show backup only if asked)
Co-Authored-By: Claude Fable 5 <noreply@anthropic.com>
</commit_message>
<xml_diff>
--- a/snolab/presentation/SNOLAB_R4_pulse_templates_20260715.pptx
+++ b/snolab/presentation/SNOLAB_R4_pulse_templates_20260715.pptx
@@ -1073,7 +1073,7 @@
           <a:lstStyle/>
           <a:p>
             <a:r>
-              <a:t>First quality cut. The NRMSE distribution of physical fits is bimodal on every detector: a good-fit population around 0.05 to 0.1, and a noise-trigger population around 1 to 2, separated by a valley at about 0.4. We place the cut in the valley - it is read off the distribution itself. This is Z7 PBS1, the channel used throughout the talk. On the weak detectors the same bimodal picture appears with the noise peak dominating - one example is in the backup slide - and there this same cut is what digs the real pulses out of the mixture.</a:t>
+              <a:t>First quality cut. The NRMSE distribution of physical fits is bimodal on every detector: a good-fit population around 0.05 to 0.1, and a noise-trigger population around 1 to 2, separated by a valley at about 0.4. We place the cut in the valley - it is read off the distribution itself. This is Z7 PBS1, the channel used throughout the talk. The weak detectors - Z22, for example - show the same bimodal picture with the noise peak dominating, and there this same cut is what digs the real pulses out of the mixture. (If someone asks what a weak detector looks like, show the backup slide.)</a:t>
             </a:r>
           </a:p>
         </p:txBody>
@@ -6705,7 +6705,7 @@
                 </a:solidFill>
                 <a:latin typeface="Arial"/>
               </a:rPr>
-              <a:t>• Weak detectors (Z1, Z4, Z6, Z18, Z19, Z22, Z24): same bimodal picture, noise peak dominates — backup slide</a:t>
+              <a:t>• Weak detectors (Z1, Z4, Z6, Z18, Z19, Z22, Z24): same bimodal picture, noise peak dominates</a:t>
             </a:r>
           </a:p>
         </p:txBody>

</xml_diff>

<commit_message>
snolab: presentation — Slide 8, plainer register: "slow physics" -> "a genuinely slow pulse", drop the preachy "two separate things" for a factual "Z7 best overall, PDS2 genuinely bad"
Co-Authored-By: Claude Opus 4.8 <noreply@anthropic.com>
</commit_message>
<xml_diff>
--- a/snolab/presentation/SNOLAB_R4_pulse_templates_20260715.pptx
+++ b/snolab/presentation/SNOLAB_R4_pulse_templates_20260715.pptx
@@ -1213,7 +1213,7 @@
           <a:lstStyle/>
           <a:p>
             <a:r>
-              <a:t>The first lead comes from the fan plot after the cut: some curves still fall very slowly. We chased it by sampling: among events passing the cut, take fall times above one point five milliseconds, randomly sample ten, and draw raw versus fit in every channel. Two findings. First, the sampled events are real pulses - so they stay in, and we apply no fall cut. Second, their extreme fall times all trace back to one channel: only PDS2 is swinging wildly, while the same events are normal fast pulses in the other eleven channels - so the extreme tail is a one-channel low-frequency artifact, not slow physics.</a:t>
+              <a:t>The first lead comes from the fan plot after the cut: some curves still fall very slowly. We chased it by sampling: among events passing the cut, take fall times above one point five milliseconds, randomly sample ten, and draw raw versus fit in every channel. Two findings. First, the sampled events are real pulses - so they stay in, and we apply no fall cut. Second, their extreme fall times all trace back to one channel: only PDS2 is swinging wildly, while the same events are normal fast pulses in the other eleven channels - so the extreme tail is a one-channel low-frequency artifact, not a genuinely slow pulse.</a:t>
             </a:r>
           </a:p>
         </p:txBody>
@@ -7289,7 +7289,7 @@
                 </a:solidFill>
                 <a:latin typeface="Arial"/>
               </a:rPr>
-              <a:t>• Conclusion: no τ_fall cut — slow-fall events passing NRMSE stay in; the extreme tail is a one-channel artifact, not physics</a:t>
+              <a:t>• Conclusion: no τ_fall cut — slow-fall events passing NRMSE stay in; the extreme tail is a one-channel artifact, not a slow pulse</a:t>
             </a:r>
           </a:p>
         </p:txBody>

</xml_diff>

<commit_message>
snolab: presentation — restore the τ_rise ≤ 0.3 ms ceiling slide as a second backup (keyword bullets + removal %)
Brings back the rise-time-ceiling slide (dropped earlier per Prof. Saab) as
backup 2, keyword-only: slow drift mimics slow rise, fast pulses at ~0.1 ms,
ceiling at 0.3 ms; removal relative to the NRMSE step — Z7 1.6% (quiet 2–6%),
weak 55–74% (Z22 71%), 54% pooled; slowest genuine pulses trimmed (open
trade-off). Deck now 13 slides; deck PDF + speech md/PDF + README updated.

Co-Authored-By: Claude Opus 4.8 <noreply@anthropic.com>
</commit_message>
<xml_diff>
--- a/snolab/presentation/SNOLAB_R4_pulse_templates_20260715.pptx
+++ b/snolab/presentation/SNOLAB_R4_pulse_templates_20260715.pptx
@@ -17,6 +17,7 @@
     <p:sldId id="265" r:id="rId17"/>
     <p:sldId id="266" r:id="rId18"/>
     <p:sldId id="267" r:id="rId19"/>
+    <p:sldId id="268" r:id="rId20"/>
   </p:sldIdLst>
   <p:sldSz cx="12191695" cy="6858000" type="screen4x3"/>
   <p:notesSz cx="6858000" cy="9144000"/>
@@ -724,6 +725,76 @@
           <a:p>
             <a:r>
               <a:t>Backup. On the weak detectors the K-line overlaps the noise population, so the PTOF window admits a noise-dominated mixture. The NRMSE distribution is still bimodal but the noise peak dominates, and the same 0.4 cut is what extracts the real pulses - on Z22 PCS1 about forty percent of the physical fits are removed. The kept bundle is broader than on a quiet detector, and the steep red curves are fits latching onto sharp noise spikes, not fast pulses being thrown away. The rise-time ceiling then removes fifty-five to seventy-four percent of what survived the NRMSE cut on the weak zips - residual slow drift - versus one point six percent on Z7. The surviving shape family is at the bottom.</a:t>
+            </a:r>
+          </a:p>
+        </p:txBody>
+      </p:sp>
+      <p:sp>
+        <p:nvSpPr>
+          <p:cNvPr id="4" name="Slide Number Placeholder 3"/>
+          <p:cNvSpPr>
+            <a:spLocks noGrp="1"/>
+          </p:cNvSpPr>
+          <p:nvPr>
+            <p:ph type="sldNum" idx="5" sz="quarter"/>
+          </p:nvPr>
+        </p:nvSpPr>
+        <p:spPr/>
+      </p:sp>
+    </p:spTree>
+  </p:cSld>
+  <p:clrMapOvr>
+    <a:masterClrMapping/>
+  </p:clrMapOvr>
+</p:notes>
+</file>
+
+<file path=ppt/notesSlides/notesSlide13.xml><?xml version="1.0" encoding="utf-8"?>
+<p:notes xmlns:a="http://schemas.openxmlformats.org/drawingml/2006/main" xmlns:p="http://schemas.openxmlformats.org/presentationml/2006/main" xmlns:r="http://schemas.openxmlformats.org/officeDocument/2006/relationships">
+  <p:cSld>
+    <p:spTree>
+      <p:nvGrpSpPr>
+        <p:cNvPr id="1" name=""/>
+        <p:cNvGrpSpPr/>
+        <p:nvPr/>
+      </p:nvGrpSpPr>
+      <p:grpSpPr>
+        <a:xfrm>
+          <a:off x="0" y="0"/>
+          <a:ext cx="0" cy="0"/>
+          <a:chOff x="0" y="0"/>
+          <a:chExt cx="0" cy="0"/>
+        </a:xfrm>
+      </p:grpSpPr>
+      <p:sp>
+        <p:nvSpPr>
+          <p:cNvPr id="2" name="Slide Image Placeholder 1"/>
+          <p:cNvSpPr>
+            <a:spLocks noGrp="1"/>
+          </p:cNvSpPr>
+          <p:nvPr>
+            <p:ph type="sldImg" idx="2"/>
+          </p:nvPr>
+        </p:nvSpPr>
+        <p:spPr/>
+      </p:sp>
+      <p:sp>
+        <p:nvSpPr>
+          <p:cNvPr id="3" name="Notes Placeholder 2"/>
+          <p:cNvSpPr>
+            <a:spLocks noGrp="1"/>
+          </p:cNvSpPr>
+          <p:nvPr>
+            <p:ph type="body" idx="3" sz="quarter"/>
+          </p:nvPr>
+        </p:nvSpPr>
+        <p:spPr/>
+        <p:txBody>
+          <a:bodyPr/>
+          <a:lstStyle/>
+          <a:p>
+            <a:r>
+              <a:t>Backup for the rise-time cut. On weak-window detectors a slow baseline drift also fits as a slow rise, with a tiny residual, so NRMSE cannot catch it. Real fast pulses cluster near 0.1 ms while the drift tail stretches much further, so the PCA input gets a ceiling at 0.3 ms. Relative to the NRMSE step it removes almost nothing on quiet detectors - 1.6% on Z7, mostly the bad channel PDS2 - but 55 to 74% on the weak ones, 71% on Z22, pooled 54% over all zips. The price is that the very slowest genuine pulses get trimmed too; that trade-off is documented and not final.</a:t>
             </a:r>
           </a:p>
         </p:txBody>
@@ -4646,7 +4717,7 @@
                 </a:solidFill>
                 <a:latin typeface="Arial"/>
               </a:rPr>
-              <a:t>10 / 12</a:t>
+              <a:t>10 / 13</a:t>
             </a:r>
           </a:p>
         </p:txBody>
@@ -4847,7 +4918,7 @@
                 </a:solidFill>
                 <a:latin typeface="Arial"/>
               </a:rPr>
-              <a:t>11 / 12</a:t>
+              <a:t>11 / 13</a:t>
             </a:r>
           </a:p>
         </p:txBody>
@@ -5241,7 +5312,283 @@
                 </a:solidFill>
                 <a:latin typeface="Arial"/>
               </a:rPr>
-              <a:t>12 / 12</a:t>
+              <a:t>12 / 13</a:t>
+            </a:r>
+          </a:p>
+        </p:txBody>
+      </p:sp>
+    </p:spTree>
+  </p:cSld>
+  <p:clrMapOvr>
+    <a:masterClrMapping/>
+  </p:clrMapOvr>
+</p:sld>
+</file>
+
+<file path=ppt/slides/slide13.xml><?xml version="1.0" encoding="utf-8"?>
+<p:sld xmlns:a="http://schemas.openxmlformats.org/drawingml/2006/main" xmlns:p="http://schemas.openxmlformats.org/presentationml/2006/main" xmlns:r="http://schemas.openxmlformats.org/officeDocument/2006/relationships">
+  <p:cSld>
+    <p:spTree>
+      <p:nvGrpSpPr>
+        <p:cNvPr id="1" name=""/>
+        <p:cNvGrpSpPr/>
+        <p:nvPr/>
+      </p:nvGrpSpPr>
+      <p:grpSpPr/>
+      <p:sp>
+        <p:nvSpPr>
+          <p:cNvPr id="2" name="TextBox 1"/>
+          <p:cNvSpPr txBox="1"/>
+          <p:nvPr/>
+        </p:nvSpPr>
+        <p:spPr>
+          <a:xfrm>
+            <a:off x="502920" y="256032"/>
+            <a:ext cx="11247120" cy="685800"/>
+          </a:xfrm>
+          <a:prstGeom prst="rect">
+            <a:avLst/>
+          </a:prstGeom>
+          <a:noFill/>
+        </p:spPr>
+        <p:txBody>
+          <a:bodyPr wrap="square">
+            <a:spAutoFit/>
+          </a:bodyPr>
+          <a:lstStyle/>
+          <a:p>
+            <a:r>
+              <a:rPr sz="2700" b="1">
+                <a:solidFill>
+                  <a:srgbClr val="1F3864"/>
+                </a:solidFill>
+                <a:latin typeface="Arial"/>
+              </a:rPr>
+              <a:t>Backup — the τ_rise ≤ 0.3 ms ceiling (PCA input)</a:t>
+            </a:r>
+          </a:p>
+        </p:txBody>
+      </p:sp>
+      <p:sp>
+        <p:nvSpPr>
+          <p:cNvPr id="3" name="Rectangle 2"/>
+          <p:cNvSpPr/>
+          <p:nvPr/>
+        </p:nvSpPr>
+        <p:spPr>
+          <a:xfrm>
+            <a:off x="502920" y="932688"/>
+            <a:ext cx="11247120" cy="18000"/>
+          </a:xfrm>
+          <a:prstGeom prst="rect">
+            <a:avLst/>
+          </a:prstGeom>
+          <a:solidFill>
+            <a:srgbClr val="1F3864"/>
+          </a:solidFill>
+          <a:ln>
+            <a:noFill/>
+          </a:ln>
+        </p:spPr>
+        <p:style>
+          <a:lnRef idx="1">
+            <a:schemeClr val="accent1"/>
+          </a:lnRef>
+          <a:fillRef idx="3">
+            <a:schemeClr val="accent1"/>
+          </a:fillRef>
+          <a:effectRef idx="2">
+            <a:schemeClr val="accent1"/>
+          </a:effectRef>
+          <a:fontRef idx="minor">
+            <a:schemeClr val="lt1"/>
+          </a:fontRef>
+        </p:style>
+        <p:txBody>
+          <a:bodyPr rtlCol="0" anchor="ctr"/>
+          <a:lstStyle/>
+          <a:p>
+            <a:pPr algn="ctr"/>
+          </a:p>
+        </p:txBody>
+      </p:sp>
+      <p:sp>
+        <p:nvSpPr>
+          <p:cNvPr id="4" name="TextBox 3"/>
+          <p:cNvSpPr txBox="1"/>
+          <p:nvPr/>
+        </p:nvSpPr>
+        <p:spPr>
+          <a:xfrm>
+            <a:off x="502920" y="1097280"/>
+            <a:ext cx="11247120" cy="1965960"/>
+          </a:xfrm>
+          <a:prstGeom prst="rect">
+            <a:avLst/>
+          </a:prstGeom>
+          <a:noFill/>
+        </p:spPr>
+        <p:txBody>
+          <a:bodyPr wrap="square">
+            <a:spAutoFit/>
+          </a:bodyPr>
+          <a:lstStyle/>
+          <a:p>
+            <a:pPr>
+              <a:spcAft>
+                <a:spcPts val="500"/>
+              </a:spcAft>
+            </a:pPr>
+            <a:r>
+              <a:rPr sz="1400">
+                <a:solidFill>
+                  <a:srgbClr val="333333"/>
+                </a:solidFill>
+                <a:latin typeface="Arial"/>
+              </a:rPr>
+              <a:t>• Slow baseline drift survives NRMSE (a slow 2-exp hugs it) → mimics a slow rise</a:t>
+            </a:r>
+          </a:p>
+          <a:p>
+            <a:pPr>
+              <a:spcAft>
+                <a:spcPts val="500"/>
+              </a:spcAft>
+            </a:pPr>
+            <a:r>
+              <a:rPr sz="1400">
+                <a:solidFill>
+                  <a:srgbClr val="333333"/>
+                </a:solidFill>
+                <a:latin typeface="Arial"/>
+              </a:rPr>
+              <a:t>• Fast pulses at τ_rise ≈ 0.1 ms (p90 ≈ 0.15 ms) → ceiling at 0.3 ms blocks the drift tail</a:t>
+            </a:r>
+          </a:p>
+          <a:p>
+            <a:pPr>
+              <a:spcAft>
+                <a:spcPts val="500"/>
+              </a:spcAft>
+            </a:pPr>
+            <a:r>
+              <a:rPr sz="1400">
+                <a:solidFill>
+                  <a:srgbClr val="333333"/>
+                </a:solidFill>
+                <a:latin typeface="Arial"/>
+              </a:rPr>
+              <a:t>• Removed after the NRMSE cut: Z7 1.6% (quiet 2–6%) — weak 55–74% (Z22 71%) — all zips 54%</a:t>
+            </a:r>
+          </a:p>
+          <a:p>
+            <a:pPr>
+              <a:spcAft>
+                <a:spcPts val="500"/>
+              </a:spcAft>
+            </a:pPr>
+            <a:r>
+              <a:rPr sz="1400">
+                <a:solidFill>
+                  <a:srgbClr val="333333"/>
+                </a:solidFill>
+                <a:latin typeface="Arial"/>
+              </a:rPr>
+              <a:t>• Trade-off: trims the very slowest genuine pulses → decision pending</a:t>
+            </a:r>
+          </a:p>
+        </p:txBody>
+      </p:sp>
+      <p:pic>
+        <p:nvPicPr>
+          <p:cNvPr id="5" name="Picture 4" descr="time_constants_zip7_PAS1.png"/>
+          <p:cNvPicPr>
+            <a:picLocks noChangeAspect="1"/>
+          </p:cNvPicPr>
+          <p:nvPr/>
+        </p:nvPicPr>
+        <p:blipFill>
+          <a:blip r:embed="rId2"/>
+          <a:stretch>
+            <a:fillRect/>
+          </a:stretch>
+        </p:blipFill>
+        <p:spPr>
+          <a:xfrm>
+            <a:off x="1280160" y="3291840"/>
+            <a:ext cx="9601200" cy="1851803"/>
+          </a:xfrm>
+          <a:prstGeom prst="rect">
+            <a:avLst/>
+          </a:prstGeom>
+        </p:spPr>
+      </p:pic>
+      <p:sp>
+        <p:nvSpPr>
+          <p:cNvPr id="6" name="TextBox 5"/>
+          <p:cNvSpPr txBox="1"/>
+          <p:nvPr/>
+        </p:nvSpPr>
+        <p:spPr>
+          <a:xfrm>
+            <a:off x="1280160" y="5173643"/>
+            <a:ext cx="9601200" cy="274320"/>
+          </a:xfrm>
+          <a:prstGeom prst="rect">
+            <a:avLst/>
+          </a:prstGeom>
+          <a:noFill/>
+        </p:spPr>
+        <p:txBody>
+          <a:bodyPr wrap="square">
+            <a:spAutoFit/>
+          </a:bodyPr>
+          <a:lstStyle/>
+          <a:p>
+            <a:pPr algn="ctr"/>
+            <a:r>
+              <a:rPr sz="1100" i="1">
+                <a:solidFill>
+                  <a:srgbClr val="666666"/>
+                </a:solidFill>
+                <a:latin typeface="Arial"/>
+              </a:rPr>
+              <a:t>Z7 PAS1: fitted τ_rise (median 0.105 ms) and τ_fall distributions</a:t>
+            </a:r>
+          </a:p>
+        </p:txBody>
+      </p:sp>
+      <p:sp>
+        <p:nvSpPr>
+          <p:cNvPr id="7" name="TextBox 6"/>
+          <p:cNvSpPr txBox="1"/>
+          <p:nvPr/>
+        </p:nvSpPr>
+        <p:spPr>
+          <a:xfrm>
+            <a:off x="10957255" y="6446520"/>
+            <a:ext cx="1005840" cy="274320"/>
+          </a:xfrm>
+          <a:prstGeom prst="rect">
+            <a:avLst/>
+          </a:prstGeom>
+          <a:noFill/>
+        </p:spPr>
+        <p:txBody>
+          <a:bodyPr wrap="none">
+            <a:spAutoFit/>
+          </a:bodyPr>
+          <a:lstStyle/>
+          <a:p>
+            <a:pPr algn="r"/>
+            <a:r>
+              <a:rPr sz="1100">
+                <a:solidFill>
+                  <a:srgbClr val="666666"/>
+                </a:solidFill>
+                <a:latin typeface="Arial"/>
+              </a:rPr>
+              <a:t>13 / 13</a:t>
             </a:r>
           </a:p>
         </p:txBody>
@@ -5576,7 +5923,7 @@
                 </a:solidFill>
                 <a:latin typeface="Arial"/>
               </a:rPr>
-              <a:t>2 / 12</a:t>
+              <a:t>2 / 13</a:t>
             </a:r>
           </a:p>
         </p:txBody>
@@ -5879,7 +6226,7 @@
                 </a:solidFill>
                 <a:latin typeface="Arial"/>
               </a:rPr>
-              <a:t>3 / 12</a:t>
+              <a:t>3 / 13</a:t>
             </a:r>
           </a:p>
         </p:txBody>
@@ -6252,7 +6599,7 @@
                 </a:solidFill>
                 <a:latin typeface="Arial"/>
               </a:rPr>
-              <a:t>4 / 12</a:t>
+              <a:t>4 / 13</a:t>
             </a:r>
           </a:p>
         </p:txBody>
@@ -6539,7 +6886,7 @@
                 </a:solidFill>
                 <a:latin typeface="Arial"/>
               </a:rPr>
-              <a:t>5 / 12</a:t>
+              <a:t>5 / 13</a:t>
             </a:r>
           </a:p>
         </p:txBody>
@@ -6799,7 +7146,7 @@
                 </a:solidFill>
                 <a:latin typeface="Arial"/>
               </a:rPr>
-              <a:t>6 / 12</a:t>
+              <a:t>6 / 13</a:t>
             </a:r>
           </a:p>
         </p:txBody>
@@ -7123,7 +7470,7 @@
                 </a:solidFill>
                 <a:latin typeface="Arial"/>
               </a:rPr>
-              <a:t>7 / 12</a:t>
+              <a:t>7 / 13</a:t>
             </a:r>
           </a:p>
         </p:txBody>
@@ -7535,7 +7882,7 @@
                 </a:solidFill>
                 <a:latin typeface="Arial"/>
               </a:rPr>
-              <a:t>8 / 12</a:t>
+              <a:t>8 / 13</a:t>
             </a:r>
           </a:p>
         </p:txBody>
@@ -7795,7 +8142,7 @@
                 </a:solidFill>
                 <a:latin typeface="Arial"/>
               </a:rPr>
-              <a:t>9 / 12</a:t>
+              <a:t>9 / 13</a:t>
             </a:r>
           </a:p>
         </p:txBody>

</xml_diff>

<commit_message>
snolab: presentation — two more τ_rise backups: good-vs-bad channel fan (Z7 PBS1/PDS2) and what-it-removes drift grid (Z22)
Backup 3: τ_rise ≤ 0.3 ms before/after on Z7's good channel PBS1 (removes ~0%,
clean tight bundle) vs bad channel PDS2 (broad messy fan = channel is bad;
1462 → 1154, 21% trimmed). Backup 4: Z22 events that pass NRMSE but have slow
rise — PCS1/PDS1 at NRMSE~0.15 are pure slow baseline drift, no clean pulse =
exactly what the ceiling removes; honest trade-off (also trims some genuine
slow pulses) kept. New crops: fan_zip7_PDS2_{nrmse,after}.png, drift_zip22_crop.png
(added to make_crops.py). Deck now 15 slides; deck PDF + speech md/PDF + README.

Co-Authored-By: Claude Opus 4.8 <noreply@anthropic.com>
</commit_message>
<xml_diff>
--- a/snolab/presentation/SNOLAB_R4_pulse_templates_20260715.pptx
+++ b/snolab/presentation/SNOLAB_R4_pulse_templates_20260715.pptx
@@ -18,6 +18,8 @@
     <p:sldId id="266" r:id="rId18"/>
     <p:sldId id="267" r:id="rId19"/>
     <p:sldId id="268" r:id="rId20"/>
+    <p:sldId id="269" r:id="rId21"/>
+    <p:sldId id="270" r:id="rId22"/>
   </p:sldIdLst>
   <p:sldSz cx="12191695" cy="6858000" type="screen4x3"/>
   <p:notesSz cx="6858000" cy="9144000"/>
@@ -795,6 +797,146 @@
           <a:p>
             <a:r>
               <a:t>Backup for the rise-time cut. On weak-window detectors a slow baseline drift also fits as a slow rise, with a tiny residual, so NRMSE cannot catch it. Real fast pulses cluster near 0.1 ms while the drift tail stretches much further, so the PCA input gets a ceiling at 0.3 ms. Relative to the NRMSE step it removes almost nothing on quiet detectors - 1.6% on Z7, mostly the bad channel PDS2 - but 55 to 74% on the weak ones, 71% on Z22, pooled 54% over all zips. The price is that the very slowest genuine pulses get trimmed too; that trade-off is documented and not final.</a:t>
+            </a:r>
+          </a:p>
+        </p:txBody>
+      </p:sp>
+      <p:sp>
+        <p:nvSpPr>
+          <p:cNvPr id="4" name="Slide Number Placeholder 3"/>
+          <p:cNvSpPr>
+            <a:spLocks noGrp="1"/>
+          </p:cNvSpPr>
+          <p:nvPr>
+            <p:ph type="sldNum" idx="5" sz="quarter"/>
+          </p:nvPr>
+        </p:nvSpPr>
+        <p:spPr/>
+      </p:sp>
+    </p:spTree>
+  </p:cSld>
+  <p:clrMapOvr>
+    <a:masterClrMapping/>
+  </p:clrMapOvr>
+</p:notes>
+</file>
+
+<file path=ppt/notesSlides/notesSlide14.xml><?xml version="1.0" encoding="utf-8"?>
+<p:notes xmlns:a="http://schemas.openxmlformats.org/drawingml/2006/main" xmlns:p="http://schemas.openxmlformats.org/presentationml/2006/main" xmlns:r="http://schemas.openxmlformats.org/officeDocument/2006/relationships">
+  <p:cSld>
+    <p:spTree>
+      <p:nvGrpSpPr>
+        <p:cNvPr id="1" name=""/>
+        <p:cNvGrpSpPr/>
+        <p:nvPr/>
+      </p:nvGrpSpPr>
+      <p:grpSpPr>
+        <a:xfrm>
+          <a:off x="0" y="0"/>
+          <a:ext cx="0" cy="0"/>
+          <a:chOff x="0" y="0"/>
+          <a:chExt cx="0" cy="0"/>
+        </a:xfrm>
+      </p:grpSpPr>
+      <p:sp>
+        <p:nvSpPr>
+          <p:cNvPr id="2" name="Slide Image Placeholder 1"/>
+          <p:cNvSpPr>
+            <a:spLocks noGrp="1"/>
+          </p:cNvSpPr>
+          <p:nvPr>
+            <p:ph type="sldImg" idx="2"/>
+          </p:nvPr>
+        </p:nvSpPr>
+        <p:spPr/>
+      </p:sp>
+      <p:sp>
+        <p:nvSpPr>
+          <p:cNvPr id="3" name="Notes Placeholder 2"/>
+          <p:cNvSpPr>
+            <a:spLocks noGrp="1"/>
+          </p:cNvSpPr>
+          <p:nvPr>
+            <p:ph type="body" idx="3" sz="quarter"/>
+          </p:nvPr>
+        </p:nvSpPr>
+        <p:spPr/>
+        <p:txBody>
+          <a:bodyPr/>
+          <a:lstStyle/>
+          <a:p>
+            <a:r>
+              <a:t>Backup showing the cut channel-by-channel on Z7. On the good channel PBS1 the fitted curves are already a tight, clean bundle, and adding the rise-time ceiling changes essentially nothing - it removes about zero percent. On the bad channel PDS2 the fan is broad and messy, which by itself shows the channel is misbehaving; there the ceiling trims the slow-rising curves, 1462 down to 1154, about twenty-one percent. So the cut is nearly free where the data is clean and does real work only where a channel is bad.</a:t>
+            </a:r>
+          </a:p>
+        </p:txBody>
+      </p:sp>
+      <p:sp>
+        <p:nvSpPr>
+          <p:cNvPr id="4" name="Slide Number Placeholder 3"/>
+          <p:cNvSpPr>
+            <a:spLocks noGrp="1"/>
+          </p:cNvSpPr>
+          <p:nvPr>
+            <p:ph type="sldNum" idx="5" sz="quarter"/>
+          </p:nvPr>
+        </p:nvSpPr>
+        <p:spPr/>
+      </p:sp>
+    </p:spTree>
+  </p:cSld>
+  <p:clrMapOvr>
+    <a:masterClrMapping/>
+  </p:clrMapOvr>
+</p:notes>
+</file>
+
+<file path=ppt/notesSlides/notesSlide15.xml><?xml version="1.0" encoding="utf-8"?>
+<p:notes xmlns:a="http://schemas.openxmlformats.org/drawingml/2006/main" xmlns:p="http://schemas.openxmlformats.org/presentationml/2006/main" xmlns:r="http://schemas.openxmlformats.org/officeDocument/2006/relationships">
+  <p:cSld>
+    <p:spTree>
+      <p:nvGrpSpPr>
+        <p:cNvPr id="1" name=""/>
+        <p:cNvGrpSpPr/>
+        <p:nvPr/>
+      </p:nvGrpSpPr>
+      <p:grpSpPr>
+        <a:xfrm>
+          <a:off x="0" y="0"/>
+          <a:ext cx="0" cy="0"/>
+          <a:chOff x="0" y="0"/>
+          <a:chExt cx="0" cy="0"/>
+        </a:xfrm>
+      </p:grpSpPr>
+      <p:sp>
+        <p:nvSpPr>
+          <p:cNvPr id="2" name="Slide Image Placeholder 1"/>
+          <p:cNvSpPr>
+            <a:spLocks noGrp="1"/>
+          </p:cNvSpPr>
+          <p:nvPr>
+            <p:ph type="sldImg" idx="2"/>
+          </p:nvPr>
+        </p:nvSpPr>
+        <p:spPr/>
+      </p:sp>
+      <p:sp>
+        <p:nvSpPr>
+          <p:cNvPr id="3" name="Notes Placeholder 2"/>
+          <p:cNvSpPr>
+            <a:spLocks noGrp="1"/>
+          </p:cNvSpPr>
+          <p:nvPr>
+            <p:ph type="body" idx="3" sz="quarter"/>
+          </p:nvPr>
+        </p:nvSpPr>
+        <p:spPr/>
+        <p:txBody>
+          <a:bodyPr/>
+          <a:lstStyle/>
+          <a:p>
+            <a:r>
+              <a:t>Backup: what the rise-time cut actually removes. These are Z22 events that pass the NRMSE cut but have a slow rise. Look at PCS1 and PDS1: their NRMSE is low, around 0.15, because a slow two-exp hugs the trace with a tiny residual - but the raw trace is just a slow baseline drift, there is no clean fast pulse. That is exactly the population the 0.3 ms ceiling removes. The honest caveat is that the same cut also trims a small number of genuine slow-rise pulses, which is the documented, still-open trade-off.</a:t>
             </a:r>
           </a:p>
         </p:txBody>
@@ -4717,7 +4859,7 @@
                 </a:solidFill>
                 <a:latin typeface="Arial"/>
               </a:rPr>
-              <a:t>10 / 13</a:t>
+              <a:t>10 / 15</a:t>
             </a:r>
           </a:p>
         </p:txBody>
@@ -4918,7 +5060,7 @@
                 </a:solidFill>
                 <a:latin typeface="Arial"/>
               </a:rPr>
-              <a:t>11 / 13</a:t>
+              <a:t>11 / 15</a:t>
             </a:r>
           </a:p>
         </p:txBody>
@@ -5312,7 +5454,7 @@
                 </a:solidFill>
                 <a:latin typeface="Arial"/>
               </a:rPr>
-              <a:t>12 / 13</a:t>
+              <a:t>12 / 15</a:t>
             </a:r>
           </a:p>
         </p:txBody>
@@ -5588,7 +5730,688 @@
                 </a:solidFill>
                 <a:latin typeface="Arial"/>
               </a:rPr>
-              <a:t>13 / 13</a:t>
+              <a:t>13 / 15</a:t>
+            </a:r>
+          </a:p>
+        </p:txBody>
+      </p:sp>
+    </p:spTree>
+  </p:cSld>
+  <p:clrMapOvr>
+    <a:masterClrMapping/>
+  </p:clrMapOvr>
+</p:sld>
+</file>
+
+<file path=ppt/slides/slide14.xml><?xml version="1.0" encoding="utf-8"?>
+<p:sld xmlns:a="http://schemas.openxmlformats.org/drawingml/2006/main" xmlns:p="http://schemas.openxmlformats.org/presentationml/2006/main" xmlns:r="http://schemas.openxmlformats.org/officeDocument/2006/relationships">
+  <p:cSld>
+    <p:spTree>
+      <p:nvGrpSpPr>
+        <p:cNvPr id="1" name=""/>
+        <p:cNvGrpSpPr/>
+        <p:nvPr/>
+      </p:nvGrpSpPr>
+      <p:grpSpPr/>
+      <p:sp>
+        <p:nvSpPr>
+          <p:cNvPr id="2" name="TextBox 1"/>
+          <p:cNvSpPr txBox="1"/>
+          <p:nvPr/>
+        </p:nvSpPr>
+        <p:spPr>
+          <a:xfrm>
+            <a:off x="502920" y="256032"/>
+            <a:ext cx="11247120" cy="685800"/>
+          </a:xfrm>
+          <a:prstGeom prst="rect">
+            <a:avLst/>
+          </a:prstGeom>
+          <a:noFill/>
+        </p:spPr>
+        <p:txBody>
+          <a:bodyPr wrap="square">
+            <a:spAutoFit/>
+          </a:bodyPr>
+          <a:lstStyle/>
+          <a:p>
+            <a:r>
+              <a:rPr sz="2700" b="1">
+                <a:solidFill>
+                  <a:srgbClr val="1F3864"/>
+                </a:solidFill>
+                <a:latin typeface="Arial"/>
+              </a:rPr>
+              <a:t>Backup — τ_rise cut: a good vs a bad channel (Z7)</a:t>
+            </a:r>
+          </a:p>
+        </p:txBody>
+      </p:sp>
+      <p:sp>
+        <p:nvSpPr>
+          <p:cNvPr id="3" name="Rectangle 2"/>
+          <p:cNvSpPr/>
+          <p:nvPr/>
+        </p:nvSpPr>
+        <p:spPr>
+          <a:xfrm>
+            <a:off x="502920" y="932688"/>
+            <a:ext cx="11247120" cy="18000"/>
+          </a:xfrm>
+          <a:prstGeom prst="rect">
+            <a:avLst/>
+          </a:prstGeom>
+          <a:solidFill>
+            <a:srgbClr val="1F3864"/>
+          </a:solidFill>
+          <a:ln>
+            <a:noFill/>
+          </a:ln>
+        </p:spPr>
+        <p:style>
+          <a:lnRef idx="1">
+            <a:schemeClr val="accent1"/>
+          </a:lnRef>
+          <a:fillRef idx="3">
+            <a:schemeClr val="accent1"/>
+          </a:fillRef>
+          <a:effectRef idx="2">
+            <a:schemeClr val="accent1"/>
+          </a:effectRef>
+          <a:fontRef idx="minor">
+            <a:schemeClr val="lt1"/>
+          </a:fontRef>
+        </p:style>
+        <p:txBody>
+          <a:bodyPr rtlCol="0" anchor="ctr"/>
+          <a:lstStyle/>
+          <a:p>
+            <a:pPr algn="ctr"/>
+          </a:p>
+        </p:txBody>
+      </p:sp>
+      <p:sp>
+        <p:nvSpPr>
+          <p:cNvPr id="4" name="TextBox 3"/>
+          <p:cNvSpPr txBox="1"/>
+          <p:nvPr/>
+        </p:nvSpPr>
+        <p:spPr>
+          <a:xfrm>
+            <a:off x="502920" y="1051560"/>
+            <a:ext cx="11247120" cy="1234440"/>
+          </a:xfrm>
+          <a:prstGeom prst="rect">
+            <a:avLst/>
+          </a:prstGeom>
+          <a:noFill/>
+        </p:spPr>
+        <p:txBody>
+          <a:bodyPr wrap="square">
+            <a:spAutoFit/>
+          </a:bodyPr>
+          <a:lstStyle/>
+          <a:p>
+            <a:pPr>
+              <a:spcAft>
+                <a:spcPts val="500"/>
+              </a:spcAft>
+            </a:pPr>
+            <a:r>
+              <a:rPr sz="1400">
+                <a:solidFill>
+                  <a:srgbClr val="333333"/>
+                </a:solidFill>
+                <a:latin typeface="Arial"/>
+              </a:rPr>
+              <a:t>• Good channel PBS1: tight clean bundle — the τ_rise ≤ 0.3 ms cut removes ~0% (nearly free on quiet channels)</a:t>
+            </a:r>
+          </a:p>
+          <a:p>
+            <a:pPr>
+              <a:spcAft>
+                <a:spcPts val="500"/>
+              </a:spcAft>
+            </a:pPr>
+            <a:r>
+              <a:rPr sz="1400">
+                <a:solidFill>
+                  <a:srgbClr val="333333"/>
+                </a:solidFill>
+                <a:latin typeface="Arial"/>
+              </a:rPr>
+              <a:t>• Bad channel PDS2: broad, messy fan — the channel itself is bad; the cut trims the slow-rise curves, 1462 → 1154 (21%)</a:t>
+            </a:r>
+          </a:p>
+        </p:txBody>
+      </p:sp>
+      <p:pic>
+        <p:nvPicPr>
+          <p:cNvPr id="5" name="Picture 4" descr="fan_zip7_PBS1_after.png"/>
+          <p:cNvPicPr>
+            <a:picLocks noChangeAspect="1"/>
+          </p:cNvPicPr>
+          <p:nvPr/>
+        </p:nvPicPr>
+        <p:blipFill>
+          <a:blip r:embed="rId2"/>
+          <a:stretch>
+            <a:fillRect/>
+          </a:stretch>
+        </p:blipFill>
+        <p:spPr>
+          <a:xfrm>
+            <a:off x="526097" y="2468880"/>
+            <a:ext cx="5302885" cy="1600200"/>
+          </a:xfrm>
+          <a:prstGeom prst="rect">
+            <a:avLst/>
+          </a:prstGeom>
+        </p:spPr>
+      </p:pic>
+      <p:sp>
+        <p:nvSpPr>
+          <p:cNvPr id="6" name="TextBox 5"/>
+          <p:cNvSpPr txBox="1"/>
+          <p:nvPr/>
+        </p:nvSpPr>
+        <p:spPr>
+          <a:xfrm>
+            <a:off x="320040" y="4099080"/>
+            <a:ext cx="5715000" cy="274320"/>
+          </a:xfrm>
+          <a:prstGeom prst="rect">
+            <a:avLst/>
+          </a:prstGeom>
+          <a:noFill/>
+        </p:spPr>
+        <p:txBody>
+          <a:bodyPr wrap="square">
+            <a:spAutoFit/>
+          </a:bodyPr>
+          <a:lstStyle/>
+          <a:p>
+            <a:pPr algn="ctr"/>
+            <a:r>
+              <a:rPr sz="1100" i="1">
+                <a:solidFill>
+                  <a:srgbClr val="666666"/>
+                </a:solidFill>
+                <a:latin typeface="Arial"/>
+              </a:rPr>
+              <a:t>PBS1 (good) — NRMSE ≤ 0.4</a:t>
+            </a:r>
+          </a:p>
+        </p:txBody>
+      </p:sp>
+      <p:pic>
+        <p:nvPicPr>
+          <p:cNvPr id="7" name="Picture 6" descr="fan_zip7_PBS1_after.png"/>
+          <p:cNvPicPr>
+            <a:picLocks noChangeAspect="1"/>
+          </p:cNvPicPr>
+          <p:nvPr/>
+        </p:nvPicPr>
+        <p:blipFill>
+          <a:blip r:embed="rId2"/>
+          <a:stretch>
+            <a:fillRect/>
+          </a:stretch>
+        </p:blipFill>
+        <p:spPr>
+          <a:xfrm>
+            <a:off x="6469697" y="2468880"/>
+            <a:ext cx="5302885" cy="1600200"/>
+          </a:xfrm>
+          <a:prstGeom prst="rect">
+            <a:avLst/>
+          </a:prstGeom>
+        </p:spPr>
+      </p:pic>
+      <p:sp>
+        <p:nvSpPr>
+          <p:cNvPr id="8" name="TextBox 7"/>
+          <p:cNvSpPr txBox="1"/>
+          <p:nvPr/>
+        </p:nvSpPr>
+        <p:spPr>
+          <a:xfrm>
+            <a:off x="6263640" y="4099080"/>
+            <a:ext cx="5715000" cy="274320"/>
+          </a:xfrm>
+          <a:prstGeom prst="rect">
+            <a:avLst/>
+          </a:prstGeom>
+          <a:noFill/>
+        </p:spPr>
+        <p:txBody>
+          <a:bodyPr wrap="square">
+            <a:spAutoFit/>
+          </a:bodyPr>
+          <a:lstStyle/>
+          <a:p>
+            <a:pPr algn="ctr"/>
+            <a:r>
+              <a:rPr sz="1100" i="1">
+                <a:solidFill>
+                  <a:srgbClr val="666666"/>
+                </a:solidFill>
+                <a:latin typeface="Arial"/>
+              </a:rPr>
+              <a:t>PBS1 (good) — + τ_rise ≤ 0.3 ms  (unchanged)</a:t>
+            </a:r>
+          </a:p>
+        </p:txBody>
+      </p:sp>
+      <p:pic>
+        <p:nvPicPr>
+          <p:cNvPr id="9" name="Picture 8" descr="fan_zip7_PDS2_nrmse.png"/>
+          <p:cNvPicPr>
+            <a:picLocks noChangeAspect="1"/>
+          </p:cNvPicPr>
+          <p:nvPr/>
+        </p:nvPicPr>
+        <p:blipFill>
+          <a:blip r:embed="rId3"/>
+          <a:stretch>
+            <a:fillRect/>
+          </a:stretch>
+        </p:blipFill>
+        <p:spPr>
+          <a:xfrm>
+            <a:off x="533442" y="4617720"/>
+            <a:ext cx="5288195" cy="1600200"/>
+          </a:xfrm>
+          <a:prstGeom prst="rect">
+            <a:avLst/>
+          </a:prstGeom>
+        </p:spPr>
+      </p:pic>
+      <p:sp>
+        <p:nvSpPr>
+          <p:cNvPr id="10" name="TextBox 9"/>
+          <p:cNvSpPr txBox="1"/>
+          <p:nvPr/>
+        </p:nvSpPr>
+        <p:spPr>
+          <a:xfrm>
+            <a:off x="320040" y="6247920"/>
+            <a:ext cx="5715000" cy="274320"/>
+          </a:xfrm>
+          <a:prstGeom prst="rect">
+            <a:avLst/>
+          </a:prstGeom>
+          <a:noFill/>
+        </p:spPr>
+        <p:txBody>
+          <a:bodyPr wrap="square">
+            <a:spAutoFit/>
+          </a:bodyPr>
+          <a:lstStyle/>
+          <a:p>
+            <a:pPr algn="ctr"/>
+            <a:r>
+              <a:rPr sz="1100" i="1">
+                <a:solidFill>
+                  <a:srgbClr val="666666"/>
+                </a:solidFill>
+                <a:latin typeface="Arial"/>
+              </a:rPr>
+              <a:t>PDS2 (bad) — NRMSE ≤ 0.4</a:t>
+            </a:r>
+          </a:p>
+        </p:txBody>
+      </p:sp>
+      <p:pic>
+        <p:nvPicPr>
+          <p:cNvPr id="11" name="Picture 10" descr="fan_zip7_PDS2_after.png"/>
+          <p:cNvPicPr>
+            <a:picLocks noChangeAspect="1"/>
+          </p:cNvPicPr>
+          <p:nvPr/>
+        </p:nvPicPr>
+        <p:blipFill>
+          <a:blip r:embed="rId4"/>
+          <a:stretch>
+            <a:fillRect/>
+          </a:stretch>
+        </p:blipFill>
+        <p:spPr>
+          <a:xfrm>
+            <a:off x="6477042" y="4617720"/>
+            <a:ext cx="5288195" cy="1600200"/>
+          </a:xfrm>
+          <a:prstGeom prst="rect">
+            <a:avLst/>
+          </a:prstGeom>
+        </p:spPr>
+      </p:pic>
+      <p:sp>
+        <p:nvSpPr>
+          <p:cNvPr id="12" name="TextBox 11"/>
+          <p:cNvSpPr txBox="1"/>
+          <p:nvPr/>
+        </p:nvSpPr>
+        <p:spPr>
+          <a:xfrm>
+            <a:off x="6263640" y="6247920"/>
+            <a:ext cx="5715000" cy="274320"/>
+          </a:xfrm>
+          <a:prstGeom prst="rect">
+            <a:avLst/>
+          </a:prstGeom>
+          <a:noFill/>
+        </p:spPr>
+        <p:txBody>
+          <a:bodyPr wrap="square">
+            <a:spAutoFit/>
+          </a:bodyPr>
+          <a:lstStyle/>
+          <a:p>
+            <a:pPr algn="ctr"/>
+            <a:r>
+              <a:rPr sz="1100" i="1">
+                <a:solidFill>
+                  <a:srgbClr val="666666"/>
+                </a:solidFill>
+                <a:latin typeface="Arial"/>
+              </a:rPr>
+              <a:t>PDS2 (bad) — + τ_rise ≤ 0.3 ms  (slow risers trimmed)</a:t>
+            </a:r>
+          </a:p>
+        </p:txBody>
+      </p:sp>
+      <p:sp>
+        <p:nvSpPr>
+          <p:cNvPr id="13" name="TextBox 12"/>
+          <p:cNvSpPr txBox="1"/>
+          <p:nvPr/>
+        </p:nvSpPr>
+        <p:spPr>
+          <a:xfrm>
+            <a:off x="10957255" y="6446520"/>
+            <a:ext cx="1005840" cy="274320"/>
+          </a:xfrm>
+          <a:prstGeom prst="rect">
+            <a:avLst/>
+          </a:prstGeom>
+          <a:noFill/>
+        </p:spPr>
+        <p:txBody>
+          <a:bodyPr wrap="none">
+            <a:spAutoFit/>
+          </a:bodyPr>
+          <a:lstStyle/>
+          <a:p>
+            <a:pPr algn="r"/>
+            <a:r>
+              <a:rPr sz="1100">
+                <a:solidFill>
+                  <a:srgbClr val="666666"/>
+                </a:solidFill>
+                <a:latin typeface="Arial"/>
+              </a:rPr>
+              <a:t>14 / 15</a:t>
+            </a:r>
+          </a:p>
+        </p:txBody>
+      </p:sp>
+    </p:spTree>
+  </p:cSld>
+  <p:clrMapOvr>
+    <a:masterClrMapping/>
+  </p:clrMapOvr>
+</p:sld>
+</file>
+
+<file path=ppt/slides/slide15.xml><?xml version="1.0" encoding="utf-8"?>
+<p:sld xmlns:a="http://schemas.openxmlformats.org/drawingml/2006/main" xmlns:p="http://schemas.openxmlformats.org/presentationml/2006/main" xmlns:r="http://schemas.openxmlformats.org/officeDocument/2006/relationships">
+  <p:cSld>
+    <p:spTree>
+      <p:nvGrpSpPr>
+        <p:cNvPr id="1" name=""/>
+        <p:cNvGrpSpPr/>
+        <p:nvPr/>
+      </p:nvGrpSpPr>
+      <p:grpSpPr/>
+      <p:sp>
+        <p:nvSpPr>
+          <p:cNvPr id="2" name="TextBox 1"/>
+          <p:cNvSpPr txBox="1"/>
+          <p:nvPr/>
+        </p:nvSpPr>
+        <p:spPr>
+          <a:xfrm>
+            <a:off x="502920" y="256032"/>
+            <a:ext cx="11247120" cy="685800"/>
+          </a:xfrm>
+          <a:prstGeom prst="rect">
+            <a:avLst/>
+          </a:prstGeom>
+          <a:noFill/>
+        </p:spPr>
+        <p:txBody>
+          <a:bodyPr wrap="square">
+            <a:spAutoFit/>
+          </a:bodyPr>
+          <a:lstStyle/>
+          <a:p>
+            <a:r>
+              <a:rPr sz="2700" b="1">
+                <a:solidFill>
+                  <a:srgbClr val="1F3864"/>
+                </a:solidFill>
+                <a:latin typeface="Arial"/>
+              </a:rPr>
+              <a:t>Backup — what the τ_rise cut removes: slow drift (Z22)</a:t>
+            </a:r>
+          </a:p>
+        </p:txBody>
+      </p:sp>
+      <p:sp>
+        <p:nvSpPr>
+          <p:cNvPr id="3" name="Rectangle 2"/>
+          <p:cNvSpPr/>
+          <p:nvPr/>
+        </p:nvSpPr>
+        <p:spPr>
+          <a:xfrm>
+            <a:off x="502920" y="932688"/>
+            <a:ext cx="11247120" cy="18000"/>
+          </a:xfrm>
+          <a:prstGeom prst="rect">
+            <a:avLst/>
+          </a:prstGeom>
+          <a:solidFill>
+            <a:srgbClr val="1F3864"/>
+          </a:solidFill>
+          <a:ln>
+            <a:noFill/>
+          </a:ln>
+        </p:spPr>
+        <p:style>
+          <a:lnRef idx="1">
+            <a:schemeClr val="accent1"/>
+          </a:lnRef>
+          <a:fillRef idx="3">
+            <a:schemeClr val="accent1"/>
+          </a:fillRef>
+          <a:effectRef idx="2">
+            <a:schemeClr val="accent1"/>
+          </a:effectRef>
+          <a:fontRef idx="minor">
+            <a:schemeClr val="lt1"/>
+          </a:fontRef>
+        </p:style>
+        <p:txBody>
+          <a:bodyPr rtlCol="0" anchor="ctr"/>
+          <a:lstStyle/>
+          <a:p>
+            <a:pPr algn="ctr"/>
+          </a:p>
+        </p:txBody>
+      </p:sp>
+      <p:sp>
+        <p:nvSpPr>
+          <p:cNvPr id="4" name="TextBox 3"/>
+          <p:cNvSpPr txBox="1"/>
+          <p:nvPr/>
+        </p:nvSpPr>
+        <p:spPr>
+          <a:xfrm>
+            <a:off x="502920" y="1051560"/>
+            <a:ext cx="11247120" cy="1554480"/>
+          </a:xfrm>
+          <a:prstGeom prst="rect">
+            <a:avLst/>
+          </a:prstGeom>
+          <a:noFill/>
+        </p:spPr>
+        <p:txBody>
+          <a:bodyPr wrap="square">
+            <a:spAutoFit/>
+          </a:bodyPr>
+          <a:lstStyle/>
+          <a:p>
+            <a:pPr>
+              <a:spcAft>
+                <a:spcPts val="500"/>
+              </a:spcAft>
+            </a:pPr>
+            <a:r>
+              <a:rPr sz="1400">
+                <a:solidFill>
+                  <a:srgbClr val="333333"/>
+                </a:solidFill>
+                <a:latin typeface="Arial"/>
+              </a:rPr>
+              <a:t>• Events that pass NRMSE (0.15–0.19) but have a slow rise: the raw traces are slow baseline drift — no clean fast pulse</a:t>
+            </a:r>
+          </a:p>
+          <a:p>
+            <a:pPr>
+              <a:spcAft>
+                <a:spcPts val="500"/>
+              </a:spcAft>
+            </a:pPr>
+            <a:r>
+              <a:rPr sz="1400">
+                <a:solidFill>
+                  <a:srgbClr val="333333"/>
+                </a:solidFill>
+                <a:latin typeface="Arial"/>
+              </a:rPr>
+              <a:t>• A slow 2-exp hugs the drift with a tiny residual → inflated τ_rise → removed by the 0.3 ms ceiling</a:t>
+            </a:r>
+          </a:p>
+          <a:p>
+            <a:pPr>
+              <a:spcAft>
+                <a:spcPts val="500"/>
+              </a:spcAft>
+            </a:pPr>
+            <a:r>
+              <a:rPr sz="1400">
+                <a:solidFill>
+                  <a:srgbClr val="333333"/>
+                </a:solidFill>
+                <a:latin typeface="Arial"/>
+              </a:rPr>
+              <a:t>• Trade-off: the same cut also trims genuine slow-rise pulses — documented, decision pending</a:t>
+            </a:r>
+          </a:p>
+        </p:txBody>
+      </p:sp>
+      <p:pic>
+        <p:nvPicPr>
+          <p:cNvPr id="5" name="Picture 4" descr="drift_zip22_crop.png"/>
+          <p:cNvPicPr>
+            <a:picLocks noChangeAspect="1"/>
+          </p:cNvPicPr>
+          <p:nvPr/>
+        </p:nvPicPr>
+        <p:blipFill>
+          <a:blip r:embed="rId2"/>
+          <a:stretch>
+            <a:fillRect/>
+          </a:stretch>
+        </p:blipFill>
+        <p:spPr>
+          <a:xfrm>
+            <a:off x="2730551" y="2971800"/>
+            <a:ext cx="6700418" cy="3474720"/>
+          </a:xfrm>
+          <a:prstGeom prst="rect">
+            <a:avLst/>
+          </a:prstGeom>
+        </p:spPr>
+      </p:pic>
+      <p:sp>
+        <p:nvSpPr>
+          <p:cNvPr id="6" name="TextBox 5"/>
+          <p:cNvSpPr txBox="1"/>
+          <p:nvPr/>
+        </p:nvSpPr>
+        <p:spPr>
+          <a:xfrm>
+            <a:off x="1920240" y="6476520"/>
+            <a:ext cx="8321040" cy="274320"/>
+          </a:xfrm>
+          <a:prstGeom prst="rect">
+            <a:avLst/>
+          </a:prstGeom>
+          <a:noFill/>
+        </p:spPr>
+        <p:txBody>
+          <a:bodyPr wrap="square">
+            <a:spAutoFit/>
+          </a:bodyPr>
+          <a:lstStyle/>
+          <a:p>
+            <a:pPr algn="ctr"/>
+            <a:r>
+              <a:rPr sz="1100" i="1">
+                <a:solidFill>
+                  <a:srgbClr val="666666"/>
+                </a:solidFill>
+                <a:latin typeface="Arial"/>
+              </a:rPr>
+              <a:t>Z22: 3 events × PAS1/PBS1/PCS1/PDS1 — PCS1/PDS1 pass NRMSE yet are pure slow drift</a:t>
+            </a:r>
+          </a:p>
+        </p:txBody>
+      </p:sp>
+      <p:sp>
+        <p:nvSpPr>
+          <p:cNvPr id="7" name="TextBox 6"/>
+          <p:cNvSpPr txBox="1"/>
+          <p:nvPr/>
+        </p:nvSpPr>
+        <p:spPr>
+          <a:xfrm>
+            <a:off x="10957255" y="6446520"/>
+            <a:ext cx="1005840" cy="274320"/>
+          </a:xfrm>
+          <a:prstGeom prst="rect">
+            <a:avLst/>
+          </a:prstGeom>
+          <a:noFill/>
+        </p:spPr>
+        <p:txBody>
+          <a:bodyPr wrap="none">
+            <a:spAutoFit/>
+          </a:bodyPr>
+          <a:lstStyle/>
+          <a:p>
+            <a:pPr algn="r"/>
+            <a:r>
+              <a:rPr sz="1100">
+                <a:solidFill>
+                  <a:srgbClr val="666666"/>
+                </a:solidFill>
+                <a:latin typeface="Arial"/>
+              </a:rPr>
+              <a:t>15 / 15</a:t>
             </a:r>
           </a:p>
         </p:txBody>
@@ -5923,7 +6746,7 @@
                 </a:solidFill>
                 <a:latin typeface="Arial"/>
               </a:rPr>
-              <a:t>2 / 13</a:t>
+              <a:t>2 / 15</a:t>
             </a:r>
           </a:p>
         </p:txBody>
@@ -6226,7 +7049,7 @@
                 </a:solidFill>
                 <a:latin typeface="Arial"/>
               </a:rPr>
-              <a:t>3 / 13</a:t>
+              <a:t>3 / 15</a:t>
             </a:r>
           </a:p>
         </p:txBody>
@@ -6599,7 +7422,7 @@
                 </a:solidFill>
                 <a:latin typeface="Arial"/>
               </a:rPr>
-              <a:t>4 / 13</a:t>
+              <a:t>4 / 15</a:t>
             </a:r>
           </a:p>
         </p:txBody>
@@ -6886,7 +7709,7 @@
                 </a:solidFill>
                 <a:latin typeface="Arial"/>
               </a:rPr>
-              <a:t>5 / 13</a:t>
+              <a:t>5 / 15</a:t>
             </a:r>
           </a:p>
         </p:txBody>
@@ -7146,7 +7969,7 @@
                 </a:solidFill>
                 <a:latin typeface="Arial"/>
               </a:rPr>
-              <a:t>6 / 13</a:t>
+              <a:t>6 / 15</a:t>
             </a:r>
           </a:p>
         </p:txBody>
@@ -7470,7 +8293,7 @@
                 </a:solidFill>
                 <a:latin typeface="Arial"/>
               </a:rPr>
-              <a:t>7 / 13</a:t>
+              <a:t>7 / 15</a:t>
             </a:r>
           </a:p>
         </p:txBody>
@@ -7882,7 +8705,7 @@
                 </a:solidFill>
                 <a:latin typeface="Arial"/>
               </a:rPr>
-              <a:t>8 / 13</a:t>
+              <a:t>8 / 15</a:t>
             </a:r>
           </a:p>
         </p:txBody>
@@ -8142,7 +8965,7 @@
                 </a:solidFill>
                 <a:latin typeface="Arial"/>
               </a:rPr>
-              <a:t>9 / 13</a:t>
+              <a:t>9 / 15</a:t>
             </a:r>
           </a:p>
         </p:txBody>

</xml_diff>

<commit_message>
snolab: presentation — backup 4 now uses the EXACT "pass NRMSE<=0.4 but removed by tau_rise<=0.3ms" population
Replaced the shadow_events (t_rise>0.2, median) crop with a freshly generated
figure at the exact cut: median NRMSE<=0.4 AND median t_rise>0.3ms (Z22), i.e.
the noise 0.4 lets through and 0.3 catches. New versioned script
lp_fit_align/scripts/plot_trise_removed_grid.py (run in cdmsfull_V07-02-00.sif)
and full figure results/plots/trise_removed/zip22_trise_removed.png; make_crops.py
now crops drift_zip22_crop.png from it. Slide/speech wording made exact. PCS1/PDS1
pass at NRMSE~0.15 yet are pure slow drift. Honest slow-pulse trade-off kept.

Co-Authored-By: Claude Opus 4.8 <noreply@anthropic.com>
</commit_message>
<xml_diff>
--- a/snolab/presentation/SNOLAB_R4_pulse_templates_20260715.pptx
+++ b/snolab/presentation/SNOLAB_R4_pulse_templates_20260715.pptx
@@ -936,7 +936,7 @@
           <a:lstStyle/>
           <a:p>
             <a:r>
-              <a:t>Backup: what the rise-time cut actually removes. These are Z22 events that pass the NRMSE cut but have a slow rise. Look at PCS1 and PDS1: their NRMSE is low, around 0.15, because a slow two-exp hugs the trace with a tiny residual - but the raw trace is just a slow baseline drift, there is no clean fast pulse. That is exactly the population the 0.3 ms ceiling removes. The honest caveat is that the same cut also trims a small number of genuine slow-rise pulses, which is the documented, still-open trade-off.</a:t>
+              <a:t>Backup: what the rise-time cut actually removes. These are exactly the Z22 events that pass the NRMSE cut - median NRMSE below 0.4 - but are removed by the rise-time ceiling, median t_rise above 0.3 ms. In other words, the noise that 0.4 let through and 0.3 catches. Look at PCS1 and PDS1: their NRMSE is low, around 0.15, because a slow two-exp hugs the trace with a tiny residual - but the raw trace is just a slow baseline drift, there is no clean fast pulse. The honest caveat is that the same cut also trims a small number of genuine slow-rise pulses, which is the documented, still-open trade-off.</a:t>
             </a:r>
           </a:p>
         </p:txBody>
@@ -6203,7 +6203,7 @@
                 </a:solidFill>
                 <a:latin typeface="Arial"/>
               </a:rPr>
-              <a:t>Backup — what the τ_rise cut removes: slow drift (Z22)</a:t>
+              <a:t>Backup — what the τ_rise cut removes: noise NRMSE missed (Z22)</a:t>
             </a:r>
           </a:p>
         </p:txBody>
@@ -6285,7 +6285,7 @@
                 </a:solidFill>
                 <a:latin typeface="Arial"/>
               </a:rPr>
-              <a:t>• Events that pass NRMSE (0.15–0.19) but have a slow rise: the raw traces are slow baseline drift — no clean fast pulse</a:t>
+              <a:t>• Exactly the events that PASS NRMSE ≤ 0.4 but are REMOVED by τ_rise ≤ 0.3 ms — the noise 0.4 let through, 0.3 catches</a:t>
             </a:r>
           </a:p>
           <a:p>
@@ -6301,7 +6301,7 @@
                 </a:solidFill>
                 <a:latin typeface="Arial"/>
               </a:rPr>
-              <a:t>• A slow 2-exp hugs the drift with a tiny residual → inflated τ_rise → removed by the 0.3 ms ceiling</a:t>
+              <a:t>• PCS1 / PDS1 pass at NRMSE ≈ 0.15 (a slow 2-exp hugs a slow baseline drift) — but the raw trace has no clean fast pulse</a:t>
             </a:r>
           </a:p>
           <a:p>
@@ -6376,7 +6376,7 @@
                 </a:solidFill>
                 <a:latin typeface="Arial"/>
               </a:rPr>
-              <a:t>Z22: 3 events × PAS1/PBS1/PCS1/PDS1 — PCS1/PDS1 pass NRMSE yet are pure slow drift</a:t>
+              <a:t>Z22: 3 events × PAS1/PBS1/PCS1/PDS1 — pass NRMSE ≤ 0.4, removed by τ_rise ≤ 0.3 ms; PCS1/PDS1 are pure slow drift</a:t>
             </a:r>
           </a:p>
         </p:txBody>

</xml_diff>

<commit_message>
snolab: presentation — template family 1 slide now shows INPUT (fan of fitted curves) -> OUTPUT (the delivered 1x1 template, one curve read straight from the ROOT file); add make_template_curve.py; speech synced
Co-Authored-By: Claude Opus 4.8 <noreply@anthropic.com>
</commit_message>
<xml_diff>
--- a/snolab/presentation/SNOLAB_R4_pulse_templates_20260715.pptx
+++ b/snolab/presentation/SNOLAB_R4_pulse_templates_20260715.pptx
@@ -8892,8 +8892,8 @@
         </p:blipFill>
         <p:spPr>
           <a:xfrm>
-            <a:off x="1383919" y="3063240"/>
-            <a:ext cx="9393682" cy="2834640"/>
+            <a:off x="320040" y="2880360"/>
+            <a:ext cx="5669279" cy="1710763"/>
           </a:xfrm>
           <a:prstGeom prst="rect">
             <a:avLst/>
@@ -8908,8 +8908,8 @@
         </p:nvSpPr>
         <p:spPr>
           <a:xfrm>
-            <a:off x="1280160" y="5927880"/>
-            <a:ext cx="9601200" cy="274320"/>
+            <a:off x="320040" y="4621123"/>
+            <a:ext cx="5669280" cy="274320"/>
           </a:xfrm>
           <a:prstGeom prst="rect">
             <a:avLst/>
@@ -8930,14 +8930,116 @@
                 </a:solidFill>
                 <a:latin typeface="Arial"/>
               </a:rPr>
-              <a:t>Z7 PBS1, fitted curves after NRMSE ≤ 0.4 and τ_rise ≤ 0.3 ms — the NRMSE-weighted mean of this family is the 1x1 template</a:t>
-            </a:r>
-          </a:p>
-        </p:txBody>
-      </p:sp>
-      <p:sp>
-        <p:nvSpPr>
-          <p:cNvPr id="7" name="TextBox 6"/>
+              <a:t>INPUT — the fitted curves that pass the cuts (Z7 PBS1)</a:t>
+            </a:r>
+          </a:p>
+        </p:txBody>
+      </p:sp>
+      <p:pic>
+        <p:nvPicPr>
+          <p:cNvPr id="7" name="Picture 6" descr="template_1x1_zip7_PBS1.png"/>
+          <p:cNvPicPr>
+            <a:picLocks noChangeAspect="1"/>
+          </p:cNvPicPr>
+          <p:nvPr/>
+        </p:nvPicPr>
+        <p:blipFill>
+          <a:blip r:embed="rId3"/>
+          <a:stretch>
+            <a:fillRect/>
+          </a:stretch>
+        </p:blipFill>
+        <p:spPr>
+          <a:xfrm>
+            <a:off x="6263640" y="2880360"/>
+            <a:ext cx="5669280" cy="2640486"/>
+          </a:xfrm>
+          <a:prstGeom prst="rect">
+            <a:avLst/>
+          </a:prstGeom>
+        </p:spPr>
+      </p:pic>
+      <p:sp>
+        <p:nvSpPr>
+          <p:cNvPr id="8" name="TextBox 7"/>
+          <p:cNvSpPr txBox="1"/>
+          <p:nvPr/>
+        </p:nvSpPr>
+        <p:spPr>
+          <a:xfrm>
+            <a:off x="6263640" y="5550846"/>
+            <a:ext cx="5669280" cy="274320"/>
+          </a:xfrm>
+          <a:prstGeom prst="rect">
+            <a:avLst/>
+          </a:prstGeom>
+          <a:noFill/>
+        </p:spPr>
+        <p:txBody>
+          <a:bodyPr wrap="square">
+            <a:spAutoFit/>
+          </a:bodyPr>
+          <a:lstStyle/>
+          <a:p>
+            <a:pPr algn="ctr"/>
+            <a:r>
+              <a:rPr sz="1100" i="1">
+                <a:solidFill>
+                  <a:srgbClr val="666666"/>
+                </a:solidFill>
+                <a:latin typeface="Arial"/>
+              </a:rPr>
+              <a:t>OUTPUT — their NRMSE-weighted mean: the delivered 1x1 template</a:t>
+            </a:r>
+          </a:p>
+        </p:txBody>
+      </p:sp>
+      <p:sp>
+        <p:nvSpPr>
+          <p:cNvPr id="9" name="Right Arrow 8"/>
+          <p:cNvSpPr/>
+          <p:nvPr/>
+        </p:nvSpPr>
+        <p:spPr>
+          <a:xfrm>
+            <a:off x="5742432" y="4160520"/>
+            <a:ext cx="502920" cy="310896"/>
+          </a:xfrm>
+          <a:prstGeom prst="rightArrow">
+            <a:avLst/>
+          </a:prstGeom>
+          <a:solidFill>
+            <a:srgbClr val="1F3864"/>
+          </a:solidFill>
+          <a:ln>
+            <a:noFill/>
+          </a:ln>
+        </p:spPr>
+        <p:style>
+          <a:lnRef idx="1">
+            <a:schemeClr val="accent1"/>
+          </a:lnRef>
+          <a:fillRef idx="3">
+            <a:schemeClr val="accent1"/>
+          </a:fillRef>
+          <a:effectRef idx="2">
+            <a:schemeClr val="accent1"/>
+          </a:effectRef>
+          <a:fontRef idx="minor">
+            <a:schemeClr val="lt1"/>
+          </a:fontRef>
+        </p:style>
+        <p:txBody>
+          <a:bodyPr rtlCol="0" anchor="ctr"/>
+          <a:lstStyle/>
+          <a:p>
+            <a:pPr algn="ctr"/>
+          </a:p>
+        </p:txBody>
+      </p:sp>
+      <p:sp>
+        <p:nvSpPr>
+          <p:cNvPr id="10" name="TextBox 9"/>
           <p:cNvSpPr txBox="1"/>
           <p:nvPr/>
         </p:nvSpPr>

</xml_diff>

<commit_message>
snolab: presentation — template family 1: overlay the delivered 1x1 template (red, read from the ROOT file) directly on the fan of fitted curves instead of two mismatched side-by-side panels; add make_template_overlay.py with tick-calibrated pixel->data mapping; speech synced
Co-Authored-By: Claude Opus 4.8 <noreply@anthropic.com>
</commit_message>
<xml_diff>
--- a/snolab/presentation/SNOLAB_R4_pulse_templates_20260715.pptx
+++ b/snolab/presentation/SNOLAB_R4_pulse_templates_20260715.pptx
@@ -5887,7 +5887,7 @@
       </p:sp>
       <p:pic>
         <p:nvPicPr>
-          <p:cNvPr id="5" name="Picture 4" descr="fan_zip7_PBS1_after.png"/>
+          <p:cNvPr id="5" name="Picture 4" descr="fan_zip7_PBS1_nrmse.png"/>
           <p:cNvPicPr>
             <a:picLocks noChangeAspect="1"/>
           </p:cNvPicPr>
@@ -5946,7 +5946,7 @@
       </p:sp>
       <p:pic>
         <p:nvPicPr>
-          <p:cNvPr id="7" name="Picture 6" descr="fan_zip7_PBS1_after.png"/>
+          <p:cNvPr id="7" name="Picture 6" descr="fan_zip7_PBS1_nrmse.png"/>
           <p:cNvPicPr>
             <a:picLocks noChangeAspect="1"/>
           </p:cNvPicPr>
@@ -8878,7 +8878,7 @@
       </p:sp>
       <p:pic>
         <p:nvPicPr>
-          <p:cNvPr id="5" name="Picture 4" descr="fan_zip7_PBS1_after.png"/>
+          <p:cNvPr id="5" name="Picture 4" descr="template_overlay_zip7_PBS1.png"/>
           <p:cNvPicPr>
             <a:picLocks noChangeAspect="1"/>
           </p:cNvPicPr>
@@ -8892,8 +8892,8 @@
         </p:blipFill>
         <p:spPr>
           <a:xfrm>
-            <a:off x="320040" y="2880360"/>
-            <a:ext cx="5669279" cy="1710763"/>
+            <a:off x="619163" y="2834640"/>
+            <a:ext cx="10923194" cy="3291840"/>
           </a:xfrm>
           <a:prstGeom prst="rect">
             <a:avLst/>
@@ -8908,8 +8908,8 @@
         </p:nvSpPr>
         <p:spPr>
           <a:xfrm>
-            <a:off x="320040" y="4621123"/>
-            <a:ext cx="5669280" cy="274320"/>
+            <a:off x="457200" y="6156480"/>
+            <a:ext cx="11247120" cy="274320"/>
           </a:xfrm>
           <a:prstGeom prst="rect">
             <a:avLst/>
@@ -8930,116 +8930,14 @@
                 </a:solidFill>
                 <a:latin typeface="Arial"/>
               </a:rPr>
-              <a:t>INPUT — the fitted curves that pass the cuts (Z7 PBS1)</a:t>
-            </a:r>
-          </a:p>
-        </p:txBody>
-      </p:sp>
-      <p:pic>
-        <p:nvPicPr>
-          <p:cNvPr id="7" name="Picture 6" descr="template_1x1_zip7_PBS1.png"/>
-          <p:cNvPicPr>
-            <a:picLocks noChangeAspect="1"/>
-          </p:cNvPicPr>
-          <p:nvPr/>
-        </p:nvPicPr>
-        <p:blipFill>
-          <a:blip r:embed="rId3"/>
-          <a:stretch>
-            <a:fillRect/>
-          </a:stretch>
-        </p:blipFill>
-        <p:spPr>
-          <a:xfrm>
-            <a:off x="6263640" y="2880360"/>
-            <a:ext cx="5669280" cy="2640486"/>
-          </a:xfrm>
-          <a:prstGeom prst="rect">
-            <a:avLst/>
-          </a:prstGeom>
-        </p:spPr>
-      </p:pic>
-      <p:sp>
-        <p:nvSpPr>
-          <p:cNvPr id="8" name="TextBox 7"/>
-          <p:cNvSpPr txBox="1"/>
-          <p:nvPr/>
-        </p:nvSpPr>
-        <p:spPr>
-          <a:xfrm>
-            <a:off x="6263640" y="5550846"/>
-            <a:ext cx="5669280" cy="274320"/>
-          </a:xfrm>
-          <a:prstGeom prst="rect">
-            <a:avLst/>
-          </a:prstGeom>
-          <a:noFill/>
-        </p:spPr>
-        <p:txBody>
-          <a:bodyPr wrap="square">
-            <a:spAutoFit/>
-          </a:bodyPr>
-          <a:lstStyle/>
-          <a:p>
-            <a:pPr algn="ctr"/>
-            <a:r>
-              <a:rPr sz="1100" i="1">
-                <a:solidFill>
-                  <a:srgbClr val="666666"/>
-                </a:solidFill>
-                <a:latin typeface="Arial"/>
-              </a:rPr>
-              <a:t>OUTPUT — their NRMSE-weighted mean: the delivered 1x1 template</a:t>
-            </a:r>
-          </a:p>
-        </p:txBody>
-      </p:sp>
-      <p:sp>
-        <p:nvSpPr>
-          <p:cNvPr id="9" name="Right Arrow 8"/>
-          <p:cNvSpPr/>
-          <p:nvPr/>
-        </p:nvSpPr>
-        <p:spPr>
-          <a:xfrm>
-            <a:off x="5742432" y="4160520"/>
-            <a:ext cx="502920" cy="310896"/>
-          </a:xfrm>
-          <a:prstGeom prst="rightArrow">
-            <a:avLst/>
-          </a:prstGeom>
-          <a:solidFill>
-            <a:srgbClr val="1F3864"/>
-          </a:solidFill>
-          <a:ln>
-            <a:noFill/>
-          </a:ln>
-        </p:spPr>
-        <p:style>
-          <a:lnRef idx="1">
-            <a:schemeClr val="accent1"/>
-          </a:lnRef>
-          <a:fillRef idx="3">
-            <a:schemeClr val="accent1"/>
-          </a:fillRef>
-          <a:effectRef idx="2">
-            <a:schemeClr val="accent1"/>
-          </a:effectRef>
-          <a:fontRef idx="minor">
-            <a:schemeClr val="lt1"/>
-          </a:fontRef>
-        </p:style>
-        <p:txBody>
-          <a:bodyPr rtlCol="0" anchor="ctr"/>
-          <a:lstStyle/>
-          <a:p>
-            <a:pPr algn="ctr"/>
-          </a:p>
-        </p:txBody>
-      </p:sp>
-      <p:sp>
-        <p:nvSpPr>
-          <p:cNvPr id="10" name="TextBox 9"/>
+              <a:t>Z7 PBS1 — blue: the fitted curves (200 of 1931 drawn);  red: the delivered 1x1 template, the NRMSE-weighted mean of all fit_ok curves, read back from the ROOT file</a:t>
+            </a:r>
+          </a:p>
+        </p:txBody>
+      </p:sp>
+      <p:sp>
+        <p:nvSpPr>
+          <p:cNvPr id="7" name="TextBox 6"/>
           <p:cNvSpPr txBox="1"/>
           <p:nvPr/>
         </p:nvSpPr>

</xml_diff>

<commit_message>
snolab: presentation — drop the '(how we fit each trace: next slide)' pointer and 'TH1D' jargon from slides; drop the closing 'how the NRMSE threshold is set' line from the Slide 5 speech
Co-Authored-By: Claude Opus 4.8 <noreply@anthropic.com>
</commit_message>
<xml_diff>
--- a/snolab/presentation/SNOLAB_R4_pulse_templates_20260715.pptx
+++ b/snolab/presentation/SNOLAB_R4_pulse_templates_20260715.pptx
@@ -6896,7 +6896,7 @@
                 </a:solidFill>
                 <a:latin typeface="Arial"/>
               </a:rPr>
-              <a:t>• A real event fits well in every channel at once; a noise trigger fails in every channel — a clean handle on which events are real (how we fit each trace: next slide)</a:t>
+              <a:t>• A real event fits well in every channel at once; a noise trigger fails in every channel — a clean handle on which events are real</a:t>
             </a:r>
           </a:p>
         </p:txBody>
@@ -8871,7 +8871,7 @@
                 </a:solidFill>
                 <a:latin typeface="Arial"/>
               </a:rPr>
-              <a:t>• ROOT TH1D, peak-normalized (+ summed PT / PS1 / PS2)</a:t>
+              <a:t>• ROOT histograms, peak-normalized (+ summed PT / PS1 / PS2)</a:t>
             </a:r>
           </a:p>
         </p:txBody>

</xml_diff>